<commit_message>
docs(pitch): rebuild the deck after the mentor session; STATUS entry for the evening
The .pptx and .pdf now match the generator committed in 470be78: slide 2
carries why-we-built-it and the labelled manual-check estimate, slide 3 the
four steps a desk takes under a run-page capture with the new status words
and nav, slide 8 "What makes it different" with the five features and the
scan read-out beside them. Ten slides, rendered and checked.

STATUS gains the evening's entry: what the mentor said, what changed
tonight, what is assigned to session 8.

Co-Authored-By: Claude Fable 5.1 <noreply@anthropic.com>
</commit_message>
<xml_diff>
--- a/docs/Sentinel-final-pitch.pptx
+++ b/docs/Sentinel-final-pitch.pptx
@@ -199,7 +199,7 @@
             </a:lvl1pPr>
           </a:lstStyle>
           <a:p>
-            <a:fld id="{665CB654-6198-4212-A711-96AA5A8DB821}" type="datetimeFigureOut">
+            <a:fld id="{592D12D2-935B-49E8-BF1E-3F0C487C06CE}" type="datetimeFigureOut">
               <a:rPr lang="en-MY" smtClean="0"/>
               <a:t>24/9/2026</a:t>
             </a:fld>
@@ -358,7 +358,7 @@
             </a:lvl1pPr>
           </a:lstStyle>
           <a:p>
-            <a:fld id="{9ED7B76F-B3BD-4F0D-8114-EFC19D398380}" type="slidenum">
+            <a:fld id="{21F61A80-68B1-422B-9D68-85FD71C666C5}" type="slidenum">
               <a:rPr lang="en-MY" smtClean="0"/>
               <a:t>‹#›</a:t>
             </a:fld>
@@ -369,7 +369,7 @@
     </p:spTree>
     <p:extLst>
       <p:ext uri="{BB962C8B-B14F-4D97-AF65-F5344CB8AC3E}">
-        <p14:creationId xmlns:p14="http://schemas.microsoft.com/office/powerpoint/2010/main" val="2645294980"/>
+        <p14:creationId xmlns:p14="http://schemas.microsoft.com/office/powerpoint/2010/main" val="1018011492"/>
       </p:ext>
     </p:extLst>
   </p:cSld>
@@ -536,7 +536,7 @@
           <a:bodyPr/>
           <a:lstStyle/>
           <a:p>
-            <a:fld id="{9ED7B76F-B3BD-4F0D-8114-EFC19D398380}" type="slidenum">
+            <a:fld id="{21F61A80-68B1-422B-9D68-85FD71C666C5}" type="slidenum">
               <a:rPr lang="en-MY" smtClean="0"/>
               <a:t>1</a:t>
             </a:fld>
@@ -547,7 +547,7 @@
     </p:spTree>
     <p:extLst>
       <p:ext uri="{BB962C8B-B14F-4D97-AF65-F5344CB8AC3E}">
-        <p14:creationId xmlns:p14="http://schemas.microsoft.com/office/powerpoint/2010/main" val="1451372670"/>
+        <p14:creationId xmlns:p14="http://schemas.microsoft.com/office/powerpoint/2010/main" val="4291143848"/>
       </p:ext>
     </p:extLst>
   </p:cSld>
@@ -624,7 +624,7 @@
           <a:bodyPr/>
           <a:lstStyle/>
           <a:p>
-            <a:fld id="{9ED7B76F-B3BD-4F0D-8114-EFC19D398380}" type="slidenum">
+            <a:fld id="{21F61A80-68B1-422B-9D68-85FD71C666C5}" type="slidenum">
               <a:rPr lang="en-MY" smtClean="0"/>
               <a:t>10</a:t>
             </a:fld>
@@ -635,7 +635,7 @@
     </p:spTree>
     <p:extLst>
       <p:ext uri="{BB962C8B-B14F-4D97-AF65-F5344CB8AC3E}">
-        <p14:creationId xmlns:p14="http://schemas.microsoft.com/office/powerpoint/2010/main" val="1859837402"/>
+        <p14:creationId xmlns:p14="http://schemas.microsoft.com/office/powerpoint/2010/main" val="4257150790"/>
       </p:ext>
     </p:extLst>
   </p:cSld>
@@ -691,7 +691,7 @@
           <a:p>
             <a:r>
               <a:rPr lang="en-US"/>
-              <a:t>A shipping desk gets five kinds of mail in one inbox. For a document check someone compares the Shipping Instruction against the draft Bill of Lading - seven fields, by hand. Miss one and it's a correction, a delay, rework. And there's a fourth case the statement names: sometimes the check can't be done - an unreadable scan, a blank field, the wrong document. That has to reach a person with the reason, not be guessed at. Sentinel does all four. (0:15-0:40)</a:t>
+              <a:t>Why we built it: a shipping desk gets five kinds of mail in one inbox, and for every document check a person compares the Shipping Instruction against the draft Bill of Lading - seven fields, by hand. At a conservative estimate that is about four minutes a pair and twenty seconds to triage each email; this inbox alone is a day and a half of desk work. Miss one field and it's a correction, a delay, rework. And there's a fourth case the statement names: sometimes the check can't be done - an unreadable scan, a blank field, the wrong document. That has to reach a person with the reason, not be guessed at. Sentinel does all four. (0:15-0:40)</a:t>
             </a:r>
             <a:endParaRPr lang="en-MY"/>
           </a:p>
@@ -712,7 +712,7 @@
           <a:bodyPr/>
           <a:lstStyle/>
           <a:p>
-            <a:fld id="{9ED7B76F-B3BD-4F0D-8114-EFC19D398380}" type="slidenum">
+            <a:fld id="{21F61A80-68B1-422B-9D68-85FD71C666C5}" type="slidenum">
               <a:rPr lang="en-MY" smtClean="0"/>
               <a:t>2</a:t>
             </a:fld>
@@ -723,7 +723,7 @@
     </p:spTree>
     <p:extLst>
       <p:ext uri="{BB962C8B-B14F-4D97-AF65-F5344CB8AC3E}">
-        <p14:creationId xmlns:p14="http://schemas.microsoft.com/office/powerpoint/2010/main" val="1822523164"/>
+        <p14:creationId xmlns:p14="http://schemas.microsoft.com/office/powerpoint/2010/main" val="966233640"/>
       </p:ext>
     </p:extLst>
   </p:cSld>
@@ -779,7 +779,7 @@
           <a:p>
             <a:r>
               <a:rPr lang="en-US"/>
-              <a:t>This is the whole inbox, live on Render and Vercel - not a sample, the organisers' 520 emails. Every email classified, every document pair compared, every case Sentinel can't decide sent to a person with the reason attached. Thirteen seconds. You'll press the button yourself in a minute. Do not say the accuracy here - that is slide 6. (0:40-1:05)</a:t>
+              <a:t>This is the whole inbox, live on Render and Vercel - not a sample, the organisers' 520 emails. Every email classified, every document pair compared, every case Sentinel can't decide sent to a person with the reason attached. Thirteen seconds. And this is how a desk uses it, four steps: run the inbox, open a flagged case, confirm it or correct one field or re-upload the corrected document, send the drafted reply. Do not say the accuracy here - that is slide 6. (0:40-1:05)</a:t>
             </a:r>
             <a:endParaRPr lang="en-MY"/>
           </a:p>
@@ -800,7 +800,7 @@
           <a:bodyPr/>
           <a:lstStyle/>
           <a:p>
-            <a:fld id="{9ED7B76F-B3BD-4F0D-8114-EFC19D398380}" type="slidenum">
+            <a:fld id="{21F61A80-68B1-422B-9D68-85FD71C666C5}" type="slidenum">
               <a:rPr lang="en-MY" smtClean="0"/>
               <a:t>3</a:t>
             </a:fld>
@@ -811,7 +811,7 @@
     </p:spTree>
     <p:extLst>
       <p:ext uri="{BB962C8B-B14F-4D97-AF65-F5344CB8AC3E}">
-        <p14:creationId xmlns:p14="http://schemas.microsoft.com/office/powerpoint/2010/main" val="3019124358"/>
+        <p14:creationId xmlns:p14="http://schemas.microsoft.com/office/powerpoint/2010/main" val="1839013987"/>
       </p:ext>
     </p:extLst>
   </p:cSld>
@@ -888,7 +888,7 @@
           <a:bodyPr/>
           <a:lstStyle/>
           <a:p>
-            <a:fld id="{9ED7B76F-B3BD-4F0D-8114-EFC19D398380}" type="slidenum">
+            <a:fld id="{21F61A80-68B1-422B-9D68-85FD71C666C5}" type="slidenum">
               <a:rPr lang="en-MY" smtClean="0"/>
               <a:t>4</a:t>
             </a:fld>
@@ -899,7 +899,7 @@
     </p:spTree>
     <p:extLst>
       <p:ext uri="{BB962C8B-B14F-4D97-AF65-F5344CB8AC3E}">
-        <p14:creationId xmlns:p14="http://schemas.microsoft.com/office/powerpoint/2010/main" val="1915543079"/>
+        <p14:creationId xmlns:p14="http://schemas.microsoft.com/office/powerpoint/2010/main" val="217516439"/>
       </p:ext>
     </p:extLst>
   </p:cSld>
@@ -955,7 +955,7 @@
           <a:p>
             <a:r>
               <a:rPr lang="en-US"/>
-              <a:t>A judge in the first round said we use AI less than most teams. True, and measured. On this inbox the rules answer all 520 and the scoring is all-or-nothing per email, so a model that is almost always right costs places. The model goes only where the rules admit they can't read: an ambiguous email, a label we've never seen, a scanned page. On documents with wording we invented, rules alone send 168 of 188 cases to a human; with the model, two - and false discrepancies stay at zero, because nothing the model says is adopted until we find it again in the source. You'll see both in the demo: a scan read out for the reviewer, and four unknown labels read on request. (1:40-2:20)</a:t>
+              <a:t>Never say 'we use less AI'. Say: the AI is reserved for the cases the rules cannot handle - and the system performs just as well. A judge in the first round said we use AI less than most teams. True, and measured. On this inbox the rules answer all 520 and the scoring is all-or-nothing per email, so a model that is almost always right costs places. The model goes only where the rules admit they can't read: an ambiguous email, a label we've never seen, a scanned page. On documents with wording we invented, rules alone send 168 of 188 cases to a human; with the model, two - and false discrepancies stay at zero, because nothing the model says is adopted until we find it again in the source. You'll see both in the demo: a scan read out for the reviewer, and four unknown labels read on request. (1:40-2:20)</a:t>
             </a:r>
             <a:endParaRPr lang="en-MY"/>
           </a:p>
@@ -976,7 +976,7 @@
           <a:bodyPr/>
           <a:lstStyle/>
           <a:p>
-            <a:fld id="{9ED7B76F-B3BD-4F0D-8114-EFC19D398380}" type="slidenum">
+            <a:fld id="{21F61A80-68B1-422B-9D68-85FD71C666C5}" type="slidenum">
               <a:rPr lang="en-MY" smtClean="0"/>
               <a:t>5</a:t>
             </a:fld>
@@ -987,7 +987,7 @@
     </p:spTree>
     <p:extLst>
       <p:ext uri="{BB962C8B-B14F-4D97-AF65-F5344CB8AC3E}">
-        <p14:creationId xmlns:p14="http://schemas.microsoft.com/office/powerpoint/2010/main" val="825658002"/>
+        <p14:creationId xmlns:p14="http://schemas.microsoft.com/office/powerpoint/2010/main" val="3833377137"/>
       </p:ext>
     </p:extLst>
   </p:cSld>
@@ -1064,7 +1064,7 @@
           <a:bodyPr/>
           <a:lstStyle/>
           <a:p>
-            <a:fld id="{9ED7B76F-B3BD-4F0D-8114-EFC19D398380}" type="slidenum">
+            <a:fld id="{21F61A80-68B1-422B-9D68-85FD71C666C5}" type="slidenum">
               <a:rPr lang="en-MY" smtClean="0"/>
               <a:t>6</a:t>
             </a:fld>
@@ -1075,7 +1075,7 @@
     </p:spTree>
     <p:extLst>
       <p:ext uri="{BB962C8B-B14F-4D97-AF65-F5344CB8AC3E}">
-        <p14:creationId xmlns:p14="http://schemas.microsoft.com/office/powerpoint/2010/main" val="610951104"/>
+        <p14:creationId xmlns:p14="http://schemas.microsoft.com/office/powerpoint/2010/main" val="1879101604"/>
       </p:ext>
     </p:extLst>
   </p:cSld>
@@ -1152,7 +1152,7 @@
           <a:bodyPr/>
           <a:lstStyle/>
           <a:p>
-            <a:fld id="{9ED7B76F-B3BD-4F0D-8114-EFC19D398380}" type="slidenum">
+            <a:fld id="{21F61A80-68B1-422B-9D68-85FD71C666C5}" type="slidenum">
               <a:rPr lang="en-MY" smtClean="0"/>
               <a:t>7</a:t>
             </a:fld>
@@ -1163,7 +1163,7 @@
     </p:spTree>
     <p:extLst>
       <p:ext uri="{BB962C8B-B14F-4D97-AF65-F5344CB8AC3E}">
-        <p14:creationId xmlns:p14="http://schemas.microsoft.com/office/powerpoint/2010/main" val="975346833"/>
+        <p14:creationId xmlns:p14="http://schemas.microsoft.com/office/powerpoint/2010/main" val="1150897354"/>
       </p:ext>
     </p:extLst>
   </p:cSld>
@@ -1219,7 +1219,7 @@
           <a:p>
             <a:r>
               <a:rPr lang="en-US"/>
-              <a:t>Every other checker shows you a verdict. This one shows you the line, lets you correct a single field, groups the same shipper's repeated mistakes, and drafts the reply from the corrected outcome - not the stale one. Fifteen seconds; the demo already did the work. (4:25-4:40)</a:t>
+              <a:t>At the top-ten stage everyone meets the brief, so this is the slide to slow down on - thirty seconds. Five things the others mostly don't have: the sender re-sends a fixed document and you re-upload it on the case, the check runs again and the old answer stays on record; a scan still goes to a person but already read out by the model; correcting a field shows this shipper's history on that field; the original document is one click away from every value; and the reply is drafted from what the reviewer decided, not the stale answer. (4:10-4:40)</a:t>
             </a:r>
             <a:endParaRPr lang="en-MY"/>
           </a:p>
@@ -1240,7 +1240,7 @@
           <a:bodyPr/>
           <a:lstStyle/>
           <a:p>
-            <a:fld id="{9ED7B76F-B3BD-4F0D-8114-EFC19D398380}" type="slidenum">
+            <a:fld id="{21F61A80-68B1-422B-9D68-85FD71C666C5}" type="slidenum">
               <a:rPr lang="en-MY" smtClean="0"/>
               <a:t>8</a:t>
             </a:fld>
@@ -1251,7 +1251,7 @@
     </p:spTree>
     <p:extLst>
       <p:ext uri="{BB962C8B-B14F-4D97-AF65-F5344CB8AC3E}">
-        <p14:creationId xmlns:p14="http://schemas.microsoft.com/office/powerpoint/2010/main" val="384433492"/>
+        <p14:creationId xmlns:p14="http://schemas.microsoft.com/office/powerpoint/2010/main" val="3851826723"/>
       </p:ext>
     </p:extLst>
   </p:cSld>
@@ -1328,7 +1328,7 @@
           <a:bodyPr/>
           <a:lstStyle/>
           <a:p>
-            <a:fld id="{9ED7B76F-B3BD-4F0D-8114-EFC19D398380}" type="slidenum">
+            <a:fld id="{21F61A80-68B1-422B-9D68-85FD71C666C5}" type="slidenum">
               <a:rPr lang="en-MY" smtClean="0"/>
               <a:t>9</a:t>
             </a:fld>
@@ -1339,7 +1339,7 @@
     </p:spTree>
     <p:extLst>
       <p:ext uri="{BB962C8B-B14F-4D97-AF65-F5344CB8AC3E}">
-        <p14:creationId xmlns:p14="http://schemas.microsoft.com/office/powerpoint/2010/main" val="576049738"/>
+        <p14:creationId xmlns:p14="http://schemas.microsoft.com/office/powerpoint/2010/main" val="1588068160"/>
       </p:ext>
     </p:extLst>
   </p:cSld>
@@ -1371,7 +1371,7 @@
           <p:cNvPr id="2" name="Title 1">
             <a:extLst>
               <a:ext uri="{FF2B5EF4-FFF2-40B4-BE49-F238E27FC236}">
-                <a16:creationId xmlns:a16="http://schemas.microsoft.com/office/drawing/2014/main" id="{3B6FABF8-CE87-4581-E9FE-200AA370FE93}"/>
+                <a16:creationId xmlns:a16="http://schemas.microsoft.com/office/drawing/2014/main" id="{686CC9FC-85CD-1FCB-2B8B-B1C956648C32}"/>
               </a:ext>
             </a:extLst>
           </p:cNvPr>
@@ -1409,7 +1409,7 @@
           <p:cNvPr id="3" name="Subtitle 2">
             <a:extLst>
               <a:ext uri="{FF2B5EF4-FFF2-40B4-BE49-F238E27FC236}">
-                <a16:creationId xmlns:a16="http://schemas.microsoft.com/office/drawing/2014/main" id="{B4E0ABDD-441D-421E-FE47-F73B44D5A19B}"/>
+                <a16:creationId xmlns:a16="http://schemas.microsoft.com/office/drawing/2014/main" id="{32EFD356-D93D-C4D7-75E1-0CC1E3A26ECA}"/>
               </a:ext>
             </a:extLst>
           </p:cNvPr>
@@ -1480,7 +1480,7 @@
           <p:cNvPr id="4" name="Date Placeholder 3">
             <a:extLst>
               <a:ext uri="{FF2B5EF4-FFF2-40B4-BE49-F238E27FC236}">
-                <a16:creationId xmlns:a16="http://schemas.microsoft.com/office/drawing/2014/main" id="{4FDEEFD2-91F4-5FBB-0D05-0AAACC776C7B}"/>
+                <a16:creationId xmlns:a16="http://schemas.microsoft.com/office/drawing/2014/main" id="{24980623-15B8-71E2-5338-54BCE67E659B}"/>
               </a:ext>
             </a:extLst>
           </p:cNvPr>
@@ -1496,7 +1496,7 @@
           <a:bodyPr/>
           <a:lstStyle/>
           <a:p>
-            <a:fld id="{3D5D1A14-1EE2-4E92-B4FE-304EE26A3F66}" type="datetimeFigureOut">
+            <a:fld id="{2F8D26A6-D71B-4538-BE7E-D2A35FE8C500}" type="datetimeFigureOut">
               <a:rPr lang="en-MY" smtClean="0"/>
               <a:t>24/9/2026</a:t>
             </a:fld>
@@ -1509,7 +1509,7 @@
           <p:cNvPr id="5" name="Footer Placeholder 4">
             <a:extLst>
               <a:ext uri="{FF2B5EF4-FFF2-40B4-BE49-F238E27FC236}">
-                <a16:creationId xmlns:a16="http://schemas.microsoft.com/office/drawing/2014/main" id="{65F3753A-9EF0-AB22-B237-D56724D94AD5}"/>
+                <a16:creationId xmlns:a16="http://schemas.microsoft.com/office/drawing/2014/main" id="{E72EC12D-2DDA-2C56-2F70-EFBC3FBA8437}"/>
               </a:ext>
             </a:extLst>
           </p:cNvPr>
@@ -1534,7 +1534,7 @@
           <p:cNvPr id="6" name="Slide Number Placeholder 5">
             <a:extLst>
               <a:ext uri="{FF2B5EF4-FFF2-40B4-BE49-F238E27FC236}">
-                <a16:creationId xmlns:a16="http://schemas.microsoft.com/office/drawing/2014/main" id="{143A7B2A-9330-703B-5076-86D8AEA50F3C}"/>
+                <a16:creationId xmlns:a16="http://schemas.microsoft.com/office/drawing/2014/main" id="{07BEA3D9-0A18-698E-81BA-826D2308A65B}"/>
               </a:ext>
             </a:extLst>
           </p:cNvPr>
@@ -1550,7 +1550,7 @@
           <a:bodyPr/>
           <a:lstStyle/>
           <a:p>
-            <a:fld id="{C3AED862-024E-41DA-81A7-2FE9CB15877D}" type="slidenum">
+            <a:fld id="{3A1571EA-3779-4ED8-A27C-B0EAA1CBA9CE}" type="slidenum">
               <a:rPr lang="en-MY" smtClean="0"/>
               <a:t>‹#›</a:t>
             </a:fld>
@@ -1561,7 +1561,7 @@
     </p:spTree>
     <p:extLst>
       <p:ext uri="{BB962C8B-B14F-4D97-AF65-F5344CB8AC3E}">
-        <p14:creationId xmlns:p14="http://schemas.microsoft.com/office/powerpoint/2010/main" val="4247354257"/>
+        <p14:creationId xmlns:p14="http://schemas.microsoft.com/office/powerpoint/2010/main" val="1553467972"/>
       </p:ext>
     </p:extLst>
   </p:cSld>
@@ -1593,7 +1593,7 @@
           <p:cNvPr id="2" name="Title 1">
             <a:extLst>
               <a:ext uri="{FF2B5EF4-FFF2-40B4-BE49-F238E27FC236}">
-                <a16:creationId xmlns:a16="http://schemas.microsoft.com/office/drawing/2014/main" id="{E8741EA4-3A57-FD85-3E51-3188339C25FE}"/>
+                <a16:creationId xmlns:a16="http://schemas.microsoft.com/office/drawing/2014/main" id="{ECC59A2F-1856-0EC6-5771-C53BBE2126F3}"/>
               </a:ext>
             </a:extLst>
           </p:cNvPr>
@@ -1622,7 +1622,7 @@
           <p:cNvPr id="3" name="Vertical Text Placeholder 2">
             <a:extLst>
               <a:ext uri="{FF2B5EF4-FFF2-40B4-BE49-F238E27FC236}">
-                <a16:creationId xmlns:a16="http://schemas.microsoft.com/office/drawing/2014/main" id="{B9A7E264-8A27-B97B-1461-A64B5F416314}"/>
+                <a16:creationId xmlns:a16="http://schemas.microsoft.com/office/drawing/2014/main" id="{14628F09-881E-7BA0-38D4-031A79D17012}"/>
               </a:ext>
             </a:extLst>
           </p:cNvPr>
@@ -1680,7 +1680,7 @@
           <p:cNvPr id="4" name="Date Placeholder 3">
             <a:extLst>
               <a:ext uri="{FF2B5EF4-FFF2-40B4-BE49-F238E27FC236}">
-                <a16:creationId xmlns:a16="http://schemas.microsoft.com/office/drawing/2014/main" id="{5538A968-E026-75CE-1134-5E501F457F06}"/>
+                <a16:creationId xmlns:a16="http://schemas.microsoft.com/office/drawing/2014/main" id="{79E449A9-7395-EAD7-A978-6117EC91000D}"/>
               </a:ext>
             </a:extLst>
           </p:cNvPr>
@@ -1696,7 +1696,7 @@
           <a:bodyPr/>
           <a:lstStyle/>
           <a:p>
-            <a:fld id="{3D5D1A14-1EE2-4E92-B4FE-304EE26A3F66}" type="datetimeFigureOut">
+            <a:fld id="{2F8D26A6-D71B-4538-BE7E-D2A35FE8C500}" type="datetimeFigureOut">
               <a:rPr lang="en-MY" smtClean="0"/>
               <a:t>24/9/2026</a:t>
             </a:fld>
@@ -1709,7 +1709,7 @@
           <p:cNvPr id="5" name="Footer Placeholder 4">
             <a:extLst>
               <a:ext uri="{FF2B5EF4-FFF2-40B4-BE49-F238E27FC236}">
-                <a16:creationId xmlns:a16="http://schemas.microsoft.com/office/drawing/2014/main" id="{56DAF037-6C39-C715-7B92-C9D145855177}"/>
+                <a16:creationId xmlns:a16="http://schemas.microsoft.com/office/drawing/2014/main" id="{B4270686-63C5-2C96-35D9-1115F792AF58}"/>
               </a:ext>
             </a:extLst>
           </p:cNvPr>
@@ -1734,7 +1734,7 @@
           <p:cNvPr id="6" name="Slide Number Placeholder 5">
             <a:extLst>
               <a:ext uri="{FF2B5EF4-FFF2-40B4-BE49-F238E27FC236}">
-                <a16:creationId xmlns:a16="http://schemas.microsoft.com/office/drawing/2014/main" id="{DA2C53EB-60C7-4EFE-8801-7FF942D94D41}"/>
+                <a16:creationId xmlns:a16="http://schemas.microsoft.com/office/drawing/2014/main" id="{1E0348DC-BCE1-D3F0-4514-CE5391B0E8A4}"/>
               </a:ext>
             </a:extLst>
           </p:cNvPr>
@@ -1750,7 +1750,7 @@
           <a:bodyPr/>
           <a:lstStyle/>
           <a:p>
-            <a:fld id="{C3AED862-024E-41DA-81A7-2FE9CB15877D}" type="slidenum">
+            <a:fld id="{3A1571EA-3779-4ED8-A27C-B0EAA1CBA9CE}" type="slidenum">
               <a:rPr lang="en-MY" smtClean="0"/>
               <a:t>‹#›</a:t>
             </a:fld>
@@ -1761,7 +1761,7 @@
     </p:spTree>
     <p:extLst>
       <p:ext uri="{BB962C8B-B14F-4D97-AF65-F5344CB8AC3E}">
-        <p14:creationId xmlns:p14="http://schemas.microsoft.com/office/powerpoint/2010/main" val="164559848"/>
+        <p14:creationId xmlns:p14="http://schemas.microsoft.com/office/powerpoint/2010/main" val="2304108578"/>
       </p:ext>
     </p:extLst>
   </p:cSld>
@@ -1793,7 +1793,7 @@
           <p:cNvPr id="2" name="Vertical Title 1">
             <a:extLst>
               <a:ext uri="{FF2B5EF4-FFF2-40B4-BE49-F238E27FC236}">
-                <a16:creationId xmlns:a16="http://schemas.microsoft.com/office/drawing/2014/main" id="{22AA4FC2-830E-2E7C-7774-BF159DD594CC}"/>
+                <a16:creationId xmlns:a16="http://schemas.microsoft.com/office/drawing/2014/main" id="{C797B5DB-3C13-A7EA-D2E7-CD589CDDCB52}"/>
               </a:ext>
             </a:extLst>
           </p:cNvPr>
@@ -1827,7 +1827,7 @@
           <p:cNvPr id="3" name="Vertical Text Placeholder 2">
             <a:extLst>
               <a:ext uri="{FF2B5EF4-FFF2-40B4-BE49-F238E27FC236}">
-                <a16:creationId xmlns:a16="http://schemas.microsoft.com/office/drawing/2014/main" id="{1122E747-D248-251F-BFEE-FA1867907B74}"/>
+                <a16:creationId xmlns:a16="http://schemas.microsoft.com/office/drawing/2014/main" id="{CC52690E-804E-05B8-C094-7CB34921D760}"/>
               </a:ext>
             </a:extLst>
           </p:cNvPr>
@@ -1890,7 +1890,7 @@
           <p:cNvPr id="4" name="Date Placeholder 3">
             <a:extLst>
               <a:ext uri="{FF2B5EF4-FFF2-40B4-BE49-F238E27FC236}">
-                <a16:creationId xmlns:a16="http://schemas.microsoft.com/office/drawing/2014/main" id="{6ED24FEF-762C-B873-2CB5-6FE9C3E5D950}"/>
+                <a16:creationId xmlns:a16="http://schemas.microsoft.com/office/drawing/2014/main" id="{72C68D13-FDFF-B1C8-01ED-06180EF0BC34}"/>
               </a:ext>
             </a:extLst>
           </p:cNvPr>
@@ -1906,7 +1906,7 @@
           <a:bodyPr/>
           <a:lstStyle/>
           <a:p>
-            <a:fld id="{3D5D1A14-1EE2-4E92-B4FE-304EE26A3F66}" type="datetimeFigureOut">
+            <a:fld id="{2F8D26A6-D71B-4538-BE7E-D2A35FE8C500}" type="datetimeFigureOut">
               <a:rPr lang="en-MY" smtClean="0"/>
               <a:t>24/9/2026</a:t>
             </a:fld>
@@ -1919,7 +1919,7 @@
           <p:cNvPr id="5" name="Footer Placeholder 4">
             <a:extLst>
               <a:ext uri="{FF2B5EF4-FFF2-40B4-BE49-F238E27FC236}">
-                <a16:creationId xmlns:a16="http://schemas.microsoft.com/office/drawing/2014/main" id="{A807BBD0-1492-EE96-50FD-AE808D8489E3}"/>
+                <a16:creationId xmlns:a16="http://schemas.microsoft.com/office/drawing/2014/main" id="{819CE22C-68F6-0D57-A1A0-0D9D6E65AC76}"/>
               </a:ext>
             </a:extLst>
           </p:cNvPr>
@@ -1944,7 +1944,7 @@
           <p:cNvPr id="6" name="Slide Number Placeholder 5">
             <a:extLst>
               <a:ext uri="{FF2B5EF4-FFF2-40B4-BE49-F238E27FC236}">
-                <a16:creationId xmlns:a16="http://schemas.microsoft.com/office/drawing/2014/main" id="{663530D5-23DD-3045-F135-DBBB64937AC4}"/>
+                <a16:creationId xmlns:a16="http://schemas.microsoft.com/office/drawing/2014/main" id="{500C94AB-11EF-8B96-DA2A-4953DCDD1F42}"/>
               </a:ext>
             </a:extLst>
           </p:cNvPr>
@@ -1960,7 +1960,7 @@
           <a:bodyPr/>
           <a:lstStyle/>
           <a:p>
-            <a:fld id="{C3AED862-024E-41DA-81A7-2FE9CB15877D}" type="slidenum">
+            <a:fld id="{3A1571EA-3779-4ED8-A27C-B0EAA1CBA9CE}" type="slidenum">
               <a:rPr lang="en-MY" smtClean="0"/>
               <a:t>‹#›</a:t>
             </a:fld>
@@ -1971,7 +1971,7 @@
     </p:spTree>
     <p:extLst>
       <p:ext uri="{BB962C8B-B14F-4D97-AF65-F5344CB8AC3E}">
-        <p14:creationId xmlns:p14="http://schemas.microsoft.com/office/powerpoint/2010/main" val="3654758781"/>
+        <p14:creationId xmlns:p14="http://schemas.microsoft.com/office/powerpoint/2010/main" val="950173206"/>
       </p:ext>
     </p:extLst>
   </p:cSld>
@@ -2003,7 +2003,7 @@
           <p:cNvPr id="2" name="Title 1">
             <a:extLst>
               <a:ext uri="{FF2B5EF4-FFF2-40B4-BE49-F238E27FC236}">
-                <a16:creationId xmlns:a16="http://schemas.microsoft.com/office/drawing/2014/main" id="{A8F284F7-68D3-4A89-9724-284BCD4FCDA5}"/>
+                <a16:creationId xmlns:a16="http://schemas.microsoft.com/office/drawing/2014/main" id="{9B620C09-64EE-4F98-E127-92E992DA418F}"/>
               </a:ext>
             </a:extLst>
           </p:cNvPr>
@@ -2032,7 +2032,7 @@
           <p:cNvPr id="3" name="Content Placeholder 2">
             <a:extLst>
               <a:ext uri="{FF2B5EF4-FFF2-40B4-BE49-F238E27FC236}">
-                <a16:creationId xmlns:a16="http://schemas.microsoft.com/office/drawing/2014/main" id="{15335988-A780-5C4D-B05B-DCCA049D1131}"/>
+                <a16:creationId xmlns:a16="http://schemas.microsoft.com/office/drawing/2014/main" id="{E58E8323-0378-D6D5-C708-0609029FC75B}"/>
               </a:ext>
             </a:extLst>
           </p:cNvPr>
@@ -2090,7 +2090,7 @@
           <p:cNvPr id="4" name="Date Placeholder 3">
             <a:extLst>
               <a:ext uri="{FF2B5EF4-FFF2-40B4-BE49-F238E27FC236}">
-                <a16:creationId xmlns:a16="http://schemas.microsoft.com/office/drawing/2014/main" id="{438332E5-F26C-47AE-7D93-112F4D199E13}"/>
+                <a16:creationId xmlns:a16="http://schemas.microsoft.com/office/drawing/2014/main" id="{83117E4D-8376-A8F7-B588-6EFF3201A14F}"/>
               </a:ext>
             </a:extLst>
           </p:cNvPr>
@@ -2106,7 +2106,7 @@
           <a:bodyPr/>
           <a:lstStyle/>
           <a:p>
-            <a:fld id="{3D5D1A14-1EE2-4E92-B4FE-304EE26A3F66}" type="datetimeFigureOut">
+            <a:fld id="{2F8D26A6-D71B-4538-BE7E-D2A35FE8C500}" type="datetimeFigureOut">
               <a:rPr lang="en-MY" smtClean="0"/>
               <a:t>24/9/2026</a:t>
             </a:fld>
@@ -2119,7 +2119,7 @@
           <p:cNvPr id="5" name="Footer Placeholder 4">
             <a:extLst>
               <a:ext uri="{FF2B5EF4-FFF2-40B4-BE49-F238E27FC236}">
-                <a16:creationId xmlns:a16="http://schemas.microsoft.com/office/drawing/2014/main" id="{A33FFACA-E62A-F90D-D4F5-1247022E70C1}"/>
+                <a16:creationId xmlns:a16="http://schemas.microsoft.com/office/drawing/2014/main" id="{55C14C2B-F51D-CA8F-9356-684F8631193F}"/>
               </a:ext>
             </a:extLst>
           </p:cNvPr>
@@ -2144,7 +2144,7 @@
           <p:cNvPr id="6" name="Slide Number Placeholder 5">
             <a:extLst>
               <a:ext uri="{FF2B5EF4-FFF2-40B4-BE49-F238E27FC236}">
-                <a16:creationId xmlns:a16="http://schemas.microsoft.com/office/drawing/2014/main" id="{CA455B31-E309-479A-E225-E5578C1C63B4}"/>
+                <a16:creationId xmlns:a16="http://schemas.microsoft.com/office/drawing/2014/main" id="{66353F87-7097-7B58-18BF-3219EC9E2BD5}"/>
               </a:ext>
             </a:extLst>
           </p:cNvPr>
@@ -2160,7 +2160,7 @@
           <a:bodyPr/>
           <a:lstStyle/>
           <a:p>
-            <a:fld id="{C3AED862-024E-41DA-81A7-2FE9CB15877D}" type="slidenum">
+            <a:fld id="{3A1571EA-3779-4ED8-A27C-B0EAA1CBA9CE}" type="slidenum">
               <a:rPr lang="en-MY" smtClean="0"/>
               <a:t>‹#›</a:t>
             </a:fld>
@@ -2171,7 +2171,7 @@
     </p:spTree>
     <p:extLst>
       <p:ext uri="{BB962C8B-B14F-4D97-AF65-F5344CB8AC3E}">
-        <p14:creationId xmlns:p14="http://schemas.microsoft.com/office/powerpoint/2010/main" val="3379437603"/>
+        <p14:creationId xmlns:p14="http://schemas.microsoft.com/office/powerpoint/2010/main" val="1999681918"/>
       </p:ext>
     </p:extLst>
   </p:cSld>
@@ -2203,7 +2203,7 @@
           <p:cNvPr id="2" name="Title 1">
             <a:extLst>
               <a:ext uri="{FF2B5EF4-FFF2-40B4-BE49-F238E27FC236}">
-                <a16:creationId xmlns:a16="http://schemas.microsoft.com/office/drawing/2014/main" id="{EC1389D2-7159-8B64-481C-FE32FB2E01BB}"/>
+                <a16:creationId xmlns:a16="http://schemas.microsoft.com/office/drawing/2014/main" id="{7F23EE73-0C43-16FA-1D49-DDB1F392A9BA}"/>
               </a:ext>
             </a:extLst>
           </p:cNvPr>
@@ -2241,7 +2241,7 @@
           <p:cNvPr id="3" name="Text Placeholder 2">
             <a:extLst>
               <a:ext uri="{FF2B5EF4-FFF2-40B4-BE49-F238E27FC236}">
-                <a16:creationId xmlns:a16="http://schemas.microsoft.com/office/drawing/2014/main" id="{9EB89A49-B4A8-DAE1-CB4C-6785BFC77083}"/>
+                <a16:creationId xmlns:a16="http://schemas.microsoft.com/office/drawing/2014/main" id="{53657038-E67F-A147-6C5B-6394E166D75C}"/>
               </a:ext>
             </a:extLst>
           </p:cNvPr>
@@ -2366,7 +2366,7 @@
           <p:cNvPr id="4" name="Date Placeholder 3">
             <a:extLst>
               <a:ext uri="{FF2B5EF4-FFF2-40B4-BE49-F238E27FC236}">
-                <a16:creationId xmlns:a16="http://schemas.microsoft.com/office/drawing/2014/main" id="{01ACA4BD-C788-CDCD-B0FC-46B44BB1A1EF}"/>
+                <a16:creationId xmlns:a16="http://schemas.microsoft.com/office/drawing/2014/main" id="{E5F8EE7C-0EDD-D017-D7AD-7F4C2053336F}"/>
               </a:ext>
             </a:extLst>
           </p:cNvPr>
@@ -2382,7 +2382,7 @@
           <a:bodyPr/>
           <a:lstStyle/>
           <a:p>
-            <a:fld id="{3D5D1A14-1EE2-4E92-B4FE-304EE26A3F66}" type="datetimeFigureOut">
+            <a:fld id="{2F8D26A6-D71B-4538-BE7E-D2A35FE8C500}" type="datetimeFigureOut">
               <a:rPr lang="en-MY" smtClean="0"/>
               <a:t>24/9/2026</a:t>
             </a:fld>
@@ -2395,7 +2395,7 @@
           <p:cNvPr id="5" name="Footer Placeholder 4">
             <a:extLst>
               <a:ext uri="{FF2B5EF4-FFF2-40B4-BE49-F238E27FC236}">
-                <a16:creationId xmlns:a16="http://schemas.microsoft.com/office/drawing/2014/main" id="{DA1AB0ED-5926-1527-43AB-BC0B4AD031EF}"/>
+                <a16:creationId xmlns:a16="http://schemas.microsoft.com/office/drawing/2014/main" id="{E1ABE3C9-6F6C-1B81-9909-8E7255E27944}"/>
               </a:ext>
             </a:extLst>
           </p:cNvPr>
@@ -2420,7 +2420,7 @@
           <p:cNvPr id="6" name="Slide Number Placeholder 5">
             <a:extLst>
               <a:ext uri="{FF2B5EF4-FFF2-40B4-BE49-F238E27FC236}">
-                <a16:creationId xmlns:a16="http://schemas.microsoft.com/office/drawing/2014/main" id="{48E7B8C3-B9DA-EF79-C678-962BA94E62D0}"/>
+                <a16:creationId xmlns:a16="http://schemas.microsoft.com/office/drawing/2014/main" id="{A391389A-F1D1-0724-EE4C-FE31D43D9E4C}"/>
               </a:ext>
             </a:extLst>
           </p:cNvPr>
@@ -2436,7 +2436,7 @@
           <a:bodyPr/>
           <a:lstStyle/>
           <a:p>
-            <a:fld id="{C3AED862-024E-41DA-81A7-2FE9CB15877D}" type="slidenum">
+            <a:fld id="{3A1571EA-3779-4ED8-A27C-B0EAA1CBA9CE}" type="slidenum">
               <a:rPr lang="en-MY" smtClean="0"/>
               <a:t>‹#›</a:t>
             </a:fld>
@@ -2447,7 +2447,7 @@
     </p:spTree>
     <p:extLst>
       <p:ext uri="{BB962C8B-B14F-4D97-AF65-F5344CB8AC3E}">
-        <p14:creationId xmlns:p14="http://schemas.microsoft.com/office/powerpoint/2010/main" val="2510010278"/>
+        <p14:creationId xmlns:p14="http://schemas.microsoft.com/office/powerpoint/2010/main" val="1275454861"/>
       </p:ext>
     </p:extLst>
   </p:cSld>
@@ -2479,7 +2479,7 @@
           <p:cNvPr id="2" name="Title 1">
             <a:extLst>
               <a:ext uri="{FF2B5EF4-FFF2-40B4-BE49-F238E27FC236}">
-                <a16:creationId xmlns:a16="http://schemas.microsoft.com/office/drawing/2014/main" id="{6148B277-0A60-4AFC-E03D-AB010A3744E7}"/>
+                <a16:creationId xmlns:a16="http://schemas.microsoft.com/office/drawing/2014/main" id="{1A4C2AC4-B386-B674-3BC1-BAE12A74AB44}"/>
               </a:ext>
             </a:extLst>
           </p:cNvPr>
@@ -2508,7 +2508,7 @@
           <p:cNvPr id="3" name="Content Placeholder 2">
             <a:extLst>
               <a:ext uri="{FF2B5EF4-FFF2-40B4-BE49-F238E27FC236}">
-                <a16:creationId xmlns:a16="http://schemas.microsoft.com/office/drawing/2014/main" id="{934994C6-648C-55E2-6154-56F17AA06544}"/>
+                <a16:creationId xmlns:a16="http://schemas.microsoft.com/office/drawing/2014/main" id="{ABADD1D7-5DFC-44EF-103E-D8C80A8F4678}"/>
               </a:ext>
             </a:extLst>
           </p:cNvPr>
@@ -2571,7 +2571,7 @@
           <p:cNvPr id="4" name="Content Placeholder 3">
             <a:extLst>
               <a:ext uri="{FF2B5EF4-FFF2-40B4-BE49-F238E27FC236}">
-                <a16:creationId xmlns:a16="http://schemas.microsoft.com/office/drawing/2014/main" id="{05E439CF-59E0-480B-6BA4-987F9B2EB3A0}"/>
+                <a16:creationId xmlns:a16="http://schemas.microsoft.com/office/drawing/2014/main" id="{80523931-5A72-EC64-1F14-1212A54BFB04}"/>
               </a:ext>
             </a:extLst>
           </p:cNvPr>
@@ -2634,7 +2634,7 @@
           <p:cNvPr id="5" name="Date Placeholder 4">
             <a:extLst>
               <a:ext uri="{FF2B5EF4-FFF2-40B4-BE49-F238E27FC236}">
-                <a16:creationId xmlns:a16="http://schemas.microsoft.com/office/drawing/2014/main" id="{40624883-3780-8FA1-436E-471BC99326B1}"/>
+                <a16:creationId xmlns:a16="http://schemas.microsoft.com/office/drawing/2014/main" id="{5317711C-1E25-1A5F-AAFD-E08D5EEC7470}"/>
               </a:ext>
             </a:extLst>
           </p:cNvPr>
@@ -2650,7 +2650,7 @@
           <a:bodyPr/>
           <a:lstStyle/>
           <a:p>
-            <a:fld id="{3D5D1A14-1EE2-4E92-B4FE-304EE26A3F66}" type="datetimeFigureOut">
+            <a:fld id="{2F8D26A6-D71B-4538-BE7E-D2A35FE8C500}" type="datetimeFigureOut">
               <a:rPr lang="en-MY" smtClean="0"/>
               <a:t>24/9/2026</a:t>
             </a:fld>
@@ -2663,7 +2663,7 @@
           <p:cNvPr id="6" name="Footer Placeholder 5">
             <a:extLst>
               <a:ext uri="{FF2B5EF4-FFF2-40B4-BE49-F238E27FC236}">
-                <a16:creationId xmlns:a16="http://schemas.microsoft.com/office/drawing/2014/main" id="{B3AFB9AE-AE95-7C7C-55A4-5533C58B3DC2}"/>
+                <a16:creationId xmlns:a16="http://schemas.microsoft.com/office/drawing/2014/main" id="{07F32876-7EFF-6C5C-8965-9CF11B136184}"/>
               </a:ext>
             </a:extLst>
           </p:cNvPr>
@@ -2688,7 +2688,7 @@
           <p:cNvPr id="7" name="Slide Number Placeholder 6">
             <a:extLst>
               <a:ext uri="{FF2B5EF4-FFF2-40B4-BE49-F238E27FC236}">
-                <a16:creationId xmlns:a16="http://schemas.microsoft.com/office/drawing/2014/main" id="{C1A8917E-35EC-FC28-F2EA-015CA6AFC4E5}"/>
+                <a16:creationId xmlns:a16="http://schemas.microsoft.com/office/drawing/2014/main" id="{ED819C50-EDA7-CD83-965F-FF59C69B4972}"/>
               </a:ext>
             </a:extLst>
           </p:cNvPr>
@@ -2704,7 +2704,7 @@
           <a:bodyPr/>
           <a:lstStyle/>
           <a:p>
-            <a:fld id="{C3AED862-024E-41DA-81A7-2FE9CB15877D}" type="slidenum">
+            <a:fld id="{3A1571EA-3779-4ED8-A27C-B0EAA1CBA9CE}" type="slidenum">
               <a:rPr lang="en-MY" smtClean="0"/>
               <a:t>‹#›</a:t>
             </a:fld>
@@ -2715,7 +2715,7 @@
     </p:spTree>
     <p:extLst>
       <p:ext uri="{BB962C8B-B14F-4D97-AF65-F5344CB8AC3E}">
-        <p14:creationId xmlns:p14="http://schemas.microsoft.com/office/powerpoint/2010/main" val="851594687"/>
+        <p14:creationId xmlns:p14="http://schemas.microsoft.com/office/powerpoint/2010/main" val="3875219953"/>
       </p:ext>
     </p:extLst>
   </p:cSld>
@@ -2747,7 +2747,7 @@
           <p:cNvPr id="2" name="Title 1">
             <a:extLst>
               <a:ext uri="{FF2B5EF4-FFF2-40B4-BE49-F238E27FC236}">
-                <a16:creationId xmlns:a16="http://schemas.microsoft.com/office/drawing/2014/main" id="{5E79C28F-B4E5-6F69-9336-C6097D1CD868}"/>
+                <a16:creationId xmlns:a16="http://schemas.microsoft.com/office/drawing/2014/main" id="{D31E9EAF-92EC-B4B3-668F-DBE0CDFD4870}"/>
               </a:ext>
             </a:extLst>
           </p:cNvPr>
@@ -2781,7 +2781,7 @@
           <p:cNvPr id="3" name="Text Placeholder 2">
             <a:extLst>
               <a:ext uri="{FF2B5EF4-FFF2-40B4-BE49-F238E27FC236}">
-                <a16:creationId xmlns:a16="http://schemas.microsoft.com/office/drawing/2014/main" id="{B292AE4C-8B70-5279-8A28-E9FF09E60A30}"/>
+                <a16:creationId xmlns:a16="http://schemas.microsoft.com/office/drawing/2014/main" id="{82E63AA3-0A68-5F62-3CB9-3FDFB00D5E24}"/>
               </a:ext>
             </a:extLst>
           </p:cNvPr>
@@ -2852,7 +2852,7 @@
           <p:cNvPr id="4" name="Content Placeholder 3">
             <a:extLst>
               <a:ext uri="{FF2B5EF4-FFF2-40B4-BE49-F238E27FC236}">
-                <a16:creationId xmlns:a16="http://schemas.microsoft.com/office/drawing/2014/main" id="{C927A1B6-9F8A-4DB9-75FD-3880219E283B}"/>
+                <a16:creationId xmlns:a16="http://schemas.microsoft.com/office/drawing/2014/main" id="{1D9C4D1E-3392-6F55-6E4C-A1EA7ABED16C}"/>
               </a:ext>
             </a:extLst>
           </p:cNvPr>
@@ -2915,7 +2915,7 @@
           <p:cNvPr id="5" name="Text Placeholder 4">
             <a:extLst>
               <a:ext uri="{FF2B5EF4-FFF2-40B4-BE49-F238E27FC236}">
-                <a16:creationId xmlns:a16="http://schemas.microsoft.com/office/drawing/2014/main" id="{8A8C7E7A-7848-DC21-4EBF-F5F499EC0718}"/>
+                <a16:creationId xmlns:a16="http://schemas.microsoft.com/office/drawing/2014/main" id="{8FC3261C-221D-9223-654F-EF428AF401AD}"/>
               </a:ext>
             </a:extLst>
           </p:cNvPr>
@@ -2986,7 +2986,7 @@
           <p:cNvPr id="6" name="Content Placeholder 5">
             <a:extLst>
               <a:ext uri="{FF2B5EF4-FFF2-40B4-BE49-F238E27FC236}">
-                <a16:creationId xmlns:a16="http://schemas.microsoft.com/office/drawing/2014/main" id="{4E753958-609A-03F0-9DA9-C1157D71D330}"/>
+                <a16:creationId xmlns:a16="http://schemas.microsoft.com/office/drawing/2014/main" id="{D6A78D58-5C7D-E701-3A5B-EDCD29D9F5BD}"/>
               </a:ext>
             </a:extLst>
           </p:cNvPr>
@@ -3049,7 +3049,7 @@
           <p:cNvPr id="7" name="Date Placeholder 6">
             <a:extLst>
               <a:ext uri="{FF2B5EF4-FFF2-40B4-BE49-F238E27FC236}">
-                <a16:creationId xmlns:a16="http://schemas.microsoft.com/office/drawing/2014/main" id="{4054395C-83BA-A86B-1673-AE3E9C48247C}"/>
+                <a16:creationId xmlns:a16="http://schemas.microsoft.com/office/drawing/2014/main" id="{22D4F4A8-AC9F-5609-1E38-4C2BBE4F9A5B}"/>
               </a:ext>
             </a:extLst>
           </p:cNvPr>
@@ -3065,7 +3065,7 @@
           <a:bodyPr/>
           <a:lstStyle/>
           <a:p>
-            <a:fld id="{3D5D1A14-1EE2-4E92-B4FE-304EE26A3F66}" type="datetimeFigureOut">
+            <a:fld id="{2F8D26A6-D71B-4538-BE7E-D2A35FE8C500}" type="datetimeFigureOut">
               <a:rPr lang="en-MY" smtClean="0"/>
               <a:t>24/9/2026</a:t>
             </a:fld>
@@ -3078,7 +3078,7 @@
           <p:cNvPr id="8" name="Footer Placeholder 7">
             <a:extLst>
               <a:ext uri="{FF2B5EF4-FFF2-40B4-BE49-F238E27FC236}">
-                <a16:creationId xmlns:a16="http://schemas.microsoft.com/office/drawing/2014/main" id="{DCC1455E-DB9A-1140-D834-191458EAD4BF}"/>
+                <a16:creationId xmlns:a16="http://schemas.microsoft.com/office/drawing/2014/main" id="{6199F672-CA61-8F20-01FF-68EE92292478}"/>
               </a:ext>
             </a:extLst>
           </p:cNvPr>
@@ -3103,7 +3103,7 @@
           <p:cNvPr id="9" name="Slide Number Placeholder 8">
             <a:extLst>
               <a:ext uri="{FF2B5EF4-FFF2-40B4-BE49-F238E27FC236}">
-                <a16:creationId xmlns:a16="http://schemas.microsoft.com/office/drawing/2014/main" id="{D597D2FE-CDD9-7C1D-16D6-9B402C74E58A}"/>
+                <a16:creationId xmlns:a16="http://schemas.microsoft.com/office/drawing/2014/main" id="{CC789F15-7F6E-16B5-43D3-2D679A9FE041}"/>
               </a:ext>
             </a:extLst>
           </p:cNvPr>
@@ -3119,7 +3119,7 @@
           <a:bodyPr/>
           <a:lstStyle/>
           <a:p>
-            <a:fld id="{C3AED862-024E-41DA-81A7-2FE9CB15877D}" type="slidenum">
+            <a:fld id="{3A1571EA-3779-4ED8-A27C-B0EAA1CBA9CE}" type="slidenum">
               <a:rPr lang="en-MY" smtClean="0"/>
               <a:t>‹#›</a:t>
             </a:fld>
@@ -3130,7 +3130,7 @@
     </p:spTree>
     <p:extLst>
       <p:ext uri="{BB962C8B-B14F-4D97-AF65-F5344CB8AC3E}">
-        <p14:creationId xmlns:p14="http://schemas.microsoft.com/office/powerpoint/2010/main" val="4217287487"/>
+        <p14:creationId xmlns:p14="http://schemas.microsoft.com/office/powerpoint/2010/main" val="3818558036"/>
       </p:ext>
     </p:extLst>
   </p:cSld>
@@ -3162,7 +3162,7 @@
           <p:cNvPr id="2" name="Title 1">
             <a:extLst>
               <a:ext uri="{FF2B5EF4-FFF2-40B4-BE49-F238E27FC236}">
-                <a16:creationId xmlns:a16="http://schemas.microsoft.com/office/drawing/2014/main" id="{15C0CA4C-883F-277E-284F-8F4E81E14795}"/>
+                <a16:creationId xmlns:a16="http://schemas.microsoft.com/office/drawing/2014/main" id="{8912A4DF-AC8D-B685-35A5-2725D019BC88}"/>
               </a:ext>
             </a:extLst>
           </p:cNvPr>
@@ -3191,7 +3191,7 @@
           <p:cNvPr id="3" name="Date Placeholder 2">
             <a:extLst>
               <a:ext uri="{FF2B5EF4-FFF2-40B4-BE49-F238E27FC236}">
-                <a16:creationId xmlns:a16="http://schemas.microsoft.com/office/drawing/2014/main" id="{3E1EE01D-918D-CE52-938A-A56DD06DAE98}"/>
+                <a16:creationId xmlns:a16="http://schemas.microsoft.com/office/drawing/2014/main" id="{0308B965-5D73-14E2-E2D8-6A6F0A5E4539}"/>
               </a:ext>
             </a:extLst>
           </p:cNvPr>
@@ -3207,7 +3207,7 @@
           <a:bodyPr/>
           <a:lstStyle/>
           <a:p>
-            <a:fld id="{3D5D1A14-1EE2-4E92-B4FE-304EE26A3F66}" type="datetimeFigureOut">
+            <a:fld id="{2F8D26A6-D71B-4538-BE7E-D2A35FE8C500}" type="datetimeFigureOut">
               <a:rPr lang="en-MY" smtClean="0"/>
               <a:t>24/9/2026</a:t>
             </a:fld>
@@ -3220,7 +3220,7 @@
           <p:cNvPr id="4" name="Footer Placeholder 3">
             <a:extLst>
               <a:ext uri="{FF2B5EF4-FFF2-40B4-BE49-F238E27FC236}">
-                <a16:creationId xmlns:a16="http://schemas.microsoft.com/office/drawing/2014/main" id="{F28E0214-6409-A0D2-9AD3-801ADBDF6A5D}"/>
+                <a16:creationId xmlns:a16="http://schemas.microsoft.com/office/drawing/2014/main" id="{F6B60080-C673-1CDC-B779-B964784BE37C}"/>
               </a:ext>
             </a:extLst>
           </p:cNvPr>
@@ -3245,7 +3245,7 @@
           <p:cNvPr id="5" name="Slide Number Placeholder 4">
             <a:extLst>
               <a:ext uri="{FF2B5EF4-FFF2-40B4-BE49-F238E27FC236}">
-                <a16:creationId xmlns:a16="http://schemas.microsoft.com/office/drawing/2014/main" id="{F3CAA409-8D5A-CDB7-847C-91552B4C0489}"/>
+                <a16:creationId xmlns:a16="http://schemas.microsoft.com/office/drawing/2014/main" id="{5D656AF1-B230-2462-582E-2FBF5CE9F297}"/>
               </a:ext>
             </a:extLst>
           </p:cNvPr>
@@ -3261,7 +3261,7 @@
           <a:bodyPr/>
           <a:lstStyle/>
           <a:p>
-            <a:fld id="{C3AED862-024E-41DA-81A7-2FE9CB15877D}" type="slidenum">
+            <a:fld id="{3A1571EA-3779-4ED8-A27C-B0EAA1CBA9CE}" type="slidenum">
               <a:rPr lang="en-MY" smtClean="0"/>
               <a:t>‹#›</a:t>
             </a:fld>
@@ -3272,7 +3272,7 @@
     </p:spTree>
     <p:extLst>
       <p:ext uri="{BB962C8B-B14F-4D97-AF65-F5344CB8AC3E}">
-        <p14:creationId xmlns:p14="http://schemas.microsoft.com/office/powerpoint/2010/main" val="3153302154"/>
+        <p14:creationId xmlns:p14="http://schemas.microsoft.com/office/powerpoint/2010/main" val="1715134392"/>
       </p:ext>
     </p:extLst>
   </p:cSld>
@@ -3304,7 +3304,7 @@
           <p:cNvPr id="2" name="Date Placeholder 1">
             <a:extLst>
               <a:ext uri="{FF2B5EF4-FFF2-40B4-BE49-F238E27FC236}">
-                <a16:creationId xmlns:a16="http://schemas.microsoft.com/office/drawing/2014/main" id="{3A3E2CCB-3D1D-9CA2-70D0-AF69EBA56F5E}"/>
+                <a16:creationId xmlns:a16="http://schemas.microsoft.com/office/drawing/2014/main" id="{0B4F3FEB-F1B2-B4A5-5F8A-8979177BEE73}"/>
               </a:ext>
             </a:extLst>
           </p:cNvPr>
@@ -3320,7 +3320,7 @@
           <a:bodyPr/>
           <a:lstStyle/>
           <a:p>
-            <a:fld id="{3D5D1A14-1EE2-4E92-B4FE-304EE26A3F66}" type="datetimeFigureOut">
+            <a:fld id="{2F8D26A6-D71B-4538-BE7E-D2A35FE8C500}" type="datetimeFigureOut">
               <a:rPr lang="en-MY" smtClean="0"/>
               <a:t>24/9/2026</a:t>
             </a:fld>
@@ -3333,7 +3333,7 @@
           <p:cNvPr id="3" name="Footer Placeholder 2">
             <a:extLst>
               <a:ext uri="{FF2B5EF4-FFF2-40B4-BE49-F238E27FC236}">
-                <a16:creationId xmlns:a16="http://schemas.microsoft.com/office/drawing/2014/main" id="{72F25564-5996-02D3-92CC-A0E6EB2D938C}"/>
+                <a16:creationId xmlns:a16="http://schemas.microsoft.com/office/drawing/2014/main" id="{84115850-7D30-F05E-4F34-BB3B79145506}"/>
               </a:ext>
             </a:extLst>
           </p:cNvPr>
@@ -3358,7 +3358,7 @@
           <p:cNvPr id="4" name="Slide Number Placeholder 3">
             <a:extLst>
               <a:ext uri="{FF2B5EF4-FFF2-40B4-BE49-F238E27FC236}">
-                <a16:creationId xmlns:a16="http://schemas.microsoft.com/office/drawing/2014/main" id="{D20D788C-66E0-E830-2975-D1062BAFB47B}"/>
+                <a16:creationId xmlns:a16="http://schemas.microsoft.com/office/drawing/2014/main" id="{0C6DBCCA-1AF8-A7F4-33DA-6354CA81E505}"/>
               </a:ext>
             </a:extLst>
           </p:cNvPr>
@@ -3374,7 +3374,7 @@
           <a:bodyPr/>
           <a:lstStyle/>
           <a:p>
-            <a:fld id="{C3AED862-024E-41DA-81A7-2FE9CB15877D}" type="slidenum">
+            <a:fld id="{3A1571EA-3779-4ED8-A27C-B0EAA1CBA9CE}" type="slidenum">
               <a:rPr lang="en-MY" smtClean="0"/>
               <a:t>‹#›</a:t>
             </a:fld>
@@ -3385,7 +3385,7 @@
     </p:spTree>
     <p:extLst>
       <p:ext uri="{BB962C8B-B14F-4D97-AF65-F5344CB8AC3E}">
-        <p14:creationId xmlns:p14="http://schemas.microsoft.com/office/powerpoint/2010/main" val="3802334596"/>
+        <p14:creationId xmlns:p14="http://schemas.microsoft.com/office/powerpoint/2010/main" val="1658236945"/>
       </p:ext>
     </p:extLst>
   </p:cSld>
@@ -3417,7 +3417,7 @@
           <p:cNvPr id="2" name="Title 1">
             <a:extLst>
               <a:ext uri="{FF2B5EF4-FFF2-40B4-BE49-F238E27FC236}">
-                <a16:creationId xmlns:a16="http://schemas.microsoft.com/office/drawing/2014/main" id="{9CF7EF69-F69E-D828-B2D5-2DC1F5DCEE9B}"/>
+                <a16:creationId xmlns:a16="http://schemas.microsoft.com/office/drawing/2014/main" id="{105FD0A8-4BDE-DB82-89F2-817042BB153C}"/>
               </a:ext>
             </a:extLst>
           </p:cNvPr>
@@ -3455,7 +3455,7 @@
           <p:cNvPr id="3" name="Content Placeholder 2">
             <a:extLst>
               <a:ext uri="{FF2B5EF4-FFF2-40B4-BE49-F238E27FC236}">
-                <a16:creationId xmlns:a16="http://schemas.microsoft.com/office/drawing/2014/main" id="{BB207C3C-08CD-655E-D35C-C9E820F780F1}"/>
+                <a16:creationId xmlns:a16="http://schemas.microsoft.com/office/drawing/2014/main" id="{2B1780A2-D2F0-73DA-7259-4B91C4DEDE6E}"/>
               </a:ext>
             </a:extLst>
           </p:cNvPr>
@@ -3546,7 +3546,7 @@
           <p:cNvPr id="4" name="Text Placeholder 3">
             <a:extLst>
               <a:ext uri="{FF2B5EF4-FFF2-40B4-BE49-F238E27FC236}">
-                <a16:creationId xmlns:a16="http://schemas.microsoft.com/office/drawing/2014/main" id="{2B425ADC-B3CE-B77E-592D-E9B0E3E1C120}"/>
+                <a16:creationId xmlns:a16="http://schemas.microsoft.com/office/drawing/2014/main" id="{3AA70730-9B95-696E-38C0-7B1F8D460B00}"/>
               </a:ext>
             </a:extLst>
           </p:cNvPr>
@@ -3617,7 +3617,7 @@
           <p:cNvPr id="5" name="Date Placeholder 4">
             <a:extLst>
               <a:ext uri="{FF2B5EF4-FFF2-40B4-BE49-F238E27FC236}">
-                <a16:creationId xmlns:a16="http://schemas.microsoft.com/office/drawing/2014/main" id="{F7B4B95D-F608-67B5-13E3-1C9DF757A47A}"/>
+                <a16:creationId xmlns:a16="http://schemas.microsoft.com/office/drawing/2014/main" id="{745A39B1-B87C-A9C9-6CD4-B33A0EF05004}"/>
               </a:ext>
             </a:extLst>
           </p:cNvPr>
@@ -3633,7 +3633,7 @@
           <a:bodyPr/>
           <a:lstStyle/>
           <a:p>
-            <a:fld id="{3D5D1A14-1EE2-4E92-B4FE-304EE26A3F66}" type="datetimeFigureOut">
+            <a:fld id="{2F8D26A6-D71B-4538-BE7E-D2A35FE8C500}" type="datetimeFigureOut">
               <a:rPr lang="en-MY" smtClean="0"/>
               <a:t>24/9/2026</a:t>
             </a:fld>
@@ -3646,7 +3646,7 @@
           <p:cNvPr id="6" name="Footer Placeholder 5">
             <a:extLst>
               <a:ext uri="{FF2B5EF4-FFF2-40B4-BE49-F238E27FC236}">
-                <a16:creationId xmlns:a16="http://schemas.microsoft.com/office/drawing/2014/main" id="{31457E1C-9549-3059-0462-D869E83EBE0E}"/>
+                <a16:creationId xmlns:a16="http://schemas.microsoft.com/office/drawing/2014/main" id="{5261FCB0-ACD3-26A1-9312-3FCB1B237BDD}"/>
               </a:ext>
             </a:extLst>
           </p:cNvPr>
@@ -3671,7 +3671,7 @@
           <p:cNvPr id="7" name="Slide Number Placeholder 6">
             <a:extLst>
               <a:ext uri="{FF2B5EF4-FFF2-40B4-BE49-F238E27FC236}">
-                <a16:creationId xmlns:a16="http://schemas.microsoft.com/office/drawing/2014/main" id="{C32AD905-583D-C576-E177-86FBA1CBE35A}"/>
+                <a16:creationId xmlns:a16="http://schemas.microsoft.com/office/drawing/2014/main" id="{41D74D84-18C2-AB84-50D5-7F1E02D55B81}"/>
               </a:ext>
             </a:extLst>
           </p:cNvPr>
@@ -3687,7 +3687,7 @@
           <a:bodyPr/>
           <a:lstStyle/>
           <a:p>
-            <a:fld id="{C3AED862-024E-41DA-81A7-2FE9CB15877D}" type="slidenum">
+            <a:fld id="{3A1571EA-3779-4ED8-A27C-B0EAA1CBA9CE}" type="slidenum">
               <a:rPr lang="en-MY" smtClean="0"/>
               <a:t>‹#›</a:t>
             </a:fld>
@@ -3698,7 +3698,7 @@
     </p:spTree>
     <p:extLst>
       <p:ext uri="{BB962C8B-B14F-4D97-AF65-F5344CB8AC3E}">
-        <p14:creationId xmlns:p14="http://schemas.microsoft.com/office/powerpoint/2010/main" val="1965467850"/>
+        <p14:creationId xmlns:p14="http://schemas.microsoft.com/office/powerpoint/2010/main" val="1906720132"/>
       </p:ext>
     </p:extLst>
   </p:cSld>
@@ -3730,7 +3730,7 @@
           <p:cNvPr id="2" name="Title 1">
             <a:extLst>
               <a:ext uri="{FF2B5EF4-FFF2-40B4-BE49-F238E27FC236}">
-                <a16:creationId xmlns:a16="http://schemas.microsoft.com/office/drawing/2014/main" id="{F7CAB5D8-4EEA-B1D9-1F35-413CE0FDC408}"/>
+                <a16:creationId xmlns:a16="http://schemas.microsoft.com/office/drawing/2014/main" id="{49CE2EAB-8EB8-5809-B09E-C5A0A68D27F3}"/>
               </a:ext>
             </a:extLst>
           </p:cNvPr>
@@ -3768,7 +3768,7 @@
           <p:cNvPr id="3" name="Picture Placeholder 2">
             <a:extLst>
               <a:ext uri="{FF2B5EF4-FFF2-40B4-BE49-F238E27FC236}">
-                <a16:creationId xmlns:a16="http://schemas.microsoft.com/office/drawing/2014/main" id="{3E80417E-CFFD-D8A8-EB78-EE9D0E7F930D}"/>
+                <a16:creationId xmlns:a16="http://schemas.microsoft.com/office/drawing/2014/main" id="{3B8E499D-8849-39FF-0382-9CFF05A0719C}"/>
               </a:ext>
             </a:extLst>
           </p:cNvPr>
@@ -3835,7 +3835,7 @@
           <p:cNvPr id="4" name="Text Placeholder 3">
             <a:extLst>
               <a:ext uri="{FF2B5EF4-FFF2-40B4-BE49-F238E27FC236}">
-                <a16:creationId xmlns:a16="http://schemas.microsoft.com/office/drawing/2014/main" id="{5190F6CA-C0CF-0876-37DD-DF5FF4366E41}"/>
+                <a16:creationId xmlns:a16="http://schemas.microsoft.com/office/drawing/2014/main" id="{1E4AE888-E2D5-CA38-BA31-6F24910AD44D}"/>
               </a:ext>
             </a:extLst>
           </p:cNvPr>
@@ -3906,7 +3906,7 @@
           <p:cNvPr id="5" name="Date Placeholder 4">
             <a:extLst>
               <a:ext uri="{FF2B5EF4-FFF2-40B4-BE49-F238E27FC236}">
-                <a16:creationId xmlns:a16="http://schemas.microsoft.com/office/drawing/2014/main" id="{ABAF9F37-027E-FEDD-36F2-D7784B1AA8E3}"/>
+                <a16:creationId xmlns:a16="http://schemas.microsoft.com/office/drawing/2014/main" id="{D62CCA2A-DD7C-0253-3FF5-7DEDD211D120}"/>
               </a:ext>
             </a:extLst>
           </p:cNvPr>
@@ -3922,7 +3922,7 @@
           <a:bodyPr/>
           <a:lstStyle/>
           <a:p>
-            <a:fld id="{3D5D1A14-1EE2-4E92-B4FE-304EE26A3F66}" type="datetimeFigureOut">
+            <a:fld id="{2F8D26A6-D71B-4538-BE7E-D2A35FE8C500}" type="datetimeFigureOut">
               <a:rPr lang="en-MY" smtClean="0"/>
               <a:t>24/9/2026</a:t>
             </a:fld>
@@ -3935,7 +3935,7 @@
           <p:cNvPr id="6" name="Footer Placeholder 5">
             <a:extLst>
               <a:ext uri="{FF2B5EF4-FFF2-40B4-BE49-F238E27FC236}">
-                <a16:creationId xmlns:a16="http://schemas.microsoft.com/office/drawing/2014/main" id="{AA12D354-0205-80BA-0D5D-339CA2E1A1BC}"/>
+                <a16:creationId xmlns:a16="http://schemas.microsoft.com/office/drawing/2014/main" id="{5B00417B-837E-4429-405B-2209D41A0354}"/>
               </a:ext>
             </a:extLst>
           </p:cNvPr>
@@ -3960,7 +3960,7 @@
           <p:cNvPr id="7" name="Slide Number Placeholder 6">
             <a:extLst>
               <a:ext uri="{FF2B5EF4-FFF2-40B4-BE49-F238E27FC236}">
-                <a16:creationId xmlns:a16="http://schemas.microsoft.com/office/drawing/2014/main" id="{EBFCCE91-7461-D7E8-3D36-BCE46ACD3B7E}"/>
+                <a16:creationId xmlns:a16="http://schemas.microsoft.com/office/drawing/2014/main" id="{DE762FA2-6CE3-E274-4B6C-2EDA6EE660C6}"/>
               </a:ext>
             </a:extLst>
           </p:cNvPr>
@@ -3976,7 +3976,7 @@
           <a:bodyPr/>
           <a:lstStyle/>
           <a:p>
-            <a:fld id="{C3AED862-024E-41DA-81A7-2FE9CB15877D}" type="slidenum">
+            <a:fld id="{3A1571EA-3779-4ED8-A27C-B0EAA1CBA9CE}" type="slidenum">
               <a:rPr lang="en-MY" smtClean="0"/>
               <a:t>‹#›</a:t>
             </a:fld>
@@ -3987,7 +3987,7 @@
     </p:spTree>
     <p:extLst>
       <p:ext uri="{BB962C8B-B14F-4D97-AF65-F5344CB8AC3E}">
-        <p14:creationId xmlns:p14="http://schemas.microsoft.com/office/powerpoint/2010/main" val="2775128465"/>
+        <p14:creationId xmlns:p14="http://schemas.microsoft.com/office/powerpoint/2010/main" val="881667646"/>
       </p:ext>
     </p:extLst>
   </p:cSld>
@@ -4024,7 +4024,7 @@
           <p:cNvPr id="2" name="Title Placeholder 1">
             <a:extLst>
               <a:ext uri="{FF2B5EF4-FFF2-40B4-BE49-F238E27FC236}">
-                <a16:creationId xmlns:a16="http://schemas.microsoft.com/office/drawing/2014/main" id="{CA983453-8157-7340-CDD7-6E9AC931A24E}"/>
+                <a16:creationId xmlns:a16="http://schemas.microsoft.com/office/drawing/2014/main" id="{0A23BD1A-37C8-8331-A9AB-6E2AB9766420}"/>
               </a:ext>
             </a:extLst>
           </p:cNvPr>
@@ -4063,7 +4063,7 @@
           <p:cNvPr id="3" name="Text Placeholder 2">
             <a:extLst>
               <a:ext uri="{FF2B5EF4-FFF2-40B4-BE49-F238E27FC236}">
-                <a16:creationId xmlns:a16="http://schemas.microsoft.com/office/drawing/2014/main" id="{ABF5C709-878F-67DF-5C30-62B0CE10E4DB}"/>
+                <a16:creationId xmlns:a16="http://schemas.microsoft.com/office/drawing/2014/main" id="{8AA7ACD9-0A91-47F1-6E7F-668571C3E313}"/>
               </a:ext>
             </a:extLst>
           </p:cNvPr>
@@ -4131,7 +4131,7 @@
           <p:cNvPr id="4" name="Date Placeholder 3">
             <a:extLst>
               <a:ext uri="{FF2B5EF4-FFF2-40B4-BE49-F238E27FC236}">
-                <a16:creationId xmlns:a16="http://schemas.microsoft.com/office/drawing/2014/main" id="{1E305A2C-8322-28AC-EE8D-A98846DD042F}"/>
+                <a16:creationId xmlns:a16="http://schemas.microsoft.com/office/drawing/2014/main" id="{DD49AE63-1565-10AC-91FF-007FC2788FF4}"/>
               </a:ext>
             </a:extLst>
           </p:cNvPr>
@@ -4165,7 +4165,7 @@
             </a:lvl1pPr>
           </a:lstStyle>
           <a:p>
-            <a:fld id="{3D5D1A14-1EE2-4E92-B4FE-304EE26A3F66}" type="datetimeFigureOut">
+            <a:fld id="{2F8D26A6-D71B-4538-BE7E-D2A35FE8C500}" type="datetimeFigureOut">
               <a:rPr lang="en-MY" smtClean="0"/>
               <a:t>24/9/2026</a:t>
             </a:fld>
@@ -4178,7 +4178,7 @@
           <p:cNvPr id="5" name="Footer Placeholder 4">
             <a:extLst>
               <a:ext uri="{FF2B5EF4-FFF2-40B4-BE49-F238E27FC236}">
-                <a16:creationId xmlns:a16="http://schemas.microsoft.com/office/drawing/2014/main" id="{9DCBC6F9-5738-1F38-EFF1-772176B6B70C}"/>
+                <a16:creationId xmlns:a16="http://schemas.microsoft.com/office/drawing/2014/main" id="{B5A60928-FB6D-3A7F-D452-5ACB74753CD7}"/>
               </a:ext>
             </a:extLst>
           </p:cNvPr>
@@ -4221,7 +4221,7 @@
           <p:cNvPr id="6" name="Slide Number Placeholder 5">
             <a:extLst>
               <a:ext uri="{FF2B5EF4-FFF2-40B4-BE49-F238E27FC236}">
-                <a16:creationId xmlns:a16="http://schemas.microsoft.com/office/drawing/2014/main" id="{20761C6B-E757-3F1E-F75F-D0A75ACCA995}"/>
+                <a16:creationId xmlns:a16="http://schemas.microsoft.com/office/drawing/2014/main" id="{E0BBF07E-1364-8772-1087-DA776997BEC5}"/>
               </a:ext>
             </a:extLst>
           </p:cNvPr>
@@ -4255,7 +4255,7 @@
             </a:lvl1pPr>
           </a:lstStyle>
           <a:p>
-            <a:fld id="{C3AED862-024E-41DA-81A7-2FE9CB15877D}" type="slidenum">
+            <a:fld id="{3A1571EA-3779-4ED8-A27C-B0EAA1CBA9CE}" type="slidenum">
               <a:rPr lang="en-MY" smtClean="0"/>
               <a:t>‹#›</a:t>
             </a:fld>
@@ -4266,7 +4266,7 @@
     </p:spTree>
     <p:extLst>
       <p:ext uri="{BB962C8B-B14F-4D97-AF65-F5344CB8AC3E}">
-        <p14:creationId xmlns:p14="http://schemas.microsoft.com/office/powerpoint/2010/main" val="1674910211"/>
+        <p14:creationId xmlns:p14="http://schemas.microsoft.com/office/powerpoint/2010/main" val="1452899008"/>
       </p:ext>
     </p:extLst>
   </p:cSld>
@@ -4597,7 +4597,7 @@
           <p:cNvPr id="2" name="TextBox 1">
             <a:extLst>
               <a:ext uri="{FF2B5EF4-FFF2-40B4-BE49-F238E27FC236}">
-                <a16:creationId xmlns:a16="http://schemas.microsoft.com/office/drawing/2014/main" id="{47E3DE10-207D-09B2-FACF-0DC8721DF6B3}"/>
+                <a16:creationId xmlns:a16="http://schemas.microsoft.com/office/drawing/2014/main" id="{04688185-681C-B34E-810A-0A8877458AB1}"/>
               </a:ext>
             </a:extLst>
           </p:cNvPr>
@@ -4637,7 +4637,7 @@
           <p:cNvPr id="3" name="TextBox 2">
             <a:extLst>
               <a:ext uri="{FF2B5EF4-FFF2-40B4-BE49-F238E27FC236}">
-                <a16:creationId xmlns:a16="http://schemas.microsoft.com/office/drawing/2014/main" id="{52D8CF0F-60E7-5C52-3E73-7B2FA19BF283}"/>
+                <a16:creationId xmlns:a16="http://schemas.microsoft.com/office/drawing/2014/main" id="{51568EAB-E7D6-8521-1BE2-FA84676E2452}"/>
               </a:ext>
             </a:extLst>
           </p:cNvPr>
@@ -4683,7 +4683,7 @@
           <p:cNvPr id="4" name="TextBox 3">
             <a:extLst>
               <a:ext uri="{FF2B5EF4-FFF2-40B4-BE49-F238E27FC236}">
-                <a16:creationId xmlns:a16="http://schemas.microsoft.com/office/drawing/2014/main" id="{A8FFCEDB-EDA9-9918-79AF-708BC8909F20}"/>
+                <a16:creationId xmlns:a16="http://schemas.microsoft.com/office/drawing/2014/main" id="{1F2D47D5-2481-95B1-4CC3-8CD19FCA3166}"/>
               </a:ext>
             </a:extLst>
           </p:cNvPr>
@@ -4729,7 +4729,7 @@
           <p:cNvPr id="5" name="TextBox 4">
             <a:extLst>
               <a:ext uri="{FF2B5EF4-FFF2-40B4-BE49-F238E27FC236}">
-                <a16:creationId xmlns:a16="http://schemas.microsoft.com/office/drawing/2014/main" id="{BC6BAB37-9222-47A5-5164-DF507D1A40D2}"/>
+                <a16:creationId xmlns:a16="http://schemas.microsoft.com/office/drawing/2014/main" id="{1B0FD74F-7A65-AF98-B07E-04AB0F9AFF3C}"/>
               </a:ext>
             </a:extLst>
           </p:cNvPr>
@@ -4775,7 +4775,7 @@
           <p:cNvPr id="6" name="TextBox 5">
             <a:extLst>
               <a:ext uri="{FF2B5EF4-FFF2-40B4-BE49-F238E27FC236}">
-                <a16:creationId xmlns:a16="http://schemas.microsoft.com/office/drawing/2014/main" id="{99C6E92A-1BF1-C622-871C-A2CA6B2F993F}"/>
+                <a16:creationId xmlns:a16="http://schemas.microsoft.com/office/drawing/2014/main" id="{C7D69BDF-93F1-2297-291F-21D4BAA5099E}"/>
               </a:ext>
             </a:extLst>
           </p:cNvPr>
@@ -4815,7 +4815,7 @@
           <p:cNvPr id="7" name="TextBox 6">
             <a:extLst>
               <a:ext uri="{FF2B5EF4-FFF2-40B4-BE49-F238E27FC236}">
-                <a16:creationId xmlns:a16="http://schemas.microsoft.com/office/drawing/2014/main" id="{E2FE2169-1C15-A37D-DD6E-32937C516D6C}"/>
+                <a16:creationId xmlns:a16="http://schemas.microsoft.com/office/drawing/2014/main" id="{982AF74C-62FF-3ADC-854D-55A7B87A5293}"/>
               </a:ext>
             </a:extLst>
           </p:cNvPr>
@@ -4860,7 +4860,7 @@
     </p:spTree>
     <p:extLst>
       <p:ext uri="{BB962C8B-B14F-4D97-AF65-F5344CB8AC3E}">
-        <p14:creationId xmlns:p14="http://schemas.microsoft.com/office/powerpoint/2010/main" val="138250535"/>
+        <p14:creationId xmlns:p14="http://schemas.microsoft.com/office/powerpoint/2010/main" val="2007751059"/>
       </p:ext>
     </p:extLst>
   </p:cSld>
@@ -4900,7 +4900,7 @@
           <p:cNvPr id="2" name="TextBox 1">
             <a:extLst>
               <a:ext uri="{FF2B5EF4-FFF2-40B4-BE49-F238E27FC236}">
-                <a16:creationId xmlns:a16="http://schemas.microsoft.com/office/drawing/2014/main" id="{7A608786-5998-A83A-AC45-9F128E268305}"/>
+                <a16:creationId xmlns:a16="http://schemas.microsoft.com/office/drawing/2014/main" id="{85225ABB-F83B-7C1B-9319-97F9C972F146}"/>
               </a:ext>
             </a:extLst>
           </p:cNvPr>
@@ -4947,7 +4947,7 @@
           <p:cNvPr id="3" name="TextBox 2">
             <a:extLst>
               <a:ext uri="{FF2B5EF4-FFF2-40B4-BE49-F238E27FC236}">
-                <a16:creationId xmlns:a16="http://schemas.microsoft.com/office/drawing/2014/main" id="{0BA21938-34D9-F132-4809-C0B83E3DC61F}"/>
+                <a16:creationId xmlns:a16="http://schemas.microsoft.com/office/drawing/2014/main" id="{AB59134A-766F-CC39-5370-E1D4761D6BE5}"/>
               </a:ext>
             </a:extLst>
           </p:cNvPr>
@@ -4988,7 +4988,7 @@
           <p:cNvPr id="4" name="TextBox 3">
             <a:extLst>
               <a:ext uri="{FF2B5EF4-FFF2-40B4-BE49-F238E27FC236}">
-                <a16:creationId xmlns:a16="http://schemas.microsoft.com/office/drawing/2014/main" id="{6B3AE39B-DDEB-3D32-C05C-58E295E7A705}"/>
+                <a16:creationId xmlns:a16="http://schemas.microsoft.com/office/drawing/2014/main" id="{202F9563-F324-610B-1360-28668B9BE730}"/>
               </a:ext>
             </a:extLst>
           </p:cNvPr>
@@ -5027,7 +5027,7 @@
     </p:spTree>
     <p:extLst>
       <p:ext uri="{BB962C8B-B14F-4D97-AF65-F5344CB8AC3E}">
-        <p14:creationId xmlns:p14="http://schemas.microsoft.com/office/powerpoint/2010/main" val="1364286150"/>
+        <p14:creationId xmlns:p14="http://schemas.microsoft.com/office/powerpoint/2010/main" val="2554288377"/>
       </p:ext>
     </p:extLst>
   </p:cSld>
@@ -5067,7 +5067,7 @@
           <p:cNvPr id="2" name="TextBox 1">
             <a:extLst>
               <a:ext uri="{FF2B5EF4-FFF2-40B4-BE49-F238E27FC236}">
-                <a16:creationId xmlns:a16="http://schemas.microsoft.com/office/drawing/2014/main" id="{B7F64AF6-07F3-7C85-B416-5656605CD3B7}"/>
+                <a16:creationId xmlns:a16="http://schemas.microsoft.com/office/drawing/2014/main" id="{155ED394-EAE2-B73B-E5FF-50C696B3B0A4}"/>
               </a:ext>
             </a:extLst>
           </p:cNvPr>
@@ -5113,7 +5113,7 @@
           <p:cNvPr id="3" name="Rectangle: Rounded Corners 2">
             <a:extLst>
               <a:ext uri="{FF2B5EF4-FFF2-40B4-BE49-F238E27FC236}">
-                <a16:creationId xmlns:a16="http://schemas.microsoft.com/office/drawing/2014/main" id="{336B3AC9-CD63-45EE-4BDD-F6FA8337680C}"/>
+                <a16:creationId xmlns:a16="http://schemas.microsoft.com/office/drawing/2014/main" id="{9BF4ABDB-995D-31DE-3B13-3789C1A37E78}"/>
               </a:ext>
             </a:extLst>
           </p:cNvPr>
@@ -5183,7 +5183,7 @@
           <p:cNvPr id="4" name="Oval 3">
             <a:extLst>
               <a:ext uri="{FF2B5EF4-FFF2-40B4-BE49-F238E27FC236}">
-                <a16:creationId xmlns:a16="http://schemas.microsoft.com/office/drawing/2014/main" id="{90756D41-49FF-46B4-DE82-7F6B1A84ED0D}"/>
+                <a16:creationId xmlns:a16="http://schemas.microsoft.com/office/drawing/2014/main" id="{8EE34568-2BEF-B4DC-3EB5-8D8F0F0D075D}"/>
               </a:ext>
             </a:extLst>
           </p:cNvPr>
@@ -5259,7 +5259,7 @@
           <p:cNvPr id="5" name="TextBox 4">
             <a:extLst>
               <a:ext uri="{FF2B5EF4-FFF2-40B4-BE49-F238E27FC236}">
-                <a16:creationId xmlns:a16="http://schemas.microsoft.com/office/drawing/2014/main" id="{D6E3F0A2-903F-31E0-D7C7-BD00C4460004}"/>
+                <a16:creationId xmlns:a16="http://schemas.microsoft.com/office/drawing/2014/main" id="{FEAA5F87-A9CD-DB72-D6C4-CD93FEAB0FFA}"/>
               </a:ext>
             </a:extLst>
           </p:cNvPr>
@@ -5299,7 +5299,7 @@
           <p:cNvPr id="6" name="TextBox 5">
             <a:extLst>
               <a:ext uri="{FF2B5EF4-FFF2-40B4-BE49-F238E27FC236}">
-                <a16:creationId xmlns:a16="http://schemas.microsoft.com/office/drawing/2014/main" id="{62628E8D-5693-2491-67A0-3D4CA9A6F644}"/>
+                <a16:creationId xmlns:a16="http://schemas.microsoft.com/office/drawing/2014/main" id="{F78D9F93-08F4-D9AD-0D58-ED7D621A6459}"/>
               </a:ext>
             </a:extLst>
           </p:cNvPr>
@@ -5339,7 +5339,7 @@
           <p:cNvPr id="7" name="Rectangle: Rounded Corners 6">
             <a:extLst>
               <a:ext uri="{FF2B5EF4-FFF2-40B4-BE49-F238E27FC236}">
-                <a16:creationId xmlns:a16="http://schemas.microsoft.com/office/drawing/2014/main" id="{1C8C4BFA-8786-85BD-CDA5-7D0E6EB7B5A7}"/>
+                <a16:creationId xmlns:a16="http://schemas.microsoft.com/office/drawing/2014/main" id="{01D93166-7B04-76BB-ECA4-ADEA8F4340DE}"/>
               </a:ext>
             </a:extLst>
           </p:cNvPr>
@@ -5409,7 +5409,7 @@
           <p:cNvPr id="8" name="Oval 7">
             <a:extLst>
               <a:ext uri="{FF2B5EF4-FFF2-40B4-BE49-F238E27FC236}">
-                <a16:creationId xmlns:a16="http://schemas.microsoft.com/office/drawing/2014/main" id="{984530E5-58B9-FEF1-D76C-EF640074D865}"/>
+                <a16:creationId xmlns:a16="http://schemas.microsoft.com/office/drawing/2014/main" id="{B3BFCEDA-DEA8-2BDE-BD18-56DAD6F4DEF7}"/>
               </a:ext>
             </a:extLst>
           </p:cNvPr>
@@ -5485,7 +5485,7 @@
           <p:cNvPr id="9" name="TextBox 8">
             <a:extLst>
               <a:ext uri="{FF2B5EF4-FFF2-40B4-BE49-F238E27FC236}">
-                <a16:creationId xmlns:a16="http://schemas.microsoft.com/office/drawing/2014/main" id="{C66C2B9A-8D14-A9E5-28B9-12B09D987B38}"/>
+                <a16:creationId xmlns:a16="http://schemas.microsoft.com/office/drawing/2014/main" id="{FC4CC75F-136A-8DFB-2878-3C10E175A096}"/>
               </a:ext>
             </a:extLst>
           </p:cNvPr>
@@ -5525,7 +5525,7 @@
           <p:cNvPr id="10" name="TextBox 9">
             <a:extLst>
               <a:ext uri="{FF2B5EF4-FFF2-40B4-BE49-F238E27FC236}">
-                <a16:creationId xmlns:a16="http://schemas.microsoft.com/office/drawing/2014/main" id="{09E11D71-2D30-9789-1C54-6A0182278A0D}"/>
+                <a16:creationId xmlns:a16="http://schemas.microsoft.com/office/drawing/2014/main" id="{05305E01-A1DE-22F3-C14D-48B5A0A2504A}"/>
               </a:ext>
             </a:extLst>
           </p:cNvPr>
@@ -5571,7 +5571,7 @@
           <p:cNvPr id="11" name="Rectangle: Rounded Corners 10">
             <a:extLst>
               <a:ext uri="{FF2B5EF4-FFF2-40B4-BE49-F238E27FC236}">
-                <a16:creationId xmlns:a16="http://schemas.microsoft.com/office/drawing/2014/main" id="{783D1827-4D91-ED73-9874-133BAE26AD5A}"/>
+                <a16:creationId xmlns:a16="http://schemas.microsoft.com/office/drawing/2014/main" id="{A7779ABA-ACD1-F11C-7459-68684860B058}"/>
               </a:ext>
             </a:extLst>
           </p:cNvPr>
@@ -5641,7 +5641,7 @@
           <p:cNvPr id="12" name="Oval 11">
             <a:extLst>
               <a:ext uri="{FF2B5EF4-FFF2-40B4-BE49-F238E27FC236}">
-                <a16:creationId xmlns:a16="http://schemas.microsoft.com/office/drawing/2014/main" id="{8DC051C7-36F5-9004-5E9C-11027B402D58}"/>
+                <a16:creationId xmlns:a16="http://schemas.microsoft.com/office/drawing/2014/main" id="{FC29447A-8E9B-3EB7-7E3C-93584493EFD6}"/>
               </a:ext>
             </a:extLst>
           </p:cNvPr>
@@ -5717,7 +5717,7 @@
           <p:cNvPr id="13" name="TextBox 12">
             <a:extLst>
               <a:ext uri="{FF2B5EF4-FFF2-40B4-BE49-F238E27FC236}">
-                <a16:creationId xmlns:a16="http://schemas.microsoft.com/office/drawing/2014/main" id="{95317139-9CB0-914E-6D2D-B24DDC67FF42}"/>
+                <a16:creationId xmlns:a16="http://schemas.microsoft.com/office/drawing/2014/main" id="{821A25C5-1F69-C158-D2B6-386EBF239FBE}"/>
               </a:ext>
             </a:extLst>
           </p:cNvPr>
@@ -5757,7 +5757,7 @@
           <p:cNvPr id="14" name="TextBox 13">
             <a:extLst>
               <a:ext uri="{FF2B5EF4-FFF2-40B4-BE49-F238E27FC236}">
-                <a16:creationId xmlns:a16="http://schemas.microsoft.com/office/drawing/2014/main" id="{51D9963B-5CD0-EB47-2745-CE28D2A4D30A}"/>
+                <a16:creationId xmlns:a16="http://schemas.microsoft.com/office/drawing/2014/main" id="{6496D5D2-2E50-B42D-80DF-6B79133BA98F}"/>
               </a:ext>
             </a:extLst>
           </p:cNvPr>
@@ -5803,7 +5803,7 @@
           <p:cNvPr id="15" name="Rectangle: Rounded Corners 14">
             <a:extLst>
               <a:ext uri="{FF2B5EF4-FFF2-40B4-BE49-F238E27FC236}">
-                <a16:creationId xmlns:a16="http://schemas.microsoft.com/office/drawing/2014/main" id="{28C6DA60-E50D-6CC4-0AAC-26F9A3FC3683}"/>
+                <a16:creationId xmlns:a16="http://schemas.microsoft.com/office/drawing/2014/main" id="{09529E7B-4E89-D09A-DFE8-83652183BDCE}"/>
               </a:ext>
             </a:extLst>
           </p:cNvPr>
@@ -5873,7 +5873,7 @@
           <p:cNvPr id="16" name="Oval 15">
             <a:extLst>
               <a:ext uri="{FF2B5EF4-FFF2-40B4-BE49-F238E27FC236}">
-                <a16:creationId xmlns:a16="http://schemas.microsoft.com/office/drawing/2014/main" id="{9A33FE28-6255-314A-38BE-F879E83BD6F2}"/>
+                <a16:creationId xmlns:a16="http://schemas.microsoft.com/office/drawing/2014/main" id="{699CE4F5-89CD-83DA-2414-5C9065B4B087}"/>
               </a:ext>
             </a:extLst>
           </p:cNvPr>
@@ -5949,7 +5949,7 @@
           <p:cNvPr id="17" name="TextBox 16">
             <a:extLst>
               <a:ext uri="{FF2B5EF4-FFF2-40B4-BE49-F238E27FC236}">
-                <a16:creationId xmlns:a16="http://schemas.microsoft.com/office/drawing/2014/main" id="{3F2AAC89-5226-1F5A-6269-4FE29EB2D050}"/>
+                <a16:creationId xmlns:a16="http://schemas.microsoft.com/office/drawing/2014/main" id="{997993B5-4333-0281-DAD8-97958FE50A7F}"/>
               </a:ext>
             </a:extLst>
           </p:cNvPr>
@@ -5989,7 +5989,7 @@
           <p:cNvPr id="18" name="TextBox 17">
             <a:extLst>
               <a:ext uri="{FF2B5EF4-FFF2-40B4-BE49-F238E27FC236}">
-                <a16:creationId xmlns:a16="http://schemas.microsoft.com/office/drawing/2014/main" id="{6E89322D-3D80-2FF6-276A-62595170D00C}"/>
+                <a16:creationId xmlns:a16="http://schemas.microsoft.com/office/drawing/2014/main" id="{6B3445B8-F7AF-69F7-0957-10E0F0D5D7E6}"/>
               </a:ext>
             </a:extLst>
           </p:cNvPr>
@@ -6035,7 +6035,7 @@
           <p:cNvPr id="19" name="TextBox 18">
             <a:extLst>
               <a:ext uri="{FF2B5EF4-FFF2-40B4-BE49-F238E27FC236}">
-                <a16:creationId xmlns:a16="http://schemas.microsoft.com/office/drawing/2014/main" id="{0419B6F2-E242-EA0A-6357-AA9AEB1D4D91}"/>
+                <a16:creationId xmlns:a16="http://schemas.microsoft.com/office/drawing/2014/main" id="{D64E800A-F043-AA62-316E-5071C3FC342F}"/>
               </a:ext>
             </a:extLst>
           </p:cNvPr>
@@ -6044,7 +6044,7 @@
         </p:nvSpPr>
         <p:spPr>
           <a:xfrm>
-            <a:off x="609600" y="3403600"/>
+            <a:off x="609600" y="3378200"/>
             <a:ext cx="10972800" cy="300082"/>
           </a:xfrm>
           <a:prstGeom prst="rect">
@@ -6059,17 +6059,17 @@
           <a:lstStyle/>
           <a:p>
             <a:r>
-              <a:rPr lang="en-US" sz="1200">
-                <a:solidFill>
-                  <a:srgbClr val="6B7280"/>
+              <a:rPr lang="en-US" sz="1150">
+                <a:solidFill>
+                  <a:srgbClr val="1F2430"/>
                 </a:solidFill>
                 <a:latin typeface="Calibri" panose="020F0502020204030204" pitchFamily="34" charset="0"/>
               </a:rPr>
-              <a:t>The organisers' own four capabilities. The SI is the reference; the goal is to catch incorrect details before the draft is finalised.</a:t>
-            </a:r>
-            <a:endParaRPr lang="en-MY" sz="1200">
+              <a:t>Why we built it: today a documentation clerk does this by hand - about 4 minutes per SI/BL pair and 20 seconds to triage each email (a conservative estimate, not a measurement) - and a missed field becomes a correction, a delay, rework.</a:t>
+            </a:r>
+            <a:endParaRPr lang="en-MY" sz="1150">
               <a:solidFill>
-                <a:srgbClr val="6B7280"/>
+                <a:srgbClr val="1F2430"/>
               </a:solidFill>
               <a:latin typeface="Calibri" panose="020F0502020204030204" pitchFamily="34" charset="0"/>
             </a:endParaRPr>
@@ -6081,7 +6081,7 @@
           <p:cNvPr id="20" name="TextBox 19">
             <a:extLst>
               <a:ext uri="{FF2B5EF4-FFF2-40B4-BE49-F238E27FC236}">
-                <a16:creationId xmlns:a16="http://schemas.microsoft.com/office/drawing/2014/main" id="{B151FF69-8F6E-854E-3D8C-E072759BA8F7}"/>
+                <a16:creationId xmlns:a16="http://schemas.microsoft.com/office/drawing/2014/main" id="{CE6290B6-92E5-DDE1-4A45-86EBDE78BD5E}"/>
               </a:ext>
             </a:extLst>
           </p:cNvPr>
@@ -6127,7 +6127,7 @@
           <p:cNvPr id="21" name="TextBox 20">
             <a:extLst>
               <a:ext uri="{FF2B5EF4-FFF2-40B4-BE49-F238E27FC236}">
-                <a16:creationId xmlns:a16="http://schemas.microsoft.com/office/drawing/2014/main" id="{9F06BD75-CD9D-4903-DC59-5A5B5E55EBC0}"/>
+                <a16:creationId xmlns:a16="http://schemas.microsoft.com/office/drawing/2014/main" id="{6CF3586E-6E8C-F9B0-AD56-857489101578}"/>
               </a:ext>
             </a:extLst>
           </p:cNvPr>
@@ -6173,7 +6173,7 @@
           <p:cNvPr id="22" name="TextBox 21">
             <a:extLst>
               <a:ext uri="{FF2B5EF4-FFF2-40B4-BE49-F238E27FC236}">
-                <a16:creationId xmlns:a16="http://schemas.microsoft.com/office/drawing/2014/main" id="{42D076DB-522E-FBBE-3EB9-0EBD1797E990}"/>
+                <a16:creationId xmlns:a16="http://schemas.microsoft.com/office/drawing/2014/main" id="{7E65143E-E947-7E61-8233-219E9BAB8CFD}"/>
               </a:ext>
             </a:extLst>
           </p:cNvPr>
@@ -6219,7 +6219,7 @@
           <p:cNvPr id="23" name="TextBox 22">
             <a:extLst>
               <a:ext uri="{FF2B5EF4-FFF2-40B4-BE49-F238E27FC236}">
-                <a16:creationId xmlns:a16="http://schemas.microsoft.com/office/drawing/2014/main" id="{726DCCB7-A2B0-69D6-0E0F-FC714AACBBCA}"/>
+                <a16:creationId xmlns:a16="http://schemas.microsoft.com/office/drawing/2014/main" id="{288B3E9E-02E1-18E1-94D6-67CFB87DA086}"/>
               </a:ext>
             </a:extLst>
           </p:cNvPr>
@@ -6265,7 +6265,7 @@
           <p:cNvPr id="24" name="TextBox 23">
             <a:extLst>
               <a:ext uri="{FF2B5EF4-FFF2-40B4-BE49-F238E27FC236}">
-                <a16:creationId xmlns:a16="http://schemas.microsoft.com/office/drawing/2014/main" id="{7BA41D7B-6FB4-0CD3-F042-D0BACEFFB7C2}"/>
+                <a16:creationId xmlns:a16="http://schemas.microsoft.com/office/drawing/2014/main" id="{6890D010-EBCC-C972-24E7-AC0EDE13A5DC}"/>
               </a:ext>
             </a:extLst>
           </p:cNvPr>
@@ -6311,7 +6311,7 @@
           <p:cNvPr id="25" name="TextBox 24">
             <a:extLst>
               <a:ext uri="{FF2B5EF4-FFF2-40B4-BE49-F238E27FC236}">
-                <a16:creationId xmlns:a16="http://schemas.microsoft.com/office/drawing/2014/main" id="{4F1FD76E-735E-0458-4E84-CA0166EAD2FA}"/>
+                <a16:creationId xmlns:a16="http://schemas.microsoft.com/office/drawing/2014/main" id="{BED1208B-B573-1B59-EFE6-A30711210E28}"/>
               </a:ext>
             </a:extLst>
           </p:cNvPr>
@@ -6357,7 +6357,7 @@
           <p:cNvPr id="26" name="Rectangle: Rounded Corners 25">
             <a:extLst>
               <a:ext uri="{FF2B5EF4-FFF2-40B4-BE49-F238E27FC236}">
-                <a16:creationId xmlns:a16="http://schemas.microsoft.com/office/drawing/2014/main" id="{20990368-7D34-B023-0655-FCD6C8765885}"/>
+                <a16:creationId xmlns:a16="http://schemas.microsoft.com/office/drawing/2014/main" id="{2D174602-3BE8-1A03-4EED-0AFB74E41F72}"/>
               </a:ext>
             </a:extLst>
           </p:cNvPr>
@@ -6427,7 +6427,7 @@
           <p:cNvPr id="27" name="TextBox 26">
             <a:extLst>
               <a:ext uri="{FF2B5EF4-FFF2-40B4-BE49-F238E27FC236}">
-                <a16:creationId xmlns:a16="http://schemas.microsoft.com/office/drawing/2014/main" id="{C4DD5677-D30A-E2E2-5095-BF233199C798}"/>
+                <a16:creationId xmlns:a16="http://schemas.microsoft.com/office/drawing/2014/main" id="{C77247F8-7C2B-071B-78B6-727628AB7857}"/>
               </a:ext>
             </a:extLst>
           </p:cNvPr>
@@ -6473,7 +6473,7 @@
           <p:cNvPr id="28" name="TextBox 27">
             <a:extLst>
               <a:ext uri="{FF2B5EF4-FFF2-40B4-BE49-F238E27FC236}">
-                <a16:creationId xmlns:a16="http://schemas.microsoft.com/office/drawing/2014/main" id="{66332F32-448D-4BCF-9680-B5E44EA58701}"/>
+                <a16:creationId xmlns:a16="http://schemas.microsoft.com/office/drawing/2014/main" id="{A70982EC-AAE6-473E-E60F-56FA31B64A3C}"/>
               </a:ext>
             </a:extLst>
           </p:cNvPr>
@@ -6518,7 +6518,7 @@
     </p:spTree>
     <p:extLst>
       <p:ext uri="{BB962C8B-B14F-4D97-AF65-F5344CB8AC3E}">
-        <p14:creationId xmlns:p14="http://schemas.microsoft.com/office/powerpoint/2010/main" val="2714817090"/>
+        <p14:creationId xmlns:p14="http://schemas.microsoft.com/office/powerpoint/2010/main" val="3699902665"/>
       </p:ext>
     </p:extLst>
   </p:cSld>
@@ -6558,7 +6558,7 @@
           <p:cNvPr id="2" name="TextBox 1">
             <a:extLst>
               <a:ext uri="{FF2B5EF4-FFF2-40B4-BE49-F238E27FC236}">
-                <a16:creationId xmlns:a16="http://schemas.microsoft.com/office/drawing/2014/main" id="{720B4F02-BA5B-93F5-AAAE-82F4AD7DED7F}"/>
+                <a16:creationId xmlns:a16="http://schemas.microsoft.com/office/drawing/2014/main" id="{AD43D84F-5A8B-7685-1146-1338948D88F1}"/>
               </a:ext>
             </a:extLst>
           </p:cNvPr>
@@ -6604,7 +6604,7 @@
           <p:cNvPr id="4" name="Picture 3">
             <a:extLst>
               <a:ext uri="{FF2B5EF4-FFF2-40B4-BE49-F238E27FC236}">
-                <a16:creationId xmlns:a16="http://schemas.microsoft.com/office/drawing/2014/main" id="{4D85ABE0-F8D6-3831-3056-0FCC928A5BCF}"/>
+                <a16:creationId xmlns:a16="http://schemas.microsoft.com/office/drawing/2014/main" id="{B39AEFDB-A4F0-9301-8DDB-39A69CB7EAAC}"/>
               </a:ext>
             </a:extLst>
           </p:cNvPr>
@@ -6645,7 +6645,7 @@
           <p:cNvPr id="5" name="TextBox 4">
             <a:extLst>
               <a:ext uri="{FF2B5EF4-FFF2-40B4-BE49-F238E27FC236}">
-                <a16:creationId xmlns:a16="http://schemas.microsoft.com/office/drawing/2014/main" id="{639E5150-CC67-83FC-FAD3-21676905821E}"/>
+                <a16:creationId xmlns:a16="http://schemas.microsoft.com/office/drawing/2014/main" id="{C107C9FD-4F4A-918F-07DF-32992E4F16B1}"/>
               </a:ext>
             </a:extLst>
           </p:cNvPr>
@@ -6685,7 +6685,7 @@
           <p:cNvPr id="6" name="TextBox 5">
             <a:extLst>
               <a:ext uri="{FF2B5EF4-FFF2-40B4-BE49-F238E27FC236}">
-                <a16:creationId xmlns:a16="http://schemas.microsoft.com/office/drawing/2014/main" id="{6429D772-AEFF-1B9E-3E78-208F0DB633DC}"/>
+                <a16:creationId xmlns:a16="http://schemas.microsoft.com/office/drawing/2014/main" id="{8DAAAD95-132B-4F8A-A18D-2CABC9FD7194}"/>
               </a:ext>
             </a:extLst>
           </p:cNvPr>
@@ -6725,7 +6725,7 @@
           <p:cNvPr id="7" name="TextBox 6">
             <a:extLst>
               <a:ext uri="{FF2B5EF4-FFF2-40B4-BE49-F238E27FC236}">
-                <a16:creationId xmlns:a16="http://schemas.microsoft.com/office/drawing/2014/main" id="{6639CAEE-0806-8826-7E7D-85441623287A}"/>
+                <a16:creationId xmlns:a16="http://schemas.microsoft.com/office/drawing/2014/main" id="{E8ADE83B-7E2F-6548-0462-364E35F53722}"/>
               </a:ext>
             </a:extLst>
           </p:cNvPr>
@@ -6765,7 +6765,7 @@
           <p:cNvPr id="8" name="TextBox 7">
             <a:extLst>
               <a:ext uri="{FF2B5EF4-FFF2-40B4-BE49-F238E27FC236}">
-                <a16:creationId xmlns:a16="http://schemas.microsoft.com/office/drawing/2014/main" id="{4EC2C78E-BF9C-902A-3940-8B6B0965F85D}"/>
+                <a16:creationId xmlns:a16="http://schemas.microsoft.com/office/drawing/2014/main" id="{E01A2123-0637-9355-7D07-8C7E66503E9D}"/>
               </a:ext>
             </a:extLst>
           </p:cNvPr>
@@ -6811,7 +6811,7 @@
           <p:cNvPr id="9" name="TextBox 8">
             <a:extLst>
               <a:ext uri="{FF2B5EF4-FFF2-40B4-BE49-F238E27FC236}">
-                <a16:creationId xmlns:a16="http://schemas.microsoft.com/office/drawing/2014/main" id="{1411D413-9B28-EDE4-A8C1-6691BB8A595E}"/>
+                <a16:creationId xmlns:a16="http://schemas.microsoft.com/office/drawing/2014/main" id="{67FF3DC6-6984-502A-CBAA-D59705E4278D}"/>
               </a:ext>
             </a:extLst>
           </p:cNvPr>
@@ -6851,7 +6851,7 @@
           <p:cNvPr id="10" name="TextBox 9">
             <a:extLst>
               <a:ext uri="{FF2B5EF4-FFF2-40B4-BE49-F238E27FC236}">
-                <a16:creationId xmlns:a16="http://schemas.microsoft.com/office/drawing/2014/main" id="{37EDB249-71C6-521E-553F-756D9AB69F7A}"/>
+                <a16:creationId xmlns:a16="http://schemas.microsoft.com/office/drawing/2014/main" id="{52667BCF-44AD-DDED-EDA6-818D91EFC955}"/>
               </a:ext>
             </a:extLst>
           </p:cNvPr>
@@ -6897,7 +6897,7 @@
           <p:cNvPr id="11" name="TextBox 10">
             <a:extLst>
               <a:ext uri="{FF2B5EF4-FFF2-40B4-BE49-F238E27FC236}">
-                <a16:creationId xmlns:a16="http://schemas.microsoft.com/office/drawing/2014/main" id="{3DD15C58-B364-BCB8-DCB9-0934341814D3}"/>
+                <a16:creationId xmlns:a16="http://schemas.microsoft.com/office/drawing/2014/main" id="{9295EE4C-66A0-181A-96DA-F211AA160F7A}"/>
               </a:ext>
             </a:extLst>
           </p:cNvPr>
@@ -6937,7 +6937,7 @@
           <p:cNvPr id="12" name="TextBox 11">
             <a:extLst>
               <a:ext uri="{FF2B5EF4-FFF2-40B4-BE49-F238E27FC236}">
-                <a16:creationId xmlns:a16="http://schemas.microsoft.com/office/drawing/2014/main" id="{DEDDD999-18D6-2357-D6A1-794CAA60D93D}"/>
+                <a16:creationId xmlns:a16="http://schemas.microsoft.com/office/drawing/2014/main" id="{CA1399FD-C70D-68F7-36FC-12CE0573971A}"/>
               </a:ext>
             </a:extLst>
           </p:cNvPr>
@@ -6983,7 +6983,7 @@
           <p:cNvPr id="13" name="TextBox 12">
             <a:extLst>
               <a:ext uri="{FF2B5EF4-FFF2-40B4-BE49-F238E27FC236}">
-                <a16:creationId xmlns:a16="http://schemas.microsoft.com/office/drawing/2014/main" id="{3BE0A213-8DBC-FB1F-010A-678566BBBEEF}"/>
+                <a16:creationId xmlns:a16="http://schemas.microsoft.com/office/drawing/2014/main" id="{FDCAB584-D163-5A5F-6F28-5A4676360938}"/>
               </a:ext>
             </a:extLst>
           </p:cNvPr>
@@ -6992,7 +6992,7 @@
         </p:nvSpPr>
         <p:spPr>
           <a:xfrm>
-            <a:off x="609600" y="5740400"/>
+            <a:off x="609600" y="5715000"/>
             <a:ext cx="10972800" cy="300082"/>
           </a:xfrm>
           <a:prstGeom prst="rect">
@@ -7007,14 +7007,20 @@
           <a:lstStyle/>
           <a:p>
             <a:r>
-              <a:rPr lang="en-MY" sz="1100">
-                <a:solidFill>
-                  <a:srgbClr val="6B7280"/>
+              <a:rPr lang="en-US" sz="1150">
+                <a:solidFill>
+                  <a:srgbClr val="1F2430"/>
                 </a:solidFill>
                 <a:latin typeface="Calibri" panose="020F0502020204030204" pitchFamily="34" charset="0"/>
               </a:rPr>
-              <a:t>duocode-sentinel.vercel.app · sdoc-sentinel-api.onrender.com - deployed from the repository by the committed render.yaml and vercel.json.</a:t>
-            </a:r>
+              <a:t>How a desk uses it:   1  Run the inbox   ·   2  Open a flagged case   ·   3  Confirm it, correct a single field, or re-upload the corrected document   ·   4  Send the drafted reply</a:t>
+            </a:r>
+            <a:endParaRPr lang="en-MY" sz="1150">
+              <a:solidFill>
+                <a:srgbClr val="1F2430"/>
+              </a:solidFill>
+              <a:latin typeface="Calibri" panose="020F0502020204030204" pitchFamily="34" charset="0"/>
+            </a:endParaRPr>
           </a:p>
         </p:txBody>
       </p:sp>
@@ -7023,7 +7029,7 @@
           <p:cNvPr id="14" name="TextBox 13">
             <a:extLst>
               <a:ext uri="{FF2B5EF4-FFF2-40B4-BE49-F238E27FC236}">
-                <a16:creationId xmlns:a16="http://schemas.microsoft.com/office/drawing/2014/main" id="{C0E3F026-8250-91EA-8386-730FCD63D92C}"/>
+                <a16:creationId xmlns:a16="http://schemas.microsoft.com/office/drawing/2014/main" id="{14CC8A3B-5EC3-7DE0-F0C3-5F1B7AAB73A2}"/>
               </a:ext>
             </a:extLst>
           </p:cNvPr>
@@ -7062,7 +7068,7 @@
     </p:spTree>
     <p:extLst>
       <p:ext uri="{BB962C8B-B14F-4D97-AF65-F5344CB8AC3E}">
-        <p14:creationId xmlns:p14="http://schemas.microsoft.com/office/powerpoint/2010/main" val="1345112154"/>
+        <p14:creationId xmlns:p14="http://schemas.microsoft.com/office/powerpoint/2010/main" val="1220596969"/>
       </p:ext>
     </p:extLst>
   </p:cSld>
@@ -7102,7 +7108,7 @@
           <p:cNvPr id="2" name="TextBox 1">
             <a:extLst>
               <a:ext uri="{FF2B5EF4-FFF2-40B4-BE49-F238E27FC236}">
-                <a16:creationId xmlns:a16="http://schemas.microsoft.com/office/drawing/2014/main" id="{065EFC2B-41CA-DBF3-1D87-E578B9C4BC28}"/>
+                <a16:creationId xmlns:a16="http://schemas.microsoft.com/office/drawing/2014/main" id="{705210E2-601F-E436-7829-E814D3EA6B90}"/>
               </a:ext>
             </a:extLst>
           </p:cNvPr>
@@ -7142,7 +7148,7 @@
           <p:cNvPr id="3" name="Rectangle: Rounded Corners 2">
             <a:extLst>
               <a:ext uri="{FF2B5EF4-FFF2-40B4-BE49-F238E27FC236}">
-                <a16:creationId xmlns:a16="http://schemas.microsoft.com/office/drawing/2014/main" id="{39C32F9D-8557-0772-8CC2-79736CB854D4}"/>
+                <a16:creationId xmlns:a16="http://schemas.microsoft.com/office/drawing/2014/main" id="{60A5824E-E493-86C3-36B0-457917776671}"/>
               </a:ext>
             </a:extLst>
           </p:cNvPr>
@@ -7220,7 +7226,7 @@
           <p:cNvPr id="4" name="Straight Connector 3">
             <a:extLst>
               <a:ext uri="{FF2B5EF4-FFF2-40B4-BE49-F238E27FC236}">
-                <a16:creationId xmlns:a16="http://schemas.microsoft.com/office/drawing/2014/main" id="{4FADACCE-B7B3-C685-E45E-7791A9FC2FB2}"/>
+                <a16:creationId xmlns:a16="http://schemas.microsoft.com/office/drawing/2014/main" id="{4389B498-9609-20EB-1B68-5F9191CE8B21}"/>
               </a:ext>
             </a:extLst>
           </p:cNvPr>
@@ -7262,7 +7268,7 @@
           <p:cNvPr id="5" name="Rectangle: Rounded Corners 4">
             <a:extLst>
               <a:ext uri="{FF2B5EF4-FFF2-40B4-BE49-F238E27FC236}">
-                <a16:creationId xmlns:a16="http://schemas.microsoft.com/office/drawing/2014/main" id="{F90E9877-801E-33B9-2A56-3813EF50A954}"/>
+                <a16:creationId xmlns:a16="http://schemas.microsoft.com/office/drawing/2014/main" id="{9700954B-1423-972A-92A1-B5E494485D66}"/>
               </a:ext>
             </a:extLst>
           </p:cNvPr>
@@ -7340,7 +7346,7 @@
           <p:cNvPr id="6" name="Straight Connector 5">
             <a:extLst>
               <a:ext uri="{FF2B5EF4-FFF2-40B4-BE49-F238E27FC236}">
-                <a16:creationId xmlns:a16="http://schemas.microsoft.com/office/drawing/2014/main" id="{979C24F3-A844-C9A0-461A-27C4AD66A942}"/>
+                <a16:creationId xmlns:a16="http://schemas.microsoft.com/office/drawing/2014/main" id="{0BD93353-9F52-B126-B37E-C81D9FB509C1}"/>
               </a:ext>
             </a:extLst>
           </p:cNvPr>
@@ -7382,7 +7388,7 @@
           <p:cNvPr id="7" name="Rectangle: Rounded Corners 6">
             <a:extLst>
               <a:ext uri="{FF2B5EF4-FFF2-40B4-BE49-F238E27FC236}">
-                <a16:creationId xmlns:a16="http://schemas.microsoft.com/office/drawing/2014/main" id="{34E56A55-DCAF-52C5-2999-8D2612B7DB7C}"/>
+                <a16:creationId xmlns:a16="http://schemas.microsoft.com/office/drawing/2014/main" id="{86C72DA4-1D4F-C20F-A311-5A8307320CDA}"/>
               </a:ext>
             </a:extLst>
           </p:cNvPr>
@@ -7460,7 +7466,7 @@
           <p:cNvPr id="8" name="Straight Connector 7">
             <a:extLst>
               <a:ext uri="{FF2B5EF4-FFF2-40B4-BE49-F238E27FC236}">
-                <a16:creationId xmlns:a16="http://schemas.microsoft.com/office/drawing/2014/main" id="{6ABB396F-FB9D-2C88-A9C1-18838BAB7834}"/>
+                <a16:creationId xmlns:a16="http://schemas.microsoft.com/office/drawing/2014/main" id="{2C595D6C-4653-C985-26E3-5992F8B3FB29}"/>
               </a:ext>
             </a:extLst>
           </p:cNvPr>
@@ -7502,7 +7508,7 @@
           <p:cNvPr id="9" name="Rectangle: Rounded Corners 8">
             <a:extLst>
               <a:ext uri="{FF2B5EF4-FFF2-40B4-BE49-F238E27FC236}">
-                <a16:creationId xmlns:a16="http://schemas.microsoft.com/office/drawing/2014/main" id="{57BBF386-7089-A0EE-DC0F-16D54F4096BF}"/>
+                <a16:creationId xmlns:a16="http://schemas.microsoft.com/office/drawing/2014/main" id="{8CFCD73A-4C3B-B69A-D703-ADA60986DFF2}"/>
               </a:ext>
             </a:extLst>
           </p:cNvPr>
@@ -7580,7 +7586,7 @@
           <p:cNvPr id="10" name="Straight Connector 9">
             <a:extLst>
               <a:ext uri="{FF2B5EF4-FFF2-40B4-BE49-F238E27FC236}">
-                <a16:creationId xmlns:a16="http://schemas.microsoft.com/office/drawing/2014/main" id="{136EA03A-6294-E848-95A1-4F1A0558590B}"/>
+                <a16:creationId xmlns:a16="http://schemas.microsoft.com/office/drawing/2014/main" id="{6E295A24-E05E-D7D0-0891-8AC0DBE0878A}"/>
               </a:ext>
             </a:extLst>
           </p:cNvPr>
@@ -7622,7 +7628,7 @@
           <p:cNvPr id="11" name="Rectangle: Rounded Corners 10">
             <a:extLst>
               <a:ext uri="{FF2B5EF4-FFF2-40B4-BE49-F238E27FC236}">
-                <a16:creationId xmlns:a16="http://schemas.microsoft.com/office/drawing/2014/main" id="{B63CC564-8B9C-46CF-B900-287F8972F1C3}"/>
+                <a16:creationId xmlns:a16="http://schemas.microsoft.com/office/drawing/2014/main" id="{65B568CD-DAF8-9F18-BAAE-559CF785EBAE}"/>
               </a:ext>
             </a:extLst>
           </p:cNvPr>
@@ -7700,7 +7706,7 @@
           <p:cNvPr id="12" name="Straight Connector 11">
             <a:extLst>
               <a:ext uri="{FF2B5EF4-FFF2-40B4-BE49-F238E27FC236}">
-                <a16:creationId xmlns:a16="http://schemas.microsoft.com/office/drawing/2014/main" id="{1A713E5B-4B82-4E74-B9F3-995A45075AC8}"/>
+                <a16:creationId xmlns:a16="http://schemas.microsoft.com/office/drawing/2014/main" id="{FC6C8729-E9DB-DBC4-E40F-500924B62702}"/>
               </a:ext>
             </a:extLst>
           </p:cNvPr>
@@ -7742,7 +7748,7 @@
           <p:cNvPr id="13" name="Rectangle: Rounded Corners 12">
             <a:extLst>
               <a:ext uri="{FF2B5EF4-FFF2-40B4-BE49-F238E27FC236}">
-                <a16:creationId xmlns:a16="http://schemas.microsoft.com/office/drawing/2014/main" id="{4DC00A6D-191D-9FB8-1655-437BA96B0FCB}"/>
+                <a16:creationId xmlns:a16="http://schemas.microsoft.com/office/drawing/2014/main" id="{3C0278A6-4C2F-5C97-1974-880A6915CC12}"/>
               </a:ext>
             </a:extLst>
           </p:cNvPr>
@@ -7820,7 +7826,7 @@
           <p:cNvPr id="14" name="Straight Connector 13">
             <a:extLst>
               <a:ext uri="{FF2B5EF4-FFF2-40B4-BE49-F238E27FC236}">
-                <a16:creationId xmlns:a16="http://schemas.microsoft.com/office/drawing/2014/main" id="{DD4E3524-74B1-61EA-EC0F-093CDD704E29}"/>
+                <a16:creationId xmlns:a16="http://schemas.microsoft.com/office/drawing/2014/main" id="{3AC4D31B-65EA-753F-FDA9-C21133F00C51}"/>
               </a:ext>
             </a:extLst>
           </p:cNvPr>
@@ -7863,7 +7869,7 @@
           <p:cNvPr id="15" name="TextBox 14">
             <a:extLst>
               <a:ext uri="{FF2B5EF4-FFF2-40B4-BE49-F238E27FC236}">
-                <a16:creationId xmlns:a16="http://schemas.microsoft.com/office/drawing/2014/main" id="{44E33244-FA64-A95D-936F-FEE2B852A912}"/>
+                <a16:creationId xmlns:a16="http://schemas.microsoft.com/office/drawing/2014/main" id="{FE1E9ED4-FE6E-3826-5728-6F8C0DF3195C}"/>
               </a:ext>
             </a:extLst>
           </p:cNvPr>
@@ -7904,7 +7910,7 @@
           <p:cNvPr id="16" name="TextBox 15">
             <a:extLst>
               <a:ext uri="{FF2B5EF4-FFF2-40B4-BE49-F238E27FC236}">
-                <a16:creationId xmlns:a16="http://schemas.microsoft.com/office/drawing/2014/main" id="{5F82947C-28A4-9931-7E26-D0150607763C}"/>
+                <a16:creationId xmlns:a16="http://schemas.microsoft.com/office/drawing/2014/main" id="{45BB0B3F-B584-28E9-A031-94589BEDFE3D}"/>
               </a:ext>
             </a:extLst>
           </p:cNvPr>
@@ -7950,7 +7956,7 @@
           <p:cNvPr id="17" name="Rectangle: Rounded Corners 16">
             <a:extLst>
               <a:ext uri="{FF2B5EF4-FFF2-40B4-BE49-F238E27FC236}">
-                <a16:creationId xmlns:a16="http://schemas.microsoft.com/office/drawing/2014/main" id="{EEB151C9-4134-EB0A-0346-82A7E63EB719}"/>
+                <a16:creationId xmlns:a16="http://schemas.microsoft.com/office/drawing/2014/main" id="{CA57345F-E631-5C5E-05D5-EB6E9EC2A020}"/>
               </a:ext>
             </a:extLst>
           </p:cNvPr>
@@ -8020,7 +8026,7 @@
           <p:cNvPr id="18" name="TextBox 17">
             <a:extLst>
               <a:ext uri="{FF2B5EF4-FFF2-40B4-BE49-F238E27FC236}">
-                <a16:creationId xmlns:a16="http://schemas.microsoft.com/office/drawing/2014/main" id="{AA99DC06-DA52-CBD5-92C6-744D60C3A8F1}"/>
+                <a16:creationId xmlns:a16="http://schemas.microsoft.com/office/drawing/2014/main" id="{B6B7DF2C-40E1-152A-A702-6200F13AEB0F}"/>
               </a:ext>
             </a:extLst>
           </p:cNvPr>
@@ -8066,7 +8072,7 @@
           <p:cNvPr id="19" name="TextBox 18">
             <a:extLst>
               <a:ext uri="{FF2B5EF4-FFF2-40B4-BE49-F238E27FC236}">
-                <a16:creationId xmlns:a16="http://schemas.microsoft.com/office/drawing/2014/main" id="{8EA12B2C-61C2-AB69-D905-59D7A294FDD5}"/>
+                <a16:creationId xmlns:a16="http://schemas.microsoft.com/office/drawing/2014/main" id="{EE5DFF2B-E755-F292-2AE9-58FB050BB0C6}"/>
               </a:ext>
             </a:extLst>
           </p:cNvPr>
@@ -8112,7 +8118,7 @@
           <p:cNvPr id="20" name="Rectangle: Rounded Corners 19">
             <a:extLst>
               <a:ext uri="{FF2B5EF4-FFF2-40B4-BE49-F238E27FC236}">
-                <a16:creationId xmlns:a16="http://schemas.microsoft.com/office/drawing/2014/main" id="{2E246042-A189-CA4B-CF6D-8BDA5BC1A79A}"/>
+                <a16:creationId xmlns:a16="http://schemas.microsoft.com/office/drawing/2014/main" id="{B43EA754-3CC1-2F41-FEBB-D97E7A88E6A2}"/>
               </a:ext>
             </a:extLst>
           </p:cNvPr>
@@ -8182,7 +8188,7 @@
           <p:cNvPr id="21" name="TextBox 20">
             <a:extLst>
               <a:ext uri="{FF2B5EF4-FFF2-40B4-BE49-F238E27FC236}">
-                <a16:creationId xmlns:a16="http://schemas.microsoft.com/office/drawing/2014/main" id="{BBCA0344-277F-34F7-E11B-43FBE70CE5AB}"/>
+                <a16:creationId xmlns:a16="http://schemas.microsoft.com/office/drawing/2014/main" id="{BAAE596F-436E-6D1C-8626-5EC395EDC526}"/>
               </a:ext>
             </a:extLst>
           </p:cNvPr>
@@ -8222,7 +8228,7 @@
           <p:cNvPr id="22" name="TextBox 21">
             <a:extLst>
               <a:ext uri="{FF2B5EF4-FFF2-40B4-BE49-F238E27FC236}">
-                <a16:creationId xmlns:a16="http://schemas.microsoft.com/office/drawing/2014/main" id="{A476A62E-5720-C103-2737-72236A4F01E2}"/>
+                <a16:creationId xmlns:a16="http://schemas.microsoft.com/office/drawing/2014/main" id="{7BBB9AA5-53C0-6D06-E82A-B402228F5BAF}"/>
               </a:ext>
             </a:extLst>
           </p:cNvPr>
@@ -8268,7 +8274,7 @@
           <p:cNvPr id="23" name="Rectangle: Rounded Corners 22">
             <a:extLst>
               <a:ext uri="{FF2B5EF4-FFF2-40B4-BE49-F238E27FC236}">
-                <a16:creationId xmlns:a16="http://schemas.microsoft.com/office/drawing/2014/main" id="{59BBC391-2145-C053-125D-211F9B420E8D}"/>
+                <a16:creationId xmlns:a16="http://schemas.microsoft.com/office/drawing/2014/main" id="{F8D7BF01-4221-CCE9-6386-1BA4027FB55F}"/>
               </a:ext>
             </a:extLst>
           </p:cNvPr>
@@ -8338,7 +8344,7 @@
           <p:cNvPr id="24" name="TextBox 23">
             <a:extLst>
               <a:ext uri="{FF2B5EF4-FFF2-40B4-BE49-F238E27FC236}">
-                <a16:creationId xmlns:a16="http://schemas.microsoft.com/office/drawing/2014/main" id="{3ACFCBA4-A8A7-46EE-8E59-27E7E7891FD6}"/>
+                <a16:creationId xmlns:a16="http://schemas.microsoft.com/office/drawing/2014/main" id="{883F700B-6F27-5486-1430-74F16503E3C2}"/>
               </a:ext>
             </a:extLst>
           </p:cNvPr>
@@ -8378,7 +8384,7 @@
           <p:cNvPr id="25" name="TextBox 24">
             <a:extLst>
               <a:ext uri="{FF2B5EF4-FFF2-40B4-BE49-F238E27FC236}">
-                <a16:creationId xmlns:a16="http://schemas.microsoft.com/office/drawing/2014/main" id="{068D8E07-C4A6-5E3E-7B94-1B85B7813FC2}"/>
+                <a16:creationId xmlns:a16="http://schemas.microsoft.com/office/drawing/2014/main" id="{B4A64297-CF63-1392-ED5B-218253132056}"/>
               </a:ext>
             </a:extLst>
           </p:cNvPr>
@@ -8424,7 +8430,7 @@
           <p:cNvPr id="26" name="TextBox 25">
             <a:extLst>
               <a:ext uri="{FF2B5EF4-FFF2-40B4-BE49-F238E27FC236}">
-                <a16:creationId xmlns:a16="http://schemas.microsoft.com/office/drawing/2014/main" id="{1B8D7B75-15FD-2912-D22B-BEA00D03181F}"/>
+                <a16:creationId xmlns:a16="http://schemas.microsoft.com/office/drawing/2014/main" id="{D153B89B-B970-E337-3027-C6A8987A682C}"/>
               </a:ext>
             </a:extLst>
           </p:cNvPr>
@@ -8470,7 +8476,7 @@
           <p:cNvPr id="27" name="TextBox 26">
             <a:extLst>
               <a:ext uri="{FF2B5EF4-FFF2-40B4-BE49-F238E27FC236}">
-                <a16:creationId xmlns:a16="http://schemas.microsoft.com/office/drawing/2014/main" id="{573F9127-DCA7-812C-2C9D-D56F2214E3D7}"/>
+                <a16:creationId xmlns:a16="http://schemas.microsoft.com/office/drawing/2014/main" id="{C6DFEC5C-6B4C-E46D-E634-68A35670CDF6}"/>
               </a:ext>
             </a:extLst>
           </p:cNvPr>
@@ -8509,7 +8515,7 @@
     </p:spTree>
     <p:extLst>
       <p:ext uri="{BB962C8B-B14F-4D97-AF65-F5344CB8AC3E}">
-        <p14:creationId xmlns:p14="http://schemas.microsoft.com/office/powerpoint/2010/main" val="3887469736"/>
+        <p14:creationId xmlns:p14="http://schemas.microsoft.com/office/powerpoint/2010/main" val="1782283618"/>
       </p:ext>
     </p:extLst>
   </p:cSld>
@@ -8549,7 +8555,7 @@
           <p:cNvPr id="2" name="TextBox 1">
             <a:extLst>
               <a:ext uri="{FF2B5EF4-FFF2-40B4-BE49-F238E27FC236}">
-                <a16:creationId xmlns:a16="http://schemas.microsoft.com/office/drawing/2014/main" id="{803C6697-6C1D-0E5A-28D7-763ED1E689AE}"/>
+                <a16:creationId xmlns:a16="http://schemas.microsoft.com/office/drawing/2014/main" id="{CAFB1CD9-D6D1-D2ED-8C0F-9D9BD01967DA}"/>
               </a:ext>
             </a:extLst>
           </p:cNvPr>
@@ -8595,7 +8601,7 @@
           <p:cNvPr id="3" name="Oval 2">
             <a:extLst>
               <a:ext uri="{FF2B5EF4-FFF2-40B4-BE49-F238E27FC236}">
-                <a16:creationId xmlns:a16="http://schemas.microsoft.com/office/drawing/2014/main" id="{04866B18-0FD4-0F75-BB6D-A4DD8D907E0E}"/>
+                <a16:creationId xmlns:a16="http://schemas.microsoft.com/office/drawing/2014/main" id="{962AED0B-9F4C-C6C9-5BBF-9DBB023811F6}"/>
               </a:ext>
             </a:extLst>
           </p:cNvPr>
@@ -8671,7 +8677,7 @@
           <p:cNvPr id="4" name="TextBox 3">
             <a:extLst>
               <a:ext uri="{FF2B5EF4-FFF2-40B4-BE49-F238E27FC236}">
-                <a16:creationId xmlns:a16="http://schemas.microsoft.com/office/drawing/2014/main" id="{30E22211-0671-7187-FA45-31363A97AE60}"/>
+                <a16:creationId xmlns:a16="http://schemas.microsoft.com/office/drawing/2014/main" id="{27159FF5-CB36-5287-5577-AA7F2C18E208}"/>
               </a:ext>
             </a:extLst>
           </p:cNvPr>
@@ -8717,7 +8723,7 @@
           <p:cNvPr id="5" name="TextBox 4">
             <a:extLst>
               <a:ext uri="{FF2B5EF4-FFF2-40B4-BE49-F238E27FC236}">
-                <a16:creationId xmlns:a16="http://schemas.microsoft.com/office/drawing/2014/main" id="{7679415B-9136-60DD-A540-9C54E210AF8E}"/>
+                <a16:creationId xmlns:a16="http://schemas.microsoft.com/office/drawing/2014/main" id="{6DE69856-5847-64C1-300E-C9E633953501}"/>
               </a:ext>
             </a:extLst>
           </p:cNvPr>
@@ -8763,7 +8769,7 @@
           <p:cNvPr id="6" name="Oval 5">
             <a:extLst>
               <a:ext uri="{FF2B5EF4-FFF2-40B4-BE49-F238E27FC236}">
-                <a16:creationId xmlns:a16="http://schemas.microsoft.com/office/drawing/2014/main" id="{C0F38589-49AE-00DB-ED91-F00CBB7ED11F}"/>
+                <a16:creationId xmlns:a16="http://schemas.microsoft.com/office/drawing/2014/main" id="{0DC57F6D-BB3A-A59B-8571-59E4B23CEF89}"/>
               </a:ext>
             </a:extLst>
           </p:cNvPr>
@@ -8839,7 +8845,7 @@
           <p:cNvPr id="7" name="TextBox 6">
             <a:extLst>
               <a:ext uri="{FF2B5EF4-FFF2-40B4-BE49-F238E27FC236}">
-                <a16:creationId xmlns:a16="http://schemas.microsoft.com/office/drawing/2014/main" id="{D971A8F2-C2C8-01F3-06E9-B85F6B56C20B}"/>
+                <a16:creationId xmlns:a16="http://schemas.microsoft.com/office/drawing/2014/main" id="{5845C49A-E799-8A15-5692-534E5E10EBE5}"/>
               </a:ext>
             </a:extLst>
           </p:cNvPr>
@@ -8885,7 +8891,7 @@
           <p:cNvPr id="8" name="TextBox 7">
             <a:extLst>
               <a:ext uri="{FF2B5EF4-FFF2-40B4-BE49-F238E27FC236}">
-                <a16:creationId xmlns:a16="http://schemas.microsoft.com/office/drawing/2014/main" id="{6C98A002-17A8-52D5-5061-4E88F5F655A6}"/>
+                <a16:creationId xmlns:a16="http://schemas.microsoft.com/office/drawing/2014/main" id="{96CE63B4-5855-882F-4536-5011E0A9DF1E}"/>
               </a:ext>
             </a:extLst>
           </p:cNvPr>
@@ -8931,7 +8937,7 @@
           <p:cNvPr id="9" name="Oval 8">
             <a:extLst>
               <a:ext uri="{FF2B5EF4-FFF2-40B4-BE49-F238E27FC236}">
-                <a16:creationId xmlns:a16="http://schemas.microsoft.com/office/drawing/2014/main" id="{D861E4A2-431D-E146-C949-CB69A7A30EAF}"/>
+                <a16:creationId xmlns:a16="http://schemas.microsoft.com/office/drawing/2014/main" id="{52AB324B-7053-C306-F6B9-46F2A818E094}"/>
               </a:ext>
             </a:extLst>
           </p:cNvPr>
@@ -9007,7 +9013,7 @@
           <p:cNvPr id="10" name="TextBox 9">
             <a:extLst>
               <a:ext uri="{FF2B5EF4-FFF2-40B4-BE49-F238E27FC236}">
-                <a16:creationId xmlns:a16="http://schemas.microsoft.com/office/drawing/2014/main" id="{6364EF5A-4F5E-C556-CB65-C23B6D392ABE}"/>
+                <a16:creationId xmlns:a16="http://schemas.microsoft.com/office/drawing/2014/main" id="{D7B1E7F6-F198-175C-9990-E67FBF484FE5}"/>
               </a:ext>
             </a:extLst>
           </p:cNvPr>
@@ -9053,7 +9059,7 @@
           <p:cNvPr id="11" name="TextBox 10">
             <a:extLst>
               <a:ext uri="{FF2B5EF4-FFF2-40B4-BE49-F238E27FC236}">
-                <a16:creationId xmlns:a16="http://schemas.microsoft.com/office/drawing/2014/main" id="{B1F7A0D3-1E18-AA30-C7DE-6E29BB68AA12}"/>
+                <a16:creationId xmlns:a16="http://schemas.microsoft.com/office/drawing/2014/main" id="{EB0B4AEA-972B-4836-E1AD-C75395FDAA66}"/>
               </a:ext>
             </a:extLst>
           </p:cNvPr>
@@ -9099,7 +9105,7 @@
           <p:cNvPr id="12" name="TextBox 11">
             <a:extLst>
               <a:ext uri="{FF2B5EF4-FFF2-40B4-BE49-F238E27FC236}">
-                <a16:creationId xmlns:a16="http://schemas.microsoft.com/office/drawing/2014/main" id="{B49FFF05-C334-1B10-BA1C-9ECFE75BD56D}"/>
+                <a16:creationId xmlns:a16="http://schemas.microsoft.com/office/drawing/2014/main" id="{820AD510-FDB3-66D8-327A-FD31C7EF2B91}"/>
               </a:ext>
             </a:extLst>
           </p:cNvPr>
@@ -9145,7 +9151,7 @@
           <p:cNvPr id="13" name="Rectangle: Rounded Corners 12">
             <a:extLst>
               <a:ext uri="{FF2B5EF4-FFF2-40B4-BE49-F238E27FC236}">
-                <a16:creationId xmlns:a16="http://schemas.microsoft.com/office/drawing/2014/main" id="{216FE3E6-B9F0-F6EC-E238-854265D50E5A}"/>
+                <a16:creationId xmlns:a16="http://schemas.microsoft.com/office/drawing/2014/main" id="{1AD2C984-4A87-6DE0-D1E5-210D67806E14}"/>
               </a:ext>
             </a:extLst>
           </p:cNvPr>
@@ -9215,7 +9221,7 @@
           <p:cNvPr id="14" name="TextBox 13">
             <a:extLst>
               <a:ext uri="{FF2B5EF4-FFF2-40B4-BE49-F238E27FC236}">
-                <a16:creationId xmlns:a16="http://schemas.microsoft.com/office/drawing/2014/main" id="{87508D42-7752-76B0-F9A3-DEC20F8CFF37}"/>
+                <a16:creationId xmlns:a16="http://schemas.microsoft.com/office/drawing/2014/main" id="{99C3BFC0-5A23-E2B1-66A9-158F6A69B6E0}"/>
               </a:ext>
             </a:extLst>
           </p:cNvPr>
@@ -9256,7 +9262,7 @@
           <p:cNvPr id="15" name="TextBox 14">
             <a:extLst>
               <a:ext uri="{FF2B5EF4-FFF2-40B4-BE49-F238E27FC236}">
-                <a16:creationId xmlns:a16="http://schemas.microsoft.com/office/drawing/2014/main" id="{0A4AB2F7-FCF1-2936-FF6D-C72D56F7844F}"/>
+                <a16:creationId xmlns:a16="http://schemas.microsoft.com/office/drawing/2014/main" id="{B27D22E1-1A0B-5989-CCB6-98AA6748722C}"/>
               </a:ext>
             </a:extLst>
           </p:cNvPr>
@@ -9297,7 +9303,7 @@
           <p:cNvPr id="16" name="TextBox 15">
             <a:extLst>
               <a:ext uri="{FF2B5EF4-FFF2-40B4-BE49-F238E27FC236}">
-                <a16:creationId xmlns:a16="http://schemas.microsoft.com/office/drawing/2014/main" id="{96C5147D-4BB4-DDB9-97EB-ADA4C60C3645}"/>
+                <a16:creationId xmlns:a16="http://schemas.microsoft.com/office/drawing/2014/main" id="{1B227F73-56C3-F808-7B26-1CA4C0A738B1}"/>
               </a:ext>
             </a:extLst>
           </p:cNvPr>
@@ -9337,7 +9343,7 @@
           <p:cNvPr id="17" name="TextBox 16">
             <a:extLst>
               <a:ext uri="{FF2B5EF4-FFF2-40B4-BE49-F238E27FC236}">
-                <a16:creationId xmlns:a16="http://schemas.microsoft.com/office/drawing/2014/main" id="{78F8709E-F3F6-E11E-9B34-7C68AB5F7CE9}"/>
+                <a16:creationId xmlns:a16="http://schemas.microsoft.com/office/drawing/2014/main" id="{F47F7929-D7C4-028C-53E4-CB3048027614}"/>
               </a:ext>
             </a:extLst>
           </p:cNvPr>
@@ -9383,7 +9389,7 @@
           <p:cNvPr id="18" name="TextBox 17">
             <a:extLst>
               <a:ext uri="{FF2B5EF4-FFF2-40B4-BE49-F238E27FC236}">
-                <a16:creationId xmlns:a16="http://schemas.microsoft.com/office/drawing/2014/main" id="{EF691F02-744C-4F5C-02C6-D11EB977E782}"/>
+                <a16:creationId xmlns:a16="http://schemas.microsoft.com/office/drawing/2014/main" id="{343D4037-E95C-C9F9-9673-6B6704950B71}"/>
               </a:ext>
             </a:extLst>
           </p:cNvPr>
@@ -9429,7 +9435,7 @@
           <p:cNvPr id="19" name="Rectangle: Rounded Corners 18">
             <a:extLst>
               <a:ext uri="{FF2B5EF4-FFF2-40B4-BE49-F238E27FC236}">
-                <a16:creationId xmlns:a16="http://schemas.microsoft.com/office/drawing/2014/main" id="{49BB3F4C-2A0A-A306-B2E1-0AEF9B8B0BCA}"/>
+                <a16:creationId xmlns:a16="http://schemas.microsoft.com/office/drawing/2014/main" id="{6454FCD0-B0EC-4096-6EF2-6B1643EDF26D}"/>
               </a:ext>
             </a:extLst>
           </p:cNvPr>
@@ -9499,7 +9505,7 @@
           <p:cNvPr id="20" name="TextBox 19">
             <a:extLst>
               <a:ext uri="{FF2B5EF4-FFF2-40B4-BE49-F238E27FC236}">
-                <a16:creationId xmlns:a16="http://schemas.microsoft.com/office/drawing/2014/main" id="{8FC89E20-7F78-62CD-E6A5-5CB35CD7421A}"/>
+                <a16:creationId xmlns:a16="http://schemas.microsoft.com/office/drawing/2014/main" id="{679D6760-0D40-025E-DE44-984863C822DC}"/>
               </a:ext>
             </a:extLst>
           </p:cNvPr>
@@ -9545,7 +9551,7 @@
           <p:cNvPr id="21" name="TextBox 20">
             <a:extLst>
               <a:ext uri="{FF2B5EF4-FFF2-40B4-BE49-F238E27FC236}">
-                <a16:creationId xmlns:a16="http://schemas.microsoft.com/office/drawing/2014/main" id="{D3D31C88-201F-202E-3A0F-4C78C201E158}"/>
+                <a16:creationId xmlns:a16="http://schemas.microsoft.com/office/drawing/2014/main" id="{00EA700B-8363-4AA9-E3A2-E9E824C3052D}"/>
               </a:ext>
             </a:extLst>
           </p:cNvPr>
@@ -9584,7 +9590,7 @@
     </p:spTree>
     <p:extLst>
       <p:ext uri="{BB962C8B-B14F-4D97-AF65-F5344CB8AC3E}">
-        <p14:creationId xmlns:p14="http://schemas.microsoft.com/office/powerpoint/2010/main" val="2386186350"/>
+        <p14:creationId xmlns:p14="http://schemas.microsoft.com/office/powerpoint/2010/main" val="3233756946"/>
       </p:ext>
     </p:extLst>
   </p:cSld>
@@ -9624,7 +9630,7 @@
           <p:cNvPr id="2" name="TextBox 1">
             <a:extLst>
               <a:ext uri="{FF2B5EF4-FFF2-40B4-BE49-F238E27FC236}">
-                <a16:creationId xmlns:a16="http://schemas.microsoft.com/office/drawing/2014/main" id="{93FD31E3-4223-9847-2159-A886B194CFFC}"/>
+                <a16:creationId xmlns:a16="http://schemas.microsoft.com/office/drawing/2014/main" id="{B083DEC8-4B15-A868-DE93-7782D4B06137}"/>
               </a:ext>
             </a:extLst>
           </p:cNvPr>
@@ -9670,7 +9676,7 @@
           <p:cNvPr id="3" name="Rectangle: Rounded Corners 2">
             <a:extLst>
               <a:ext uri="{FF2B5EF4-FFF2-40B4-BE49-F238E27FC236}">
-                <a16:creationId xmlns:a16="http://schemas.microsoft.com/office/drawing/2014/main" id="{0874BEAB-2256-2813-F6D9-FFE380D69649}"/>
+                <a16:creationId xmlns:a16="http://schemas.microsoft.com/office/drawing/2014/main" id="{E99D0CC1-4E90-FDA7-DC68-C24B3579448E}"/>
               </a:ext>
             </a:extLst>
           </p:cNvPr>
@@ -9740,7 +9746,7 @@
           <p:cNvPr id="4" name="TextBox 3">
             <a:extLst>
               <a:ext uri="{FF2B5EF4-FFF2-40B4-BE49-F238E27FC236}">
-                <a16:creationId xmlns:a16="http://schemas.microsoft.com/office/drawing/2014/main" id="{8687C8B5-2320-906C-859F-8F0698A4FC7D}"/>
+                <a16:creationId xmlns:a16="http://schemas.microsoft.com/office/drawing/2014/main" id="{63CB9491-737E-BDFA-D52F-34F7FABB058B}"/>
               </a:ext>
             </a:extLst>
           </p:cNvPr>
@@ -9780,7 +9786,7 @@
           <p:cNvPr id="5" name="TextBox 4">
             <a:extLst>
               <a:ext uri="{FF2B5EF4-FFF2-40B4-BE49-F238E27FC236}">
-                <a16:creationId xmlns:a16="http://schemas.microsoft.com/office/drawing/2014/main" id="{59DA03E7-0F6E-F424-540F-FF850279D25A}"/>
+                <a16:creationId xmlns:a16="http://schemas.microsoft.com/office/drawing/2014/main" id="{C59AD20D-CC9B-39CE-2B00-3777976A59EE}"/>
               </a:ext>
             </a:extLst>
           </p:cNvPr>
@@ -9826,7 +9832,7 @@
           <p:cNvPr id="6" name="Rectangle: Rounded Corners 5">
             <a:extLst>
               <a:ext uri="{FF2B5EF4-FFF2-40B4-BE49-F238E27FC236}">
-                <a16:creationId xmlns:a16="http://schemas.microsoft.com/office/drawing/2014/main" id="{AA0A3163-821F-A073-64AA-EA045276B9A9}"/>
+                <a16:creationId xmlns:a16="http://schemas.microsoft.com/office/drawing/2014/main" id="{D3ED4F47-0D85-08F7-7C38-76ABB94039CD}"/>
               </a:ext>
             </a:extLst>
           </p:cNvPr>
@@ -9896,7 +9902,7 @@
           <p:cNvPr id="7" name="TextBox 6">
             <a:extLst>
               <a:ext uri="{FF2B5EF4-FFF2-40B4-BE49-F238E27FC236}">
-                <a16:creationId xmlns:a16="http://schemas.microsoft.com/office/drawing/2014/main" id="{112AC709-4318-8C90-2BB5-B4459D85757C}"/>
+                <a16:creationId xmlns:a16="http://schemas.microsoft.com/office/drawing/2014/main" id="{6F14A506-C458-DB3E-4D7F-A5373A12727C}"/>
               </a:ext>
             </a:extLst>
           </p:cNvPr>
@@ -9936,7 +9942,7 @@
           <p:cNvPr id="8" name="TextBox 7">
             <a:extLst>
               <a:ext uri="{FF2B5EF4-FFF2-40B4-BE49-F238E27FC236}">
-                <a16:creationId xmlns:a16="http://schemas.microsoft.com/office/drawing/2014/main" id="{1D79C96E-6F98-4AA7-650C-0B66919736FF}"/>
+                <a16:creationId xmlns:a16="http://schemas.microsoft.com/office/drawing/2014/main" id="{94CA03B4-9243-75BF-1E2F-31DF474BC2F9}"/>
               </a:ext>
             </a:extLst>
           </p:cNvPr>
@@ -9982,7 +9988,7 @@
           <p:cNvPr id="9" name="Rectangle: Rounded Corners 8">
             <a:extLst>
               <a:ext uri="{FF2B5EF4-FFF2-40B4-BE49-F238E27FC236}">
-                <a16:creationId xmlns:a16="http://schemas.microsoft.com/office/drawing/2014/main" id="{129E185C-3384-2FEB-2D09-C02B4D24E0F0}"/>
+                <a16:creationId xmlns:a16="http://schemas.microsoft.com/office/drawing/2014/main" id="{6F60F3FF-7C01-4F8C-C790-80BFB15DEB48}"/>
               </a:ext>
             </a:extLst>
           </p:cNvPr>
@@ -10052,7 +10058,7 @@
           <p:cNvPr id="10" name="TextBox 9">
             <a:extLst>
               <a:ext uri="{FF2B5EF4-FFF2-40B4-BE49-F238E27FC236}">
-                <a16:creationId xmlns:a16="http://schemas.microsoft.com/office/drawing/2014/main" id="{CE9F4573-8A87-C9D7-3EDC-0C7AB91106BF}"/>
+                <a16:creationId xmlns:a16="http://schemas.microsoft.com/office/drawing/2014/main" id="{DEEE0929-96B0-281F-1BEE-B41C6430B388}"/>
               </a:ext>
             </a:extLst>
           </p:cNvPr>
@@ -10092,7 +10098,7 @@
           <p:cNvPr id="11" name="TextBox 10">
             <a:extLst>
               <a:ext uri="{FF2B5EF4-FFF2-40B4-BE49-F238E27FC236}">
-                <a16:creationId xmlns:a16="http://schemas.microsoft.com/office/drawing/2014/main" id="{917EAF4A-E651-3DBF-A3B4-198C66086FA9}"/>
+                <a16:creationId xmlns:a16="http://schemas.microsoft.com/office/drawing/2014/main" id="{EA231BF5-B316-C032-B52F-168851CB5BE8}"/>
               </a:ext>
             </a:extLst>
           </p:cNvPr>
@@ -10138,7 +10144,7 @@
           <p:cNvPr id="12" name="Rectangle: Rounded Corners 11">
             <a:extLst>
               <a:ext uri="{FF2B5EF4-FFF2-40B4-BE49-F238E27FC236}">
-                <a16:creationId xmlns:a16="http://schemas.microsoft.com/office/drawing/2014/main" id="{ADCB26E8-4967-606A-E930-402E64226C3F}"/>
+                <a16:creationId xmlns:a16="http://schemas.microsoft.com/office/drawing/2014/main" id="{CC037217-0643-4E79-67DB-A55402FB4680}"/>
               </a:ext>
             </a:extLst>
           </p:cNvPr>
@@ -10208,7 +10214,7 @@
           <p:cNvPr id="13" name="TextBox 12">
             <a:extLst>
               <a:ext uri="{FF2B5EF4-FFF2-40B4-BE49-F238E27FC236}">
-                <a16:creationId xmlns:a16="http://schemas.microsoft.com/office/drawing/2014/main" id="{F701DEE3-08FF-8812-C261-03D18AA55A23}"/>
+                <a16:creationId xmlns:a16="http://schemas.microsoft.com/office/drawing/2014/main" id="{825D4B8B-F73D-AB3C-B759-DBF23E98C357}"/>
               </a:ext>
             </a:extLst>
           </p:cNvPr>
@@ -10248,7 +10254,7 @@
           <p:cNvPr id="14" name="TextBox 13">
             <a:extLst>
               <a:ext uri="{FF2B5EF4-FFF2-40B4-BE49-F238E27FC236}">
-                <a16:creationId xmlns:a16="http://schemas.microsoft.com/office/drawing/2014/main" id="{4F4203CB-9537-79D3-5F7E-A34857EAC61B}"/>
+                <a16:creationId xmlns:a16="http://schemas.microsoft.com/office/drawing/2014/main" id="{84F76765-C96B-30B6-0C28-84419440260C}"/>
               </a:ext>
             </a:extLst>
           </p:cNvPr>
@@ -10294,7 +10300,7 @@
           <p:cNvPr id="15" name="Rectangle: Rounded Corners 14">
             <a:extLst>
               <a:ext uri="{FF2B5EF4-FFF2-40B4-BE49-F238E27FC236}">
-                <a16:creationId xmlns:a16="http://schemas.microsoft.com/office/drawing/2014/main" id="{3EAC2738-62BC-0F4A-D43B-29DF799D13D5}"/>
+                <a16:creationId xmlns:a16="http://schemas.microsoft.com/office/drawing/2014/main" id="{E2204F93-9FD6-CA9F-600C-E2533024A9AA}"/>
               </a:ext>
             </a:extLst>
           </p:cNvPr>
@@ -10364,7 +10370,7 @@
           <p:cNvPr id="16" name="TextBox 15">
             <a:extLst>
               <a:ext uri="{FF2B5EF4-FFF2-40B4-BE49-F238E27FC236}">
-                <a16:creationId xmlns:a16="http://schemas.microsoft.com/office/drawing/2014/main" id="{66BD5936-45A3-2ABE-ADB5-0436D6117826}"/>
+                <a16:creationId xmlns:a16="http://schemas.microsoft.com/office/drawing/2014/main" id="{6A8212FB-227D-53FB-1A62-DDC989A5F306}"/>
               </a:ext>
             </a:extLst>
           </p:cNvPr>
@@ -10404,7 +10410,7 @@
           <p:cNvPr id="17" name="TextBox 16">
             <a:extLst>
               <a:ext uri="{FF2B5EF4-FFF2-40B4-BE49-F238E27FC236}">
-                <a16:creationId xmlns:a16="http://schemas.microsoft.com/office/drawing/2014/main" id="{0C4396BA-8907-5301-4ECF-88FBD5B15B30}"/>
+                <a16:creationId xmlns:a16="http://schemas.microsoft.com/office/drawing/2014/main" id="{D4BE6B6E-A481-96B4-E85A-BBB334EBB6F6}"/>
               </a:ext>
             </a:extLst>
           </p:cNvPr>
@@ -10469,7 +10475,7 @@
           <p:cNvPr id="18" name="TextBox 17">
             <a:extLst>
               <a:ext uri="{FF2B5EF4-FFF2-40B4-BE49-F238E27FC236}">
-                <a16:creationId xmlns:a16="http://schemas.microsoft.com/office/drawing/2014/main" id="{C4CFD30E-B1AE-F4A4-26CE-DF1610691690}"/>
+                <a16:creationId xmlns:a16="http://schemas.microsoft.com/office/drawing/2014/main" id="{D096255A-517A-E6B4-2D85-C691891DB3E7}"/>
               </a:ext>
             </a:extLst>
           </p:cNvPr>
@@ -10515,7 +10521,7 @@
           <p:cNvPr id="19" name="TextBox 18">
             <a:extLst>
               <a:ext uri="{FF2B5EF4-FFF2-40B4-BE49-F238E27FC236}">
-                <a16:creationId xmlns:a16="http://schemas.microsoft.com/office/drawing/2014/main" id="{F0162692-723C-6FBB-1695-1E6F5933369A}"/>
+                <a16:creationId xmlns:a16="http://schemas.microsoft.com/office/drawing/2014/main" id="{8357D6AC-1677-BBFD-B1CA-7775A150E5FA}"/>
               </a:ext>
             </a:extLst>
           </p:cNvPr>
@@ -10561,7 +10567,7 @@
           <p:cNvPr id="20" name="TextBox 19">
             <a:extLst>
               <a:ext uri="{FF2B5EF4-FFF2-40B4-BE49-F238E27FC236}">
-                <a16:creationId xmlns:a16="http://schemas.microsoft.com/office/drawing/2014/main" id="{986AA309-E2D1-19EB-648B-F44BD8146CC7}"/>
+                <a16:creationId xmlns:a16="http://schemas.microsoft.com/office/drawing/2014/main" id="{9AD529C0-4237-7AF9-0EE1-52D403638FE1}"/>
               </a:ext>
             </a:extLst>
           </p:cNvPr>
@@ -10606,7 +10612,7 @@
     </p:spTree>
     <p:extLst>
       <p:ext uri="{BB962C8B-B14F-4D97-AF65-F5344CB8AC3E}">
-        <p14:creationId xmlns:p14="http://schemas.microsoft.com/office/powerpoint/2010/main" val="409971176"/>
+        <p14:creationId xmlns:p14="http://schemas.microsoft.com/office/powerpoint/2010/main" val="513068102"/>
       </p:ext>
     </p:extLst>
   </p:cSld>
@@ -10646,7 +10652,7 @@
           <p:cNvPr id="2" name="TextBox 1">
             <a:extLst>
               <a:ext uri="{FF2B5EF4-FFF2-40B4-BE49-F238E27FC236}">
-                <a16:creationId xmlns:a16="http://schemas.microsoft.com/office/drawing/2014/main" id="{0CCDC2BE-E76D-E028-5C76-A7626E46A29C}"/>
+                <a16:creationId xmlns:a16="http://schemas.microsoft.com/office/drawing/2014/main" id="{AB0769EA-E699-9CA5-A518-4A2A9A41BE24}"/>
               </a:ext>
             </a:extLst>
           </p:cNvPr>
@@ -10686,7 +10692,7 @@
           <p:cNvPr id="3" name="TextBox 2">
             <a:extLst>
               <a:ext uri="{FF2B5EF4-FFF2-40B4-BE49-F238E27FC236}">
-                <a16:creationId xmlns:a16="http://schemas.microsoft.com/office/drawing/2014/main" id="{0686F2CC-F1A1-E8FE-5C84-8AA4E6A84348}"/>
+                <a16:creationId xmlns:a16="http://schemas.microsoft.com/office/drawing/2014/main" id="{5881A2C1-D09D-0BD7-4433-EBDB5B1F1C29}"/>
               </a:ext>
             </a:extLst>
           </p:cNvPr>
@@ -10732,7 +10738,7 @@
           <p:cNvPr id="4" name="Oval 3">
             <a:extLst>
               <a:ext uri="{FF2B5EF4-FFF2-40B4-BE49-F238E27FC236}">
-                <a16:creationId xmlns:a16="http://schemas.microsoft.com/office/drawing/2014/main" id="{7041BBFA-0C88-585D-DC87-71434917F96D}"/>
+                <a16:creationId xmlns:a16="http://schemas.microsoft.com/office/drawing/2014/main" id="{AC3F65EF-1758-6BB6-529A-F854F08D1C80}"/>
               </a:ext>
             </a:extLst>
           </p:cNvPr>
@@ -10808,7 +10814,7 @@
           <p:cNvPr id="5" name="TextBox 4">
             <a:extLst>
               <a:ext uri="{FF2B5EF4-FFF2-40B4-BE49-F238E27FC236}">
-                <a16:creationId xmlns:a16="http://schemas.microsoft.com/office/drawing/2014/main" id="{470E8F7A-5915-D1ED-AAA3-EE1DB4259AB8}"/>
+                <a16:creationId xmlns:a16="http://schemas.microsoft.com/office/drawing/2014/main" id="{BB6C4AE5-C918-ACE3-8092-1AFA39CCE60A}"/>
               </a:ext>
             </a:extLst>
           </p:cNvPr>
@@ -10854,7 +10860,7 @@
           <p:cNvPr id="6" name="Oval 5">
             <a:extLst>
               <a:ext uri="{FF2B5EF4-FFF2-40B4-BE49-F238E27FC236}">
-                <a16:creationId xmlns:a16="http://schemas.microsoft.com/office/drawing/2014/main" id="{A7A15DB8-B014-96E5-8609-84F06C8B5659}"/>
+                <a16:creationId xmlns:a16="http://schemas.microsoft.com/office/drawing/2014/main" id="{E27029DA-BB52-1FCD-276F-AA915D1B3F30}"/>
               </a:ext>
             </a:extLst>
           </p:cNvPr>
@@ -10930,7 +10936,7 @@
           <p:cNvPr id="7" name="TextBox 6">
             <a:extLst>
               <a:ext uri="{FF2B5EF4-FFF2-40B4-BE49-F238E27FC236}">
-                <a16:creationId xmlns:a16="http://schemas.microsoft.com/office/drawing/2014/main" id="{EEFEB5AA-36A7-F161-4AE8-950855185136}"/>
+                <a16:creationId xmlns:a16="http://schemas.microsoft.com/office/drawing/2014/main" id="{A1A8CEDE-3942-8E21-3EF3-01EC57AFFD07}"/>
               </a:ext>
             </a:extLst>
           </p:cNvPr>
@@ -10976,7 +10982,7 @@
           <p:cNvPr id="8" name="Oval 7">
             <a:extLst>
               <a:ext uri="{FF2B5EF4-FFF2-40B4-BE49-F238E27FC236}">
-                <a16:creationId xmlns:a16="http://schemas.microsoft.com/office/drawing/2014/main" id="{6226C8A5-F0FE-0279-62DD-F2E330F3061A}"/>
+                <a16:creationId xmlns:a16="http://schemas.microsoft.com/office/drawing/2014/main" id="{43C0904F-1215-726A-B2F1-45C7A4BD5B3C}"/>
               </a:ext>
             </a:extLst>
           </p:cNvPr>
@@ -11052,7 +11058,7 @@
           <p:cNvPr id="9" name="TextBox 8">
             <a:extLst>
               <a:ext uri="{FF2B5EF4-FFF2-40B4-BE49-F238E27FC236}">
-                <a16:creationId xmlns:a16="http://schemas.microsoft.com/office/drawing/2014/main" id="{7F3FC030-F60C-579B-C031-D35A31984C20}"/>
+                <a16:creationId xmlns:a16="http://schemas.microsoft.com/office/drawing/2014/main" id="{18D79AF6-CC6B-9D07-0550-B46B7EC8FE7D}"/>
               </a:ext>
             </a:extLst>
           </p:cNvPr>
@@ -11098,7 +11104,7 @@
           <p:cNvPr id="10" name="Oval 9">
             <a:extLst>
               <a:ext uri="{FF2B5EF4-FFF2-40B4-BE49-F238E27FC236}">
-                <a16:creationId xmlns:a16="http://schemas.microsoft.com/office/drawing/2014/main" id="{E5D6D556-523B-86D6-B5BF-CE2D74343955}"/>
+                <a16:creationId xmlns:a16="http://schemas.microsoft.com/office/drawing/2014/main" id="{2A45EEDA-6464-D86A-12B3-E08F54920F90}"/>
               </a:ext>
             </a:extLst>
           </p:cNvPr>
@@ -11174,7 +11180,7 @@
           <p:cNvPr id="11" name="TextBox 10">
             <a:extLst>
               <a:ext uri="{FF2B5EF4-FFF2-40B4-BE49-F238E27FC236}">
-                <a16:creationId xmlns:a16="http://schemas.microsoft.com/office/drawing/2014/main" id="{6C9AD358-4E5F-B538-6267-86EE9563D790}"/>
+                <a16:creationId xmlns:a16="http://schemas.microsoft.com/office/drawing/2014/main" id="{47223473-0096-EC57-1996-4C02A929076B}"/>
               </a:ext>
             </a:extLst>
           </p:cNvPr>
@@ -11220,7 +11226,7 @@
           <p:cNvPr id="12" name="Oval 11">
             <a:extLst>
               <a:ext uri="{FF2B5EF4-FFF2-40B4-BE49-F238E27FC236}">
-                <a16:creationId xmlns:a16="http://schemas.microsoft.com/office/drawing/2014/main" id="{1822F9DC-7626-0882-19DD-15845A800924}"/>
+                <a16:creationId xmlns:a16="http://schemas.microsoft.com/office/drawing/2014/main" id="{5382F9AE-45CC-7770-BBE1-AA4AA357E351}"/>
               </a:ext>
             </a:extLst>
           </p:cNvPr>
@@ -11296,7 +11302,7 @@
           <p:cNvPr id="13" name="TextBox 12">
             <a:extLst>
               <a:ext uri="{FF2B5EF4-FFF2-40B4-BE49-F238E27FC236}">
-                <a16:creationId xmlns:a16="http://schemas.microsoft.com/office/drawing/2014/main" id="{049B884A-4017-7D16-931B-A0A2A822BF08}"/>
+                <a16:creationId xmlns:a16="http://schemas.microsoft.com/office/drawing/2014/main" id="{8EED635F-AFFC-379F-F623-5501E1BC5174}"/>
               </a:ext>
             </a:extLst>
           </p:cNvPr>
@@ -11342,7 +11348,7 @@
           <p:cNvPr id="15" name="Picture 14">
             <a:extLst>
               <a:ext uri="{FF2B5EF4-FFF2-40B4-BE49-F238E27FC236}">
-                <a16:creationId xmlns:a16="http://schemas.microsoft.com/office/drawing/2014/main" id="{EC9B5C11-9EA9-1985-3505-77F9D98FE130}"/>
+                <a16:creationId xmlns:a16="http://schemas.microsoft.com/office/drawing/2014/main" id="{7F6F7046-D363-E936-35B8-C2C77878A2E8}"/>
               </a:ext>
             </a:extLst>
           </p:cNvPr>
@@ -11383,7 +11389,7 @@
           <p:cNvPr id="16" name="TextBox 15">
             <a:extLst>
               <a:ext uri="{FF2B5EF4-FFF2-40B4-BE49-F238E27FC236}">
-                <a16:creationId xmlns:a16="http://schemas.microsoft.com/office/drawing/2014/main" id="{E477F25D-8F4A-70FD-6FCC-F97482A9B0FC}"/>
+                <a16:creationId xmlns:a16="http://schemas.microsoft.com/office/drawing/2014/main" id="{7F1EB5F6-C7C6-E60D-0A6F-CBAA2F77111D}"/>
               </a:ext>
             </a:extLst>
           </p:cNvPr>
@@ -11427,7 +11433,7 @@
     </p:spTree>
     <p:extLst>
       <p:ext uri="{BB962C8B-B14F-4D97-AF65-F5344CB8AC3E}">
-        <p14:creationId xmlns:p14="http://schemas.microsoft.com/office/powerpoint/2010/main" val="1190387608"/>
+        <p14:creationId xmlns:p14="http://schemas.microsoft.com/office/powerpoint/2010/main" val="1037793958"/>
       </p:ext>
     </p:extLst>
   </p:cSld>
@@ -11467,7 +11473,7 @@
           <p:cNvPr id="2" name="TextBox 1">
             <a:extLst>
               <a:ext uri="{FF2B5EF4-FFF2-40B4-BE49-F238E27FC236}">
-                <a16:creationId xmlns:a16="http://schemas.microsoft.com/office/drawing/2014/main" id="{52295240-EE2C-1E1D-274A-4B994B4C31BB}"/>
+                <a16:creationId xmlns:a16="http://schemas.microsoft.com/office/drawing/2014/main" id="{0361A244-F027-F4DF-B51B-DA1B9B51D349}"/>
               </a:ext>
             </a:extLst>
           </p:cNvPr>
@@ -11497,58 +11503,93 @@
                 </a:solidFill>
                 <a:latin typeface="Cambria" panose="02040503050406030204" pitchFamily="18" charset="0"/>
               </a:rPr>
-              <a:t>What a reviewer gets</a:t>
-            </a:r>
-          </a:p>
-        </p:txBody>
-      </p:sp>
-      <p:pic>
-        <p:nvPicPr>
-          <p:cNvPr id="4" name="Picture 3">
-            <a:extLst>
-              <a:ext uri="{FF2B5EF4-FFF2-40B4-BE49-F238E27FC236}">
-                <a16:creationId xmlns:a16="http://schemas.microsoft.com/office/drawing/2014/main" id="{A4654793-5F34-66D5-AD29-64332EE2E529}"/>
-              </a:ext>
-            </a:extLst>
-          </p:cNvPr>
-          <p:cNvPicPr>
-            <a:picLocks/>
-          </p:cNvPicPr>
-          <p:nvPr/>
-        </p:nvPicPr>
-        <p:blipFill>
-          <a:blip r:embed="rId3">
-            <a:extLst>
-              <a:ext uri="{28A0092B-C50C-407E-A947-70E740481C1C}">
-                <a14:useLocalDpi xmlns:a14="http://schemas.microsoft.com/office/drawing/2010/main" val="0"/>
-              </a:ext>
-            </a:extLst>
-          </a:blip>
-          <a:stretch>
-            <a:fillRect/>
-          </a:stretch>
-        </p:blipFill>
+              <a:t>What makes it different</a:t>
+            </a:r>
+          </a:p>
+        </p:txBody>
+      </p:sp>
+      <p:sp>
+        <p:nvSpPr>
+          <p:cNvPr id="3" name="Oval 2">
+            <a:extLst>
+              <a:ext uri="{FF2B5EF4-FFF2-40B4-BE49-F238E27FC236}">
+                <a16:creationId xmlns:a16="http://schemas.microsoft.com/office/drawing/2014/main" id="{3AC75AD2-E50B-A0C0-5B79-BAC6611C6B19}"/>
+              </a:ext>
+            </a:extLst>
+          </p:cNvPr>
+          <p:cNvSpPr/>
+          <p:nvPr/>
+        </p:nvSpPr>
         <p:spPr>
           <a:xfrm>
             <a:off x="609600" y="1219200"/>
-            <a:ext cx="3669792" cy="3276600"/>
-          </a:xfrm>
-          <a:prstGeom prst="rect">
-            <a:avLst/>
-          </a:prstGeom>
-          <a:ln w="9525">
-            <a:solidFill>
-              <a:srgbClr val="D1D5DB"/>
-            </a:solidFill>
+            <a:ext cx="330200" cy="330200"/>
+          </a:xfrm>
+          <a:prstGeom prst="ellipse">
+            <a:avLst/>
+          </a:prstGeom>
+          <a:solidFill>
+            <a:srgbClr val="D9A441"/>
+          </a:solidFill>
+          <a:ln w="19050" cap="flat" cmpd="sng" algn="ctr">
+            <a:noFill/>
+            <a:prstDash val="solid"/>
+            <a:miter lim="800000"/>
           </a:ln>
-        </p:spPr>
-      </p:pic>
-      <p:sp>
-        <p:nvSpPr>
-          <p:cNvPr id="5" name="TextBox 4">
-            <a:extLst>
-              <a:ext uri="{FF2B5EF4-FFF2-40B4-BE49-F238E27FC236}">
-                <a16:creationId xmlns:a16="http://schemas.microsoft.com/office/drawing/2014/main" id="{4C7F1A74-127B-053F-CF57-75C97518C089}"/>
+          <a:effectLst/>
+          <a:extLst>
+            <a:ext uri="{91240B29-F687-4F45-9708-019B960494DF}">
+              <a14:hiddenLine xmlns:a14="http://schemas.microsoft.com/office/drawing/2010/main" w="19050" cap="flat" cmpd="sng" algn="ctr">
+                <a:solidFill>
+                  <a:schemeClr val="accent1">
+                    <a:shade val="15000"/>
+                  </a:schemeClr>
+                </a:solidFill>
+                <a:prstDash val="solid"/>
+                <a:miter lim="800000"/>
+              </a14:hiddenLine>
+            </a:ext>
+          </a:extLst>
+        </p:spPr>
+        <p:style>
+          <a:lnRef idx="2">
+            <a:schemeClr val="accent1">
+              <a:shade val="15000"/>
+            </a:schemeClr>
+          </a:lnRef>
+          <a:fillRef idx="1">
+            <a:schemeClr val="accent1"/>
+          </a:fillRef>
+          <a:effectRef idx="0">
+            <a:schemeClr val="accent1"/>
+          </a:effectRef>
+          <a:fontRef idx="minor">
+            <a:schemeClr val="lt1"/>
+          </a:fontRef>
+        </p:style>
+        <p:txBody>
+          <a:bodyPr lIns="0" tIns="0" rIns="0" bIns="0" rtlCol="0" anchor="ctr"/>
+          <a:lstStyle/>
+          <a:p>
+            <a:pPr algn="ctr"/>
+            <a:r>
+              <a:rPr lang="en-MY" sz="1170" b="1">
+                <a:solidFill>
+                  <a:srgbClr val="1F2430"/>
+                </a:solidFill>
+                <a:latin typeface="Calibri" panose="020F0502020204030204" pitchFamily="34" charset="0"/>
+              </a:rPr>
+              <a:t>1</a:t>
+            </a:r>
+          </a:p>
+        </p:txBody>
+      </p:sp>
+      <p:sp>
+        <p:nvSpPr>
+          <p:cNvPr id="4" name="TextBox 3">
+            <a:extLst>
+              <a:ext uri="{FF2B5EF4-FFF2-40B4-BE49-F238E27FC236}">
+                <a16:creationId xmlns:a16="http://schemas.microsoft.com/office/drawing/2014/main" id="{C05F72C1-3DEC-11E2-A1E9-81BF16D29016}"/>
               </a:ext>
             </a:extLst>
           </p:cNvPr>
@@ -11557,8 +11598,8 @@
         </p:nvSpPr>
         <p:spPr>
           <a:xfrm>
-            <a:off x="609600" y="4648200"/>
-            <a:ext cx="5334000" cy="300082"/>
+            <a:off x="1066800" y="1193800"/>
+            <a:ext cx="5588000" cy="300082"/>
           </a:xfrm>
           <a:prstGeom prst="rect">
             <a:avLst/>
@@ -11572,13 +11613,53 @@
           <a:lstStyle/>
           <a:p>
             <a:r>
-              <a:rPr lang="en-US" sz="1100">
-                <a:solidFill>
-                  <a:srgbClr val="6B7280"/>
+              <a:rPr lang="en-MY" b="1">
+                <a:solidFill>
+                  <a:srgbClr val="1F2430"/>
                 </a:solidFill>
                 <a:latin typeface="Calibri" panose="020F0502020204030204" pitchFamily="34" charset="0"/>
               </a:rPr>
-              <a:t>A mismatch: the two fields that differ, and under every value the document, the line and the label it was read from.</a:t>
+              <a:t>Correct by re-upload</a:t>
+            </a:r>
+          </a:p>
+        </p:txBody>
+      </p:sp>
+      <p:sp>
+        <p:nvSpPr>
+          <p:cNvPr id="5" name="TextBox 4">
+            <a:extLst>
+              <a:ext uri="{FF2B5EF4-FFF2-40B4-BE49-F238E27FC236}">
+                <a16:creationId xmlns:a16="http://schemas.microsoft.com/office/drawing/2014/main" id="{B84D7421-C657-CFAD-09D0-726232C6DE9F}"/>
+              </a:ext>
+            </a:extLst>
+          </p:cNvPr>
+          <p:cNvSpPr txBox="1"/>
+          <p:nvPr/>
+        </p:nvSpPr>
+        <p:spPr>
+          <a:xfrm>
+            <a:off x="1066800" y="1473200"/>
+            <a:ext cx="5588000" cy="300082"/>
+          </a:xfrm>
+          <a:prstGeom prst="rect">
+            <a:avLst/>
+          </a:prstGeom>
+          <a:noFill/>
+        </p:spPr>
+        <p:txBody>
+          <a:bodyPr vert="horz" wrap="square" lIns="0" tIns="0" rIns="0" bIns="0" rtlCol="0" anchor="t">
+            <a:noAutofit/>
+          </a:bodyPr>
+          <a:lstStyle/>
+          <a:p>
+            <a:r>
+              <a:rPr lang="en-US" sz="1100">
+                <a:solidFill>
+                  <a:srgbClr val="6B7280"/>
+                </a:solidFill>
+                <a:latin typeface="Calibri" panose="020F0502020204030204" pitchFamily="34" charset="0"/>
+              </a:rPr>
+              <a:t>The sender re-sends a fixed SI or BL? Attach it on the case and the same check runs again. The old answer stays on record.</a:t>
             </a:r>
             <a:endParaRPr lang="en-MY" sz="1100">
               <a:solidFill>
@@ -11589,53 +11670,88 @@
           </a:p>
         </p:txBody>
       </p:sp>
-      <p:pic>
-        <p:nvPicPr>
-          <p:cNvPr id="7" name="Picture 6">
-            <a:extLst>
-              <a:ext uri="{FF2B5EF4-FFF2-40B4-BE49-F238E27FC236}">
-                <a16:creationId xmlns:a16="http://schemas.microsoft.com/office/drawing/2014/main" id="{E2C8B5C3-AC4B-6690-B493-E7426EF5CA01}"/>
-              </a:ext>
-            </a:extLst>
-          </p:cNvPr>
-          <p:cNvPicPr>
-            <a:picLocks/>
-          </p:cNvPicPr>
-          <p:nvPr/>
-        </p:nvPicPr>
-        <p:blipFill>
-          <a:blip r:embed="rId4">
-            <a:extLst>
-              <a:ext uri="{28A0092B-C50C-407E-A947-70E740481C1C}">
-                <a14:useLocalDpi xmlns:a14="http://schemas.microsoft.com/office/drawing/2010/main" val="0"/>
-              </a:ext>
-            </a:extLst>
-          </a:blip>
-          <a:stretch>
-            <a:fillRect/>
-          </a:stretch>
-        </p:blipFill>
-        <p:spPr>
-          <a:xfrm>
-            <a:off x="6248400" y="1219200"/>
-            <a:ext cx="5334000" cy="2074333"/>
-          </a:xfrm>
-          <a:prstGeom prst="rect">
-            <a:avLst/>
-          </a:prstGeom>
-          <a:ln w="9525">
-            <a:solidFill>
-              <a:srgbClr val="D1D5DB"/>
-            </a:solidFill>
+      <p:sp>
+        <p:nvSpPr>
+          <p:cNvPr id="6" name="Oval 5">
+            <a:extLst>
+              <a:ext uri="{FF2B5EF4-FFF2-40B4-BE49-F238E27FC236}">
+                <a16:creationId xmlns:a16="http://schemas.microsoft.com/office/drawing/2014/main" id="{A9C5D531-C8ED-7A37-3486-0669E6662FBE}"/>
+              </a:ext>
+            </a:extLst>
+          </p:cNvPr>
+          <p:cNvSpPr/>
+          <p:nvPr/>
+        </p:nvSpPr>
+        <p:spPr>
+          <a:xfrm>
+            <a:off x="609600" y="2082800"/>
+            <a:ext cx="330200" cy="330200"/>
+          </a:xfrm>
+          <a:prstGeom prst="ellipse">
+            <a:avLst/>
+          </a:prstGeom>
+          <a:solidFill>
+            <a:srgbClr val="D9A441"/>
+          </a:solidFill>
+          <a:ln w="19050" cap="flat" cmpd="sng" algn="ctr">
+            <a:noFill/>
+            <a:prstDash val="solid"/>
+            <a:miter lim="800000"/>
           </a:ln>
-        </p:spPr>
-      </p:pic>
-      <p:sp>
-        <p:nvSpPr>
-          <p:cNvPr id="8" name="TextBox 7">
-            <a:extLst>
-              <a:ext uri="{FF2B5EF4-FFF2-40B4-BE49-F238E27FC236}">
-                <a16:creationId xmlns:a16="http://schemas.microsoft.com/office/drawing/2014/main" id="{3F7B5AF6-0799-2482-E39A-2B0002951705}"/>
+          <a:effectLst/>
+          <a:extLst>
+            <a:ext uri="{91240B29-F687-4F45-9708-019B960494DF}">
+              <a14:hiddenLine xmlns:a14="http://schemas.microsoft.com/office/drawing/2010/main" w="19050" cap="flat" cmpd="sng" algn="ctr">
+                <a:solidFill>
+                  <a:schemeClr val="accent1">
+                    <a:shade val="15000"/>
+                  </a:schemeClr>
+                </a:solidFill>
+                <a:prstDash val="solid"/>
+                <a:miter lim="800000"/>
+              </a14:hiddenLine>
+            </a:ext>
+          </a:extLst>
+        </p:spPr>
+        <p:style>
+          <a:lnRef idx="2">
+            <a:schemeClr val="accent1">
+              <a:shade val="15000"/>
+            </a:schemeClr>
+          </a:lnRef>
+          <a:fillRef idx="1">
+            <a:schemeClr val="accent1"/>
+          </a:fillRef>
+          <a:effectRef idx="0">
+            <a:schemeClr val="accent1"/>
+          </a:effectRef>
+          <a:fontRef idx="minor">
+            <a:schemeClr val="lt1"/>
+          </a:fontRef>
+        </p:style>
+        <p:txBody>
+          <a:bodyPr lIns="0" tIns="0" rIns="0" bIns="0" rtlCol="0" anchor="ctr"/>
+          <a:lstStyle/>
+          <a:p>
+            <a:pPr algn="ctr"/>
+            <a:r>
+              <a:rPr lang="en-MY" sz="1170" b="1">
+                <a:solidFill>
+                  <a:srgbClr val="1F2430"/>
+                </a:solidFill>
+                <a:latin typeface="Calibri" panose="020F0502020204030204" pitchFamily="34" charset="0"/>
+              </a:rPr>
+              <a:t>2</a:t>
+            </a:r>
+          </a:p>
+        </p:txBody>
+      </p:sp>
+      <p:sp>
+        <p:nvSpPr>
+          <p:cNvPr id="7" name="TextBox 6">
+            <a:extLst>
+              <a:ext uri="{FF2B5EF4-FFF2-40B4-BE49-F238E27FC236}">
+                <a16:creationId xmlns:a16="http://schemas.microsoft.com/office/drawing/2014/main" id="{9CDAA1BC-700D-EB24-5E07-E5A0A4B021CF}"/>
               </a:ext>
             </a:extLst>
           </p:cNvPr>
@@ -11644,8 +11760,8 @@
         </p:nvSpPr>
         <p:spPr>
           <a:xfrm>
-            <a:off x="6248400" y="4648200"/>
-            <a:ext cx="5334000" cy="300082"/>
+            <a:off x="1066800" y="2057400"/>
+            <a:ext cx="5588000" cy="300082"/>
           </a:xfrm>
           <a:prstGeom prst="rect">
             <a:avLst/>
@@ -11659,13 +11775,59 @@
           <a:lstStyle/>
           <a:p>
             <a:r>
-              <a:rPr lang="en-US" sz="1100">
-                <a:solidFill>
-                  <a:srgbClr val="6B7280"/>
+              <a:rPr lang="en-US" b="1">
+                <a:solidFill>
+                  <a:srgbClr val="1F2430"/>
                 </a:solidFill>
                 <a:latin typeface="Calibri" panose="020F0502020204030204" pitchFamily="34" charset="0"/>
               </a:rPr>
-              <a:t>A scan: the model's reading as reviewer evidence, marked as such - nothing entered the comparison.</a:t>
+              <a:t>Scans read out for the reviewer</a:t>
+            </a:r>
+            <a:endParaRPr lang="en-MY" b="1">
+              <a:solidFill>
+                <a:srgbClr val="1F2430"/>
+              </a:solidFill>
+              <a:latin typeface="Calibri" panose="020F0502020204030204" pitchFamily="34" charset="0"/>
+            </a:endParaRPr>
+          </a:p>
+        </p:txBody>
+      </p:sp>
+      <p:sp>
+        <p:nvSpPr>
+          <p:cNvPr id="8" name="TextBox 7">
+            <a:extLst>
+              <a:ext uri="{FF2B5EF4-FFF2-40B4-BE49-F238E27FC236}">
+                <a16:creationId xmlns:a16="http://schemas.microsoft.com/office/drawing/2014/main" id="{F3910C63-3416-AAF1-BBF6-BECFD56EF6A0}"/>
+              </a:ext>
+            </a:extLst>
+          </p:cNvPr>
+          <p:cNvSpPr txBox="1"/>
+          <p:nvPr/>
+        </p:nvSpPr>
+        <p:spPr>
+          <a:xfrm>
+            <a:off x="1066800" y="2336800"/>
+            <a:ext cx="5588000" cy="300082"/>
+          </a:xfrm>
+          <a:prstGeom prst="rect">
+            <a:avLst/>
+          </a:prstGeom>
+          <a:noFill/>
+        </p:spPr>
+        <p:txBody>
+          <a:bodyPr vert="horz" wrap="square" lIns="0" tIns="0" rIns="0" bIns="0" rtlCol="0" anchor="t">
+            <a:noAutofit/>
+          </a:bodyPr>
+          <a:lstStyle/>
+          <a:p>
+            <a:r>
+              <a:rPr lang="en-US" sz="1100">
+                <a:solidFill>
+                  <a:srgbClr val="6B7280"/>
+                </a:solidFill>
+                <a:latin typeface="Calibri" panose="020F0502020204030204" pitchFamily="34" charset="0"/>
+              </a:rPr>
+              <a:t>An image-only PDF still goes to a person - but with the seven fields already read by the model, marked as evidence, not a verdict.</a:t>
             </a:r>
             <a:endParaRPr lang="en-MY" sz="1100">
               <a:solidFill>
@@ -11678,10 +11840,86 @@
       </p:sp>
       <p:sp>
         <p:nvSpPr>
-          <p:cNvPr id="9" name="TextBox 8">
-            <a:extLst>
-              <a:ext uri="{FF2B5EF4-FFF2-40B4-BE49-F238E27FC236}">
-                <a16:creationId xmlns:a16="http://schemas.microsoft.com/office/drawing/2014/main" id="{905C8990-005D-30D5-982B-011DB0B08EBE}"/>
+          <p:cNvPr id="9" name="Oval 8">
+            <a:extLst>
+              <a:ext uri="{FF2B5EF4-FFF2-40B4-BE49-F238E27FC236}">
+                <a16:creationId xmlns:a16="http://schemas.microsoft.com/office/drawing/2014/main" id="{2641CD8E-D788-FD4B-5222-ACE4099FEEE6}"/>
+              </a:ext>
+            </a:extLst>
+          </p:cNvPr>
+          <p:cNvSpPr/>
+          <p:nvPr/>
+        </p:nvSpPr>
+        <p:spPr>
+          <a:xfrm>
+            <a:off x="609600" y="2946400"/>
+            <a:ext cx="330200" cy="330200"/>
+          </a:xfrm>
+          <a:prstGeom prst="ellipse">
+            <a:avLst/>
+          </a:prstGeom>
+          <a:solidFill>
+            <a:srgbClr val="D9A441"/>
+          </a:solidFill>
+          <a:ln w="19050" cap="flat" cmpd="sng" algn="ctr">
+            <a:noFill/>
+            <a:prstDash val="solid"/>
+            <a:miter lim="800000"/>
+          </a:ln>
+          <a:effectLst/>
+          <a:extLst>
+            <a:ext uri="{91240B29-F687-4F45-9708-019B960494DF}">
+              <a14:hiddenLine xmlns:a14="http://schemas.microsoft.com/office/drawing/2010/main" w="19050" cap="flat" cmpd="sng" algn="ctr">
+                <a:solidFill>
+                  <a:schemeClr val="accent1">
+                    <a:shade val="15000"/>
+                  </a:schemeClr>
+                </a:solidFill>
+                <a:prstDash val="solid"/>
+                <a:miter lim="800000"/>
+              </a14:hiddenLine>
+            </a:ext>
+          </a:extLst>
+        </p:spPr>
+        <p:style>
+          <a:lnRef idx="2">
+            <a:schemeClr val="accent1">
+              <a:shade val="15000"/>
+            </a:schemeClr>
+          </a:lnRef>
+          <a:fillRef idx="1">
+            <a:schemeClr val="accent1"/>
+          </a:fillRef>
+          <a:effectRef idx="0">
+            <a:schemeClr val="accent1"/>
+          </a:effectRef>
+          <a:fontRef idx="minor">
+            <a:schemeClr val="lt1"/>
+          </a:fontRef>
+        </p:style>
+        <p:txBody>
+          <a:bodyPr lIns="0" tIns="0" rIns="0" bIns="0" rtlCol="0" anchor="ctr"/>
+          <a:lstStyle/>
+          <a:p>
+            <a:pPr algn="ctr"/>
+            <a:r>
+              <a:rPr lang="en-MY" sz="1170" b="1">
+                <a:solidFill>
+                  <a:srgbClr val="1F2430"/>
+                </a:solidFill>
+                <a:latin typeface="Calibri" panose="020F0502020204030204" pitchFamily="34" charset="0"/>
+              </a:rPr>
+              <a:t>3</a:t>
+            </a:r>
+          </a:p>
+        </p:txBody>
+      </p:sp>
+      <p:sp>
+        <p:nvSpPr>
+          <p:cNvPr id="10" name="TextBox 9">
+            <a:extLst>
+              <a:ext uri="{FF2B5EF4-FFF2-40B4-BE49-F238E27FC236}">
+                <a16:creationId xmlns:a16="http://schemas.microsoft.com/office/drawing/2014/main" id="{36B2F309-7043-6823-CFA0-172ABBDCC853}"/>
               </a:ext>
             </a:extLst>
           </p:cNvPr>
@@ -11690,8 +11928,8 @@
         </p:nvSpPr>
         <p:spPr>
           <a:xfrm>
-            <a:off x="609600" y="5181600"/>
-            <a:ext cx="10972800" cy="300082"/>
+            <a:off x="1066800" y="2921000"/>
+            <a:ext cx="5588000" cy="300082"/>
           </a:xfrm>
           <a:prstGeom prst="rect">
             <a:avLst/>
@@ -11704,87 +11942,599 @@
           </a:bodyPr>
           <a:lstStyle/>
           <a:p>
-            <a:pPr marL="177800" indent="-177800">
-              <a:spcAft>
-                <a:spcPts val="300"/>
-              </a:spcAft>
-              <a:buClr>
-                <a:srgbClr val="D9A441"/>
-              </a:buClr>
-              <a:buFont typeface="+mj-lt"/>
-              <a:buChar char="•"/>
-            </a:pPr>
-            <a:r>
-              <a:rPr lang="en-US" sz="1150">
+            <a:r>
+              <a:rPr lang="en-US" b="1">
                 <a:solidFill>
                   <a:srgbClr val="1F2430"/>
                 </a:solidFill>
                 <a:latin typeface="Calibri" panose="020F0502020204030204" pitchFamily="34" charset="0"/>
               </a:rPr>
-              <a:t>Correct a single field, with how often this shipper was wrong on it beside the box</a:t>
-            </a:r>
-          </a:p>
-          <a:p>
-            <a:pPr marL="177800" indent="-177800">
-              <a:spcAft>
-                <a:spcPts val="300"/>
-              </a:spcAft>
-              <a:buClr>
-                <a:srgbClr val="D9A441"/>
-              </a:buClr>
-              <a:buFont typeface="+mj-lt"/>
-              <a:buChar char="•"/>
-            </a:pPr>
-            <a:r>
-              <a:rPr lang="en-US" sz="1150">
-                <a:solidFill>
-                  <a:srgbClr val="1F2430"/>
+              <a:t>Shipper history on the field</a:t>
+            </a:r>
+            <a:endParaRPr lang="en-MY" b="1">
+              <a:solidFill>
+                <a:srgbClr val="1F2430"/>
+              </a:solidFill>
+              <a:latin typeface="Calibri" panose="020F0502020204030204" pitchFamily="34" charset="0"/>
+            </a:endParaRPr>
+          </a:p>
+        </p:txBody>
+      </p:sp>
+      <p:sp>
+        <p:nvSpPr>
+          <p:cNvPr id="11" name="TextBox 10">
+            <a:extLst>
+              <a:ext uri="{FF2B5EF4-FFF2-40B4-BE49-F238E27FC236}">
+                <a16:creationId xmlns:a16="http://schemas.microsoft.com/office/drawing/2014/main" id="{17DBB224-D5BB-F090-AADD-C76D84E361A2}"/>
+              </a:ext>
+            </a:extLst>
+          </p:cNvPr>
+          <p:cNvSpPr txBox="1"/>
+          <p:nvPr/>
+        </p:nvSpPr>
+        <p:spPr>
+          <a:xfrm>
+            <a:off x="1066800" y="3200400"/>
+            <a:ext cx="5588000" cy="300082"/>
+          </a:xfrm>
+          <a:prstGeom prst="rect">
+            <a:avLst/>
+          </a:prstGeom>
+          <a:noFill/>
+        </p:spPr>
+        <p:txBody>
+          <a:bodyPr vert="horz" wrap="square" lIns="0" tIns="0" rIns="0" bIns="0" rtlCol="0" anchor="t">
+            <a:noAutofit/>
+          </a:bodyPr>
+          <a:lstStyle/>
+          <a:p>
+            <a:r>
+              <a:rPr lang="en-US" sz="1100">
+                <a:solidFill>
+                  <a:srgbClr val="6B7280"/>
                 </a:solidFill>
                 <a:latin typeface="Calibri" panose="020F0502020204030204" pitchFamily="34" charset="0"/>
               </a:rPr>
-              <a:t>Patterns worth a second look: the same shipper's repeated mistakes, grouped</a:t>
-            </a:r>
-          </a:p>
-          <a:p>
-            <a:pPr marL="177800" indent="-177800">
-              <a:spcAft>
-                <a:spcPts val="300"/>
-              </a:spcAft>
-              <a:buClr>
-                <a:srgbClr val="D9A441"/>
-              </a:buClr>
-              <a:buFont typeface="+mj-lt"/>
-              <a:buChar char="•"/>
-            </a:pPr>
-            <a:r>
-              <a:rPr lang="en-US" sz="1150">
+              <a:t>Correcting a field shows how often this shipper was wrong on that same field before. A count, not a guess.</a:t>
+            </a:r>
+            <a:endParaRPr lang="en-MY" sz="1100">
+              <a:solidFill>
+                <a:srgbClr val="6B7280"/>
+              </a:solidFill>
+              <a:latin typeface="Calibri" panose="020F0502020204030204" pitchFamily="34" charset="0"/>
+            </a:endParaRPr>
+          </a:p>
+        </p:txBody>
+      </p:sp>
+      <p:sp>
+        <p:nvSpPr>
+          <p:cNvPr id="12" name="Oval 11">
+            <a:extLst>
+              <a:ext uri="{FF2B5EF4-FFF2-40B4-BE49-F238E27FC236}">
+                <a16:creationId xmlns:a16="http://schemas.microsoft.com/office/drawing/2014/main" id="{CA55D6EC-49B0-50BF-30B1-1EF9EF6A90C7}"/>
+              </a:ext>
+            </a:extLst>
+          </p:cNvPr>
+          <p:cNvSpPr/>
+          <p:nvPr/>
+        </p:nvSpPr>
+        <p:spPr>
+          <a:xfrm>
+            <a:off x="609600" y="3810000"/>
+            <a:ext cx="330200" cy="330200"/>
+          </a:xfrm>
+          <a:prstGeom prst="ellipse">
+            <a:avLst/>
+          </a:prstGeom>
+          <a:solidFill>
+            <a:srgbClr val="D9A441"/>
+          </a:solidFill>
+          <a:ln w="19050" cap="flat" cmpd="sng" algn="ctr">
+            <a:noFill/>
+            <a:prstDash val="solid"/>
+            <a:miter lim="800000"/>
+          </a:ln>
+          <a:effectLst/>
+          <a:extLst>
+            <a:ext uri="{91240B29-F687-4F45-9708-019B960494DF}">
+              <a14:hiddenLine xmlns:a14="http://schemas.microsoft.com/office/drawing/2010/main" w="19050" cap="flat" cmpd="sng" algn="ctr">
+                <a:solidFill>
+                  <a:schemeClr val="accent1">
+                    <a:shade val="15000"/>
+                  </a:schemeClr>
+                </a:solidFill>
+                <a:prstDash val="solid"/>
+                <a:miter lim="800000"/>
+              </a14:hiddenLine>
+            </a:ext>
+          </a:extLst>
+        </p:spPr>
+        <p:style>
+          <a:lnRef idx="2">
+            <a:schemeClr val="accent1">
+              <a:shade val="15000"/>
+            </a:schemeClr>
+          </a:lnRef>
+          <a:fillRef idx="1">
+            <a:schemeClr val="accent1"/>
+          </a:fillRef>
+          <a:effectRef idx="0">
+            <a:schemeClr val="accent1"/>
+          </a:effectRef>
+          <a:fontRef idx="minor">
+            <a:schemeClr val="lt1"/>
+          </a:fontRef>
+        </p:style>
+        <p:txBody>
+          <a:bodyPr lIns="0" tIns="0" rIns="0" bIns="0" rtlCol="0" anchor="ctr"/>
+          <a:lstStyle/>
+          <a:p>
+            <a:pPr algn="ctr"/>
+            <a:r>
+              <a:rPr lang="en-MY" sz="1170" b="1">
                 <a:solidFill>
                   <a:srgbClr val="1F2430"/>
                 </a:solidFill>
                 <a:latin typeface="Calibri" panose="020F0502020204030204" pitchFamily="34" charset="0"/>
               </a:rPr>
-              <a:t>A reply draft built from the corrected outcome, not the stale one</a:t>
-            </a:r>
-          </a:p>
-          <a:p>
-            <a:pPr marL="177800" indent="-177800">
-              <a:spcAft>
-                <a:spcPts val="300"/>
-              </a:spcAft>
-              <a:buClr>
-                <a:srgbClr val="D9A441"/>
-              </a:buClr>
-              <a:buFont typeface="+mj-lt"/>
-              <a:buChar char="•"/>
-            </a:pPr>
-            <a:r>
-              <a:rPr lang="en-US" sz="1150">
+              <a:t>4</a:t>
+            </a:r>
+          </a:p>
+        </p:txBody>
+      </p:sp>
+      <p:sp>
+        <p:nvSpPr>
+          <p:cNvPr id="13" name="TextBox 12">
+            <a:extLst>
+              <a:ext uri="{FF2B5EF4-FFF2-40B4-BE49-F238E27FC236}">
+                <a16:creationId xmlns:a16="http://schemas.microsoft.com/office/drawing/2014/main" id="{F5AAAE46-66FE-3DDC-9D9C-4E4BC7DF0296}"/>
+              </a:ext>
+            </a:extLst>
+          </p:cNvPr>
+          <p:cNvSpPr txBox="1"/>
+          <p:nvPr/>
+        </p:nvSpPr>
+        <p:spPr>
+          <a:xfrm>
+            <a:off x="1066800" y="3784600"/>
+            <a:ext cx="5588000" cy="300082"/>
+          </a:xfrm>
+          <a:prstGeom prst="rect">
+            <a:avLst/>
+          </a:prstGeom>
+          <a:noFill/>
+        </p:spPr>
+        <p:txBody>
+          <a:bodyPr vert="horz" wrap="square" lIns="0" tIns="0" rIns="0" bIns="0" rtlCol="0" anchor="t">
+            <a:noAutofit/>
+          </a:bodyPr>
+          <a:lstStyle/>
+          <a:p>
+            <a:r>
+              <a:rPr lang="en-US" b="1">
                 <a:solidFill>
                   <a:srgbClr val="1F2430"/>
                 </a:solidFill>
                 <a:latin typeface="Calibri" panose="020F0502020204030204" pitchFamily="34" charset="0"/>
               </a:rPr>
-              <a:t>Every escalation carries the reason and what to do about it</a:t>
+              <a:t>The original, one click away</a:t>
+            </a:r>
+            <a:endParaRPr lang="en-MY" b="1">
+              <a:solidFill>
+                <a:srgbClr val="1F2430"/>
+              </a:solidFill>
+              <a:latin typeface="Calibri" panose="020F0502020204030204" pitchFamily="34" charset="0"/>
+            </a:endParaRPr>
+          </a:p>
+        </p:txBody>
+      </p:sp>
+      <p:sp>
+        <p:nvSpPr>
+          <p:cNvPr id="14" name="TextBox 13">
+            <a:extLst>
+              <a:ext uri="{FF2B5EF4-FFF2-40B4-BE49-F238E27FC236}">
+                <a16:creationId xmlns:a16="http://schemas.microsoft.com/office/drawing/2014/main" id="{085032E0-6489-1F95-FE19-9A5392963135}"/>
+              </a:ext>
+            </a:extLst>
+          </p:cNvPr>
+          <p:cNvSpPr txBox="1"/>
+          <p:nvPr/>
+        </p:nvSpPr>
+        <p:spPr>
+          <a:xfrm>
+            <a:off x="1066800" y="4064000"/>
+            <a:ext cx="5588000" cy="300082"/>
+          </a:xfrm>
+          <a:prstGeom prst="rect">
+            <a:avLst/>
+          </a:prstGeom>
+          <a:noFill/>
+        </p:spPr>
+        <p:txBody>
+          <a:bodyPr vert="horz" wrap="square" lIns="0" tIns="0" rIns="0" bIns="0" rtlCol="0" anchor="t">
+            <a:noAutofit/>
+          </a:bodyPr>
+          <a:lstStyle/>
+          <a:p>
+            <a:r>
+              <a:rPr lang="en-US" sz="1100">
+                <a:solidFill>
+                  <a:srgbClr val="6B7280"/>
+                </a:solidFill>
+                <a:latin typeface="Calibri" panose="020F0502020204030204" pitchFamily="34" charset="0"/>
+              </a:rPr>
+              <a:t>Every value carries its line, and the source document opens beside it.</a:t>
+            </a:r>
+            <a:endParaRPr lang="en-MY" sz="1100">
+              <a:solidFill>
+                <a:srgbClr val="6B7280"/>
+              </a:solidFill>
+              <a:latin typeface="Calibri" panose="020F0502020204030204" pitchFamily="34" charset="0"/>
+            </a:endParaRPr>
+          </a:p>
+        </p:txBody>
+      </p:sp>
+      <p:sp>
+        <p:nvSpPr>
+          <p:cNvPr id="15" name="Oval 14">
+            <a:extLst>
+              <a:ext uri="{FF2B5EF4-FFF2-40B4-BE49-F238E27FC236}">
+                <a16:creationId xmlns:a16="http://schemas.microsoft.com/office/drawing/2014/main" id="{45E3243F-F3BD-96FD-7973-8E668BE1F9CA}"/>
+              </a:ext>
+            </a:extLst>
+          </p:cNvPr>
+          <p:cNvSpPr/>
+          <p:nvPr/>
+        </p:nvSpPr>
+        <p:spPr>
+          <a:xfrm>
+            <a:off x="609600" y="4673600"/>
+            <a:ext cx="330200" cy="330200"/>
+          </a:xfrm>
+          <a:prstGeom prst="ellipse">
+            <a:avLst/>
+          </a:prstGeom>
+          <a:solidFill>
+            <a:srgbClr val="D9A441"/>
+          </a:solidFill>
+          <a:ln w="19050" cap="flat" cmpd="sng" algn="ctr">
+            <a:noFill/>
+            <a:prstDash val="solid"/>
+            <a:miter lim="800000"/>
+          </a:ln>
+          <a:effectLst/>
+          <a:extLst>
+            <a:ext uri="{91240B29-F687-4F45-9708-019B960494DF}">
+              <a14:hiddenLine xmlns:a14="http://schemas.microsoft.com/office/drawing/2010/main" w="19050" cap="flat" cmpd="sng" algn="ctr">
+                <a:solidFill>
+                  <a:schemeClr val="accent1">
+                    <a:shade val="15000"/>
+                  </a:schemeClr>
+                </a:solidFill>
+                <a:prstDash val="solid"/>
+                <a:miter lim="800000"/>
+              </a14:hiddenLine>
+            </a:ext>
+          </a:extLst>
+        </p:spPr>
+        <p:style>
+          <a:lnRef idx="2">
+            <a:schemeClr val="accent1">
+              <a:shade val="15000"/>
+            </a:schemeClr>
+          </a:lnRef>
+          <a:fillRef idx="1">
+            <a:schemeClr val="accent1"/>
+          </a:fillRef>
+          <a:effectRef idx="0">
+            <a:schemeClr val="accent1"/>
+          </a:effectRef>
+          <a:fontRef idx="minor">
+            <a:schemeClr val="lt1"/>
+          </a:fontRef>
+        </p:style>
+        <p:txBody>
+          <a:bodyPr lIns="0" tIns="0" rIns="0" bIns="0" rtlCol="0" anchor="ctr"/>
+          <a:lstStyle/>
+          <a:p>
+            <a:pPr algn="ctr"/>
+            <a:r>
+              <a:rPr lang="en-MY" sz="1170" b="1">
+                <a:solidFill>
+                  <a:srgbClr val="1F2430"/>
+                </a:solidFill>
+                <a:latin typeface="Calibri" panose="020F0502020204030204" pitchFamily="34" charset="0"/>
+              </a:rPr>
+              <a:t>5</a:t>
+            </a:r>
+          </a:p>
+        </p:txBody>
+      </p:sp>
+      <p:sp>
+        <p:nvSpPr>
+          <p:cNvPr id="16" name="TextBox 15">
+            <a:extLst>
+              <a:ext uri="{FF2B5EF4-FFF2-40B4-BE49-F238E27FC236}">
+                <a16:creationId xmlns:a16="http://schemas.microsoft.com/office/drawing/2014/main" id="{E65204F4-DBB9-78AB-2BE7-89739FC41C8D}"/>
+              </a:ext>
+            </a:extLst>
+          </p:cNvPr>
+          <p:cNvSpPr txBox="1"/>
+          <p:nvPr/>
+        </p:nvSpPr>
+        <p:spPr>
+          <a:xfrm>
+            <a:off x="1066800" y="4648200"/>
+            <a:ext cx="5588000" cy="300082"/>
+          </a:xfrm>
+          <a:prstGeom prst="rect">
+            <a:avLst/>
+          </a:prstGeom>
+          <a:noFill/>
+        </p:spPr>
+        <p:txBody>
+          <a:bodyPr vert="horz" wrap="square" lIns="0" tIns="0" rIns="0" bIns="0" rtlCol="0" anchor="t">
+            <a:noAutofit/>
+          </a:bodyPr>
+          <a:lstStyle/>
+          <a:p>
+            <a:r>
+              <a:rPr lang="en-US" b="1">
+                <a:solidFill>
+                  <a:srgbClr val="1F2430"/>
+                </a:solidFill>
+                <a:latin typeface="Calibri" panose="020F0502020204030204" pitchFamily="34" charset="0"/>
+              </a:rPr>
+              <a:t>A reply drafted from the corrected outcome</a:t>
+            </a:r>
+            <a:endParaRPr lang="en-MY" b="1">
+              <a:solidFill>
+                <a:srgbClr val="1F2430"/>
+              </a:solidFill>
+              <a:latin typeface="Calibri" panose="020F0502020204030204" pitchFamily="34" charset="0"/>
+            </a:endParaRPr>
+          </a:p>
+        </p:txBody>
+      </p:sp>
+      <p:sp>
+        <p:nvSpPr>
+          <p:cNvPr id="17" name="TextBox 16">
+            <a:extLst>
+              <a:ext uri="{FF2B5EF4-FFF2-40B4-BE49-F238E27FC236}">
+                <a16:creationId xmlns:a16="http://schemas.microsoft.com/office/drawing/2014/main" id="{C1519ECA-C2B2-426B-F335-8450EFC22E7D}"/>
+              </a:ext>
+            </a:extLst>
+          </p:cNvPr>
+          <p:cNvSpPr txBox="1"/>
+          <p:nvPr/>
+        </p:nvSpPr>
+        <p:spPr>
+          <a:xfrm>
+            <a:off x="1066800" y="4927600"/>
+            <a:ext cx="5588000" cy="300082"/>
+          </a:xfrm>
+          <a:prstGeom prst="rect">
+            <a:avLst/>
+          </a:prstGeom>
+          <a:noFill/>
+        </p:spPr>
+        <p:txBody>
+          <a:bodyPr vert="horz" wrap="square" lIns="0" tIns="0" rIns="0" bIns="0" rtlCol="0" anchor="t">
+            <a:noAutofit/>
+          </a:bodyPr>
+          <a:lstStyle/>
+          <a:p>
+            <a:r>
+              <a:rPr lang="en-US" sz="1100">
+                <a:solidFill>
+                  <a:srgbClr val="6B7280"/>
+                </a:solidFill>
+                <a:latin typeface="Calibri" panose="020F0502020204030204" pitchFamily="34" charset="0"/>
+              </a:rPr>
+              <a:t>Subject and body ready, built from what the reviewer decided - not the stale answer. A person still presses send.</a:t>
+            </a:r>
+            <a:endParaRPr lang="en-MY" sz="1100">
+              <a:solidFill>
+                <a:srgbClr val="6B7280"/>
+              </a:solidFill>
+              <a:latin typeface="Calibri" panose="020F0502020204030204" pitchFamily="34" charset="0"/>
+            </a:endParaRPr>
+          </a:p>
+        </p:txBody>
+      </p:sp>
+      <p:pic>
+        <p:nvPicPr>
+          <p:cNvPr id="19" name="Picture 18">
+            <a:extLst>
+              <a:ext uri="{FF2B5EF4-FFF2-40B4-BE49-F238E27FC236}">
+                <a16:creationId xmlns:a16="http://schemas.microsoft.com/office/drawing/2014/main" id="{D7B028DE-82FE-871B-D738-3DB358EBECAA}"/>
+              </a:ext>
+            </a:extLst>
+          </p:cNvPr>
+          <p:cNvPicPr>
+            <a:picLocks/>
+          </p:cNvPicPr>
+          <p:nvPr/>
+        </p:nvPicPr>
+        <p:blipFill>
+          <a:blip r:embed="rId3">
+            <a:extLst>
+              <a:ext uri="{28A0092B-C50C-407E-A947-70E740481C1C}">
+                <a14:useLocalDpi xmlns:a14="http://schemas.microsoft.com/office/drawing/2010/main" val="0"/>
+              </a:ext>
+            </a:extLst>
+          </a:blip>
+          <a:stretch>
+            <a:fillRect/>
+          </a:stretch>
+        </p:blipFill>
+        <p:spPr>
+          <a:xfrm>
+            <a:off x="6858000" y="1219200"/>
+            <a:ext cx="4724400" cy="1837267"/>
+          </a:xfrm>
+          <a:prstGeom prst="rect">
+            <a:avLst/>
+          </a:prstGeom>
+          <a:ln w="9525">
+            <a:solidFill>
+              <a:srgbClr val="D1D5DB"/>
+            </a:solidFill>
+          </a:ln>
+        </p:spPr>
+      </p:pic>
+      <p:sp>
+        <p:nvSpPr>
+          <p:cNvPr id="20" name="TextBox 19">
+            <a:extLst>
+              <a:ext uri="{FF2B5EF4-FFF2-40B4-BE49-F238E27FC236}">
+                <a16:creationId xmlns:a16="http://schemas.microsoft.com/office/drawing/2014/main" id="{87AE7AD1-426C-4D04-DA2F-1AD46E680297}"/>
+              </a:ext>
+            </a:extLst>
+          </p:cNvPr>
+          <p:cNvSpPr txBox="1"/>
+          <p:nvPr/>
+        </p:nvSpPr>
+        <p:spPr>
+          <a:xfrm>
+            <a:off x="6858000" y="4318000"/>
+            <a:ext cx="4724400" cy="300082"/>
+          </a:xfrm>
+          <a:prstGeom prst="rect">
+            <a:avLst/>
+          </a:prstGeom>
+          <a:noFill/>
+        </p:spPr>
+        <p:txBody>
+          <a:bodyPr vert="horz" wrap="square" lIns="0" tIns="0" rIns="0" bIns="0" rtlCol="0" anchor="t">
+            <a:noAutofit/>
+          </a:bodyPr>
+          <a:lstStyle/>
+          <a:p>
+            <a:r>
+              <a:rPr lang="en-US" sz="1050">
+                <a:solidFill>
+                  <a:srgbClr val="6B7280"/>
+                </a:solidFill>
+                <a:latin typeface="Calibri" panose="020F0502020204030204" pitchFamily="34" charset="0"/>
+              </a:rPr>
+              <a:t>The scan read-out, as the reviewer sees it: seven fields, the model's confidence, and the sentence that none of it entered the comparison.</a:t>
+            </a:r>
+            <a:endParaRPr lang="en-MY" sz="1050">
+              <a:solidFill>
+                <a:srgbClr val="6B7280"/>
+              </a:solidFill>
+              <a:latin typeface="Calibri" panose="020F0502020204030204" pitchFamily="34" charset="0"/>
+            </a:endParaRPr>
+          </a:p>
+        </p:txBody>
+      </p:sp>
+      <p:sp>
+        <p:nvSpPr>
+          <p:cNvPr id="21" name="Rectangle: Rounded Corners 20">
+            <a:extLst>
+              <a:ext uri="{FF2B5EF4-FFF2-40B4-BE49-F238E27FC236}">
+                <a16:creationId xmlns:a16="http://schemas.microsoft.com/office/drawing/2014/main" id="{51FF6AE3-08E3-2176-ACCF-E61549E5E729}"/>
+              </a:ext>
+            </a:extLst>
+          </p:cNvPr>
+          <p:cNvSpPr/>
+          <p:nvPr/>
+        </p:nvSpPr>
+        <p:spPr>
+          <a:xfrm>
+            <a:off x="609600" y="5588000"/>
+            <a:ext cx="10972800" cy="508000"/>
+          </a:xfrm>
+          <a:prstGeom prst="roundRect">
+            <a:avLst>
+              <a:gd name="adj" fmla="val 15000"/>
+            </a:avLst>
+          </a:prstGeom>
+          <a:solidFill>
+            <a:srgbClr val="FFF4E0"/>
+          </a:solidFill>
+          <a:ln w="19050" cap="flat" cmpd="sng" algn="ctr">
+            <a:noFill/>
+            <a:prstDash val="solid"/>
+            <a:miter lim="800000"/>
+          </a:ln>
+          <a:effectLst/>
+          <a:extLst>
+            <a:ext uri="{91240B29-F687-4F45-9708-019B960494DF}">
+              <a14:hiddenLine xmlns:a14="http://schemas.microsoft.com/office/drawing/2010/main" w="19050" cap="flat" cmpd="sng" algn="ctr">
+                <a:solidFill>
+                  <a:schemeClr val="accent1">
+                    <a:shade val="15000"/>
+                  </a:schemeClr>
+                </a:solidFill>
+                <a:prstDash val="solid"/>
+                <a:miter lim="800000"/>
+              </a14:hiddenLine>
+            </a:ext>
+          </a:extLst>
+        </p:spPr>
+        <p:style>
+          <a:lnRef idx="2">
+            <a:schemeClr val="accent1">
+              <a:shade val="15000"/>
+            </a:schemeClr>
+          </a:lnRef>
+          <a:fillRef idx="1">
+            <a:schemeClr val="accent1"/>
+          </a:fillRef>
+          <a:effectRef idx="0">
+            <a:schemeClr val="accent1"/>
+          </a:effectRef>
+          <a:fontRef idx="minor">
+            <a:schemeClr val="lt1"/>
+          </a:fontRef>
+        </p:style>
+        <p:txBody>
+          <a:bodyPr rtlCol="0" anchor="ctr"/>
+          <a:lstStyle/>
+          <a:p>
+            <a:pPr algn="ctr"/>
+            <a:endParaRPr lang="en-MY"/>
+          </a:p>
+        </p:txBody>
+      </p:sp>
+      <p:sp>
+        <p:nvSpPr>
+          <p:cNvPr id="22" name="TextBox 21">
+            <a:extLst>
+              <a:ext uri="{FF2B5EF4-FFF2-40B4-BE49-F238E27FC236}">
+                <a16:creationId xmlns:a16="http://schemas.microsoft.com/office/drawing/2014/main" id="{04749409-1CF9-4C9C-993A-6609C9CD1D78}"/>
+              </a:ext>
+            </a:extLst>
+          </p:cNvPr>
+          <p:cNvSpPr txBox="1"/>
+          <p:nvPr/>
+        </p:nvSpPr>
+        <p:spPr>
+          <a:xfrm>
+            <a:off x="812800" y="5664200"/>
+            <a:ext cx="10566400" cy="300082"/>
+          </a:xfrm>
+          <a:prstGeom prst="rect">
+            <a:avLst/>
+          </a:prstGeom>
+          <a:noFill/>
+        </p:spPr>
+        <p:txBody>
+          <a:bodyPr vert="horz" wrap="square" lIns="0" tIns="0" rIns="0" bIns="0" rtlCol="0" anchor="ctr">
+            <a:noAutofit/>
+          </a:bodyPr>
+          <a:lstStyle/>
+          <a:p>
+            <a:r>
+              <a:rPr lang="en-US" sz="1150">
+                <a:solidFill>
+                  <a:srgbClr val="1F2430"/>
+                </a:solidFill>
+                <a:latin typeface="Calibri" panose="020F0502020204030204" pitchFamily="34" charset="0"/>
+              </a:rPr>
+              <a:t>Every flag carries the line it came from. Every escalation carries the reason and what to do about it. Most teams at this stage meet the brief; these are the things a reviewer actually uses.</a:t>
             </a:r>
             <a:endParaRPr lang="en-MY" sz="1150">
               <a:solidFill>
@@ -11797,10 +12547,10 @@
       </p:sp>
       <p:sp>
         <p:nvSpPr>
-          <p:cNvPr id="10" name="TextBox 9">
-            <a:extLst>
-              <a:ext uri="{FF2B5EF4-FFF2-40B4-BE49-F238E27FC236}">
-                <a16:creationId xmlns:a16="http://schemas.microsoft.com/office/drawing/2014/main" id="{81C2AD9A-F560-794F-4852-F9A2F3A9A529}"/>
+          <p:cNvPr id="23" name="TextBox 22">
+            <a:extLst>
+              <a:ext uri="{FF2B5EF4-FFF2-40B4-BE49-F238E27FC236}">
+                <a16:creationId xmlns:a16="http://schemas.microsoft.com/office/drawing/2014/main" id="{4B46A69B-E70D-0C8E-D9B8-24161E95C137}"/>
               </a:ext>
             </a:extLst>
           </p:cNvPr>
@@ -11845,7 +12595,7 @@
     </p:spTree>
     <p:extLst>
       <p:ext uri="{BB962C8B-B14F-4D97-AF65-F5344CB8AC3E}">
-        <p14:creationId xmlns:p14="http://schemas.microsoft.com/office/powerpoint/2010/main" val="2021327142"/>
+        <p14:creationId xmlns:p14="http://schemas.microsoft.com/office/powerpoint/2010/main" val="2596078402"/>
       </p:ext>
     </p:extLst>
   </p:cSld>
@@ -11885,7 +12635,7 @@
           <p:cNvPr id="2" name="TextBox 1">
             <a:extLst>
               <a:ext uri="{FF2B5EF4-FFF2-40B4-BE49-F238E27FC236}">
-                <a16:creationId xmlns:a16="http://schemas.microsoft.com/office/drawing/2014/main" id="{4A2FE522-F611-302F-BE1C-753F6ECC4044}"/>
+                <a16:creationId xmlns:a16="http://schemas.microsoft.com/office/drawing/2014/main" id="{D4F84BD4-CA6D-DD44-CEB0-727AE5B5BD7B}"/>
               </a:ext>
             </a:extLst>
           </p:cNvPr>
@@ -11931,7 +12681,7 @@
           <p:cNvPr id="3" name="Rectangle: Rounded Corners 2">
             <a:extLst>
               <a:ext uri="{FF2B5EF4-FFF2-40B4-BE49-F238E27FC236}">
-                <a16:creationId xmlns:a16="http://schemas.microsoft.com/office/drawing/2014/main" id="{D4D8DE76-4DF3-842D-1898-15B878C78BBF}"/>
+                <a16:creationId xmlns:a16="http://schemas.microsoft.com/office/drawing/2014/main" id="{14D35C28-96BC-FDDE-A400-9A38795C4C6B}"/>
               </a:ext>
             </a:extLst>
           </p:cNvPr>
@@ -12001,7 +12751,7 @@
           <p:cNvPr id="4" name="TextBox 3">
             <a:extLst>
               <a:ext uri="{FF2B5EF4-FFF2-40B4-BE49-F238E27FC236}">
-                <a16:creationId xmlns:a16="http://schemas.microsoft.com/office/drawing/2014/main" id="{C9141647-3370-6A65-7570-B7CA95625640}"/>
+                <a16:creationId xmlns:a16="http://schemas.microsoft.com/office/drawing/2014/main" id="{C1B49AE9-D6C8-5B0A-85D8-2130E8BBABE0}"/>
               </a:ext>
             </a:extLst>
           </p:cNvPr>
@@ -12041,7 +12791,7 @@
           <p:cNvPr id="5" name="TextBox 4">
             <a:extLst>
               <a:ext uri="{FF2B5EF4-FFF2-40B4-BE49-F238E27FC236}">
-                <a16:creationId xmlns:a16="http://schemas.microsoft.com/office/drawing/2014/main" id="{03696699-9FAB-FA2F-96B5-CDFFD66FD227}"/>
+                <a16:creationId xmlns:a16="http://schemas.microsoft.com/office/drawing/2014/main" id="{D180FBA5-E946-8E47-2878-B0B147F0E73A}"/>
               </a:ext>
             </a:extLst>
           </p:cNvPr>
@@ -12082,7 +12832,7 @@
           <p:cNvPr id="6" name="TextBox 5">
             <a:extLst>
               <a:ext uri="{FF2B5EF4-FFF2-40B4-BE49-F238E27FC236}">
-                <a16:creationId xmlns:a16="http://schemas.microsoft.com/office/drawing/2014/main" id="{C46D364B-E195-B359-B1E6-15C66987DF62}"/>
+                <a16:creationId xmlns:a16="http://schemas.microsoft.com/office/drawing/2014/main" id="{852ED602-2886-7D3D-029A-2E800583FAE8}"/>
               </a:ext>
             </a:extLst>
           </p:cNvPr>
@@ -12122,7 +12872,7 @@
           <p:cNvPr id="7" name="TextBox 6">
             <a:extLst>
               <a:ext uri="{FF2B5EF4-FFF2-40B4-BE49-F238E27FC236}">
-                <a16:creationId xmlns:a16="http://schemas.microsoft.com/office/drawing/2014/main" id="{4E417D21-E64B-FE73-E299-83E3539011A9}"/>
+                <a16:creationId xmlns:a16="http://schemas.microsoft.com/office/drawing/2014/main" id="{6AF2C088-8D31-CF3D-EF81-7421717E9CC3}"/>
               </a:ext>
             </a:extLst>
           </p:cNvPr>
@@ -12168,7 +12918,7 @@
           <p:cNvPr id="8" name="TextBox 7">
             <a:extLst>
               <a:ext uri="{FF2B5EF4-FFF2-40B4-BE49-F238E27FC236}">
-                <a16:creationId xmlns:a16="http://schemas.microsoft.com/office/drawing/2014/main" id="{3B9E32D3-E922-CC74-678F-6DB72E372B69}"/>
+                <a16:creationId xmlns:a16="http://schemas.microsoft.com/office/drawing/2014/main" id="{E6FA07E7-9ED3-88B7-0A23-7C74EB3913BC}"/>
               </a:ext>
             </a:extLst>
           </p:cNvPr>
@@ -12214,7 +12964,7 @@
           <p:cNvPr id="9" name="TextBox 8">
             <a:extLst>
               <a:ext uri="{FF2B5EF4-FFF2-40B4-BE49-F238E27FC236}">
-                <a16:creationId xmlns:a16="http://schemas.microsoft.com/office/drawing/2014/main" id="{F0E37033-327A-CFB9-335A-B550E1FE606B}"/>
+                <a16:creationId xmlns:a16="http://schemas.microsoft.com/office/drawing/2014/main" id="{082C4F84-0129-0A85-BBC8-80F88CE739CE}"/>
               </a:ext>
             </a:extLst>
           </p:cNvPr>
@@ -12260,7 +13010,7 @@
           <p:cNvPr id="10" name="Table 9">
             <a:extLst>
               <a:ext uri="{FF2B5EF4-FFF2-40B4-BE49-F238E27FC236}">
-                <a16:creationId xmlns:a16="http://schemas.microsoft.com/office/drawing/2014/main" id="{CF6B7342-722B-41E9-B537-0AF512BAD039}"/>
+                <a16:creationId xmlns:a16="http://schemas.microsoft.com/office/drawing/2014/main" id="{FAAD3784-CD8C-E73B-1625-194C9ECE5FD1}"/>
               </a:ext>
             </a:extLst>
           </p:cNvPr>
@@ -12270,7 +13020,7 @@
           <p:nvPr>
             <p:extLst>
               <p:ext uri="{D42A27DB-BD31-4B8C-83A1-F6EECF244321}">
-                <p14:modId xmlns:p14="http://schemas.microsoft.com/office/powerpoint/2010/main" val="2033717764"/>
+                <p14:modId xmlns:p14="http://schemas.microsoft.com/office/powerpoint/2010/main" val="67259051"/>
               </p:ext>
             </p:extLst>
           </p:nvPr>
@@ -12289,21 +13039,21 @@
                 <a:gridCol w="1905000">
                   <a:extLst>
                     <a:ext uri="{9D8B030D-6E8A-4147-A177-3AD203B41FA5}">
-                      <a16:colId xmlns:a16="http://schemas.microsoft.com/office/drawing/2014/main" val="1864668623"/>
+                      <a16:colId xmlns:a16="http://schemas.microsoft.com/office/drawing/2014/main" val="1415162259"/>
                     </a:ext>
                   </a:extLst>
                 </a:gridCol>
                 <a:gridCol w="2413000">
                   <a:extLst>
                     <a:ext uri="{9D8B030D-6E8A-4147-A177-3AD203B41FA5}">
-                      <a16:colId xmlns:a16="http://schemas.microsoft.com/office/drawing/2014/main" val="3511986980"/>
+                      <a16:colId xmlns:a16="http://schemas.microsoft.com/office/drawing/2014/main" val="1375915125"/>
                     </a:ext>
                   </a:extLst>
                 </a:gridCol>
                 <a:gridCol w="2032000">
                   <a:extLst>
                     <a:ext uri="{9D8B030D-6E8A-4147-A177-3AD203B41FA5}">
-                      <a16:colId xmlns:a16="http://schemas.microsoft.com/office/drawing/2014/main" val="1041118216"/>
+                      <a16:colId xmlns:a16="http://schemas.microsoft.com/office/drawing/2014/main" val="4199924233"/>
                     </a:ext>
                   </a:extLst>
                 </a:gridCol>
@@ -12377,7 +13127,7 @@
                 </a:tc>
                 <a:extLst>
                   <a:ext uri="{0D108BD9-81ED-4DB2-BD59-A6C34878D82A}">
-                    <a16:rowId xmlns:a16="http://schemas.microsoft.com/office/drawing/2014/main" val="3763817224"/>
+                    <a16:rowId xmlns:a16="http://schemas.microsoft.com/office/drawing/2014/main" val="361054233"/>
                   </a:ext>
                 </a:extLst>
               </a:tr>
@@ -12462,7 +13212,7 @@
                 </a:tc>
                 <a:extLst>
                   <a:ext uri="{0D108BD9-81ED-4DB2-BD59-A6C34878D82A}">
-                    <a16:rowId xmlns:a16="http://schemas.microsoft.com/office/drawing/2014/main" val="1148197845"/>
+                    <a16:rowId xmlns:a16="http://schemas.microsoft.com/office/drawing/2014/main" val="2959678648"/>
                   </a:ext>
                 </a:extLst>
               </a:tr>
@@ -12541,7 +13291,7 @@
                 </a:tc>
                 <a:extLst>
                   <a:ext uri="{0D108BD9-81ED-4DB2-BD59-A6C34878D82A}">
-                    <a16:rowId xmlns:a16="http://schemas.microsoft.com/office/drawing/2014/main" val="1774220442"/>
+                    <a16:rowId xmlns:a16="http://schemas.microsoft.com/office/drawing/2014/main" val="568926261"/>
                   </a:ext>
                 </a:extLst>
               </a:tr>
@@ -12620,7 +13370,7 @@
                 </a:tc>
                 <a:extLst>
                   <a:ext uri="{0D108BD9-81ED-4DB2-BD59-A6C34878D82A}">
-                    <a16:rowId xmlns:a16="http://schemas.microsoft.com/office/drawing/2014/main" val="541968793"/>
+                    <a16:rowId xmlns:a16="http://schemas.microsoft.com/office/drawing/2014/main" val="2167205588"/>
                   </a:ext>
                 </a:extLst>
               </a:tr>
@@ -12633,7 +13383,7 @@
           <p:cNvPr id="11" name="Rectangle: Rounded Corners 10">
             <a:extLst>
               <a:ext uri="{FF2B5EF4-FFF2-40B4-BE49-F238E27FC236}">
-                <a16:creationId xmlns:a16="http://schemas.microsoft.com/office/drawing/2014/main" id="{EEC6087C-8985-CCAD-000E-ACDA3A050384}"/>
+                <a16:creationId xmlns:a16="http://schemas.microsoft.com/office/drawing/2014/main" id="{FDD5AE3E-7485-7FE6-35CB-972C69FB3EBB}"/>
               </a:ext>
             </a:extLst>
           </p:cNvPr>
@@ -12703,7 +13453,7 @@
           <p:cNvPr id="12" name="TextBox 11">
             <a:extLst>
               <a:ext uri="{FF2B5EF4-FFF2-40B4-BE49-F238E27FC236}">
-                <a16:creationId xmlns:a16="http://schemas.microsoft.com/office/drawing/2014/main" id="{59FD35A6-6EF0-EBC2-32D7-BA169543B696}"/>
+                <a16:creationId xmlns:a16="http://schemas.microsoft.com/office/drawing/2014/main" id="{BC72DD2B-6904-FEC6-991A-D600661159FB}"/>
               </a:ext>
             </a:extLst>
           </p:cNvPr>
@@ -12743,7 +13493,7 @@
           <p:cNvPr id="13" name="Oval 12">
             <a:extLst>
               <a:ext uri="{FF2B5EF4-FFF2-40B4-BE49-F238E27FC236}">
-                <a16:creationId xmlns:a16="http://schemas.microsoft.com/office/drawing/2014/main" id="{B91493BB-16BA-1486-4D6C-1AAA9162C332}"/>
+                <a16:creationId xmlns:a16="http://schemas.microsoft.com/office/drawing/2014/main" id="{1C9E7BD2-7DAC-E8DA-303B-83B78E631E0F}"/>
               </a:ext>
             </a:extLst>
           </p:cNvPr>
@@ -12819,7 +13569,7 @@
           <p:cNvPr id="14" name="TextBox 13">
             <a:extLst>
               <a:ext uri="{FF2B5EF4-FFF2-40B4-BE49-F238E27FC236}">
-                <a16:creationId xmlns:a16="http://schemas.microsoft.com/office/drawing/2014/main" id="{E172F4AB-343A-0A9E-2E95-08B28F22FC7F}"/>
+                <a16:creationId xmlns:a16="http://schemas.microsoft.com/office/drawing/2014/main" id="{5B379FDB-4825-4C63-15DB-DFFD6141B638}"/>
               </a:ext>
             </a:extLst>
           </p:cNvPr>
@@ -12859,7 +13609,7 @@
           <p:cNvPr id="15" name="TextBox 14">
             <a:extLst>
               <a:ext uri="{FF2B5EF4-FFF2-40B4-BE49-F238E27FC236}">
-                <a16:creationId xmlns:a16="http://schemas.microsoft.com/office/drawing/2014/main" id="{1F0F8F5A-5E63-E8A7-4D99-87D2DC71D2CB}"/>
+                <a16:creationId xmlns:a16="http://schemas.microsoft.com/office/drawing/2014/main" id="{3D8B4E7E-0C81-4C8E-905F-0B0B1F180CCC}"/>
               </a:ext>
             </a:extLst>
           </p:cNvPr>
@@ -12905,7 +13655,7 @@
           <p:cNvPr id="16" name="Oval 15">
             <a:extLst>
               <a:ext uri="{FF2B5EF4-FFF2-40B4-BE49-F238E27FC236}">
-                <a16:creationId xmlns:a16="http://schemas.microsoft.com/office/drawing/2014/main" id="{8BAD0236-6D9B-08CA-C7F9-3D147D5948D2}"/>
+                <a16:creationId xmlns:a16="http://schemas.microsoft.com/office/drawing/2014/main" id="{E3E4FE72-245A-7029-1621-C3FC2A00496F}"/>
               </a:ext>
             </a:extLst>
           </p:cNvPr>
@@ -12981,7 +13731,7 @@
           <p:cNvPr id="17" name="TextBox 16">
             <a:extLst>
               <a:ext uri="{FF2B5EF4-FFF2-40B4-BE49-F238E27FC236}">
-                <a16:creationId xmlns:a16="http://schemas.microsoft.com/office/drawing/2014/main" id="{0FEA2C60-BA41-B0E2-A9F0-1490AE3D8714}"/>
+                <a16:creationId xmlns:a16="http://schemas.microsoft.com/office/drawing/2014/main" id="{9B39274F-859B-89CA-E981-525B0B112806}"/>
               </a:ext>
             </a:extLst>
           </p:cNvPr>
@@ -13027,7 +13777,7 @@
           <p:cNvPr id="18" name="TextBox 17">
             <a:extLst>
               <a:ext uri="{FF2B5EF4-FFF2-40B4-BE49-F238E27FC236}">
-                <a16:creationId xmlns:a16="http://schemas.microsoft.com/office/drawing/2014/main" id="{FE9250AF-7927-00C9-3905-A417BE391D9E}"/>
+                <a16:creationId xmlns:a16="http://schemas.microsoft.com/office/drawing/2014/main" id="{05EF6F5D-2A52-6EEF-87BB-C89164CAB1B1}"/>
               </a:ext>
             </a:extLst>
           </p:cNvPr>
@@ -13073,7 +13823,7 @@
           <p:cNvPr id="19" name="Oval 18">
             <a:extLst>
               <a:ext uri="{FF2B5EF4-FFF2-40B4-BE49-F238E27FC236}">
-                <a16:creationId xmlns:a16="http://schemas.microsoft.com/office/drawing/2014/main" id="{536CE384-5F4A-FDB5-D73C-D6B28684C82B}"/>
+                <a16:creationId xmlns:a16="http://schemas.microsoft.com/office/drawing/2014/main" id="{0C4AB10C-676E-8543-00AF-F111C5D7EF3F}"/>
               </a:ext>
             </a:extLst>
           </p:cNvPr>
@@ -13149,7 +13899,7 @@
           <p:cNvPr id="20" name="TextBox 19">
             <a:extLst>
               <a:ext uri="{FF2B5EF4-FFF2-40B4-BE49-F238E27FC236}">
-                <a16:creationId xmlns:a16="http://schemas.microsoft.com/office/drawing/2014/main" id="{26CDB9FD-3B0F-10A4-31D4-AE4779B70913}"/>
+                <a16:creationId xmlns:a16="http://schemas.microsoft.com/office/drawing/2014/main" id="{47A67589-3FF5-5FB0-B389-E299FDCB5DFA}"/>
               </a:ext>
             </a:extLst>
           </p:cNvPr>
@@ -13189,7 +13939,7 @@
           <p:cNvPr id="21" name="TextBox 20">
             <a:extLst>
               <a:ext uri="{FF2B5EF4-FFF2-40B4-BE49-F238E27FC236}">
-                <a16:creationId xmlns:a16="http://schemas.microsoft.com/office/drawing/2014/main" id="{3F9AEF3F-9996-1D32-FA64-A9872CE10E1E}"/>
+                <a16:creationId xmlns:a16="http://schemas.microsoft.com/office/drawing/2014/main" id="{645290EE-B362-CD2F-794A-5C18E1D36B6E}"/>
               </a:ext>
             </a:extLst>
           </p:cNvPr>
@@ -13235,7 +13985,7 @@
           <p:cNvPr id="22" name="TextBox 21">
             <a:extLst>
               <a:ext uri="{FF2B5EF4-FFF2-40B4-BE49-F238E27FC236}">
-                <a16:creationId xmlns:a16="http://schemas.microsoft.com/office/drawing/2014/main" id="{9121A0B2-6757-9C81-9501-D2E791590572}"/>
+                <a16:creationId xmlns:a16="http://schemas.microsoft.com/office/drawing/2014/main" id="{119025DA-FC0B-AAF1-B955-7410E0AB95DA}"/>
               </a:ext>
             </a:extLst>
           </p:cNvPr>
@@ -13281,7 +14031,7 @@
           <p:cNvPr id="23" name="TextBox 22">
             <a:extLst>
               <a:ext uri="{FF2B5EF4-FFF2-40B4-BE49-F238E27FC236}">
-                <a16:creationId xmlns:a16="http://schemas.microsoft.com/office/drawing/2014/main" id="{D12304D8-CDD5-CC4F-D847-64B094B61E40}"/>
+                <a16:creationId xmlns:a16="http://schemas.microsoft.com/office/drawing/2014/main" id="{EA1E6289-F853-5D8B-0D3D-56F270878E4A}"/>
               </a:ext>
             </a:extLst>
           </p:cNvPr>
@@ -13320,7 +14070,7 @@
     </p:spTree>
     <p:extLst>
       <p:ext uri="{BB962C8B-B14F-4D97-AF65-F5344CB8AC3E}">
-        <p14:creationId xmlns:p14="http://schemas.microsoft.com/office/powerpoint/2010/main" val="374981556"/>
+        <p14:creationId xmlns:p14="http://schemas.microsoft.com/office/powerpoint/2010/main" val="1732380028"/>
       </p:ext>
     </p:extLst>
   </p:cSld>

</xml_diff>

<commit_message>
docs(final): status for 25 Sep night, deck re-captured from a model run, 646 tests quoted everywhere
- STATUS.md: tonight's entry (Before/With, corrections on the card, the
  filter card, folded panels, alignment pass, deck); the 92% bullet now
  reads "114 of 124 SI/BL pairs", with the miscount noted.
- PITCH_DAY.md: eight-step demo order with the on-card correction and the
  email_506 sample re-check; unit-mismatch and 92% answers.
- Deck: run_page / scan_case / scan_case_crop re-captured in the light
  theme at 1440x900 from run_000003 (model tier); Sentinel-final-pitch
  .pptx / .pdf rebuilt by scripts/build_pitch_deck.ps1.
- README, ADVERSARIAL, PITCH_DECK, VIDEO_NARRATION, VIDEO_SCRIPT: the
  quoted suite is 646 tests / 504 passed.

Co-Authored-By: Claude Fable 5.1 <noreply@anthropic.com>
</commit_message>
<xml_diff>
--- a/docs/Sentinel-final-pitch.pptx
+++ b/docs/Sentinel-final-pitch.pptx
@@ -199,9 +199,9 @@
             </a:lvl1pPr>
           </a:lstStyle>
           <a:p>
-            <a:fld id="{592D12D2-935B-49E8-BF1E-3F0C487C06CE}" type="datetimeFigureOut">
+            <a:fld id="{C4464093-04F1-4DE5-AE18-503D8D710CF4}" type="datetimeFigureOut">
               <a:rPr lang="en-MY" smtClean="0"/>
-              <a:t>24/9/2026</a:t>
+              <a:t>25/9/2026</a:t>
             </a:fld>
             <a:endParaRPr lang="en-MY"/>
           </a:p>
@@ -358,7 +358,7 @@
             </a:lvl1pPr>
           </a:lstStyle>
           <a:p>
-            <a:fld id="{21F61A80-68B1-422B-9D68-85FD71C666C5}" type="slidenum">
+            <a:fld id="{31CE5959-8D78-4F7D-90FC-9D0056708953}" type="slidenum">
               <a:rPr lang="en-MY" smtClean="0"/>
               <a:t>‹#›</a:t>
             </a:fld>
@@ -369,7 +369,7 @@
     </p:spTree>
     <p:extLst>
       <p:ext uri="{BB962C8B-B14F-4D97-AF65-F5344CB8AC3E}">
-        <p14:creationId xmlns:p14="http://schemas.microsoft.com/office/powerpoint/2010/main" val="1018011492"/>
+        <p14:creationId xmlns:p14="http://schemas.microsoft.com/office/powerpoint/2010/main" val="2233926280"/>
       </p:ext>
     </p:extLst>
   </p:cSld>
@@ -536,7 +536,7 @@
           <a:bodyPr/>
           <a:lstStyle/>
           <a:p>
-            <a:fld id="{21F61A80-68B1-422B-9D68-85FD71C666C5}" type="slidenum">
+            <a:fld id="{31CE5959-8D78-4F7D-90FC-9D0056708953}" type="slidenum">
               <a:rPr lang="en-MY" smtClean="0"/>
               <a:t>1</a:t>
             </a:fld>
@@ -547,7 +547,7 @@
     </p:spTree>
     <p:extLst>
       <p:ext uri="{BB962C8B-B14F-4D97-AF65-F5344CB8AC3E}">
-        <p14:creationId xmlns:p14="http://schemas.microsoft.com/office/powerpoint/2010/main" val="4291143848"/>
+        <p14:creationId xmlns:p14="http://schemas.microsoft.com/office/powerpoint/2010/main" val="3951941528"/>
       </p:ext>
     </p:extLst>
   </p:cSld>
@@ -624,7 +624,7 @@
           <a:bodyPr/>
           <a:lstStyle/>
           <a:p>
-            <a:fld id="{21F61A80-68B1-422B-9D68-85FD71C666C5}" type="slidenum">
+            <a:fld id="{31CE5959-8D78-4F7D-90FC-9D0056708953}" type="slidenum">
               <a:rPr lang="en-MY" smtClean="0"/>
               <a:t>10</a:t>
             </a:fld>
@@ -635,7 +635,7 @@
     </p:spTree>
     <p:extLst>
       <p:ext uri="{BB962C8B-B14F-4D97-AF65-F5344CB8AC3E}">
-        <p14:creationId xmlns:p14="http://schemas.microsoft.com/office/powerpoint/2010/main" val="4257150790"/>
+        <p14:creationId xmlns:p14="http://schemas.microsoft.com/office/powerpoint/2010/main" val="2661622829"/>
       </p:ext>
     </p:extLst>
   </p:cSld>
@@ -712,7 +712,7 @@
           <a:bodyPr/>
           <a:lstStyle/>
           <a:p>
-            <a:fld id="{21F61A80-68B1-422B-9D68-85FD71C666C5}" type="slidenum">
+            <a:fld id="{31CE5959-8D78-4F7D-90FC-9D0056708953}" type="slidenum">
               <a:rPr lang="en-MY" smtClean="0"/>
               <a:t>2</a:t>
             </a:fld>
@@ -723,7 +723,7 @@
     </p:spTree>
     <p:extLst>
       <p:ext uri="{BB962C8B-B14F-4D97-AF65-F5344CB8AC3E}">
-        <p14:creationId xmlns:p14="http://schemas.microsoft.com/office/powerpoint/2010/main" val="966233640"/>
+        <p14:creationId xmlns:p14="http://schemas.microsoft.com/office/powerpoint/2010/main" val="621469268"/>
       </p:ext>
     </p:extLst>
   </p:cSld>
@@ -800,7 +800,7 @@
           <a:bodyPr/>
           <a:lstStyle/>
           <a:p>
-            <a:fld id="{21F61A80-68B1-422B-9D68-85FD71C666C5}" type="slidenum">
+            <a:fld id="{31CE5959-8D78-4F7D-90FC-9D0056708953}" type="slidenum">
               <a:rPr lang="en-MY" smtClean="0"/>
               <a:t>3</a:t>
             </a:fld>
@@ -811,7 +811,7 @@
     </p:spTree>
     <p:extLst>
       <p:ext uri="{BB962C8B-B14F-4D97-AF65-F5344CB8AC3E}">
-        <p14:creationId xmlns:p14="http://schemas.microsoft.com/office/powerpoint/2010/main" val="1839013987"/>
+        <p14:creationId xmlns:p14="http://schemas.microsoft.com/office/powerpoint/2010/main" val="3628427592"/>
       </p:ext>
     </p:extLst>
   </p:cSld>
@@ -888,7 +888,7 @@
           <a:bodyPr/>
           <a:lstStyle/>
           <a:p>
-            <a:fld id="{21F61A80-68B1-422B-9D68-85FD71C666C5}" type="slidenum">
+            <a:fld id="{31CE5959-8D78-4F7D-90FC-9D0056708953}" type="slidenum">
               <a:rPr lang="en-MY" smtClean="0"/>
               <a:t>4</a:t>
             </a:fld>
@@ -899,7 +899,7 @@
     </p:spTree>
     <p:extLst>
       <p:ext uri="{BB962C8B-B14F-4D97-AF65-F5344CB8AC3E}">
-        <p14:creationId xmlns:p14="http://schemas.microsoft.com/office/powerpoint/2010/main" val="217516439"/>
+        <p14:creationId xmlns:p14="http://schemas.microsoft.com/office/powerpoint/2010/main" val="4019959480"/>
       </p:ext>
     </p:extLst>
   </p:cSld>
@@ -976,7 +976,7 @@
           <a:bodyPr/>
           <a:lstStyle/>
           <a:p>
-            <a:fld id="{21F61A80-68B1-422B-9D68-85FD71C666C5}" type="slidenum">
+            <a:fld id="{31CE5959-8D78-4F7D-90FC-9D0056708953}" type="slidenum">
               <a:rPr lang="en-MY" smtClean="0"/>
               <a:t>5</a:t>
             </a:fld>
@@ -987,7 +987,7 @@
     </p:spTree>
     <p:extLst>
       <p:ext uri="{BB962C8B-B14F-4D97-AF65-F5344CB8AC3E}">
-        <p14:creationId xmlns:p14="http://schemas.microsoft.com/office/powerpoint/2010/main" val="3833377137"/>
+        <p14:creationId xmlns:p14="http://schemas.microsoft.com/office/powerpoint/2010/main" val="1504468129"/>
       </p:ext>
     </p:extLst>
   </p:cSld>
@@ -1064,7 +1064,7 @@
           <a:bodyPr/>
           <a:lstStyle/>
           <a:p>
-            <a:fld id="{21F61A80-68B1-422B-9D68-85FD71C666C5}" type="slidenum">
+            <a:fld id="{31CE5959-8D78-4F7D-90FC-9D0056708953}" type="slidenum">
               <a:rPr lang="en-MY" smtClean="0"/>
               <a:t>6</a:t>
             </a:fld>
@@ -1075,7 +1075,7 @@
     </p:spTree>
     <p:extLst>
       <p:ext uri="{BB962C8B-B14F-4D97-AF65-F5344CB8AC3E}">
-        <p14:creationId xmlns:p14="http://schemas.microsoft.com/office/powerpoint/2010/main" val="1879101604"/>
+        <p14:creationId xmlns:p14="http://schemas.microsoft.com/office/powerpoint/2010/main" val="1395165698"/>
       </p:ext>
     </p:extLst>
   </p:cSld>
@@ -1152,7 +1152,7 @@
           <a:bodyPr/>
           <a:lstStyle/>
           <a:p>
-            <a:fld id="{21F61A80-68B1-422B-9D68-85FD71C666C5}" type="slidenum">
+            <a:fld id="{31CE5959-8D78-4F7D-90FC-9D0056708953}" type="slidenum">
               <a:rPr lang="en-MY" smtClean="0"/>
               <a:t>7</a:t>
             </a:fld>
@@ -1163,7 +1163,7 @@
     </p:spTree>
     <p:extLst>
       <p:ext uri="{BB962C8B-B14F-4D97-AF65-F5344CB8AC3E}">
-        <p14:creationId xmlns:p14="http://schemas.microsoft.com/office/powerpoint/2010/main" val="1150897354"/>
+        <p14:creationId xmlns:p14="http://schemas.microsoft.com/office/powerpoint/2010/main" val="1458456525"/>
       </p:ext>
     </p:extLst>
   </p:cSld>
@@ -1240,7 +1240,7 @@
           <a:bodyPr/>
           <a:lstStyle/>
           <a:p>
-            <a:fld id="{21F61A80-68B1-422B-9D68-85FD71C666C5}" type="slidenum">
+            <a:fld id="{31CE5959-8D78-4F7D-90FC-9D0056708953}" type="slidenum">
               <a:rPr lang="en-MY" smtClean="0"/>
               <a:t>8</a:t>
             </a:fld>
@@ -1251,7 +1251,7 @@
     </p:spTree>
     <p:extLst>
       <p:ext uri="{BB962C8B-B14F-4D97-AF65-F5344CB8AC3E}">
-        <p14:creationId xmlns:p14="http://schemas.microsoft.com/office/powerpoint/2010/main" val="3851826723"/>
+        <p14:creationId xmlns:p14="http://schemas.microsoft.com/office/powerpoint/2010/main" val="2078771823"/>
       </p:ext>
     </p:extLst>
   </p:cSld>
@@ -1328,7 +1328,7 @@
           <a:bodyPr/>
           <a:lstStyle/>
           <a:p>
-            <a:fld id="{21F61A80-68B1-422B-9D68-85FD71C666C5}" type="slidenum">
+            <a:fld id="{31CE5959-8D78-4F7D-90FC-9D0056708953}" type="slidenum">
               <a:rPr lang="en-MY" smtClean="0"/>
               <a:t>9</a:t>
             </a:fld>
@@ -1339,7 +1339,7 @@
     </p:spTree>
     <p:extLst>
       <p:ext uri="{BB962C8B-B14F-4D97-AF65-F5344CB8AC3E}">
-        <p14:creationId xmlns:p14="http://schemas.microsoft.com/office/powerpoint/2010/main" val="1588068160"/>
+        <p14:creationId xmlns:p14="http://schemas.microsoft.com/office/powerpoint/2010/main" val="2392852950"/>
       </p:ext>
     </p:extLst>
   </p:cSld>
@@ -1371,7 +1371,7 @@
           <p:cNvPr id="2" name="Title 1">
             <a:extLst>
               <a:ext uri="{FF2B5EF4-FFF2-40B4-BE49-F238E27FC236}">
-                <a16:creationId xmlns:a16="http://schemas.microsoft.com/office/drawing/2014/main" id="{686CC9FC-85CD-1FCB-2B8B-B1C956648C32}"/>
+                <a16:creationId xmlns:a16="http://schemas.microsoft.com/office/drawing/2014/main" id="{187905FA-6DBD-BF96-093D-6DE6E88828D9}"/>
               </a:ext>
             </a:extLst>
           </p:cNvPr>
@@ -1409,7 +1409,7 @@
           <p:cNvPr id="3" name="Subtitle 2">
             <a:extLst>
               <a:ext uri="{FF2B5EF4-FFF2-40B4-BE49-F238E27FC236}">
-                <a16:creationId xmlns:a16="http://schemas.microsoft.com/office/drawing/2014/main" id="{32EFD356-D93D-C4D7-75E1-0CC1E3A26ECA}"/>
+                <a16:creationId xmlns:a16="http://schemas.microsoft.com/office/drawing/2014/main" id="{51B1925D-262C-D5C3-4FDA-2FFBB6C412A2}"/>
               </a:ext>
             </a:extLst>
           </p:cNvPr>
@@ -1480,7 +1480,7 @@
           <p:cNvPr id="4" name="Date Placeholder 3">
             <a:extLst>
               <a:ext uri="{FF2B5EF4-FFF2-40B4-BE49-F238E27FC236}">
-                <a16:creationId xmlns:a16="http://schemas.microsoft.com/office/drawing/2014/main" id="{24980623-15B8-71E2-5338-54BCE67E659B}"/>
+                <a16:creationId xmlns:a16="http://schemas.microsoft.com/office/drawing/2014/main" id="{F682E625-AD49-1E93-FDE2-8A2D4E09BA53}"/>
               </a:ext>
             </a:extLst>
           </p:cNvPr>
@@ -1496,9 +1496,9 @@
           <a:bodyPr/>
           <a:lstStyle/>
           <a:p>
-            <a:fld id="{2F8D26A6-D71B-4538-BE7E-D2A35FE8C500}" type="datetimeFigureOut">
+            <a:fld id="{75E84C95-8086-4385-A8BA-6F560668E2C3}" type="datetimeFigureOut">
               <a:rPr lang="en-MY" smtClean="0"/>
-              <a:t>24/9/2026</a:t>
+              <a:t>25/9/2026</a:t>
             </a:fld>
             <a:endParaRPr lang="en-MY"/>
           </a:p>
@@ -1509,7 +1509,7 @@
           <p:cNvPr id="5" name="Footer Placeholder 4">
             <a:extLst>
               <a:ext uri="{FF2B5EF4-FFF2-40B4-BE49-F238E27FC236}">
-                <a16:creationId xmlns:a16="http://schemas.microsoft.com/office/drawing/2014/main" id="{E72EC12D-2DDA-2C56-2F70-EFBC3FBA8437}"/>
+                <a16:creationId xmlns:a16="http://schemas.microsoft.com/office/drawing/2014/main" id="{8D2AB30D-BA00-A59F-1200-268247BE1FA2}"/>
               </a:ext>
             </a:extLst>
           </p:cNvPr>
@@ -1534,7 +1534,7 @@
           <p:cNvPr id="6" name="Slide Number Placeholder 5">
             <a:extLst>
               <a:ext uri="{FF2B5EF4-FFF2-40B4-BE49-F238E27FC236}">
-                <a16:creationId xmlns:a16="http://schemas.microsoft.com/office/drawing/2014/main" id="{07BEA3D9-0A18-698E-81BA-826D2308A65B}"/>
+                <a16:creationId xmlns:a16="http://schemas.microsoft.com/office/drawing/2014/main" id="{FE783E19-02C7-08ED-8D70-52D8185CE5C1}"/>
               </a:ext>
             </a:extLst>
           </p:cNvPr>
@@ -1550,7 +1550,7 @@
           <a:bodyPr/>
           <a:lstStyle/>
           <a:p>
-            <a:fld id="{3A1571EA-3779-4ED8-A27C-B0EAA1CBA9CE}" type="slidenum">
+            <a:fld id="{8BC4A4B2-CAF2-40F7-91B4-6AE8933782A6}" type="slidenum">
               <a:rPr lang="en-MY" smtClean="0"/>
               <a:t>‹#›</a:t>
             </a:fld>
@@ -1561,7 +1561,7 @@
     </p:spTree>
     <p:extLst>
       <p:ext uri="{BB962C8B-B14F-4D97-AF65-F5344CB8AC3E}">
-        <p14:creationId xmlns:p14="http://schemas.microsoft.com/office/powerpoint/2010/main" val="1553467972"/>
+        <p14:creationId xmlns:p14="http://schemas.microsoft.com/office/powerpoint/2010/main" val="3345836673"/>
       </p:ext>
     </p:extLst>
   </p:cSld>
@@ -1593,7 +1593,7 @@
           <p:cNvPr id="2" name="Title 1">
             <a:extLst>
               <a:ext uri="{FF2B5EF4-FFF2-40B4-BE49-F238E27FC236}">
-                <a16:creationId xmlns:a16="http://schemas.microsoft.com/office/drawing/2014/main" id="{ECC59A2F-1856-0EC6-5771-C53BBE2126F3}"/>
+                <a16:creationId xmlns:a16="http://schemas.microsoft.com/office/drawing/2014/main" id="{E631A8F7-9377-CF94-B47D-CE49CD757133}"/>
               </a:ext>
             </a:extLst>
           </p:cNvPr>
@@ -1622,7 +1622,7 @@
           <p:cNvPr id="3" name="Vertical Text Placeholder 2">
             <a:extLst>
               <a:ext uri="{FF2B5EF4-FFF2-40B4-BE49-F238E27FC236}">
-                <a16:creationId xmlns:a16="http://schemas.microsoft.com/office/drawing/2014/main" id="{14628F09-881E-7BA0-38D4-031A79D17012}"/>
+                <a16:creationId xmlns:a16="http://schemas.microsoft.com/office/drawing/2014/main" id="{95AF1562-9D9D-9110-4D40-4D6840CAE231}"/>
               </a:ext>
             </a:extLst>
           </p:cNvPr>
@@ -1680,7 +1680,7 @@
           <p:cNvPr id="4" name="Date Placeholder 3">
             <a:extLst>
               <a:ext uri="{FF2B5EF4-FFF2-40B4-BE49-F238E27FC236}">
-                <a16:creationId xmlns:a16="http://schemas.microsoft.com/office/drawing/2014/main" id="{79E449A9-7395-EAD7-A978-6117EC91000D}"/>
+                <a16:creationId xmlns:a16="http://schemas.microsoft.com/office/drawing/2014/main" id="{46D921A8-89CD-62A3-63A2-DF354C5D3884}"/>
               </a:ext>
             </a:extLst>
           </p:cNvPr>
@@ -1696,9 +1696,9 @@
           <a:bodyPr/>
           <a:lstStyle/>
           <a:p>
-            <a:fld id="{2F8D26A6-D71B-4538-BE7E-D2A35FE8C500}" type="datetimeFigureOut">
+            <a:fld id="{75E84C95-8086-4385-A8BA-6F560668E2C3}" type="datetimeFigureOut">
               <a:rPr lang="en-MY" smtClean="0"/>
-              <a:t>24/9/2026</a:t>
+              <a:t>25/9/2026</a:t>
             </a:fld>
             <a:endParaRPr lang="en-MY"/>
           </a:p>
@@ -1709,7 +1709,7 @@
           <p:cNvPr id="5" name="Footer Placeholder 4">
             <a:extLst>
               <a:ext uri="{FF2B5EF4-FFF2-40B4-BE49-F238E27FC236}">
-                <a16:creationId xmlns:a16="http://schemas.microsoft.com/office/drawing/2014/main" id="{B4270686-63C5-2C96-35D9-1115F792AF58}"/>
+                <a16:creationId xmlns:a16="http://schemas.microsoft.com/office/drawing/2014/main" id="{52408572-1F88-ECF8-2632-F1C754D79786}"/>
               </a:ext>
             </a:extLst>
           </p:cNvPr>
@@ -1734,7 +1734,7 @@
           <p:cNvPr id="6" name="Slide Number Placeholder 5">
             <a:extLst>
               <a:ext uri="{FF2B5EF4-FFF2-40B4-BE49-F238E27FC236}">
-                <a16:creationId xmlns:a16="http://schemas.microsoft.com/office/drawing/2014/main" id="{1E0348DC-BCE1-D3F0-4514-CE5391B0E8A4}"/>
+                <a16:creationId xmlns:a16="http://schemas.microsoft.com/office/drawing/2014/main" id="{91554B32-4784-34F3-904B-0215EF7321F1}"/>
               </a:ext>
             </a:extLst>
           </p:cNvPr>
@@ -1750,7 +1750,7 @@
           <a:bodyPr/>
           <a:lstStyle/>
           <a:p>
-            <a:fld id="{3A1571EA-3779-4ED8-A27C-B0EAA1CBA9CE}" type="slidenum">
+            <a:fld id="{8BC4A4B2-CAF2-40F7-91B4-6AE8933782A6}" type="slidenum">
               <a:rPr lang="en-MY" smtClean="0"/>
               <a:t>‹#›</a:t>
             </a:fld>
@@ -1761,7 +1761,7 @@
     </p:spTree>
     <p:extLst>
       <p:ext uri="{BB962C8B-B14F-4D97-AF65-F5344CB8AC3E}">
-        <p14:creationId xmlns:p14="http://schemas.microsoft.com/office/powerpoint/2010/main" val="2304108578"/>
+        <p14:creationId xmlns:p14="http://schemas.microsoft.com/office/powerpoint/2010/main" val="1200186969"/>
       </p:ext>
     </p:extLst>
   </p:cSld>
@@ -1793,7 +1793,7 @@
           <p:cNvPr id="2" name="Vertical Title 1">
             <a:extLst>
               <a:ext uri="{FF2B5EF4-FFF2-40B4-BE49-F238E27FC236}">
-                <a16:creationId xmlns:a16="http://schemas.microsoft.com/office/drawing/2014/main" id="{C797B5DB-3C13-A7EA-D2E7-CD589CDDCB52}"/>
+                <a16:creationId xmlns:a16="http://schemas.microsoft.com/office/drawing/2014/main" id="{4D9A5454-5387-5257-BDE8-8FA54C893BE8}"/>
               </a:ext>
             </a:extLst>
           </p:cNvPr>
@@ -1827,7 +1827,7 @@
           <p:cNvPr id="3" name="Vertical Text Placeholder 2">
             <a:extLst>
               <a:ext uri="{FF2B5EF4-FFF2-40B4-BE49-F238E27FC236}">
-                <a16:creationId xmlns:a16="http://schemas.microsoft.com/office/drawing/2014/main" id="{CC52690E-804E-05B8-C094-7CB34921D760}"/>
+                <a16:creationId xmlns:a16="http://schemas.microsoft.com/office/drawing/2014/main" id="{60563EEC-CBF2-905C-4D77-56E6A9F5DA0D}"/>
               </a:ext>
             </a:extLst>
           </p:cNvPr>
@@ -1890,7 +1890,7 @@
           <p:cNvPr id="4" name="Date Placeholder 3">
             <a:extLst>
               <a:ext uri="{FF2B5EF4-FFF2-40B4-BE49-F238E27FC236}">
-                <a16:creationId xmlns:a16="http://schemas.microsoft.com/office/drawing/2014/main" id="{72C68D13-FDFF-B1C8-01ED-06180EF0BC34}"/>
+                <a16:creationId xmlns:a16="http://schemas.microsoft.com/office/drawing/2014/main" id="{08FC06FD-2FB3-7A82-20AB-C9A811E53E58}"/>
               </a:ext>
             </a:extLst>
           </p:cNvPr>
@@ -1906,9 +1906,9 @@
           <a:bodyPr/>
           <a:lstStyle/>
           <a:p>
-            <a:fld id="{2F8D26A6-D71B-4538-BE7E-D2A35FE8C500}" type="datetimeFigureOut">
+            <a:fld id="{75E84C95-8086-4385-A8BA-6F560668E2C3}" type="datetimeFigureOut">
               <a:rPr lang="en-MY" smtClean="0"/>
-              <a:t>24/9/2026</a:t>
+              <a:t>25/9/2026</a:t>
             </a:fld>
             <a:endParaRPr lang="en-MY"/>
           </a:p>
@@ -1919,7 +1919,7 @@
           <p:cNvPr id="5" name="Footer Placeholder 4">
             <a:extLst>
               <a:ext uri="{FF2B5EF4-FFF2-40B4-BE49-F238E27FC236}">
-                <a16:creationId xmlns:a16="http://schemas.microsoft.com/office/drawing/2014/main" id="{819CE22C-68F6-0D57-A1A0-0D9D6E65AC76}"/>
+                <a16:creationId xmlns:a16="http://schemas.microsoft.com/office/drawing/2014/main" id="{CC1CFECA-F609-97DE-7CD4-F45FAB07B6B4}"/>
               </a:ext>
             </a:extLst>
           </p:cNvPr>
@@ -1944,7 +1944,7 @@
           <p:cNvPr id="6" name="Slide Number Placeholder 5">
             <a:extLst>
               <a:ext uri="{FF2B5EF4-FFF2-40B4-BE49-F238E27FC236}">
-                <a16:creationId xmlns:a16="http://schemas.microsoft.com/office/drawing/2014/main" id="{500C94AB-11EF-8B96-DA2A-4953DCDD1F42}"/>
+                <a16:creationId xmlns:a16="http://schemas.microsoft.com/office/drawing/2014/main" id="{182FAD25-7DF7-B784-17B3-0A5E10A788EF}"/>
               </a:ext>
             </a:extLst>
           </p:cNvPr>
@@ -1960,7 +1960,7 @@
           <a:bodyPr/>
           <a:lstStyle/>
           <a:p>
-            <a:fld id="{3A1571EA-3779-4ED8-A27C-B0EAA1CBA9CE}" type="slidenum">
+            <a:fld id="{8BC4A4B2-CAF2-40F7-91B4-6AE8933782A6}" type="slidenum">
               <a:rPr lang="en-MY" smtClean="0"/>
               <a:t>‹#›</a:t>
             </a:fld>
@@ -1971,7 +1971,7 @@
     </p:spTree>
     <p:extLst>
       <p:ext uri="{BB962C8B-B14F-4D97-AF65-F5344CB8AC3E}">
-        <p14:creationId xmlns:p14="http://schemas.microsoft.com/office/powerpoint/2010/main" val="950173206"/>
+        <p14:creationId xmlns:p14="http://schemas.microsoft.com/office/powerpoint/2010/main" val="703866454"/>
       </p:ext>
     </p:extLst>
   </p:cSld>
@@ -2003,7 +2003,7 @@
           <p:cNvPr id="2" name="Title 1">
             <a:extLst>
               <a:ext uri="{FF2B5EF4-FFF2-40B4-BE49-F238E27FC236}">
-                <a16:creationId xmlns:a16="http://schemas.microsoft.com/office/drawing/2014/main" id="{9B620C09-64EE-4F98-E127-92E992DA418F}"/>
+                <a16:creationId xmlns:a16="http://schemas.microsoft.com/office/drawing/2014/main" id="{BBD72D02-A620-4A9F-9570-E7CC9B2A01EF}"/>
               </a:ext>
             </a:extLst>
           </p:cNvPr>
@@ -2032,7 +2032,7 @@
           <p:cNvPr id="3" name="Content Placeholder 2">
             <a:extLst>
               <a:ext uri="{FF2B5EF4-FFF2-40B4-BE49-F238E27FC236}">
-                <a16:creationId xmlns:a16="http://schemas.microsoft.com/office/drawing/2014/main" id="{E58E8323-0378-D6D5-C708-0609029FC75B}"/>
+                <a16:creationId xmlns:a16="http://schemas.microsoft.com/office/drawing/2014/main" id="{2244C46F-1879-B290-4669-447BF7E3E4F4}"/>
               </a:ext>
             </a:extLst>
           </p:cNvPr>
@@ -2090,7 +2090,7 @@
           <p:cNvPr id="4" name="Date Placeholder 3">
             <a:extLst>
               <a:ext uri="{FF2B5EF4-FFF2-40B4-BE49-F238E27FC236}">
-                <a16:creationId xmlns:a16="http://schemas.microsoft.com/office/drawing/2014/main" id="{83117E4D-8376-A8F7-B588-6EFF3201A14F}"/>
+                <a16:creationId xmlns:a16="http://schemas.microsoft.com/office/drawing/2014/main" id="{25C7D08E-DCD0-4EAB-EF98-EB269751004F}"/>
               </a:ext>
             </a:extLst>
           </p:cNvPr>
@@ -2106,9 +2106,9 @@
           <a:bodyPr/>
           <a:lstStyle/>
           <a:p>
-            <a:fld id="{2F8D26A6-D71B-4538-BE7E-D2A35FE8C500}" type="datetimeFigureOut">
+            <a:fld id="{75E84C95-8086-4385-A8BA-6F560668E2C3}" type="datetimeFigureOut">
               <a:rPr lang="en-MY" smtClean="0"/>
-              <a:t>24/9/2026</a:t>
+              <a:t>25/9/2026</a:t>
             </a:fld>
             <a:endParaRPr lang="en-MY"/>
           </a:p>
@@ -2119,7 +2119,7 @@
           <p:cNvPr id="5" name="Footer Placeholder 4">
             <a:extLst>
               <a:ext uri="{FF2B5EF4-FFF2-40B4-BE49-F238E27FC236}">
-                <a16:creationId xmlns:a16="http://schemas.microsoft.com/office/drawing/2014/main" id="{55C14C2B-F51D-CA8F-9356-684F8631193F}"/>
+                <a16:creationId xmlns:a16="http://schemas.microsoft.com/office/drawing/2014/main" id="{B47B41EC-6930-2DF7-4BC9-5B9CA6461E00}"/>
               </a:ext>
             </a:extLst>
           </p:cNvPr>
@@ -2144,7 +2144,7 @@
           <p:cNvPr id="6" name="Slide Number Placeholder 5">
             <a:extLst>
               <a:ext uri="{FF2B5EF4-FFF2-40B4-BE49-F238E27FC236}">
-                <a16:creationId xmlns:a16="http://schemas.microsoft.com/office/drawing/2014/main" id="{66353F87-7097-7B58-18BF-3219EC9E2BD5}"/>
+                <a16:creationId xmlns:a16="http://schemas.microsoft.com/office/drawing/2014/main" id="{09B90177-C872-ECEE-9CCA-75C2654FADB4}"/>
               </a:ext>
             </a:extLst>
           </p:cNvPr>
@@ -2160,7 +2160,7 @@
           <a:bodyPr/>
           <a:lstStyle/>
           <a:p>
-            <a:fld id="{3A1571EA-3779-4ED8-A27C-B0EAA1CBA9CE}" type="slidenum">
+            <a:fld id="{8BC4A4B2-CAF2-40F7-91B4-6AE8933782A6}" type="slidenum">
               <a:rPr lang="en-MY" smtClean="0"/>
               <a:t>‹#›</a:t>
             </a:fld>
@@ -2171,7 +2171,7 @@
     </p:spTree>
     <p:extLst>
       <p:ext uri="{BB962C8B-B14F-4D97-AF65-F5344CB8AC3E}">
-        <p14:creationId xmlns:p14="http://schemas.microsoft.com/office/powerpoint/2010/main" val="1999681918"/>
+        <p14:creationId xmlns:p14="http://schemas.microsoft.com/office/powerpoint/2010/main" val="1677957556"/>
       </p:ext>
     </p:extLst>
   </p:cSld>
@@ -2203,7 +2203,7 @@
           <p:cNvPr id="2" name="Title 1">
             <a:extLst>
               <a:ext uri="{FF2B5EF4-FFF2-40B4-BE49-F238E27FC236}">
-                <a16:creationId xmlns:a16="http://schemas.microsoft.com/office/drawing/2014/main" id="{7F23EE73-0C43-16FA-1D49-DDB1F392A9BA}"/>
+                <a16:creationId xmlns:a16="http://schemas.microsoft.com/office/drawing/2014/main" id="{76F49AEB-95DF-3BA5-57E6-AE6B84BDAE10}"/>
               </a:ext>
             </a:extLst>
           </p:cNvPr>
@@ -2241,7 +2241,7 @@
           <p:cNvPr id="3" name="Text Placeholder 2">
             <a:extLst>
               <a:ext uri="{FF2B5EF4-FFF2-40B4-BE49-F238E27FC236}">
-                <a16:creationId xmlns:a16="http://schemas.microsoft.com/office/drawing/2014/main" id="{53657038-E67F-A147-6C5B-6394E166D75C}"/>
+                <a16:creationId xmlns:a16="http://schemas.microsoft.com/office/drawing/2014/main" id="{44D64FB8-270B-1453-55DD-33C9A099AD25}"/>
               </a:ext>
             </a:extLst>
           </p:cNvPr>
@@ -2366,7 +2366,7 @@
           <p:cNvPr id="4" name="Date Placeholder 3">
             <a:extLst>
               <a:ext uri="{FF2B5EF4-FFF2-40B4-BE49-F238E27FC236}">
-                <a16:creationId xmlns:a16="http://schemas.microsoft.com/office/drawing/2014/main" id="{E5F8EE7C-0EDD-D017-D7AD-7F4C2053336F}"/>
+                <a16:creationId xmlns:a16="http://schemas.microsoft.com/office/drawing/2014/main" id="{0D8D4DA3-0CE5-9E32-92D0-D2CF968B4CD3}"/>
               </a:ext>
             </a:extLst>
           </p:cNvPr>
@@ -2382,9 +2382,9 @@
           <a:bodyPr/>
           <a:lstStyle/>
           <a:p>
-            <a:fld id="{2F8D26A6-D71B-4538-BE7E-D2A35FE8C500}" type="datetimeFigureOut">
+            <a:fld id="{75E84C95-8086-4385-A8BA-6F560668E2C3}" type="datetimeFigureOut">
               <a:rPr lang="en-MY" smtClean="0"/>
-              <a:t>24/9/2026</a:t>
+              <a:t>25/9/2026</a:t>
             </a:fld>
             <a:endParaRPr lang="en-MY"/>
           </a:p>
@@ -2395,7 +2395,7 @@
           <p:cNvPr id="5" name="Footer Placeholder 4">
             <a:extLst>
               <a:ext uri="{FF2B5EF4-FFF2-40B4-BE49-F238E27FC236}">
-                <a16:creationId xmlns:a16="http://schemas.microsoft.com/office/drawing/2014/main" id="{E1ABE3C9-6F6C-1B81-9909-8E7255E27944}"/>
+                <a16:creationId xmlns:a16="http://schemas.microsoft.com/office/drawing/2014/main" id="{96C74B1E-21F5-0A55-74CB-F82D8BD0F725}"/>
               </a:ext>
             </a:extLst>
           </p:cNvPr>
@@ -2420,7 +2420,7 @@
           <p:cNvPr id="6" name="Slide Number Placeholder 5">
             <a:extLst>
               <a:ext uri="{FF2B5EF4-FFF2-40B4-BE49-F238E27FC236}">
-                <a16:creationId xmlns:a16="http://schemas.microsoft.com/office/drawing/2014/main" id="{A391389A-F1D1-0724-EE4C-FE31D43D9E4C}"/>
+                <a16:creationId xmlns:a16="http://schemas.microsoft.com/office/drawing/2014/main" id="{5E823E72-22E9-59E8-74D1-76A68ECEC790}"/>
               </a:ext>
             </a:extLst>
           </p:cNvPr>
@@ -2436,7 +2436,7 @@
           <a:bodyPr/>
           <a:lstStyle/>
           <a:p>
-            <a:fld id="{3A1571EA-3779-4ED8-A27C-B0EAA1CBA9CE}" type="slidenum">
+            <a:fld id="{8BC4A4B2-CAF2-40F7-91B4-6AE8933782A6}" type="slidenum">
               <a:rPr lang="en-MY" smtClean="0"/>
               <a:t>‹#›</a:t>
             </a:fld>
@@ -2447,7 +2447,7 @@
     </p:spTree>
     <p:extLst>
       <p:ext uri="{BB962C8B-B14F-4D97-AF65-F5344CB8AC3E}">
-        <p14:creationId xmlns:p14="http://schemas.microsoft.com/office/powerpoint/2010/main" val="1275454861"/>
+        <p14:creationId xmlns:p14="http://schemas.microsoft.com/office/powerpoint/2010/main" val="2038400480"/>
       </p:ext>
     </p:extLst>
   </p:cSld>
@@ -2479,7 +2479,7 @@
           <p:cNvPr id="2" name="Title 1">
             <a:extLst>
               <a:ext uri="{FF2B5EF4-FFF2-40B4-BE49-F238E27FC236}">
-                <a16:creationId xmlns:a16="http://schemas.microsoft.com/office/drawing/2014/main" id="{1A4C2AC4-B386-B674-3BC1-BAE12A74AB44}"/>
+                <a16:creationId xmlns:a16="http://schemas.microsoft.com/office/drawing/2014/main" id="{85F1D265-B9C1-0B20-E800-A12EFF0A0E28}"/>
               </a:ext>
             </a:extLst>
           </p:cNvPr>
@@ -2508,7 +2508,7 @@
           <p:cNvPr id="3" name="Content Placeholder 2">
             <a:extLst>
               <a:ext uri="{FF2B5EF4-FFF2-40B4-BE49-F238E27FC236}">
-                <a16:creationId xmlns:a16="http://schemas.microsoft.com/office/drawing/2014/main" id="{ABADD1D7-5DFC-44EF-103E-D8C80A8F4678}"/>
+                <a16:creationId xmlns:a16="http://schemas.microsoft.com/office/drawing/2014/main" id="{C8D8AE97-0523-B584-4E22-C9B59203767B}"/>
               </a:ext>
             </a:extLst>
           </p:cNvPr>
@@ -2571,7 +2571,7 @@
           <p:cNvPr id="4" name="Content Placeholder 3">
             <a:extLst>
               <a:ext uri="{FF2B5EF4-FFF2-40B4-BE49-F238E27FC236}">
-                <a16:creationId xmlns:a16="http://schemas.microsoft.com/office/drawing/2014/main" id="{80523931-5A72-EC64-1F14-1212A54BFB04}"/>
+                <a16:creationId xmlns:a16="http://schemas.microsoft.com/office/drawing/2014/main" id="{4A726C0C-C9DA-70CC-EDE3-FCF31698C273}"/>
               </a:ext>
             </a:extLst>
           </p:cNvPr>
@@ -2634,7 +2634,7 @@
           <p:cNvPr id="5" name="Date Placeholder 4">
             <a:extLst>
               <a:ext uri="{FF2B5EF4-FFF2-40B4-BE49-F238E27FC236}">
-                <a16:creationId xmlns:a16="http://schemas.microsoft.com/office/drawing/2014/main" id="{5317711C-1E25-1A5F-AAFD-E08D5EEC7470}"/>
+                <a16:creationId xmlns:a16="http://schemas.microsoft.com/office/drawing/2014/main" id="{2640D745-E51A-17B2-5899-5FD88F63D311}"/>
               </a:ext>
             </a:extLst>
           </p:cNvPr>
@@ -2650,9 +2650,9 @@
           <a:bodyPr/>
           <a:lstStyle/>
           <a:p>
-            <a:fld id="{2F8D26A6-D71B-4538-BE7E-D2A35FE8C500}" type="datetimeFigureOut">
+            <a:fld id="{75E84C95-8086-4385-A8BA-6F560668E2C3}" type="datetimeFigureOut">
               <a:rPr lang="en-MY" smtClean="0"/>
-              <a:t>24/9/2026</a:t>
+              <a:t>25/9/2026</a:t>
             </a:fld>
             <a:endParaRPr lang="en-MY"/>
           </a:p>
@@ -2663,7 +2663,7 @@
           <p:cNvPr id="6" name="Footer Placeholder 5">
             <a:extLst>
               <a:ext uri="{FF2B5EF4-FFF2-40B4-BE49-F238E27FC236}">
-                <a16:creationId xmlns:a16="http://schemas.microsoft.com/office/drawing/2014/main" id="{07F32876-7EFF-6C5C-8965-9CF11B136184}"/>
+                <a16:creationId xmlns:a16="http://schemas.microsoft.com/office/drawing/2014/main" id="{A3ADAE41-0024-28D6-E861-53E4DD21B6EB}"/>
               </a:ext>
             </a:extLst>
           </p:cNvPr>
@@ -2688,7 +2688,7 @@
           <p:cNvPr id="7" name="Slide Number Placeholder 6">
             <a:extLst>
               <a:ext uri="{FF2B5EF4-FFF2-40B4-BE49-F238E27FC236}">
-                <a16:creationId xmlns:a16="http://schemas.microsoft.com/office/drawing/2014/main" id="{ED819C50-EDA7-CD83-965F-FF59C69B4972}"/>
+                <a16:creationId xmlns:a16="http://schemas.microsoft.com/office/drawing/2014/main" id="{4A9CCD8A-9669-AA62-1709-AADB7E5F4F02}"/>
               </a:ext>
             </a:extLst>
           </p:cNvPr>
@@ -2704,7 +2704,7 @@
           <a:bodyPr/>
           <a:lstStyle/>
           <a:p>
-            <a:fld id="{3A1571EA-3779-4ED8-A27C-B0EAA1CBA9CE}" type="slidenum">
+            <a:fld id="{8BC4A4B2-CAF2-40F7-91B4-6AE8933782A6}" type="slidenum">
               <a:rPr lang="en-MY" smtClean="0"/>
               <a:t>‹#›</a:t>
             </a:fld>
@@ -2715,7 +2715,7 @@
     </p:spTree>
     <p:extLst>
       <p:ext uri="{BB962C8B-B14F-4D97-AF65-F5344CB8AC3E}">
-        <p14:creationId xmlns:p14="http://schemas.microsoft.com/office/powerpoint/2010/main" val="3875219953"/>
+        <p14:creationId xmlns:p14="http://schemas.microsoft.com/office/powerpoint/2010/main" val="1622186721"/>
       </p:ext>
     </p:extLst>
   </p:cSld>
@@ -2747,7 +2747,7 @@
           <p:cNvPr id="2" name="Title 1">
             <a:extLst>
               <a:ext uri="{FF2B5EF4-FFF2-40B4-BE49-F238E27FC236}">
-                <a16:creationId xmlns:a16="http://schemas.microsoft.com/office/drawing/2014/main" id="{D31E9EAF-92EC-B4B3-668F-DBE0CDFD4870}"/>
+                <a16:creationId xmlns:a16="http://schemas.microsoft.com/office/drawing/2014/main" id="{F8D2F994-8693-542E-3214-9ED198F9FBB3}"/>
               </a:ext>
             </a:extLst>
           </p:cNvPr>
@@ -2781,7 +2781,7 @@
           <p:cNvPr id="3" name="Text Placeholder 2">
             <a:extLst>
               <a:ext uri="{FF2B5EF4-FFF2-40B4-BE49-F238E27FC236}">
-                <a16:creationId xmlns:a16="http://schemas.microsoft.com/office/drawing/2014/main" id="{82E63AA3-0A68-5F62-3CB9-3FDFB00D5E24}"/>
+                <a16:creationId xmlns:a16="http://schemas.microsoft.com/office/drawing/2014/main" id="{62BC8352-3EDA-EA41-EE37-80FFCC02145F}"/>
               </a:ext>
             </a:extLst>
           </p:cNvPr>
@@ -2852,7 +2852,7 @@
           <p:cNvPr id="4" name="Content Placeholder 3">
             <a:extLst>
               <a:ext uri="{FF2B5EF4-FFF2-40B4-BE49-F238E27FC236}">
-                <a16:creationId xmlns:a16="http://schemas.microsoft.com/office/drawing/2014/main" id="{1D9C4D1E-3392-6F55-6E4C-A1EA7ABED16C}"/>
+                <a16:creationId xmlns:a16="http://schemas.microsoft.com/office/drawing/2014/main" id="{98A6507D-3940-28CB-5537-474B1CB03E27}"/>
               </a:ext>
             </a:extLst>
           </p:cNvPr>
@@ -2915,7 +2915,7 @@
           <p:cNvPr id="5" name="Text Placeholder 4">
             <a:extLst>
               <a:ext uri="{FF2B5EF4-FFF2-40B4-BE49-F238E27FC236}">
-                <a16:creationId xmlns:a16="http://schemas.microsoft.com/office/drawing/2014/main" id="{8FC3261C-221D-9223-654F-EF428AF401AD}"/>
+                <a16:creationId xmlns:a16="http://schemas.microsoft.com/office/drawing/2014/main" id="{3316A71A-16EA-9472-3B26-0663BAD66F11}"/>
               </a:ext>
             </a:extLst>
           </p:cNvPr>
@@ -2986,7 +2986,7 @@
           <p:cNvPr id="6" name="Content Placeholder 5">
             <a:extLst>
               <a:ext uri="{FF2B5EF4-FFF2-40B4-BE49-F238E27FC236}">
-                <a16:creationId xmlns:a16="http://schemas.microsoft.com/office/drawing/2014/main" id="{D6A78D58-5C7D-E701-3A5B-EDCD29D9F5BD}"/>
+                <a16:creationId xmlns:a16="http://schemas.microsoft.com/office/drawing/2014/main" id="{F75C11D8-B223-AF9E-9790-5BFA10888AD2}"/>
               </a:ext>
             </a:extLst>
           </p:cNvPr>
@@ -3049,7 +3049,7 @@
           <p:cNvPr id="7" name="Date Placeholder 6">
             <a:extLst>
               <a:ext uri="{FF2B5EF4-FFF2-40B4-BE49-F238E27FC236}">
-                <a16:creationId xmlns:a16="http://schemas.microsoft.com/office/drawing/2014/main" id="{22D4F4A8-AC9F-5609-1E38-4C2BBE4F9A5B}"/>
+                <a16:creationId xmlns:a16="http://schemas.microsoft.com/office/drawing/2014/main" id="{1E4A2A44-B09D-D70E-945E-1D5005C76558}"/>
               </a:ext>
             </a:extLst>
           </p:cNvPr>
@@ -3065,9 +3065,9 @@
           <a:bodyPr/>
           <a:lstStyle/>
           <a:p>
-            <a:fld id="{2F8D26A6-D71B-4538-BE7E-D2A35FE8C500}" type="datetimeFigureOut">
+            <a:fld id="{75E84C95-8086-4385-A8BA-6F560668E2C3}" type="datetimeFigureOut">
               <a:rPr lang="en-MY" smtClean="0"/>
-              <a:t>24/9/2026</a:t>
+              <a:t>25/9/2026</a:t>
             </a:fld>
             <a:endParaRPr lang="en-MY"/>
           </a:p>
@@ -3078,7 +3078,7 @@
           <p:cNvPr id="8" name="Footer Placeholder 7">
             <a:extLst>
               <a:ext uri="{FF2B5EF4-FFF2-40B4-BE49-F238E27FC236}">
-                <a16:creationId xmlns:a16="http://schemas.microsoft.com/office/drawing/2014/main" id="{6199F672-CA61-8F20-01FF-68EE92292478}"/>
+                <a16:creationId xmlns:a16="http://schemas.microsoft.com/office/drawing/2014/main" id="{1650082C-11C0-9746-415E-FF3A41859864}"/>
               </a:ext>
             </a:extLst>
           </p:cNvPr>
@@ -3103,7 +3103,7 @@
           <p:cNvPr id="9" name="Slide Number Placeholder 8">
             <a:extLst>
               <a:ext uri="{FF2B5EF4-FFF2-40B4-BE49-F238E27FC236}">
-                <a16:creationId xmlns:a16="http://schemas.microsoft.com/office/drawing/2014/main" id="{CC789F15-7F6E-16B5-43D3-2D679A9FE041}"/>
+                <a16:creationId xmlns:a16="http://schemas.microsoft.com/office/drawing/2014/main" id="{C8552E4F-395A-24C8-382D-FC8DE19631C0}"/>
               </a:ext>
             </a:extLst>
           </p:cNvPr>
@@ -3119,7 +3119,7 @@
           <a:bodyPr/>
           <a:lstStyle/>
           <a:p>
-            <a:fld id="{3A1571EA-3779-4ED8-A27C-B0EAA1CBA9CE}" type="slidenum">
+            <a:fld id="{8BC4A4B2-CAF2-40F7-91B4-6AE8933782A6}" type="slidenum">
               <a:rPr lang="en-MY" smtClean="0"/>
               <a:t>‹#›</a:t>
             </a:fld>
@@ -3130,7 +3130,7 @@
     </p:spTree>
     <p:extLst>
       <p:ext uri="{BB962C8B-B14F-4D97-AF65-F5344CB8AC3E}">
-        <p14:creationId xmlns:p14="http://schemas.microsoft.com/office/powerpoint/2010/main" val="3818558036"/>
+        <p14:creationId xmlns:p14="http://schemas.microsoft.com/office/powerpoint/2010/main" val="21832589"/>
       </p:ext>
     </p:extLst>
   </p:cSld>
@@ -3162,7 +3162,7 @@
           <p:cNvPr id="2" name="Title 1">
             <a:extLst>
               <a:ext uri="{FF2B5EF4-FFF2-40B4-BE49-F238E27FC236}">
-                <a16:creationId xmlns:a16="http://schemas.microsoft.com/office/drawing/2014/main" id="{8912A4DF-AC8D-B685-35A5-2725D019BC88}"/>
+                <a16:creationId xmlns:a16="http://schemas.microsoft.com/office/drawing/2014/main" id="{672B0EC1-F0CD-3622-F907-6422F8CD87DE}"/>
               </a:ext>
             </a:extLst>
           </p:cNvPr>
@@ -3191,7 +3191,7 @@
           <p:cNvPr id="3" name="Date Placeholder 2">
             <a:extLst>
               <a:ext uri="{FF2B5EF4-FFF2-40B4-BE49-F238E27FC236}">
-                <a16:creationId xmlns:a16="http://schemas.microsoft.com/office/drawing/2014/main" id="{0308B965-5D73-14E2-E2D8-6A6F0A5E4539}"/>
+                <a16:creationId xmlns:a16="http://schemas.microsoft.com/office/drawing/2014/main" id="{9F40030C-0311-E272-D4DA-B2D527CEFA92}"/>
               </a:ext>
             </a:extLst>
           </p:cNvPr>
@@ -3207,9 +3207,9 @@
           <a:bodyPr/>
           <a:lstStyle/>
           <a:p>
-            <a:fld id="{2F8D26A6-D71B-4538-BE7E-D2A35FE8C500}" type="datetimeFigureOut">
+            <a:fld id="{75E84C95-8086-4385-A8BA-6F560668E2C3}" type="datetimeFigureOut">
               <a:rPr lang="en-MY" smtClean="0"/>
-              <a:t>24/9/2026</a:t>
+              <a:t>25/9/2026</a:t>
             </a:fld>
             <a:endParaRPr lang="en-MY"/>
           </a:p>
@@ -3220,7 +3220,7 @@
           <p:cNvPr id="4" name="Footer Placeholder 3">
             <a:extLst>
               <a:ext uri="{FF2B5EF4-FFF2-40B4-BE49-F238E27FC236}">
-                <a16:creationId xmlns:a16="http://schemas.microsoft.com/office/drawing/2014/main" id="{F6B60080-C673-1CDC-B779-B964784BE37C}"/>
+                <a16:creationId xmlns:a16="http://schemas.microsoft.com/office/drawing/2014/main" id="{AA962ADE-FC5E-B142-6096-8E3F13B04621}"/>
               </a:ext>
             </a:extLst>
           </p:cNvPr>
@@ -3245,7 +3245,7 @@
           <p:cNvPr id="5" name="Slide Number Placeholder 4">
             <a:extLst>
               <a:ext uri="{FF2B5EF4-FFF2-40B4-BE49-F238E27FC236}">
-                <a16:creationId xmlns:a16="http://schemas.microsoft.com/office/drawing/2014/main" id="{5D656AF1-B230-2462-582E-2FBF5CE9F297}"/>
+                <a16:creationId xmlns:a16="http://schemas.microsoft.com/office/drawing/2014/main" id="{A81E6FD6-51AB-5A00-B4D2-1DBCF1F9F87E}"/>
               </a:ext>
             </a:extLst>
           </p:cNvPr>
@@ -3261,7 +3261,7 @@
           <a:bodyPr/>
           <a:lstStyle/>
           <a:p>
-            <a:fld id="{3A1571EA-3779-4ED8-A27C-B0EAA1CBA9CE}" type="slidenum">
+            <a:fld id="{8BC4A4B2-CAF2-40F7-91B4-6AE8933782A6}" type="slidenum">
               <a:rPr lang="en-MY" smtClean="0"/>
               <a:t>‹#›</a:t>
             </a:fld>
@@ -3272,7 +3272,7 @@
     </p:spTree>
     <p:extLst>
       <p:ext uri="{BB962C8B-B14F-4D97-AF65-F5344CB8AC3E}">
-        <p14:creationId xmlns:p14="http://schemas.microsoft.com/office/powerpoint/2010/main" val="1715134392"/>
+        <p14:creationId xmlns:p14="http://schemas.microsoft.com/office/powerpoint/2010/main" val="1440973876"/>
       </p:ext>
     </p:extLst>
   </p:cSld>
@@ -3304,7 +3304,7 @@
           <p:cNvPr id="2" name="Date Placeholder 1">
             <a:extLst>
               <a:ext uri="{FF2B5EF4-FFF2-40B4-BE49-F238E27FC236}">
-                <a16:creationId xmlns:a16="http://schemas.microsoft.com/office/drawing/2014/main" id="{0B4F3FEB-F1B2-B4A5-5F8A-8979177BEE73}"/>
+                <a16:creationId xmlns:a16="http://schemas.microsoft.com/office/drawing/2014/main" id="{AE12028E-CBFB-FE7A-9846-96D709CE830C}"/>
               </a:ext>
             </a:extLst>
           </p:cNvPr>
@@ -3320,9 +3320,9 @@
           <a:bodyPr/>
           <a:lstStyle/>
           <a:p>
-            <a:fld id="{2F8D26A6-D71B-4538-BE7E-D2A35FE8C500}" type="datetimeFigureOut">
+            <a:fld id="{75E84C95-8086-4385-A8BA-6F560668E2C3}" type="datetimeFigureOut">
               <a:rPr lang="en-MY" smtClean="0"/>
-              <a:t>24/9/2026</a:t>
+              <a:t>25/9/2026</a:t>
             </a:fld>
             <a:endParaRPr lang="en-MY"/>
           </a:p>
@@ -3333,7 +3333,7 @@
           <p:cNvPr id="3" name="Footer Placeholder 2">
             <a:extLst>
               <a:ext uri="{FF2B5EF4-FFF2-40B4-BE49-F238E27FC236}">
-                <a16:creationId xmlns:a16="http://schemas.microsoft.com/office/drawing/2014/main" id="{84115850-7D30-F05E-4F34-BB3B79145506}"/>
+                <a16:creationId xmlns:a16="http://schemas.microsoft.com/office/drawing/2014/main" id="{ECB41F3B-753E-7E35-99C9-D6839094484C}"/>
               </a:ext>
             </a:extLst>
           </p:cNvPr>
@@ -3358,7 +3358,7 @@
           <p:cNvPr id="4" name="Slide Number Placeholder 3">
             <a:extLst>
               <a:ext uri="{FF2B5EF4-FFF2-40B4-BE49-F238E27FC236}">
-                <a16:creationId xmlns:a16="http://schemas.microsoft.com/office/drawing/2014/main" id="{0C6DBCCA-1AF8-A7F4-33DA-6354CA81E505}"/>
+                <a16:creationId xmlns:a16="http://schemas.microsoft.com/office/drawing/2014/main" id="{9B265FCF-C759-D3D1-9BD5-2423D8CD9767}"/>
               </a:ext>
             </a:extLst>
           </p:cNvPr>
@@ -3374,7 +3374,7 @@
           <a:bodyPr/>
           <a:lstStyle/>
           <a:p>
-            <a:fld id="{3A1571EA-3779-4ED8-A27C-B0EAA1CBA9CE}" type="slidenum">
+            <a:fld id="{8BC4A4B2-CAF2-40F7-91B4-6AE8933782A6}" type="slidenum">
               <a:rPr lang="en-MY" smtClean="0"/>
               <a:t>‹#›</a:t>
             </a:fld>
@@ -3385,7 +3385,7 @@
     </p:spTree>
     <p:extLst>
       <p:ext uri="{BB962C8B-B14F-4D97-AF65-F5344CB8AC3E}">
-        <p14:creationId xmlns:p14="http://schemas.microsoft.com/office/powerpoint/2010/main" val="1658236945"/>
+        <p14:creationId xmlns:p14="http://schemas.microsoft.com/office/powerpoint/2010/main" val="2406687361"/>
       </p:ext>
     </p:extLst>
   </p:cSld>
@@ -3417,7 +3417,7 @@
           <p:cNvPr id="2" name="Title 1">
             <a:extLst>
               <a:ext uri="{FF2B5EF4-FFF2-40B4-BE49-F238E27FC236}">
-                <a16:creationId xmlns:a16="http://schemas.microsoft.com/office/drawing/2014/main" id="{105FD0A8-4BDE-DB82-89F2-817042BB153C}"/>
+                <a16:creationId xmlns:a16="http://schemas.microsoft.com/office/drawing/2014/main" id="{B5B73133-6D20-804F-720C-007E69C80AE8}"/>
               </a:ext>
             </a:extLst>
           </p:cNvPr>
@@ -3455,7 +3455,7 @@
           <p:cNvPr id="3" name="Content Placeholder 2">
             <a:extLst>
               <a:ext uri="{FF2B5EF4-FFF2-40B4-BE49-F238E27FC236}">
-                <a16:creationId xmlns:a16="http://schemas.microsoft.com/office/drawing/2014/main" id="{2B1780A2-D2F0-73DA-7259-4B91C4DEDE6E}"/>
+                <a16:creationId xmlns:a16="http://schemas.microsoft.com/office/drawing/2014/main" id="{C9A604B3-1AC1-14C9-63D2-E24B9B634FA5}"/>
               </a:ext>
             </a:extLst>
           </p:cNvPr>
@@ -3546,7 +3546,7 @@
           <p:cNvPr id="4" name="Text Placeholder 3">
             <a:extLst>
               <a:ext uri="{FF2B5EF4-FFF2-40B4-BE49-F238E27FC236}">
-                <a16:creationId xmlns:a16="http://schemas.microsoft.com/office/drawing/2014/main" id="{3AA70730-9B95-696E-38C0-7B1F8D460B00}"/>
+                <a16:creationId xmlns:a16="http://schemas.microsoft.com/office/drawing/2014/main" id="{5302ED57-AC14-63B6-C835-8991F3C0D370}"/>
               </a:ext>
             </a:extLst>
           </p:cNvPr>
@@ -3617,7 +3617,7 @@
           <p:cNvPr id="5" name="Date Placeholder 4">
             <a:extLst>
               <a:ext uri="{FF2B5EF4-FFF2-40B4-BE49-F238E27FC236}">
-                <a16:creationId xmlns:a16="http://schemas.microsoft.com/office/drawing/2014/main" id="{745A39B1-B87C-A9C9-6CD4-B33A0EF05004}"/>
+                <a16:creationId xmlns:a16="http://schemas.microsoft.com/office/drawing/2014/main" id="{C9B88963-B1B0-8BCF-49F8-98AC5BB143E0}"/>
               </a:ext>
             </a:extLst>
           </p:cNvPr>
@@ -3633,9 +3633,9 @@
           <a:bodyPr/>
           <a:lstStyle/>
           <a:p>
-            <a:fld id="{2F8D26A6-D71B-4538-BE7E-D2A35FE8C500}" type="datetimeFigureOut">
+            <a:fld id="{75E84C95-8086-4385-A8BA-6F560668E2C3}" type="datetimeFigureOut">
               <a:rPr lang="en-MY" smtClean="0"/>
-              <a:t>24/9/2026</a:t>
+              <a:t>25/9/2026</a:t>
             </a:fld>
             <a:endParaRPr lang="en-MY"/>
           </a:p>
@@ -3646,7 +3646,7 @@
           <p:cNvPr id="6" name="Footer Placeholder 5">
             <a:extLst>
               <a:ext uri="{FF2B5EF4-FFF2-40B4-BE49-F238E27FC236}">
-                <a16:creationId xmlns:a16="http://schemas.microsoft.com/office/drawing/2014/main" id="{5261FCB0-ACD3-26A1-9312-3FCB1B237BDD}"/>
+                <a16:creationId xmlns:a16="http://schemas.microsoft.com/office/drawing/2014/main" id="{DD512C86-45F1-5DFA-8460-5EF4A9DD7220}"/>
               </a:ext>
             </a:extLst>
           </p:cNvPr>
@@ -3671,7 +3671,7 @@
           <p:cNvPr id="7" name="Slide Number Placeholder 6">
             <a:extLst>
               <a:ext uri="{FF2B5EF4-FFF2-40B4-BE49-F238E27FC236}">
-                <a16:creationId xmlns:a16="http://schemas.microsoft.com/office/drawing/2014/main" id="{41D74D84-18C2-AB84-50D5-7F1E02D55B81}"/>
+                <a16:creationId xmlns:a16="http://schemas.microsoft.com/office/drawing/2014/main" id="{B853922B-EEF5-D37B-64D6-28CEDB446FC7}"/>
               </a:ext>
             </a:extLst>
           </p:cNvPr>
@@ -3687,7 +3687,7 @@
           <a:bodyPr/>
           <a:lstStyle/>
           <a:p>
-            <a:fld id="{3A1571EA-3779-4ED8-A27C-B0EAA1CBA9CE}" type="slidenum">
+            <a:fld id="{8BC4A4B2-CAF2-40F7-91B4-6AE8933782A6}" type="slidenum">
               <a:rPr lang="en-MY" smtClean="0"/>
               <a:t>‹#›</a:t>
             </a:fld>
@@ -3698,7 +3698,7 @@
     </p:spTree>
     <p:extLst>
       <p:ext uri="{BB962C8B-B14F-4D97-AF65-F5344CB8AC3E}">
-        <p14:creationId xmlns:p14="http://schemas.microsoft.com/office/powerpoint/2010/main" val="1906720132"/>
+        <p14:creationId xmlns:p14="http://schemas.microsoft.com/office/powerpoint/2010/main" val="1973147054"/>
       </p:ext>
     </p:extLst>
   </p:cSld>
@@ -3730,7 +3730,7 @@
           <p:cNvPr id="2" name="Title 1">
             <a:extLst>
               <a:ext uri="{FF2B5EF4-FFF2-40B4-BE49-F238E27FC236}">
-                <a16:creationId xmlns:a16="http://schemas.microsoft.com/office/drawing/2014/main" id="{49CE2EAB-8EB8-5809-B09E-C5A0A68D27F3}"/>
+                <a16:creationId xmlns:a16="http://schemas.microsoft.com/office/drawing/2014/main" id="{48256F1F-7360-2B11-8823-E96D1888184F}"/>
               </a:ext>
             </a:extLst>
           </p:cNvPr>
@@ -3768,7 +3768,7 @@
           <p:cNvPr id="3" name="Picture Placeholder 2">
             <a:extLst>
               <a:ext uri="{FF2B5EF4-FFF2-40B4-BE49-F238E27FC236}">
-                <a16:creationId xmlns:a16="http://schemas.microsoft.com/office/drawing/2014/main" id="{3B8E499D-8849-39FF-0382-9CFF05A0719C}"/>
+                <a16:creationId xmlns:a16="http://schemas.microsoft.com/office/drawing/2014/main" id="{3593B6C9-EC9F-2F4A-C930-31DA55721AE7}"/>
               </a:ext>
             </a:extLst>
           </p:cNvPr>
@@ -3835,7 +3835,7 @@
           <p:cNvPr id="4" name="Text Placeholder 3">
             <a:extLst>
               <a:ext uri="{FF2B5EF4-FFF2-40B4-BE49-F238E27FC236}">
-                <a16:creationId xmlns:a16="http://schemas.microsoft.com/office/drawing/2014/main" id="{1E4AE888-E2D5-CA38-BA31-6F24910AD44D}"/>
+                <a16:creationId xmlns:a16="http://schemas.microsoft.com/office/drawing/2014/main" id="{EB0D36C1-6F90-3B75-57AD-C4D1A6618431}"/>
               </a:ext>
             </a:extLst>
           </p:cNvPr>
@@ -3906,7 +3906,7 @@
           <p:cNvPr id="5" name="Date Placeholder 4">
             <a:extLst>
               <a:ext uri="{FF2B5EF4-FFF2-40B4-BE49-F238E27FC236}">
-                <a16:creationId xmlns:a16="http://schemas.microsoft.com/office/drawing/2014/main" id="{D62CCA2A-DD7C-0253-3FF5-7DEDD211D120}"/>
+                <a16:creationId xmlns:a16="http://schemas.microsoft.com/office/drawing/2014/main" id="{874AFF72-856F-AC7F-BCD5-399A5B58B399}"/>
               </a:ext>
             </a:extLst>
           </p:cNvPr>
@@ -3922,9 +3922,9 @@
           <a:bodyPr/>
           <a:lstStyle/>
           <a:p>
-            <a:fld id="{2F8D26A6-D71B-4538-BE7E-D2A35FE8C500}" type="datetimeFigureOut">
+            <a:fld id="{75E84C95-8086-4385-A8BA-6F560668E2C3}" type="datetimeFigureOut">
               <a:rPr lang="en-MY" smtClean="0"/>
-              <a:t>24/9/2026</a:t>
+              <a:t>25/9/2026</a:t>
             </a:fld>
             <a:endParaRPr lang="en-MY"/>
           </a:p>
@@ -3935,7 +3935,7 @@
           <p:cNvPr id="6" name="Footer Placeholder 5">
             <a:extLst>
               <a:ext uri="{FF2B5EF4-FFF2-40B4-BE49-F238E27FC236}">
-                <a16:creationId xmlns:a16="http://schemas.microsoft.com/office/drawing/2014/main" id="{5B00417B-837E-4429-405B-2209D41A0354}"/>
+                <a16:creationId xmlns:a16="http://schemas.microsoft.com/office/drawing/2014/main" id="{8389BB72-78E4-8F4E-AD16-6B650CBDC0CF}"/>
               </a:ext>
             </a:extLst>
           </p:cNvPr>
@@ -3960,7 +3960,7 @@
           <p:cNvPr id="7" name="Slide Number Placeholder 6">
             <a:extLst>
               <a:ext uri="{FF2B5EF4-FFF2-40B4-BE49-F238E27FC236}">
-                <a16:creationId xmlns:a16="http://schemas.microsoft.com/office/drawing/2014/main" id="{DE762FA2-6CE3-E274-4B6C-2EDA6EE660C6}"/>
+                <a16:creationId xmlns:a16="http://schemas.microsoft.com/office/drawing/2014/main" id="{57362080-6B06-0CE3-5772-D46F136578BF}"/>
               </a:ext>
             </a:extLst>
           </p:cNvPr>
@@ -3976,7 +3976,7 @@
           <a:bodyPr/>
           <a:lstStyle/>
           <a:p>
-            <a:fld id="{3A1571EA-3779-4ED8-A27C-B0EAA1CBA9CE}" type="slidenum">
+            <a:fld id="{8BC4A4B2-CAF2-40F7-91B4-6AE8933782A6}" type="slidenum">
               <a:rPr lang="en-MY" smtClean="0"/>
               <a:t>‹#›</a:t>
             </a:fld>
@@ -3987,7 +3987,7 @@
     </p:spTree>
     <p:extLst>
       <p:ext uri="{BB962C8B-B14F-4D97-AF65-F5344CB8AC3E}">
-        <p14:creationId xmlns:p14="http://schemas.microsoft.com/office/powerpoint/2010/main" val="881667646"/>
+        <p14:creationId xmlns:p14="http://schemas.microsoft.com/office/powerpoint/2010/main" val="644368543"/>
       </p:ext>
     </p:extLst>
   </p:cSld>
@@ -4024,7 +4024,7 @@
           <p:cNvPr id="2" name="Title Placeholder 1">
             <a:extLst>
               <a:ext uri="{FF2B5EF4-FFF2-40B4-BE49-F238E27FC236}">
-                <a16:creationId xmlns:a16="http://schemas.microsoft.com/office/drawing/2014/main" id="{0A23BD1A-37C8-8331-A9AB-6E2AB9766420}"/>
+                <a16:creationId xmlns:a16="http://schemas.microsoft.com/office/drawing/2014/main" id="{D0F0146B-DB96-7D77-3955-4399C1135FD2}"/>
               </a:ext>
             </a:extLst>
           </p:cNvPr>
@@ -4063,7 +4063,7 @@
           <p:cNvPr id="3" name="Text Placeholder 2">
             <a:extLst>
               <a:ext uri="{FF2B5EF4-FFF2-40B4-BE49-F238E27FC236}">
-                <a16:creationId xmlns:a16="http://schemas.microsoft.com/office/drawing/2014/main" id="{8AA7ACD9-0A91-47F1-6E7F-668571C3E313}"/>
+                <a16:creationId xmlns:a16="http://schemas.microsoft.com/office/drawing/2014/main" id="{E3CBBABB-573A-17E2-5E58-C90F21059058}"/>
               </a:ext>
             </a:extLst>
           </p:cNvPr>
@@ -4131,7 +4131,7 @@
           <p:cNvPr id="4" name="Date Placeholder 3">
             <a:extLst>
               <a:ext uri="{FF2B5EF4-FFF2-40B4-BE49-F238E27FC236}">
-                <a16:creationId xmlns:a16="http://schemas.microsoft.com/office/drawing/2014/main" id="{DD49AE63-1565-10AC-91FF-007FC2788FF4}"/>
+                <a16:creationId xmlns:a16="http://schemas.microsoft.com/office/drawing/2014/main" id="{2028028C-4A72-0171-4210-ABBB4360BC54}"/>
               </a:ext>
             </a:extLst>
           </p:cNvPr>
@@ -4165,9 +4165,9 @@
             </a:lvl1pPr>
           </a:lstStyle>
           <a:p>
-            <a:fld id="{2F8D26A6-D71B-4538-BE7E-D2A35FE8C500}" type="datetimeFigureOut">
+            <a:fld id="{75E84C95-8086-4385-A8BA-6F560668E2C3}" type="datetimeFigureOut">
               <a:rPr lang="en-MY" smtClean="0"/>
-              <a:t>24/9/2026</a:t>
+              <a:t>25/9/2026</a:t>
             </a:fld>
             <a:endParaRPr lang="en-MY"/>
           </a:p>
@@ -4178,7 +4178,7 @@
           <p:cNvPr id="5" name="Footer Placeholder 4">
             <a:extLst>
               <a:ext uri="{FF2B5EF4-FFF2-40B4-BE49-F238E27FC236}">
-                <a16:creationId xmlns:a16="http://schemas.microsoft.com/office/drawing/2014/main" id="{B5A60928-FB6D-3A7F-D452-5ACB74753CD7}"/>
+                <a16:creationId xmlns:a16="http://schemas.microsoft.com/office/drawing/2014/main" id="{15E180C4-0CCC-101E-59B9-7390C1EDBE36}"/>
               </a:ext>
             </a:extLst>
           </p:cNvPr>
@@ -4221,7 +4221,7 @@
           <p:cNvPr id="6" name="Slide Number Placeholder 5">
             <a:extLst>
               <a:ext uri="{FF2B5EF4-FFF2-40B4-BE49-F238E27FC236}">
-                <a16:creationId xmlns:a16="http://schemas.microsoft.com/office/drawing/2014/main" id="{E0BBF07E-1364-8772-1087-DA776997BEC5}"/>
+                <a16:creationId xmlns:a16="http://schemas.microsoft.com/office/drawing/2014/main" id="{E9A0CC83-49EF-A163-E374-1B0868C0FB1F}"/>
               </a:ext>
             </a:extLst>
           </p:cNvPr>
@@ -4255,7 +4255,7 @@
             </a:lvl1pPr>
           </a:lstStyle>
           <a:p>
-            <a:fld id="{3A1571EA-3779-4ED8-A27C-B0EAA1CBA9CE}" type="slidenum">
+            <a:fld id="{8BC4A4B2-CAF2-40F7-91B4-6AE8933782A6}" type="slidenum">
               <a:rPr lang="en-MY" smtClean="0"/>
               <a:t>‹#›</a:t>
             </a:fld>
@@ -4266,7 +4266,7 @@
     </p:spTree>
     <p:extLst>
       <p:ext uri="{BB962C8B-B14F-4D97-AF65-F5344CB8AC3E}">
-        <p14:creationId xmlns:p14="http://schemas.microsoft.com/office/powerpoint/2010/main" val="1452899008"/>
+        <p14:creationId xmlns:p14="http://schemas.microsoft.com/office/powerpoint/2010/main" val="242825060"/>
       </p:ext>
     </p:extLst>
   </p:cSld>
@@ -4597,7 +4597,7 @@
           <p:cNvPr id="2" name="TextBox 1">
             <a:extLst>
               <a:ext uri="{FF2B5EF4-FFF2-40B4-BE49-F238E27FC236}">
-                <a16:creationId xmlns:a16="http://schemas.microsoft.com/office/drawing/2014/main" id="{04688185-681C-B34E-810A-0A8877458AB1}"/>
+                <a16:creationId xmlns:a16="http://schemas.microsoft.com/office/drawing/2014/main" id="{C9F1DEFF-2BF6-A073-5950-66C70587A778}"/>
               </a:ext>
             </a:extLst>
           </p:cNvPr>
@@ -4637,7 +4637,7 @@
           <p:cNvPr id="3" name="TextBox 2">
             <a:extLst>
               <a:ext uri="{FF2B5EF4-FFF2-40B4-BE49-F238E27FC236}">
-                <a16:creationId xmlns:a16="http://schemas.microsoft.com/office/drawing/2014/main" id="{51568EAB-E7D6-8521-1BE2-FA84676E2452}"/>
+                <a16:creationId xmlns:a16="http://schemas.microsoft.com/office/drawing/2014/main" id="{AD0CB622-2DA3-2312-A9EE-2EE5A5A714B5}"/>
               </a:ext>
             </a:extLst>
           </p:cNvPr>
@@ -4683,7 +4683,7 @@
           <p:cNvPr id="4" name="TextBox 3">
             <a:extLst>
               <a:ext uri="{FF2B5EF4-FFF2-40B4-BE49-F238E27FC236}">
-                <a16:creationId xmlns:a16="http://schemas.microsoft.com/office/drawing/2014/main" id="{1F2D47D5-2481-95B1-4CC3-8CD19FCA3166}"/>
+                <a16:creationId xmlns:a16="http://schemas.microsoft.com/office/drawing/2014/main" id="{258BB32D-9412-17AB-927C-D83235978EA5}"/>
               </a:ext>
             </a:extLst>
           </p:cNvPr>
@@ -4729,7 +4729,7 @@
           <p:cNvPr id="5" name="TextBox 4">
             <a:extLst>
               <a:ext uri="{FF2B5EF4-FFF2-40B4-BE49-F238E27FC236}">
-                <a16:creationId xmlns:a16="http://schemas.microsoft.com/office/drawing/2014/main" id="{1B0FD74F-7A65-AF98-B07E-04AB0F9AFF3C}"/>
+                <a16:creationId xmlns:a16="http://schemas.microsoft.com/office/drawing/2014/main" id="{D81FF64F-2BE7-D58E-C517-320BC145D724}"/>
               </a:ext>
             </a:extLst>
           </p:cNvPr>
@@ -4775,7 +4775,7 @@
           <p:cNvPr id="6" name="TextBox 5">
             <a:extLst>
               <a:ext uri="{FF2B5EF4-FFF2-40B4-BE49-F238E27FC236}">
-                <a16:creationId xmlns:a16="http://schemas.microsoft.com/office/drawing/2014/main" id="{C7D69BDF-93F1-2297-291F-21D4BAA5099E}"/>
+                <a16:creationId xmlns:a16="http://schemas.microsoft.com/office/drawing/2014/main" id="{15BDB901-D66E-F877-D56A-3356C73A27EA}"/>
               </a:ext>
             </a:extLst>
           </p:cNvPr>
@@ -4815,7 +4815,7 @@
           <p:cNvPr id="7" name="TextBox 6">
             <a:extLst>
               <a:ext uri="{FF2B5EF4-FFF2-40B4-BE49-F238E27FC236}">
-                <a16:creationId xmlns:a16="http://schemas.microsoft.com/office/drawing/2014/main" id="{982AF74C-62FF-3ADC-854D-55A7B87A5293}"/>
+                <a16:creationId xmlns:a16="http://schemas.microsoft.com/office/drawing/2014/main" id="{B6355805-38F5-AADD-F740-D999FAE7FE6D}"/>
               </a:ext>
             </a:extLst>
           </p:cNvPr>
@@ -4860,7 +4860,7 @@
     </p:spTree>
     <p:extLst>
       <p:ext uri="{BB962C8B-B14F-4D97-AF65-F5344CB8AC3E}">
-        <p14:creationId xmlns:p14="http://schemas.microsoft.com/office/powerpoint/2010/main" val="2007751059"/>
+        <p14:creationId xmlns:p14="http://schemas.microsoft.com/office/powerpoint/2010/main" val="1641223872"/>
       </p:ext>
     </p:extLst>
   </p:cSld>
@@ -4900,7 +4900,7 @@
           <p:cNvPr id="2" name="TextBox 1">
             <a:extLst>
               <a:ext uri="{FF2B5EF4-FFF2-40B4-BE49-F238E27FC236}">
-                <a16:creationId xmlns:a16="http://schemas.microsoft.com/office/drawing/2014/main" id="{85225ABB-F83B-7C1B-9319-97F9C972F146}"/>
+                <a16:creationId xmlns:a16="http://schemas.microsoft.com/office/drawing/2014/main" id="{98F9FF10-4078-B6F7-737B-35D484C8F19B}"/>
               </a:ext>
             </a:extLst>
           </p:cNvPr>
@@ -4947,7 +4947,7 @@
           <p:cNvPr id="3" name="TextBox 2">
             <a:extLst>
               <a:ext uri="{FF2B5EF4-FFF2-40B4-BE49-F238E27FC236}">
-                <a16:creationId xmlns:a16="http://schemas.microsoft.com/office/drawing/2014/main" id="{AB59134A-766F-CC39-5370-E1D4761D6BE5}"/>
+                <a16:creationId xmlns:a16="http://schemas.microsoft.com/office/drawing/2014/main" id="{65DFFAFF-C10C-3691-64FA-63711ECE6907}"/>
               </a:ext>
             </a:extLst>
           </p:cNvPr>
@@ -4988,7 +4988,7 @@
           <p:cNvPr id="4" name="TextBox 3">
             <a:extLst>
               <a:ext uri="{FF2B5EF4-FFF2-40B4-BE49-F238E27FC236}">
-                <a16:creationId xmlns:a16="http://schemas.microsoft.com/office/drawing/2014/main" id="{202F9563-F324-610B-1360-28668B9BE730}"/>
+                <a16:creationId xmlns:a16="http://schemas.microsoft.com/office/drawing/2014/main" id="{A0AC3F5D-5DA3-E0A6-B2F5-308711CF43D6}"/>
               </a:ext>
             </a:extLst>
           </p:cNvPr>
@@ -5027,7 +5027,7 @@
     </p:spTree>
     <p:extLst>
       <p:ext uri="{BB962C8B-B14F-4D97-AF65-F5344CB8AC3E}">
-        <p14:creationId xmlns:p14="http://schemas.microsoft.com/office/powerpoint/2010/main" val="2554288377"/>
+        <p14:creationId xmlns:p14="http://schemas.microsoft.com/office/powerpoint/2010/main" val="3966682004"/>
       </p:ext>
     </p:extLst>
   </p:cSld>
@@ -5067,7 +5067,7 @@
           <p:cNvPr id="2" name="TextBox 1">
             <a:extLst>
               <a:ext uri="{FF2B5EF4-FFF2-40B4-BE49-F238E27FC236}">
-                <a16:creationId xmlns:a16="http://schemas.microsoft.com/office/drawing/2014/main" id="{155ED394-EAE2-B73B-E5FF-50C696B3B0A4}"/>
+                <a16:creationId xmlns:a16="http://schemas.microsoft.com/office/drawing/2014/main" id="{5EF6032B-14A9-DD7C-7C23-88DCA7A579AE}"/>
               </a:ext>
             </a:extLst>
           </p:cNvPr>
@@ -5113,7 +5113,7 @@
           <p:cNvPr id="3" name="Rectangle: Rounded Corners 2">
             <a:extLst>
               <a:ext uri="{FF2B5EF4-FFF2-40B4-BE49-F238E27FC236}">
-                <a16:creationId xmlns:a16="http://schemas.microsoft.com/office/drawing/2014/main" id="{9BF4ABDB-995D-31DE-3B13-3789C1A37E78}"/>
+                <a16:creationId xmlns:a16="http://schemas.microsoft.com/office/drawing/2014/main" id="{135E3853-F5D6-46B5-DB55-82D1675E5DF1}"/>
               </a:ext>
             </a:extLst>
           </p:cNvPr>
@@ -5183,7 +5183,7 @@
           <p:cNvPr id="4" name="Oval 3">
             <a:extLst>
               <a:ext uri="{FF2B5EF4-FFF2-40B4-BE49-F238E27FC236}">
-                <a16:creationId xmlns:a16="http://schemas.microsoft.com/office/drawing/2014/main" id="{8EE34568-2BEF-B4DC-3EB5-8D8F0F0D075D}"/>
+                <a16:creationId xmlns:a16="http://schemas.microsoft.com/office/drawing/2014/main" id="{CBA11C2A-A00A-630A-47AC-FDA0EA0B5131}"/>
               </a:ext>
             </a:extLst>
           </p:cNvPr>
@@ -5259,7 +5259,7 @@
           <p:cNvPr id="5" name="TextBox 4">
             <a:extLst>
               <a:ext uri="{FF2B5EF4-FFF2-40B4-BE49-F238E27FC236}">
-                <a16:creationId xmlns:a16="http://schemas.microsoft.com/office/drawing/2014/main" id="{FEAA5F87-A9CD-DB72-D6C4-CD93FEAB0FFA}"/>
+                <a16:creationId xmlns:a16="http://schemas.microsoft.com/office/drawing/2014/main" id="{1D8C8661-BE60-911A-3CCF-A317E330902C}"/>
               </a:ext>
             </a:extLst>
           </p:cNvPr>
@@ -5299,7 +5299,7 @@
           <p:cNvPr id="6" name="TextBox 5">
             <a:extLst>
               <a:ext uri="{FF2B5EF4-FFF2-40B4-BE49-F238E27FC236}">
-                <a16:creationId xmlns:a16="http://schemas.microsoft.com/office/drawing/2014/main" id="{F78D9F93-08F4-D9AD-0D58-ED7D621A6459}"/>
+                <a16:creationId xmlns:a16="http://schemas.microsoft.com/office/drawing/2014/main" id="{155F8971-9AF2-DBBF-1E2E-8ECD803958BD}"/>
               </a:ext>
             </a:extLst>
           </p:cNvPr>
@@ -5339,7 +5339,7 @@
           <p:cNvPr id="7" name="Rectangle: Rounded Corners 6">
             <a:extLst>
               <a:ext uri="{FF2B5EF4-FFF2-40B4-BE49-F238E27FC236}">
-                <a16:creationId xmlns:a16="http://schemas.microsoft.com/office/drawing/2014/main" id="{01D93166-7B04-76BB-ECA4-ADEA8F4340DE}"/>
+                <a16:creationId xmlns:a16="http://schemas.microsoft.com/office/drawing/2014/main" id="{0DEA6959-D12A-F5BE-925F-E740154395E4}"/>
               </a:ext>
             </a:extLst>
           </p:cNvPr>
@@ -5409,7 +5409,7 @@
           <p:cNvPr id="8" name="Oval 7">
             <a:extLst>
               <a:ext uri="{FF2B5EF4-FFF2-40B4-BE49-F238E27FC236}">
-                <a16:creationId xmlns:a16="http://schemas.microsoft.com/office/drawing/2014/main" id="{B3BFCEDA-DEA8-2BDE-BD18-56DAD6F4DEF7}"/>
+                <a16:creationId xmlns:a16="http://schemas.microsoft.com/office/drawing/2014/main" id="{C6FDEB1B-63ED-CDE6-E1C8-DC1A54C26904}"/>
               </a:ext>
             </a:extLst>
           </p:cNvPr>
@@ -5485,7 +5485,7 @@
           <p:cNvPr id="9" name="TextBox 8">
             <a:extLst>
               <a:ext uri="{FF2B5EF4-FFF2-40B4-BE49-F238E27FC236}">
-                <a16:creationId xmlns:a16="http://schemas.microsoft.com/office/drawing/2014/main" id="{FC4CC75F-136A-8DFB-2878-3C10E175A096}"/>
+                <a16:creationId xmlns:a16="http://schemas.microsoft.com/office/drawing/2014/main" id="{4388E605-5306-D094-CAB6-0DFF6CF8F72D}"/>
               </a:ext>
             </a:extLst>
           </p:cNvPr>
@@ -5525,7 +5525,7 @@
           <p:cNvPr id="10" name="TextBox 9">
             <a:extLst>
               <a:ext uri="{FF2B5EF4-FFF2-40B4-BE49-F238E27FC236}">
-                <a16:creationId xmlns:a16="http://schemas.microsoft.com/office/drawing/2014/main" id="{05305E01-A1DE-22F3-C14D-48B5A0A2504A}"/>
+                <a16:creationId xmlns:a16="http://schemas.microsoft.com/office/drawing/2014/main" id="{0D327335-AE18-0BE8-46E1-F01A482F6883}"/>
               </a:ext>
             </a:extLst>
           </p:cNvPr>
@@ -5571,7 +5571,7 @@
           <p:cNvPr id="11" name="Rectangle: Rounded Corners 10">
             <a:extLst>
               <a:ext uri="{FF2B5EF4-FFF2-40B4-BE49-F238E27FC236}">
-                <a16:creationId xmlns:a16="http://schemas.microsoft.com/office/drawing/2014/main" id="{A7779ABA-ACD1-F11C-7459-68684860B058}"/>
+                <a16:creationId xmlns:a16="http://schemas.microsoft.com/office/drawing/2014/main" id="{651BF659-0343-B2A9-A855-07F8471793C3}"/>
               </a:ext>
             </a:extLst>
           </p:cNvPr>
@@ -5641,7 +5641,7 @@
           <p:cNvPr id="12" name="Oval 11">
             <a:extLst>
               <a:ext uri="{FF2B5EF4-FFF2-40B4-BE49-F238E27FC236}">
-                <a16:creationId xmlns:a16="http://schemas.microsoft.com/office/drawing/2014/main" id="{FC29447A-8E9B-3EB7-7E3C-93584493EFD6}"/>
+                <a16:creationId xmlns:a16="http://schemas.microsoft.com/office/drawing/2014/main" id="{C07584C7-FEA7-EBEE-C236-CEC3DB676916}"/>
               </a:ext>
             </a:extLst>
           </p:cNvPr>
@@ -5717,7 +5717,7 @@
           <p:cNvPr id="13" name="TextBox 12">
             <a:extLst>
               <a:ext uri="{FF2B5EF4-FFF2-40B4-BE49-F238E27FC236}">
-                <a16:creationId xmlns:a16="http://schemas.microsoft.com/office/drawing/2014/main" id="{821A25C5-1F69-C158-D2B6-386EBF239FBE}"/>
+                <a16:creationId xmlns:a16="http://schemas.microsoft.com/office/drawing/2014/main" id="{2E75113C-FDAC-430F-0DBB-1CC1078FF387}"/>
               </a:ext>
             </a:extLst>
           </p:cNvPr>
@@ -5757,7 +5757,7 @@
           <p:cNvPr id="14" name="TextBox 13">
             <a:extLst>
               <a:ext uri="{FF2B5EF4-FFF2-40B4-BE49-F238E27FC236}">
-                <a16:creationId xmlns:a16="http://schemas.microsoft.com/office/drawing/2014/main" id="{6496D5D2-2E50-B42D-80DF-6B79133BA98F}"/>
+                <a16:creationId xmlns:a16="http://schemas.microsoft.com/office/drawing/2014/main" id="{96DAC7D9-ADBF-B48F-C684-F6096CBDBE4F}"/>
               </a:ext>
             </a:extLst>
           </p:cNvPr>
@@ -5803,7 +5803,7 @@
           <p:cNvPr id="15" name="Rectangle: Rounded Corners 14">
             <a:extLst>
               <a:ext uri="{FF2B5EF4-FFF2-40B4-BE49-F238E27FC236}">
-                <a16:creationId xmlns:a16="http://schemas.microsoft.com/office/drawing/2014/main" id="{09529E7B-4E89-D09A-DFE8-83652183BDCE}"/>
+                <a16:creationId xmlns:a16="http://schemas.microsoft.com/office/drawing/2014/main" id="{F38B8F90-47FA-CAE1-3ED6-662377AA65CD}"/>
               </a:ext>
             </a:extLst>
           </p:cNvPr>
@@ -5873,7 +5873,7 @@
           <p:cNvPr id="16" name="Oval 15">
             <a:extLst>
               <a:ext uri="{FF2B5EF4-FFF2-40B4-BE49-F238E27FC236}">
-                <a16:creationId xmlns:a16="http://schemas.microsoft.com/office/drawing/2014/main" id="{699CE4F5-89CD-83DA-2414-5C9065B4B087}"/>
+                <a16:creationId xmlns:a16="http://schemas.microsoft.com/office/drawing/2014/main" id="{1F900C07-8F2E-340A-F69A-EA8A15F6D247}"/>
               </a:ext>
             </a:extLst>
           </p:cNvPr>
@@ -5949,7 +5949,7 @@
           <p:cNvPr id="17" name="TextBox 16">
             <a:extLst>
               <a:ext uri="{FF2B5EF4-FFF2-40B4-BE49-F238E27FC236}">
-                <a16:creationId xmlns:a16="http://schemas.microsoft.com/office/drawing/2014/main" id="{997993B5-4333-0281-DAD8-97958FE50A7F}"/>
+                <a16:creationId xmlns:a16="http://schemas.microsoft.com/office/drawing/2014/main" id="{FCBD32BB-7E75-C5E3-435A-2280E0B55DB0}"/>
               </a:ext>
             </a:extLst>
           </p:cNvPr>
@@ -5989,7 +5989,7 @@
           <p:cNvPr id="18" name="TextBox 17">
             <a:extLst>
               <a:ext uri="{FF2B5EF4-FFF2-40B4-BE49-F238E27FC236}">
-                <a16:creationId xmlns:a16="http://schemas.microsoft.com/office/drawing/2014/main" id="{6B3445B8-F7AF-69F7-0957-10E0F0D5D7E6}"/>
+                <a16:creationId xmlns:a16="http://schemas.microsoft.com/office/drawing/2014/main" id="{020A3B65-7CF4-F129-2EC9-53280FE13F2C}"/>
               </a:ext>
             </a:extLst>
           </p:cNvPr>
@@ -6035,7 +6035,7 @@
           <p:cNvPr id="19" name="TextBox 18">
             <a:extLst>
               <a:ext uri="{FF2B5EF4-FFF2-40B4-BE49-F238E27FC236}">
-                <a16:creationId xmlns:a16="http://schemas.microsoft.com/office/drawing/2014/main" id="{D64E800A-F043-AA62-316E-5071C3FC342F}"/>
+                <a16:creationId xmlns:a16="http://schemas.microsoft.com/office/drawing/2014/main" id="{B52A5287-FE6B-5D99-AB1B-EB205949C03B}"/>
               </a:ext>
             </a:extLst>
           </p:cNvPr>
@@ -6081,7 +6081,7 @@
           <p:cNvPr id="20" name="TextBox 19">
             <a:extLst>
               <a:ext uri="{FF2B5EF4-FFF2-40B4-BE49-F238E27FC236}">
-                <a16:creationId xmlns:a16="http://schemas.microsoft.com/office/drawing/2014/main" id="{CE6290B6-92E5-DDE1-4A45-86EBDE78BD5E}"/>
+                <a16:creationId xmlns:a16="http://schemas.microsoft.com/office/drawing/2014/main" id="{74C9C63E-BBC2-BD44-56B5-7F3DA756A320}"/>
               </a:ext>
             </a:extLst>
           </p:cNvPr>
@@ -6127,7 +6127,7 @@
           <p:cNvPr id="21" name="TextBox 20">
             <a:extLst>
               <a:ext uri="{FF2B5EF4-FFF2-40B4-BE49-F238E27FC236}">
-                <a16:creationId xmlns:a16="http://schemas.microsoft.com/office/drawing/2014/main" id="{6CF3586E-6E8C-F9B0-AD56-857489101578}"/>
+                <a16:creationId xmlns:a16="http://schemas.microsoft.com/office/drawing/2014/main" id="{0CF74D31-F935-C763-39E7-63BFB9B5BC18}"/>
               </a:ext>
             </a:extLst>
           </p:cNvPr>
@@ -6173,7 +6173,7 @@
           <p:cNvPr id="22" name="TextBox 21">
             <a:extLst>
               <a:ext uri="{FF2B5EF4-FFF2-40B4-BE49-F238E27FC236}">
-                <a16:creationId xmlns:a16="http://schemas.microsoft.com/office/drawing/2014/main" id="{7E65143E-E947-7E61-8233-219E9BAB8CFD}"/>
+                <a16:creationId xmlns:a16="http://schemas.microsoft.com/office/drawing/2014/main" id="{65C62AC8-63C4-5C01-434C-0E7F37CE4DB1}"/>
               </a:ext>
             </a:extLst>
           </p:cNvPr>
@@ -6219,7 +6219,7 @@
           <p:cNvPr id="23" name="TextBox 22">
             <a:extLst>
               <a:ext uri="{FF2B5EF4-FFF2-40B4-BE49-F238E27FC236}">
-                <a16:creationId xmlns:a16="http://schemas.microsoft.com/office/drawing/2014/main" id="{288B3E9E-02E1-18E1-94D6-67CFB87DA086}"/>
+                <a16:creationId xmlns:a16="http://schemas.microsoft.com/office/drawing/2014/main" id="{7F332BC5-5282-B74F-0197-62982E97E319}"/>
               </a:ext>
             </a:extLst>
           </p:cNvPr>
@@ -6265,7 +6265,7 @@
           <p:cNvPr id="24" name="TextBox 23">
             <a:extLst>
               <a:ext uri="{FF2B5EF4-FFF2-40B4-BE49-F238E27FC236}">
-                <a16:creationId xmlns:a16="http://schemas.microsoft.com/office/drawing/2014/main" id="{6890D010-EBCC-C972-24E7-AC0EDE13A5DC}"/>
+                <a16:creationId xmlns:a16="http://schemas.microsoft.com/office/drawing/2014/main" id="{4A2409BA-261B-6B11-7D92-8A878AC216DB}"/>
               </a:ext>
             </a:extLst>
           </p:cNvPr>
@@ -6311,7 +6311,7 @@
           <p:cNvPr id="25" name="TextBox 24">
             <a:extLst>
               <a:ext uri="{FF2B5EF4-FFF2-40B4-BE49-F238E27FC236}">
-                <a16:creationId xmlns:a16="http://schemas.microsoft.com/office/drawing/2014/main" id="{BED1208B-B573-1B59-EFE6-A30711210E28}"/>
+                <a16:creationId xmlns:a16="http://schemas.microsoft.com/office/drawing/2014/main" id="{71E28FE0-01CF-D24A-ABD8-6096E9BE6050}"/>
               </a:ext>
             </a:extLst>
           </p:cNvPr>
@@ -6357,7 +6357,7 @@
           <p:cNvPr id="26" name="Rectangle: Rounded Corners 25">
             <a:extLst>
               <a:ext uri="{FF2B5EF4-FFF2-40B4-BE49-F238E27FC236}">
-                <a16:creationId xmlns:a16="http://schemas.microsoft.com/office/drawing/2014/main" id="{2D174602-3BE8-1A03-4EED-0AFB74E41F72}"/>
+                <a16:creationId xmlns:a16="http://schemas.microsoft.com/office/drawing/2014/main" id="{C2F04F24-3AC5-8C4F-67BA-66416F29F805}"/>
               </a:ext>
             </a:extLst>
           </p:cNvPr>
@@ -6427,7 +6427,7 @@
           <p:cNvPr id="27" name="TextBox 26">
             <a:extLst>
               <a:ext uri="{FF2B5EF4-FFF2-40B4-BE49-F238E27FC236}">
-                <a16:creationId xmlns:a16="http://schemas.microsoft.com/office/drawing/2014/main" id="{C77247F8-7C2B-071B-78B6-727628AB7857}"/>
+                <a16:creationId xmlns:a16="http://schemas.microsoft.com/office/drawing/2014/main" id="{6427ED9F-40C7-2EF1-BB79-33B063FE96CD}"/>
               </a:ext>
             </a:extLst>
           </p:cNvPr>
@@ -6473,7 +6473,7 @@
           <p:cNvPr id="28" name="TextBox 27">
             <a:extLst>
               <a:ext uri="{FF2B5EF4-FFF2-40B4-BE49-F238E27FC236}">
-                <a16:creationId xmlns:a16="http://schemas.microsoft.com/office/drawing/2014/main" id="{A70982EC-AAE6-473E-E60F-56FA31B64A3C}"/>
+                <a16:creationId xmlns:a16="http://schemas.microsoft.com/office/drawing/2014/main" id="{B47C50BB-1BAD-1B82-5429-7337F4357CD6}"/>
               </a:ext>
             </a:extLst>
           </p:cNvPr>
@@ -6518,7 +6518,7 @@
     </p:spTree>
     <p:extLst>
       <p:ext uri="{BB962C8B-B14F-4D97-AF65-F5344CB8AC3E}">
-        <p14:creationId xmlns:p14="http://schemas.microsoft.com/office/powerpoint/2010/main" val="3699902665"/>
+        <p14:creationId xmlns:p14="http://schemas.microsoft.com/office/powerpoint/2010/main" val="4125452464"/>
       </p:ext>
     </p:extLst>
   </p:cSld>
@@ -6558,7 +6558,7 @@
           <p:cNvPr id="2" name="TextBox 1">
             <a:extLst>
               <a:ext uri="{FF2B5EF4-FFF2-40B4-BE49-F238E27FC236}">
-                <a16:creationId xmlns:a16="http://schemas.microsoft.com/office/drawing/2014/main" id="{AD43D84F-5A8B-7685-1146-1338948D88F1}"/>
+                <a16:creationId xmlns:a16="http://schemas.microsoft.com/office/drawing/2014/main" id="{7521A7F5-19BE-1F18-C3A4-1A602085A6C3}"/>
               </a:ext>
             </a:extLst>
           </p:cNvPr>
@@ -6604,7 +6604,7 @@
           <p:cNvPr id="4" name="Picture 3">
             <a:extLst>
               <a:ext uri="{FF2B5EF4-FFF2-40B4-BE49-F238E27FC236}">
-                <a16:creationId xmlns:a16="http://schemas.microsoft.com/office/drawing/2014/main" id="{B39AEFDB-A4F0-9301-8DDB-39A69CB7EAAC}"/>
+                <a16:creationId xmlns:a16="http://schemas.microsoft.com/office/drawing/2014/main" id="{42B119A9-5AE6-3456-2FC3-8ABFECC7162D}"/>
               </a:ext>
             </a:extLst>
           </p:cNvPr>
@@ -6645,7 +6645,7 @@
           <p:cNvPr id="5" name="TextBox 4">
             <a:extLst>
               <a:ext uri="{FF2B5EF4-FFF2-40B4-BE49-F238E27FC236}">
-                <a16:creationId xmlns:a16="http://schemas.microsoft.com/office/drawing/2014/main" id="{C107C9FD-4F4A-918F-07DF-32992E4F16B1}"/>
+                <a16:creationId xmlns:a16="http://schemas.microsoft.com/office/drawing/2014/main" id="{63EFA53F-33FD-C55E-C9A0-4EF254912AEE}"/>
               </a:ext>
             </a:extLst>
           </p:cNvPr>
@@ -6685,7 +6685,7 @@
           <p:cNvPr id="6" name="TextBox 5">
             <a:extLst>
               <a:ext uri="{FF2B5EF4-FFF2-40B4-BE49-F238E27FC236}">
-                <a16:creationId xmlns:a16="http://schemas.microsoft.com/office/drawing/2014/main" id="{8DAAAD95-132B-4F8A-A18D-2CABC9FD7194}"/>
+                <a16:creationId xmlns:a16="http://schemas.microsoft.com/office/drawing/2014/main" id="{D0A17D09-63FC-C9E3-E1C4-EF7D261AFB1F}"/>
               </a:ext>
             </a:extLst>
           </p:cNvPr>
@@ -6725,7 +6725,7 @@
           <p:cNvPr id="7" name="TextBox 6">
             <a:extLst>
               <a:ext uri="{FF2B5EF4-FFF2-40B4-BE49-F238E27FC236}">
-                <a16:creationId xmlns:a16="http://schemas.microsoft.com/office/drawing/2014/main" id="{E8ADE83B-7E2F-6548-0462-364E35F53722}"/>
+                <a16:creationId xmlns:a16="http://schemas.microsoft.com/office/drawing/2014/main" id="{BA22583C-082A-C08D-403A-EBC8B75F0801}"/>
               </a:ext>
             </a:extLst>
           </p:cNvPr>
@@ -6765,7 +6765,7 @@
           <p:cNvPr id="8" name="TextBox 7">
             <a:extLst>
               <a:ext uri="{FF2B5EF4-FFF2-40B4-BE49-F238E27FC236}">
-                <a16:creationId xmlns:a16="http://schemas.microsoft.com/office/drawing/2014/main" id="{E01A2123-0637-9355-7D07-8C7E66503E9D}"/>
+                <a16:creationId xmlns:a16="http://schemas.microsoft.com/office/drawing/2014/main" id="{918AD824-7F82-12C0-4F44-DC0C0787FBFF}"/>
               </a:ext>
             </a:extLst>
           </p:cNvPr>
@@ -6811,7 +6811,7 @@
           <p:cNvPr id="9" name="TextBox 8">
             <a:extLst>
               <a:ext uri="{FF2B5EF4-FFF2-40B4-BE49-F238E27FC236}">
-                <a16:creationId xmlns:a16="http://schemas.microsoft.com/office/drawing/2014/main" id="{67FF3DC6-6984-502A-CBAA-D59705E4278D}"/>
+                <a16:creationId xmlns:a16="http://schemas.microsoft.com/office/drawing/2014/main" id="{EF2CBF0F-E652-7DBA-335D-FD7F9104266E}"/>
               </a:ext>
             </a:extLst>
           </p:cNvPr>
@@ -6851,7 +6851,7 @@
           <p:cNvPr id="10" name="TextBox 9">
             <a:extLst>
               <a:ext uri="{FF2B5EF4-FFF2-40B4-BE49-F238E27FC236}">
-                <a16:creationId xmlns:a16="http://schemas.microsoft.com/office/drawing/2014/main" id="{52667BCF-44AD-DDED-EDA6-818D91EFC955}"/>
+                <a16:creationId xmlns:a16="http://schemas.microsoft.com/office/drawing/2014/main" id="{53BAB283-F634-C18E-E978-858C569B4C4A}"/>
               </a:ext>
             </a:extLst>
           </p:cNvPr>
@@ -6897,7 +6897,7 @@
           <p:cNvPr id="11" name="TextBox 10">
             <a:extLst>
               <a:ext uri="{FF2B5EF4-FFF2-40B4-BE49-F238E27FC236}">
-                <a16:creationId xmlns:a16="http://schemas.microsoft.com/office/drawing/2014/main" id="{9295EE4C-66A0-181A-96DA-F211AA160F7A}"/>
+                <a16:creationId xmlns:a16="http://schemas.microsoft.com/office/drawing/2014/main" id="{98E4572D-E4A2-C558-FAD4-A35BA0475767}"/>
               </a:ext>
             </a:extLst>
           </p:cNvPr>
@@ -6937,7 +6937,7 @@
           <p:cNvPr id="12" name="TextBox 11">
             <a:extLst>
               <a:ext uri="{FF2B5EF4-FFF2-40B4-BE49-F238E27FC236}">
-                <a16:creationId xmlns:a16="http://schemas.microsoft.com/office/drawing/2014/main" id="{CA1399FD-C70D-68F7-36FC-12CE0573971A}"/>
+                <a16:creationId xmlns:a16="http://schemas.microsoft.com/office/drawing/2014/main" id="{1347DCDE-FF64-11BF-8567-2BEAB5E6552F}"/>
               </a:ext>
             </a:extLst>
           </p:cNvPr>
@@ -6983,7 +6983,7 @@
           <p:cNvPr id="13" name="TextBox 12">
             <a:extLst>
               <a:ext uri="{FF2B5EF4-FFF2-40B4-BE49-F238E27FC236}">
-                <a16:creationId xmlns:a16="http://schemas.microsoft.com/office/drawing/2014/main" id="{FDCAB584-D163-5A5F-6F28-5A4676360938}"/>
+                <a16:creationId xmlns:a16="http://schemas.microsoft.com/office/drawing/2014/main" id="{98172A61-515D-F4EA-A69B-687419DAB6AD}"/>
               </a:ext>
             </a:extLst>
           </p:cNvPr>
@@ -7029,7 +7029,7 @@
           <p:cNvPr id="14" name="TextBox 13">
             <a:extLst>
               <a:ext uri="{FF2B5EF4-FFF2-40B4-BE49-F238E27FC236}">
-                <a16:creationId xmlns:a16="http://schemas.microsoft.com/office/drawing/2014/main" id="{14CC8A3B-5EC3-7DE0-F0C3-5F1B7AAB73A2}"/>
+                <a16:creationId xmlns:a16="http://schemas.microsoft.com/office/drawing/2014/main" id="{9764678D-BEE0-8191-3EC1-2B341228BF3E}"/>
               </a:ext>
             </a:extLst>
           </p:cNvPr>
@@ -7068,7 +7068,7 @@
     </p:spTree>
     <p:extLst>
       <p:ext uri="{BB962C8B-B14F-4D97-AF65-F5344CB8AC3E}">
-        <p14:creationId xmlns:p14="http://schemas.microsoft.com/office/powerpoint/2010/main" val="1220596969"/>
+        <p14:creationId xmlns:p14="http://schemas.microsoft.com/office/powerpoint/2010/main" val="1366074484"/>
       </p:ext>
     </p:extLst>
   </p:cSld>
@@ -7108,7 +7108,7 @@
           <p:cNvPr id="2" name="TextBox 1">
             <a:extLst>
               <a:ext uri="{FF2B5EF4-FFF2-40B4-BE49-F238E27FC236}">
-                <a16:creationId xmlns:a16="http://schemas.microsoft.com/office/drawing/2014/main" id="{705210E2-601F-E436-7829-E814D3EA6B90}"/>
+                <a16:creationId xmlns:a16="http://schemas.microsoft.com/office/drawing/2014/main" id="{2E5126D0-CC1F-7B16-F409-F9FD224DB77D}"/>
               </a:ext>
             </a:extLst>
           </p:cNvPr>
@@ -7148,7 +7148,7 @@
           <p:cNvPr id="3" name="Rectangle: Rounded Corners 2">
             <a:extLst>
               <a:ext uri="{FF2B5EF4-FFF2-40B4-BE49-F238E27FC236}">
-                <a16:creationId xmlns:a16="http://schemas.microsoft.com/office/drawing/2014/main" id="{60A5824E-E493-86C3-36B0-457917776671}"/>
+                <a16:creationId xmlns:a16="http://schemas.microsoft.com/office/drawing/2014/main" id="{541DFD23-95A8-65A1-8A77-42DE114E7D3F}"/>
               </a:ext>
             </a:extLst>
           </p:cNvPr>
@@ -7226,7 +7226,7 @@
           <p:cNvPr id="4" name="Straight Connector 3">
             <a:extLst>
               <a:ext uri="{FF2B5EF4-FFF2-40B4-BE49-F238E27FC236}">
-                <a16:creationId xmlns:a16="http://schemas.microsoft.com/office/drawing/2014/main" id="{4389B498-9609-20EB-1B68-5F9191CE8B21}"/>
+                <a16:creationId xmlns:a16="http://schemas.microsoft.com/office/drawing/2014/main" id="{FDB3BD81-94D1-0438-3CCB-77A71B0B5D36}"/>
               </a:ext>
             </a:extLst>
           </p:cNvPr>
@@ -7268,7 +7268,7 @@
           <p:cNvPr id="5" name="Rectangle: Rounded Corners 4">
             <a:extLst>
               <a:ext uri="{FF2B5EF4-FFF2-40B4-BE49-F238E27FC236}">
-                <a16:creationId xmlns:a16="http://schemas.microsoft.com/office/drawing/2014/main" id="{9700954B-1423-972A-92A1-B5E494485D66}"/>
+                <a16:creationId xmlns:a16="http://schemas.microsoft.com/office/drawing/2014/main" id="{789885A9-0BF8-BAF0-A8B6-0A2E8E807B03}"/>
               </a:ext>
             </a:extLst>
           </p:cNvPr>
@@ -7346,7 +7346,7 @@
           <p:cNvPr id="6" name="Straight Connector 5">
             <a:extLst>
               <a:ext uri="{FF2B5EF4-FFF2-40B4-BE49-F238E27FC236}">
-                <a16:creationId xmlns:a16="http://schemas.microsoft.com/office/drawing/2014/main" id="{0BD93353-9F52-B126-B37E-C81D9FB509C1}"/>
+                <a16:creationId xmlns:a16="http://schemas.microsoft.com/office/drawing/2014/main" id="{983B57B0-8F19-BC4B-38EC-BA8F7BC65ED0}"/>
               </a:ext>
             </a:extLst>
           </p:cNvPr>
@@ -7388,7 +7388,7 @@
           <p:cNvPr id="7" name="Rectangle: Rounded Corners 6">
             <a:extLst>
               <a:ext uri="{FF2B5EF4-FFF2-40B4-BE49-F238E27FC236}">
-                <a16:creationId xmlns:a16="http://schemas.microsoft.com/office/drawing/2014/main" id="{86C72DA4-1D4F-C20F-A311-5A8307320CDA}"/>
+                <a16:creationId xmlns:a16="http://schemas.microsoft.com/office/drawing/2014/main" id="{8BED0539-84E9-7A03-7629-33D4028C8AE3}"/>
               </a:ext>
             </a:extLst>
           </p:cNvPr>
@@ -7466,7 +7466,7 @@
           <p:cNvPr id="8" name="Straight Connector 7">
             <a:extLst>
               <a:ext uri="{FF2B5EF4-FFF2-40B4-BE49-F238E27FC236}">
-                <a16:creationId xmlns:a16="http://schemas.microsoft.com/office/drawing/2014/main" id="{2C595D6C-4653-C985-26E3-5992F8B3FB29}"/>
+                <a16:creationId xmlns:a16="http://schemas.microsoft.com/office/drawing/2014/main" id="{6F451D47-5685-2D5E-C347-929A4EF4C97A}"/>
               </a:ext>
             </a:extLst>
           </p:cNvPr>
@@ -7508,7 +7508,7 @@
           <p:cNvPr id="9" name="Rectangle: Rounded Corners 8">
             <a:extLst>
               <a:ext uri="{FF2B5EF4-FFF2-40B4-BE49-F238E27FC236}">
-                <a16:creationId xmlns:a16="http://schemas.microsoft.com/office/drawing/2014/main" id="{8CFCD73A-4C3B-B69A-D703-ADA60986DFF2}"/>
+                <a16:creationId xmlns:a16="http://schemas.microsoft.com/office/drawing/2014/main" id="{8D240A4C-6055-0E7F-578A-3E0B2489C8CA}"/>
               </a:ext>
             </a:extLst>
           </p:cNvPr>
@@ -7586,7 +7586,7 @@
           <p:cNvPr id="10" name="Straight Connector 9">
             <a:extLst>
               <a:ext uri="{FF2B5EF4-FFF2-40B4-BE49-F238E27FC236}">
-                <a16:creationId xmlns:a16="http://schemas.microsoft.com/office/drawing/2014/main" id="{6E295A24-E05E-D7D0-0891-8AC0DBE0878A}"/>
+                <a16:creationId xmlns:a16="http://schemas.microsoft.com/office/drawing/2014/main" id="{B2C7DCBE-C3BC-D4B2-DC52-E840DD9F4218}"/>
               </a:ext>
             </a:extLst>
           </p:cNvPr>
@@ -7628,7 +7628,7 @@
           <p:cNvPr id="11" name="Rectangle: Rounded Corners 10">
             <a:extLst>
               <a:ext uri="{FF2B5EF4-FFF2-40B4-BE49-F238E27FC236}">
-                <a16:creationId xmlns:a16="http://schemas.microsoft.com/office/drawing/2014/main" id="{65B568CD-DAF8-9F18-BAAE-559CF785EBAE}"/>
+                <a16:creationId xmlns:a16="http://schemas.microsoft.com/office/drawing/2014/main" id="{C67698B5-A410-FE3E-8260-7C296BBB21AD}"/>
               </a:ext>
             </a:extLst>
           </p:cNvPr>
@@ -7706,7 +7706,7 @@
           <p:cNvPr id="12" name="Straight Connector 11">
             <a:extLst>
               <a:ext uri="{FF2B5EF4-FFF2-40B4-BE49-F238E27FC236}">
-                <a16:creationId xmlns:a16="http://schemas.microsoft.com/office/drawing/2014/main" id="{FC6C8729-E9DB-DBC4-E40F-500924B62702}"/>
+                <a16:creationId xmlns:a16="http://schemas.microsoft.com/office/drawing/2014/main" id="{A0C13F1D-0AF2-2254-D180-BDA419285193}"/>
               </a:ext>
             </a:extLst>
           </p:cNvPr>
@@ -7748,7 +7748,7 @@
           <p:cNvPr id="13" name="Rectangle: Rounded Corners 12">
             <a:extLst>
               <a:ext uri="{FF2B5EF4-FFF2-40B4-BE49-F238E27FC236}">
-                <a16:creationId xmlns:a16="http://schemas.microsoft.com/office/drawing/2014/main" id="{3C0278A6-4C2F-5C97-1974-880A6915CC12}"/>
+                <a16:creationId xmlns:a16="http://schemas.microsoft.com/office/drawing/2014/main" id="{50850153-50B6-C973-2594-BA57D74A8F35}"/>
               </a:ext>
             </a:extLst>
           </p:cNvPr>
@@ -7826,7 +7826,7 @@
           <p:cNvPr id="14" name="Straight Connector 13">
             <a:extLst>
               <a:ext uri="{FF2B5EF4-FFF2-40B4-BE49-F238E27FC236}">
-                <a16:creationId xmlns:a16="http://schemas.microsoft.com/office/drawing/2014/main" id="{3AC4D31B-65EA-753F-FDA9-C21133F00C51}"/>
+                <a16:creationId xmlns:a16="http://schemas.microsoft.com/office/drawing/2014/main" id="{F25B0960-7F81-222D-394A-5037E390D177}"/>
               </a:ext>
             </a:extLst>
           </p:cNvPr>
@@ -7869,7 +7869,7 @@
           <p:cNvPr id="15" name="TextBox 14">
             <a:extLst>
               <a:ext uri="{FF2B5EF4-FFF2-40B4-BE49-F238E27FC236}">
-                <a16:creationId xmlns:a16="http://schemas.microsoft.com/office/drawing/2014/main" id="{FE1E9ED4-FE6E-3826-5728-6F8C0DF3195C}"/>
+                <a16:creationId xmlns:a16="http://schemas.microsoft.com/office/drawing/2014/main" id="{2FFB93AD-BBFD-DF91-051B-6F18983AC0E9}"/>
               </a:ext>
             </a:extLst>
           </p:cNvPr>
@@ -7910,7 +7910,7 @@
           <p:cNvPr id="16" name="TextBox 15">
             <a:extLst>
               <a:ext uri="{FF2B5EF4-FFF2-40B4-BE49-F238E27FC236}">
-                <a16:creationId xmlns:a16="http://schemas.microsoft.com/office/drawing/2014/main" id="{45BB0B3F-B584-28E9-A031-94589BEDFE3D}"/>
+                <a16:creationId xmlns:a16="http://schemas.microsoft.com/office/drawing/2014/main" id="{AB5D4198-F56E-6897-22A3-B532C6B338D3}"/>
               </a:ext>
             </a:extLst>
           </p:cNvPr>
@@ -7956,7 +7956,7 @@
           <p:cNvPr id="17" name="Rectangle: Rounded Corners 16">
             <a:extLst>
               <a:ext uri="{FF2B5EF4-FFF2-40B4-BE49-F238E27FC236}">
-                <a16:creationId xmlns:a16="http://schemas.microsoft.com/office/drawing/2014/main" id="{CA57345F-E631-5C5E-05D5-EB6E9EC2A020}"/>
+                <a16:creationId xmlns:a16="http://schemas.microsoft.com/office/drawing/2014/main" id="{8646491D-15CC-5C95-2A78-00A6F6EEA703}"/>
               </a:ext>
             </a:extLst>
           </p:cNvPr>
@@ -8026,7 +8026,7 @@
           <p:cNvPr id="18" name="TextBox 17">
             <a:extLst>
               <a:ext uri="{FF2B5EF4-FFF2-40B4-BE49-F238E27FC236}">
-                <a16:creationId xmlns:a16="http://schemas.microsoft.com/office/drawing/2014/main" id="{B6B7DF2C-40E1-152A-A702-6200F13AEB0F}"/>
+                <a16:creationId xmlns:a16="http://schemas.microsoft.com/office/drawing/2014/main" id="{F4E951E9-167C-959D-D90A-997B8F2DCE24}"/>
               </a:ext>
             </a:extLst>
           </p:cNvPr>
@@ -8072,7 +8072,7 @@
           <p:cNvPr id="19" name="TextBox 18">
             <a:extLst>
               <a:ext uri="{FF2B5EF4-FFF2-40B4-BE49-F238E27FC236}">
-                <a16:creationId xmlns:a16="http://schemas.microsoft.com/office/drawing/2014/main" id="{EE5DFF2B-E755-F292-2AE9-58FB050BB0C6}"/>
+                <a16:creationId xmlns:a16="http://schemas.microsoft.com/office/drawing/2014/main" id="{989AC09C-0049-FF78-9469-1E34525A2CCC}"/>
               </a:ext>
             </a:extLst>
           </p:cNvPr>
@@ -8118,7 +8118,7 @@
           <p:cNvPr id="20" name="Rectangle: Rounded Corners 19">
             <a:extLst>
               <a:ext uri="{FF2B5EF4-FFF2-40B4-BE49-F238E27FC236}">
-                <a16:creationId xmlns:a16="http://schemas.microsoft.com/office/drawing/2014/main" id="{B43EA754-3CC1-2F41-FEBB-D97E7A88E6A2}"/>
+                <a16:creationId xmlns:a16="http://schemas.microsoft.com/office/drawing/2014/main" id="{3E2EB29E-E484-D442-F609-37FDAE51D4FC}"/>
               </a:ext>
             </a:extLst>
           </p:cNvPr>
@@ -8188,7 +8188,7 @@
           <p:cNvPr id="21" name="TextBox 20">
             <a:extLst>
               <a:ext uri="{FF2B5EF4-FFF2-40B4-BE49-F238E27FC236}">
-                <a16:creationId xmlns:a16="http://schemas.microsoft.com/office/drawing/2014/main" id="{BAAE596F-436E-6D1C-8626-5EC395EDC526}"/>
+                <a16:creationId xmlns:a16="http://schemas.microsoft.com/office/drawing/2014/main" id="{31975213-927D-B2F9-BB15-C933DCFD596F}"/>
               </a:ext>
             </a:extLst>
           </p:cNvPr>
@@ -8228,7 +8228,7 @@
           <p:cNvPr id="22" name="TextBox 21">
             <a:extLst>
               <a:ext uri="{FF2B5EF4-FFF2-40B4-BE49-F238E27FC236}">
-                <a16:creationId xmlns:a16="http://schemas.microsoft.com/office/drawing/2014/main" id="{7BBB9AA5-53C0-6D06-E82A-B402228F5BAF}"/>
+                <a16:creationId xmlns:a16="http://schemas.microsoft.com/office/drawing/2014/main" id="{58C815C4-FCE2-5CAF-1AD3-5A9F83F48BE0}"/>
               </a:ext>
             </a:extLst>
           </p:cNvPr>
@@ -8274,7 +8274,7 @@
           <p:cNvPr id="23" name="Rectangle: Rounded Corners 22">
             <a:extLst>
               <a:ext uri="{FF2B5EF4-FFF2-40B4-BE49-F238E27FC236}">
-                <a16:creationId xmlns:a16="http://schemas.microsoft.com/office/drawing/2014/main" id="{F8D7BF01-4221-CCE9-6386-1BA4027FB55F}"/>
+                <a16:creationId xmlns:a16="http://schemas.microsoft.com/office/drawing/2014/main" id="{0DAFFB10-BEBC-E72F-3025-C9B7500BBF34}"/>
               </a:ext>
             </a:extLst>
           </p:cNvPr>
@@ -8344,7 +8344,7 @@
           <p:cNvPr id="24" name="TextBox 23">
             <a:extLst>
               <a:ext uri="{FF2B5EF4-FFF2-40B4-BE49-F238E27FC236}">
-                <a16:creationId xmlns:a16="http://schemas.microsoft.com/office/drawing/2014/main" id="{883F700B-6F27-5486-1430-74F16503E3C2}"/>
+                <a16:creationId xmlns:a16="http://schemas.microsoft.com/office/drawing/2014/main" id="{7C7B5C12-2184-38D1-86CA-3D9766402A5C}"/>
               </a:ext>
             </a:extLst>
           </p:cNvPr>
@@ -8384,7 +8384,7 @@
           <p:cNvPr id="25" name="TextBox 24">
             <a:extLst>
               <a:ext uri="{FF2B5EF4-FFF2-40B4-BE49-F238E27FC236}">
-                <a16:creationId xmlns:a16="http://schemas.microsoft.com/office/drawing/2014/main" id="{B4A64297-CF63-1392-ED5B-218253132056}"/>
+                <a16:creationId xmlns:a16="http://schemas.microsoft.com/office/drawing/2014/main" id="{CF53E6B4-4BD4-F3AB-5191-C817FABBAEF7}"/>
               </a:ext>
             </a:extLst>
           </p:cNvPr>
@@ -8430,7 +8430,7 @@
           <p:cNvPr id="26" name="TextBox 25">
             <a:extLst>
               <a:ext uri="{FF2B5EF4-FFF2-40B4-BE49-F238E27FC236}">
-                <a16:creationId xmlns:a16="http://schemas.microsoft.com/office/drawing/2014/main" id="{D153B89B-B970-E337-3027-C6A8987A682C}"/>
+                <a16:creationId xmlns:a16="http://schemas.microsoft.com/office/drawing/2014/main" id="{611A7903-8423-D11C-6D1B-CE242BA033C4}"/>
               </a:ext>
             </a:extLst>
           </p:cNvPr>
@@ -8476,7 +8476,7 @@
           <p:cNvPr id="27" name="TextBox 26">
             <a:extLst>
               <a:ext uri="{FF2B5EF4-FFF2-40B4-BE49-F238E27FC236}">
-                <a16:creationId xmlns:a16="http://schemas.microsoft.com/office/drawing/2014/main" id="{C6DFEC5C-6B4C-E46D-E634-68A35670CDF6}"/>
+                <a16:creationId xmlns:a16="http://schemas.microsoft.com/office/drawing/2014/main" id="{26505982-A62F-F87A-2DAD-138BB74ECE73}"/>
               </a:ext>
             </a:extLst>
           </p:cNvPr>
@@ -8515,7 +8515,7 @@
     </p:spTree>
     <p:extLst>
       <p:ext uri="{BB962C8B-B14F-4D97-AF65-F5344CB8AC3E}">
-        <p14:creationId xmlns:p14="http://schemas.microsoft.com/office/powerpoint/2010/main" val="1782283618"/>
+        <p14:creationId xmlns:p14="http://schemas.microsoft.com/office/powerpoint/2010/main" val="3010893638"/>
       </p:ext>
     </p:extLst>
   </p:cSld>
@@ -8555,7 +8555,7 @@
           <p:cNvPr id="2" name="TextBox 1">
             <a:extLst>
               <a:ext uri="{FF2B5EF4-FFF2-40B4-BE49-F238E27FC236}">
-                <a16:creationId xmlns:a16="http://schemas.microsoft.com/office/drawing/2014/main" id="{CAFB1CD9-D6D1-D2ED-8C0F-9D9BD01967DA}"/>
+                <a16:creationId xmlns:a16="http://schemas.microsoft.com/office/drawing/2014/main" id="{872786C1-FC1C-5EC3-21C6-75EAE58FD9DD}"/>
               </a:ext>
             </a:extLst>
           </p:cNvPr>
@@ -8601,7 +8601,7 @@
           <p:cNvPr id="3" name="Oval 2">
             <a:extLst>
               <a:ext uri="{FF2B5EF4-FFF2-40B4-BE49-F238E27FC236}">
-                <a16:creationId xmlns:a16="http://schemas.microsoft.com/office/drawing/2014/main" id="{962AED0B-9F4C-C6C9-5BBF-9DBB023811F6}"/>
+                <a16:creationId xmlns:a16="http://schemas.microsoft.com/office/drawing/2014/main" id="{33564687-120A-AA40-6B21-C52F2DCDA949}"/>
               </a:ext>
             </a:extLst>
           </p:cNvPr>
@@ -8677,7 +8677,7 @@
           <p:cNvPr id="4" name="TextBox 3">
             <a:extLst>
               <a:ext uri="{FF2B5EF4-FFF2-40B4-BE49-F238E27FC236}">
-                <a16:creationId xmlns:a16="http://schemas.microsoft.com/office/drawing/2014/main" id="{27159FF5-CB36-5287-5577-AA7F2C18E208}"/>
+                <a16:creationId xmlns:a16="http://schemas.microsoft.com/office/drawing/2014/main" id="{185A989F-76CE-FB0A-1258-378A14585D18}"/>
               </a:ext>
             </a:extLst>
           </p:cNvPr>
@@ -8723,7 +8723,7 @@
           <p:cNvPr id="5" name="TextBox 4">
             <a:extLst>
               <a:ext uri="{FF2B5EF4-FFF2-40B4-BE49-F238E27FC236}">
-                <a16:creationId xmlns:a16="http://schemas.microsoft.com/office/drawing/2014/main" id="{6DE69856-5847-64C1-300E-C9E633953501}"/>
+                <a16:creationId xmlns:a16="http://schemas.microsoft.com/office/drawing/2014/main" id="{665A588F-8FD0-679F-6132-478F7A8A0A1E}"/>
               </a:ext>
             </a:extLst>
           </p:cNvPr>
@@ -8769,7 +8769,7 @@
           <p:cNvPr id="6" name="Oval 5">
             <a:extLst>
               <a:ext uri="{FF2B5EF4-FFF2-40B4-BE49-F238E27FC236}">
-                <a16:creationId xmlns:a16="http://schemas.microsoft.com/office/drawing/2014/main" id="{0DC57F6D-BB3A-A59B-8571-59E4B23CEF89}"/>
+                <a16:creationId xmlns:a16="http://schemas.microsoft.com/office/drawing/2014/main" id="{AA6B03BB-C3BE-7C5B-E1AB-CF0263CCCEB2}"/>
               </a:ext>
             </a:extLst>
           </p:cNvPr>
@@ -8845,7 +8845,7 @@
           <p:cNvPr id="7" name="TextBox 6">
             <a:extLst>
               <a:ext uri="{FF2B5EF4-FFF2-40B4-BE49-F238E27FC236}">
-                <a16:creationId xmlns:a16="http://schemas.microsoft.com/office/drawing/2014/main" id="{5845C49A-E799-8A15-5692-534E5E10EBE5}"/>
+                <a16:creationId xmlns:a16="http://schemas.microsoft.com/office/drawing/2014/main" id="{8770DBE9-74EA-2D6B-C8C9-CCB616DE604C}"/>
               </a:ext>
             </a:extLst>
           </p:cNvPr>
@@ -8891,7 +8891,7 @@
           <p:cNvPr id="8" name="TextBox 7">
             <a:extLst>
               <a:ext uri="{FF2B5EF4-FFF2-40B4-BE49-F238E27FC236}">
-                <a16:creationId xmlns:a16="http://schemas.microsoft.com/office/drawing/2014/main" id="{96CE63B4-5855-882F-4536-5011E0A9DF1E}"/>
+                <a16:creationId xmlns:a16="http://schemas.microsoft.com/office/drawing/2014/main" id="{D646C673-FBBE-7942-0DDE-0CC4679843F3}"/>
               </a:ext>
             </a:extLst>
           </p:cNvPr>
@@ -8937,7 +8937,7 @@
           <p:cNvPr id="9" name="Oval 8">
             <a:extLst>
               <a:ext uri="{FF2B5EF4-FFF2-40B4-BE49-F238E27FC236}">
-                <a16:creationId xmlns:a16="http://schemas.microsoft.com/office/drawing/2014/main" id="{52AB324B-7053-C306-F6B9-46F2A818E094}"/>
+                <a16:creationId xmlns:a16="http://schemas.microsoft.com/office/drawing/2014/main" id="{F417B6B4-890E-93FD-3996-7A6EC64ACB0D}"/>
               </a:ext>
             </a:extLst>
           </p:cNvPr>
@@ -9013,7 +9013,7 @@
           <p:cNvPr id="10" name="TextBox 9">
             <a:extLst>
               <a:ext uri="{FF2B5EF4-FFF2-40B4-BE49-F238E27FC236}">
-                <a16:creationId xmlns:a16="http://schemas.microsoft.com/office/drawing/2014/main" id="{D7B1E7F6-F198-175C-9990-E67FBF484FE5}"/>
+                <a16:creationId xmlns:a16="http://schemas.microsoft.com/office/drawing/2014/main" id="{4BEE0B44-C4F6-72A6-7641-CB9731A27123}"/>
               </a:ext>
             </a:extLst>
           </p:cNvPr>
@@ -9059,7 +9059,7 @@
           <p:cNvPr id="11" name="TextBox 10">
             <a:extLst>
               <a:ext uri="{FF2B5EF4-FFF2-40B4-BE49-F238E27FC236}">
-                <a16:creationId xmlns:a16="http://schemas.microsoft.com/office/drawing/2014/main" id="{EB0B4AEA-972B-4836-E1AD-C75395FDAA66}"/>
+                <a16:creationId xmlns:a16="http://schemas.microsoft.com/office/drawing/2014/main" id="{F9C50713-EE6F-5CB3-6EBE-472DD83C9BDA}"/>
               </a:ext>
             </a:extLst>
           </p:cNvPr>
@@ -9105,7 +9105,7 @@
           <p:cNvPr id="12" name="TextBox 11">
             <a:extLst>
               <a:ext uri="{FF2B5EF4-FFF2-40B4-BE49-F238E27FC236}">
-                <a16:creationId xmlns:a16="http://schemas.microsoft.com/office/drawing/2014/main" id="{820AD510-FDB3-66D8-327A-FD31C7EF2B91}"/>
+                <a16:creationId xmlns:a16="http://schemas.microsoft.com/office/drawing/2014/main" id="{AC18F73F-7AE0-2CD2-5302-E1031E0A88C7}"/>
               </a:ext>
             </a:extLst>
           </p:cNvPr>
@@ -9151,7 +9151,7 @@
           <p:cNvPr id="13" name="Rectangle: Rounded Corners 12">
             <a:extLst>
               <a:ext uri="{FF2B5EF4-FFF2-40B4-BE49-F238E27FC236}">
-                <a16:creationId xmlns:a16="http://schemas.microsoft.com/office/drawing/2014/main" id="{1AD2C984-4A87-6DE0-D1E5-210D67806E14}"/>
+                <a16:creationId xmlns:a16="http://schemas.microsoft.com/office/drawing/2014/main" id="{19417101-718D-F66C-7B63-3C84ABFE6D22}"/>
               </a:ext>
             </a:extLst>
           </p:cNvPr>
@@ -9221,7 +9221,7 @@
           <p:cNvPr id="14" name="TextBox 13">
             <a:extLst>
               <a:ext uri="{FF2B5EF4-FFF2-40B4-BE49-F238E27FC236}">
-                <a16:creationId xmlns:a16="http://schemas.microsoft.com/office/drawing/2014/main" id="{99C3BFC0-5A23-E2B1-66A9-158F6A69B6E0}"/>
+                <a16:creationId xmlns:a16="http://schemas.microsoft.com/office/drawing/2014/main" id="{C81EB399-8862-5C6B-4D96-BE7F9471EB7A}"/>
               </a:ext>
             </a:extLst>
           </p:cNvPr>
@@ -9262,7 +9262,7 @@
           <p:cNvPr id="15" name="TextBox 14">
             <a:extLst>
               <a:ext uri="{FF2B5EF4-FFF2-40B4-BE49-F238E27FC236}">
-                <a16:creationId xmlns:a16="http://schemas.microsoft.com/office/drawing/2014/main" id="{B27D22E1-1A0B-5989-CCB6-98AA6748722C}"/>
+                <a16:creationId xmlns:a16="http://schemas.microsoft.com/office/drawing/2014/main" id="{6D4DABCF-805F-A61C-6398-BFEE85707039}"/>
               </a:ext>
             </a:extLst>
           </p:cNvPr>
@@ -9303,7 +9303,7 @@
           <p:cNvPr id="16" name="TextBox 15">
             <a:extLst>
               <a:ext uri="{FF2B5EF4-FFF2-40B4-BE49-F238E27FC236}">
-                <a16:creationId xmlns:a16="http://schemas.microsoft.com/office/drawing/2014/main" id="{1B227F73-56C3-F808-7B26-1CA4C0A738B1}"/>
+                <a16:creationId xmlns:a16="http://schemas.microsoft.com/office/drawing/2014/main" id="{94DB2374-B730-A8E0-FA15-D51BD71AAA5C}"/>
               </a:ext>
             </a:extLst>
           </p:cNvPr>
@@ -9343,7 +9343,7 @@
           <p:cNvPr id="17" name="TextBox 16">
             <a:extLst>
               <a:ext uri="{FF2B5EF4-FFF2-40B4-BE49-F238E27FC236}">
-                <a16:creationId xmlns:a16="http://schemas.microsoft.com/office/drawing/2014/main" id="{F47F7929-D7C4-028C-53E4-CB3048027614}"/>
+                <a16:creationId xmlns:a16="http://schemas.microsoft.com/office/drawing/2014/main" id="{49A536C5-7FB1-672D-CDF0-C1AEB675DEE5}"/>
               </a:ext>
             </a:extLst>
           </p:cNvPr>
@@ -9389,7 +9389,7 @@
           <p:cNvPr id="18" name="TextBox 17">
             <a:extLst>
               <a:ext uri="{FF2B5EF4-FFF2-40B4-BE49-F238E27FC236}">
-                <a16:creationId xmlns:a16="http://schemas.microsoft.com/office/drawing/2014/main" id="{343D4037-E95C-C9F9-9673-6B6704950B71}"/>
+                <a16:creationId xmlns:a16="http://schemas.microsoft.com/office/drawing/2014/main" id="{FA938686-D823-0CAA-2753-13C67EEC4EEE}"/>
               </a:ext>
             </a:extLst>
           </p:cNvPr>
@@ -9435,7 +9435,7 @@
           <p:cNvPr id="19" name="Rectangle: Rounded Corners 18">
             <a:extLst>
               <a:ext uri="{FF2B5EF4-FFF2-40B4-BE49-F238E27FC236}">
-                <a16:creationId xmlns:a16="http://schemas.microsoft.com/office/drawing/2014/main" id="{6454FCD0-B0EC-4096-6EF2-6B1643EDF26D}"/>
+                <a16:creationId xmlns:a16="http://schemas.microsoft.com/office/drawing/2014/main" id="{1E3AAEF9-E41C-4272-B2E2-E9415AC11DC5}"/>
               </a:ext>
             </a:extLst>
           </p:cNvPr>
@@ -9505,7 +9505,7 @@
           <p:cNvPr id="20" name="TextBox 19">
             <a:extLst>
               <a:ext uri="{FF2B5EF4-FFF2-40B4-BE49-F238E27FC236}">
-                <a16:creationId xmlns:a16="http://schemas.microsoft.com/office/drawing/2014/main" id="{679D6760-0D40-025E-DE44-984863C822DC}"/>
+                <a16:creationId xmlns:a16="http://schemas.microsoft.com/office/drawing/2014/main" id="{5F1DE9B5-8378-A2D0-A9F5-E6C3727DA2AF}"/>
               </a:ext>
             </a:extLst>
           </p:cNvPr>
@@ -9551,7 +9551,7 @@
           <p:cNvPr id="21" name="TextBox 20">
             <a:extLst>
               <a:ext uri="{FF2B5EF4-FFF2-40B4-BE49-F238E27FC236}">
-                <a16:creationId xmlns:a16="http://schemas.microsoft.com/office/drawing/2014/main" id="{00EA700B-8363-4AA9-E3A2-E9E824C3052D}"/>
+                <a16:creationId xmlns:a16="http://schemas.microsoft.com/office/drawing/2014/main" id="{1C33414C-C24D-B225-F100-90224D9BBE4C}"/>
               </a:ext>
             </a:extLst>
           </p:cNvPr>
@@ -9590,7 +9590,7 @@
     </p:spTree>
     <p:extLst>
       <p:ext uri="{BB962C8B-B14F-4D97-AF65-F5344CB8AC3E}">
-        <p14:creationId xmlns:p14="http://schemas.microsoft.com/office/powerpoint/2010/main" val="3233756946"/>
+        <p14:creationId xmlns:p14="http://schemas.microsoft.com/office/powerpoint/2010/main" val="13898962"/>
       </p:ext>
     </p:extLst>
   </p:cSld>
@@ -9630,7 +9630,7 @@
           <p:cNvPr id="2" name="TextBox 1">
             <a:extLst>
               <a:ext uri="{FF2B5EF4-FFF2-40B4-BE49-F238E27FC236}">
-                <a16:creationId xmlns:a16="http://schemas.microsoft.com/office/drawing/2014/main" id="{B083DEC8-4B15-A868-DE93-7782D4B06137}"/>
+                <a16:creationId xmlns:a16="http://schemas.microsoft.com/office/drawing/2014/main" id="{8F5FAC9A-03FE-A6F2-9A6A-A588F6651788}"/>
               </a:ext>
             </a:extLst>
           </p:cNvPr>
@@ -9676,7 +9676,7 @@
           <p:cNvPr id="3" name="Rectangle: Rounded Corners 2">
             <a:extLst>
               <a:ext uri="{FF2B5EF4-FFF2-40B4-BE49-F238E27FC236}">
-                <a16:creationId xmlns:a16="http://schemas.microsoft.com/office/drawing/2014/main" id="{E99D0CC1-4E90-FDA7-DC68-C24B3579448E}"/>
+                <a16:creationId xmlns:a16="http://schemas.microsoft.com/office/drawing/2014/main" id="{F5BF5507-53DB-3DAF-2E04-5259D36AC9BD}"/>
               </a:ext>
             </a:extLst>
           </p:cNvPr>
@@ -9746,7 +9746,7 @@
           <p:cNvPr id="4" name="TextBox 3">
             <a:extLst>
               <a:ext uri="{FF2B5EF4-FFF2-40B4-BE49-F238E27FC236}">
-                <a16:creationId xmlns:a16="http://schemas.microsoft.com/office/drawing/2014/main" id="{63CB9491-737E-BDFA-D52F-34F7FABB058B}"/>
+                <a16:creationId xmlns:a16="http://schemas.microsoft.com/office/drawing/2014/main" id="{CE654227-4418-FB1F-8182-FF0F6FFD3612}"/>
               </a:ext>
             </a:extLst>
           </p:cNvPr>
@@ -9786,7 +9786,7 @@
           <p:cNvPr id="5" name="TextBox 4">
             <a:extLst>
               <a:ext uri="{FF2B5EF4-FFF2-40B4-BE49-F238E27FC236}">
-                <a16:creationId xmlns:a16="http://schemas.microsoft.com/office/drawing/2014/main" id="{C59AD20D-CC9B-39CE-2B00-3777976A59EE}"/>
+                <a16:creationId xmlns:a16="http://schemas.microsoft.com/office/drawing/2014/main" id="{6C53714E-3847-3352-C9A2-DA881454B01E}"/>
               </a:ext>
             </a:extLst>
           </p:cNvPr>
@@ -9832,7 +9832,7 @@
           <p:cNvPr id="6" name="Rectangle: Rounded Corners 5">
             <a:extLst>
               <a:ext uri="{FF2B5EF4-FFF2-40B4-BE49-F238E27FC236}">
-                <a16:creationId xmlns:a16="http://schemas.microsoft.com/office/drawing/2014/main" id="{D3ED4F47-0D85-08F7-7C38-76ABB94039CD}"/>
+                <a16:creationId xmlns:a16="http://schemas.microsoft.com/office/drawing/2014/main" id="{1B13D61B-BD1E-2093-92D0-B6589F072514}"/>
               </a:ext>
             </a:extLst>
           </p:cNvPr>
@@ -9902,7 +9902,7 @@
           <p:cNvPr id="7" name="TextBox 6">
             <a:extLst>
               <a:ext uri="{FF2B5EF4-FFF2-40B4-BE49-F238E27FC236}">
-                <a16:creationId xmlns:a16="http://schemas.microsoft.com/office/drawing/2014/main" id="{6F14A506-C458-DB3E-4D7F-A5373A12727C}"/>
+                <a16:creationId xmlns:a16="http://schemas.microsoft.com/office/drawing/2014/main" id="{8373FA97-66DE-1239-0952-DE65CB75713E}"/>
               </a:ext>
             </a:extLst>
           </p:cNvPr>
@@ -9942,7 +9942,7 @@
           <p:cNvPr id="8" name="TextBox 7">
             <a:extLst>
               <a:ext uri="{FF2B5EF4-FFF2-40B4-BE49-F238E27FC236}">
-                <a16:creationId xmlns:a16="http://schemas.microsoft.com/office/drawing/2014/main" id="{94CA03B4-9243-75BF-1E2F-31DF474BC2F9}"/>
+                <a16:creationId xmlns:a16="http://schemas.microsoft.com/office/drawing/2014/main" id="{E0B0EE62-6AFA-B66E-53E9-A10690405EF6}"/>
               </a:ext>
             </a:extLst>
           </p:cNvPr>
@@ -9988,7 +9988,7 @@
           <p:cNvPr id="9" name="Rectangle: Rounded Corners 8">
             <a:extLst>
               <a:ext uri="{FF2B5EF4-FFF2-40B4-BE49-F238E27FC236}">
-                <a16:creationId xmlns:a16="http://schemas.microsoft.com/office/drawing/2014/main" id="{6F60F3FF-7C01-4F8C-C790-80BFB15DEB48}"/>
+                <a16:creationId xmlns:a16="http://schemas.microsoft.com/office/drawing/2014/main" id="{D4F70512-B0E0-06B1-972C-1DC39BE97AD6}"/>
               </a:ext>
             </a:extLst>
           </p:cNvPr>
@@ -10058,7 +10058,7 @@
           <p:cNvPr id="10" name="TextBox 9">
             <a:extLst>
               <a:ext uri="{FF2B5EF4-FFF2-40B4-BE49-F238E27FC236}">
-                <a16:creationId xmlns:a16="http://schemas.microsoft.com/office/drawing/2014/main" id="{DEEE0929-96B0-281F-1BEE-B41C6430B388}"/>
+                <a16:creationId xmlns:a16="http://schemas.microsoft.com/office/drawing/2014/main" id="{3E2F35B5-4065-03F3-4335-C8C20DF2F72B}"/>
               </a:ext>
             </a:extLst>
           </p:cNvPr>
@@ -10098,7 +10098,7 @@
           <p:cNvPr id="11" name="TextBox 10">
             <a:extLst>
               <a:ext uri="{FF2B5EF4-FFF2-40B4-BE49-F238E27FC236}">
-                <a16:creationId xmlns:a16="http://schemas.microsoft.com/office/drawing/2014/main" id="{EA231BF5-B316-C032-B52F-168851CB5BE8}"/>
+                <a16:creationId xmlns:a16="http://schemas.microsoft.com/office/drawing/2014/main" id="{E56B8937-8211-253A-389D-7A66E025CA1B}"/>
               </a:ext>
             </a:extLst>
           </p:cNvPr>
@@ -10144,7 +10144,7 @@
           <p:cNvPr id="12" name="Rectangle: Rounded Corners 11">
             <a:extLst>
               <a:ext uri="{FF2B5EF4-FFF2-40B4-BE49-F238E27FC236}">
-                <a16:creationId xmlns:a16="http://schemas.microsoft.com/office/drawing/2014/main" id="{CC037217-0643-4E79-67DB-A55402FB4680}"/>
+                <a16:creationId xmlns:a16="http://schemas.microsoft.com/office/drawing/2014/main" id="{3D207A52-D8AF-8F02-56A4-52F51314E4CF}"/>
               </a:ext>
             </a:extLst>
           </p:cNvPr>
@@ -10214,7 +10214,7 @@
           <p:cNvPr id="13" name="TextBox 12">
             <a:extLst>
               <a:ext uri="{FF2B5EF4-FFF2-40B4-BE49-F238E27FC236}">
-                <a16:creationId xmlns:a16="http://schemas.microsoft.com/office/drawing/2014/main" id="{825D4B8B-F73D-AB3C-B759-DBF23E98C357}"/>
+                <a16:creationId xmlns:a16="http://schemas.microsoft.com/office/drawing/2014/main" id="{D19C6A37-C63B-AAB0-C748-ADAF39302138}"/>
               </a:ext>
             </a:extLst>
           </p:cNvPr>
@@ -10254,7 +10254,7 @@
           <p:cNvPr id="14" name="TextBox 13">
             <a:extLst>
               <a:ext uri="{FF2B5EF4-FFF2-40B4-BE49-F238E27FC236}">
-                <a16:creationId xmlns:a16="http://schemas.microsoft.com/office/drawing/2014/main" id="{84F76765-C96B-30B6-0C28-84419440260C}"/>
+                <a16:creationId xmlns:a16="http://schemas.microsoft.com/office/drawing/2014/main" id="{0BF38BB1-F92E-A2B6-2A4F-2E4E5E73F09A}"/>
               </a:ext>
             </a:extLst>
           </p:cNvPr>
@@ -10284,7 +10284,7 @@
                 </a:solidFill>
                 <a:latin typeface="Calibri" panose="020F0502020204030204" pitchFamily="34" charset="0"/>
               </a:rPr>
-              <a:t>596 tests, 0 failing; CI on every push; a container that runs as a non-root user with no secret baked in; every value carries its evidence.</a:t>
+              <a:t>646 tests, 0 failing; CI on every push; a container that runs as a non-root user with no secret baked in; every value carries its evidence.</a:t>
             </a:r>
             <a:endParaRPr lang="en-MY" sz="1150">
               <a:solidFill>
@@ -10300,7 +10300,7 @@
           <p:cNvPr id="15" name="Rectangle: Rounded Corners 14">
             <a:extLst>
               <a:ext uri="{FF2B5EF4-FFF2-40B4-BE49-F238E27FC236}">
-                <a16:creationId xmlns:a16="http://schemas.microsoft.com/office/drawing/2014/main" id="{E2204F93-9FD6-CA9F-600C-E2533024A9AA}"/>
+                <a16:creationId xmlns:a16="http://schemas.microsoft.com/office/drawing/2014/main" id="{136F8D87-0104-B015-2FF3-C4CCC799C81C}"/>
               </a:ext>
             </a:extLst>
           </p:cNvPr>
@@ -10370,7 +10370,7 @@
           <p:cNvPr id="16" name="TextBox 15">
             <a:extLst>
               <a:ext uri="{FF2B5EF4-FFF2-40B4-BE49-F238E27FC236}">
-                <a16:creationId xmlns:a16="http://schemas.microsoft.com/office/drawing/2014/main" id="{6A8212FB-227D-53FB-1A62-DDC989A5F306}"/>
+                <a16:creationId xmlns:a16="http://schemas.microsoft.com/office/drawing/2014/main" id="{4859EE87-6684-D704-0940-041DDE055C8D}"/>
               </a:ext>
             </a:extLst>
           </p:cNvPr>
@@ -10410,7 +10410,7 @@
           <p:cNvPr id="17" name="TextBox 16">
             <a:extLst>
               <a:ext uri="{FF2B5EF4-FFF2-40B4-BE49-F238E27FC236}">
-                <a16:creationId xmlns:a16="http://schemas.microsoft.com/office/drawing/2014/main" id="{D4BE6B6E-A481-96B4-E85A-BBB334EBB6F6}"/>
+                <a16:creationId xmlns:a16="http://schemas.microsoft.com/office/drawing/2014/main" id="{A3C2D713-8CC2-C8C1-C297-2B66CE8FF1D9}"/>
               </a:ext>
             </a:extLst>
           </p:cNvPr>
@@ -10459,7 +10459,7 @@
                 </a:solidFill>
                 <a:latin typeface="Calibri" panose="020F0502020204030204" pitchFamily="34" charset="0"/>
               </a:rPr>
-              <a:t>The obvious guard would flag 92% of genuine party fields - worse than the gap - so it stays open and written down (ADVERSARIAL.md 5.2).</a:t>
+              <a:t>The obvious guard would flag 114 of 124 SI/BL pairs (92%) - worse than the gap - so it stays open and written down (ADVERSARIAL.md 5.2).</a:t>
             </a:r>
             <a:endParaRPr lang="en-MY" sz="1150">
               <a:solidFill>
@@ -10475,7 +10475,7 @@
           <p:cNvPr id="18" name="TextBox 17">
             <a:extLst>
               <a:ext uri="{FF2B5EF4-FFF2-40B4-BE49-F238E27FC236}">
-                <a16:creationId xmlns:a16="http://schemas.microsoft.com/office/drawing/2014/main" id="{D096255A-517A-E6B4-2D85-C691891DB3E7}"/>
+                <a16:creationId xmlns:a16="http://schemas.microsoft.com/office/drawing/2014/main" id="{4A8BE140-D809-61E2-B0AB-D5CECF19A6B7}"/>
               </a:ext>
             </a:extLst>
           </p:cNvPr>
@@ -10521,7 +10521,7 @@
           <p:cNvPr id="19" name="TextBox 18">
             <a:extLst>
               <a:ext uri="{FF2B5EF4-FFF2-40B4-BE49-F238E27FC236}">
-                <a16:creationId xmlns:a16="http://schemas.microsoft.com/office/drawing/2014/main" id="{8357D6AC-1677-BBFD-B1CA-7775A150E5FA}"/>
+                <a16:creationId xmlns:a16="http://schemas.microsoft.com/office/drawing/2014/main" id="{A0C0B225-41F2-204C-1E4D-F4048919720D}"/>
               </a:ext>
             </a:extLst>
           </p:cNvPr>
@@ -10567,7 +10567,7 @@
           <p:cNvPr id="20" name="TextBox 19">
             <a:extLst>
               <a:ext uri="{FF2B5EF4-FFF2-40B4-BE49-F238E27FC236}">
-                <a16:creationId xmlns:a16="http://schemas.microsoft.com/office/drawing/2014/main" id="{9AD529C0-4237-7AF9-0EE1-52D403638FE1}"/>
+                <a16:creationId xmlns:a16="http://schemas.microsoft.com/office/drawing/2014/main" id="{1C371124-B5EE-673D-257F-C958AD863836}"/>
               </a:ext>
             </a:extLst>
           </p:cNvPr>
@@ -10612,7 +10612,7 @@
     </p:spTree>
     <p:extLst>
       <p:ext uri="{BB962C8B-B14F-4D97-AF65-F5344CB8AC3E}">
-        <p14:creationId xmlns:p14="http://schemas.microsoft.com/office/powerpoint/2010/main" val="513068102"/>
+        <p14:creationId xmlns:p14="http://schemas.microsoft.com/office/powerpoint/2010/main" val="2106182432"/>
       </p:ext>
     </p:extLst>
   </p:cSld>
@@ -10652,7 +10652,7 @@
           <p:cNvPr id="2" name="TextBox 1">
             <a:extLst>
               <a:ext uri="{FF2B5EF4-FFF2-40B4-BE49-F238E27FC236}">
-                <a16:creationId xmlns:a16="http://schemas.microsoft.com/office/drawing/2014/main" id="{AB0769EA-E699-9CA5-A518-4A2A9A41BE24}"/>
+                <a16:creationId xmlns:a16="http://schemas.microsoft.com/office/drawing/2014/main" id="{8BE6607F-D76A-9472-749B-5BB26D078AC2}"/>
               </a:ext>
             </a:extLst>
           </p:cNvPr>
@@ -10692,7 +10692,7 @@
           <p:cNvPr id="3" name="TextBox 2">
             <a:extLst>
               <a:ext uri="{FF2B5EF4-FFF2-40B4-BE49-F238E27FC236}">
-                <a16:creationId xmlns:a16="http://schemas.microsoft.com/office/drawing/2014/main" id="{5881A2C1-D09D-0BD7-4433-EBDB5B1F1C29}"/>
+                <a16:creationId xmlns:a16="http://schemas.microsoft.com/office/drawing/2014/main" id="{DEE56B81-CF31-0953-D074-FE6972E77410}"/>
               </a:ext>
             </a:extLst>
           </p:cNvPr>
@@ -10738,7 +10738,7 @@
           <p:cNvPr id="4" name="Oval 3">
             <a:extLst>
               <a:ext uri="{FF2B5EF4-FFF2-40B4-BE49-F238E27FC236}">
-                <a16:creationId xmlns:a16="http://schemas.microsoft.com/office/drawing/2014/main" id="{AC3F65EF-1758-6BB6-529A-F854F08D1C80}"/>
+                <a16:creationId xmlns:a16="http://schemas.microsoft.com/office/drawing/2014/main" id="{CB5DDD60-B4F0-145E-647B-607AB321D923}"/>
               </a:ext>
             </a:extLst>
           </p:cNvPr>
@@ -10814,7 +10814,7 @@
           <p:cNvPr id="5" name="TextBox 4">
             <a:extLst>
               <a:ext uri="{FF2B5EF4-FFF2-40B4-BE49-F238E27FC236}">
-                <a16:creationId xmlns:a16="http://schemas.microsoft.com/office/drawing/2014/main" id="{BB6C4AE5-C918-ACE3-8092-1AFA39CCE60A}"/>
+                <a16:creationId xmlns:a16="http://schemas.microsoft.com/office/drawing/2014/main" id="{D318096A-E99D-5EF2-766B-E40669BA4314}"/>
               </a:ext>
             </a:extLst>
           </p:cNvPr>
@@ -10844,7 +10844,7 @@
                 </a:solidFill>
                 <a:latin typeface="Calibri" panose="020F0502020204030204" pitchFamily="34" charset="0"/>
               </a:rPr>
-              <a:t>Start a run with the model tier on - the organisers' full inbox, 520 emails</a:t>
+              <a:t>Start a run with the model tier on - then Before / With Sentinel: the inbox as it arrived, and what it made of it</a:t>
             </a:r>
             <a:endParaRPr lang="en-MY" sz="1300">
               <a:solidFill>
@@ -10860,7 +10860,7 @@
           <p:cNvPr id="6" name="Oval 5">
             <a:extLst>
               <a:ext uri="{FF2B5EF4-FFF2-40B4-BE49-F238E27FC236}">
-                <a16:creationId xmlns:a16="http://schemas.microsoft.com/office/drawing/2014/main" id="{E27029DA-BB52-1FCD-276F-AA915D1B3F30}"/>
+                <a16:creationId xmlns:a16="http://schemas.microsoft.com/office/drawing/2014/main" id="{E78AFCFB-60C1-F22C-9CD1-E4F5A90B1439}"/>
               </a:ext>
             </a:extLst>
           </p:cNvPr>
@@ -10936,7 +10936,7 @@
           <p:cNvPr id="7" name="TextBox 6">
             <a:extLst>
               <a:ext uri="{FF2B5EF4-FFF2-40B4-BE49-F238E27FC236}">
-                <a16:creationId xmlns:a16="http://schemas.microsoft.com/office/drawing/2014/main" id="{A1A8CEDE-3942-8E21-3EF3-01EC57AFFD07}"/>
+                <a16:creationId xmlns:a16="http://schemas.microsoft.com/office/drawing/2014/main" id="{FB9C4DEA-C53D-26E1-10D7-E1FC56942AE7}"/>
               </a:ext>
             </a:extLst>
           </p:cNvPr>
@@ -10966,7 +10966,7 @@
                 </a:solidFill>
                 <a:latin typeface="Calibri" panose="020F0502020204030204" pitchFamily="34" charset="0"/>
               </a:rPr>
-              <a:t>Patterns worth a second look - one shipper, one field, six times</a:t>
+              <a:t>Patterns worth a second look - one shipper, one field, seven times</a:t>
             </a:r>
             <a:endParaRPr lang="en-MY" sz="1300">
               <a:solidFill>
@@ -10982,7 +10982,7 @@
           <p:cNvPr id="8" name="Oval 7">
             <a:extLst>
               <a:ext uri="{FF2B5EF4-FFF2-40B4-BE49-F238E27FC236}">
-                <a16:creationId xmlns:a16="http://schemas.microsoft.com/office/drawing/2014/main" id="{43C0904F-1215-726A-B2F1-45C7A4BD5B3C}"/>
+                <a16:creationId xmlns:a16="http://schemas.microsoft.com/office/drawing/2014/main" id="{63BAFCA6-61E0-03D5-DE05-8850E5E78258}"/>
               </a:ext>
             </a:extLst>
           </p:cNvPr>
@@ -11058,7 +11058,7 @@
           <p:cNvPr id="9" name="TextBox 8">
             <a:extLst>
               <a:ext uri="{FF2B5EF4-FFF2-40B4-BE49-F238E27FC236}">
-                <a16:creationId xmlns:a16="http://schemas.microsoft.com/office/drawing/2014/main" id="{18D79AF6-CC6B-9D07-0550-B46B7EC8FE7D}"/>
+                <a16:creationId xmlns:a16="http://schemas.microsoft.com/office/drawing/2014/main" id="{1FEB793D-8F68-B90B-3D58-31C845516115}"/>
               </a:ext>
             </a:extLst>
           </p:cNvPr>
@@ -11104,7 +11104,7 @@
           <p:cNvPr id="10" name="Oval 9">
             <a:extLst>
               <a:ext uri="{FF2B5EF4-FFF2-40B4-BE49-F238E27FC236}">
-                <a16:creationId xmlns:a16="http://schemas.microsoft.com/office/drawing/2014/main" id="{2A45EEDA-6464-D86A-12B3-E08F54920F90}"/>
+                <a16:creationId xmlns:a16="http://schemas.microsoft.com/office/drawing/2014/main" id="{6B2FCB43-B278-E5D3-5C27-CB4B92344B9C}"/>
               </a:ext>
             </a:extLst>
           </p:cNvPr>
@@ -11180,7 +11180,7 @@
           <p:cNvPr id="11" name="TextBox 10">
             <a:extLst>
               <a:ext uri="{FF2B5EF4-FFF2-40B4-BE49-F238E27FC236}">
-                <a16:creationId xmlns:a16="http://schemas.microsoft.com/office/drawing/2014/main" id="{47223473-0096-EC57-1996-4C02A929076B}"/>
+                <a16:creationId xmlns:a16="http://schemas.microsoft.com/office/drawing/2014/main" id="{380B84F0-0C5A-4FC3-D1D7-800DB0DA8A49}"/>
               </a:ext>
             </a:extLst>
           </p:cNvPr>
@@ -11226,7 +11226,7 @@
           <p:cNvPr id="12" name="Oval 11">
             <a:extLst>
               <a:ext uri="{FF2B5EF4-FFF2-40B4-BE49-F238E27FC236}">
-                <a16:creationId xmlns:a16="http://schemas.microsoft.com/office/drawing/2014/main" id="{5382F9AE-45CC-7770-BBE1-AA4AA357E351}"/>
+                <a16:creationId xmlns:a16="http://schemas.microsoft.com/office/drawing/2014/main" id="{74A6C2D7-A2C8-DF99-25FC-D33EC4D7FA72}"/>
               </a:ext>
             </a:extLst>
           </p:cNvPr>
@@ -11302,7 +11302,7 @@
           <p:cNvPr id="13" name="TextBox 12">
             <a:extLst>
               <a:ext uri="{FF2B5EF4-FFF2-40B4-BE49-F238E27FC236}">
-                <a16:creationId xmlns:a16="http://schemas.microsoft.com/office/drawing/2014/main" id="{8EED635F-AFFC-379F-F623-5501E1BC5174}"/>
+                <a16:creationId xmlns:a16="http://schemas.microsoft.com/office/drawing/2014/main" id="{EEF8C26C-C76A-FE1A-C6CD-B8A5C8F90403}"/>
               </a:ext>
             </a:extLst>
           </p:cNvPr>
@@ -11348,7 +11348,7 @@
           <p:cNvPr id="15" name="Picture 14">
             <a:extLst>
               <a:ext uri="{FF2B5EF4-FFF2-40B4-BE49-F238E27FC236}">
-                <a16:creationId xmlns:a16="http://schemas.microsoft.com/office/drawing/2014/main" id="{7F6F7046-D363-E936-35B8-C2C77878A2E8}"/>
+                <a16:creationId xmlns:a16="http://schemas.microsoft.com/office/drawing/2014/main" id="{9D79940C-0F45-14F2-0D5D-B9AC7D04D709}"/>
               </a:ext>
             </a:extLst>
           </p:cNvPr>
@@ -11389,7 +11389,7 @@
           <p:cNvPr id="16" name="TextBox 15">
             <a:extLst>
               <a:ext uri="{FF2B5EF4-FFF2-40B4-BE49-F238E27FC236}">
-                <a16:creationId xmlns:a16="http://schemas.microsoft.com/office/drawing/2014/main" id="{7F1EB5F6-C7C6-E60D-0A6F-CBAA2F77111D}"/>
+                <a16:creationId xmlns:a16="http://schemas.microsoft.com/office/drawing/2014/main" id="{8F407935-C17E-F1FC-C3FB-5E12ABD7D975}"/>
               </a:ext>
             </a:extLst>
           </p:cNvPr>
@@ -11433,7 +11433,7 @@
     </p:spTree>
     <p:extLst>
       <p:ext uri="{BB962C8B-B14F-4D97-AF65-F5344CB8AC3E}">
-        <p14:creationId xmlns:p14="http://schemas.microsoft.com/office/powerpoint/2010/main" val="1037793958"/>
+        <p14:creationId xmlns:p14="http://schemas.microsoft.com/office/powerpoint/2010/main" val="1555293019"/>
       </p:ext>
     </p:extLst>
   </p:cSld>
@@ -11473,7 +11473,7 @@
           <p:cNvPr id="2" name="TextBox 1">
             <a:extLst>
               <a:ext uri="{FF2B5EF4-FFF2-40B4-BE49-F238E27FC236}">
-                <a16:creationId xmlns:a16="http://schemas.microsoft.com/office/drawing/2014/main" id="{0361A244-F027-F4DF-B51B-DA1B9B51D349}"/>
+                <a16:creationId xmlns:a16="http://schemas.microsoft.com/office/drawing/2014/main" id="{00F96944-B085-7D21-1F0B-6A50CBD319D4}"/>
               </a:ext>
             </a:extLst>
           </p:cNvPr>
@@ -11513,7 +11513,7 @@
           <p:cNvPr id="3" name="Oval 2">
             <a:extLst>
               <a:ext uri="{FF2B5EF4-FFF2-40B4-BE49-F238E27FC236}">
-                <a16:creationId xmlns:a16="http://schemas.microsoft.com/office/drawing/2014/main" id="{3AC75AD2-E50B-A0C0-5B79-BAC6611C6B19}"/>
+                <a16:creationId xmlns:a16="http://schemas.microsoft.com/office/drawing/2014/main" id="{BC1C1934-6A70-850A-B4F6-D4F1C4C2FE5C}"/>
               </a:ext>
             </a:extLst>
           </p:cNvPr>
@@ -11589,7 +11589,7 @@
           <p:cNvPr id="4" name="TextBox 3">
             <a:extLst>
               <a:ext uri="{FF2B5EF4-FFF2-40B4-BE49-F238E27FC236}">
-                <a16:creationId xmlns:a16="http://schemas.microsoft.com/office/drawing/2014/main" id="{C05F72C1-3DEC-11E2-A1E9-81BF16D29016}"/>
+                <a16:creationId xmlns:a16="http://schemas.microsoft.com/office/drawing/2014/main" id="{919EC386-E423-8D4C-114D-68B0DA691AF2}"/>
               </a:ext>
             </a:extLst>
           </p:cNvPr>
@@ -11629,7 +11629,7 @@
           <p:cNvPr id="5" name="TextBox 4">
             <a:extLst>
               <a:ext uri="{FF2B5EF4-FFF2-40B4-BE49-F238E27FC236}">
-                <a16:creationId xmlns:a16="http://schemas.microsoft.com/office/drawing/2014/main" id="{B84D7421-C657-CFAD-09D0-726232C6DE9F}"/>
+                <a16:creationId xmlns:a16="http://schemas.microsoft.com/office/drawing/2014/main" id="{0328FAD0-0187-B7FA-C666-38354CBB1D9E}"/>
               </a:ext>
             </a:extLst>
           </p:cNvPr>
@@ -11675,7 +11675,7 @@
           <p:cNvPr id="6" name="Oval 5">
             <a:extLst>
               <a:ext uri="{FF2B5EF4-FFF2-40B4-BE49-F238E27FC236}">
-                <a16:creationId xmlns:a16="http://schemas.microsoft.com/office/drawing/2014/main" id="{A9C5D531-C8ED-7A37-3486-0669E6662FBE}"/>
+                <a16:creationId xmlns:a16="http://schemas.microsoft.com/office/drawing/2014/main" id="{F55C6E76-59BD-BD57-CE65-83EAE1466D08}"/>
               </a:ext>
             </a:extLst>
           </p:cNvPr>
@@ -11751,7 +11751,7 @@
           <p:cNvPr id="7" name="TextBox 6">
             <a:extLst>
               <a:ext uri="{FF2B5EF4-FFF2-40B4-BE49-F238E27FC236}">
-                <a16:creationId xmlns:a16="http://schemas.microsoft.com/office/drawing/2014/main" id="{9CDAA1BC-700D-EB24-5E07-E5A0A4B021CF}"/>
+                <a16:creationId xmlns:a16="http://schemas.microsoft.com/office/drawing/2014/main" id="{480095FB-B955-719B-B5FF-29EA6BA9FD76}"/>
               </a:ext>
             </a:extLst>
           </p:cNvPr>
@@ -11797,7 +11797,7 @@
           <p:cNvPr id="8" name="TextBox 7">
             <a:extLst>
               <a:ext uri="{FF2B5EF4-FFF2-40B4-BE49-F238E27FC236}">
-                <a16:creationId xmlns:a16="http://schemas.microsoft.com/office/drawing/2014/main" id="{F3910C63-3416-AAF1-BBF6-BECFD56EF6A0}"/>
+                <a16:creationId xmlns:a16="http://schemas.microsoft.com/office/drawing/2014/main" id="{C19FB67A-9D84-FF1A-2167-96EA8ACF71BA}"/>
               </a:ext>
             </a:extLst>
           </p:cNvPr>
@@ -11843,7 +11843,7 @@
           <p:cNvPr id="9" name="Oval 8">
             <a:extLst>
               <a:ext uri="{FF2B5EF4-FFF2-40B4-BE49-F238E27FC236}">
-                <a16:creationId xmlns:a16="http://schemas.microsoft.com/office/drawing/2014/main" id="{2641CD8E-D788-FD4B-5222-ACE4099FEEE6}"/>
+                <a16:creationId xmlns:a16="http://schemas.microsoft.com/office/drawing/2014/main" id="{5A70A33D-9E9D-A7B2-CA79-F656F23ADC34}"/>
               </a:ext>
             </a:extLst>
           </p:cNvPr>
@@ -11919,7 +11919,7 @@
           <p:cNvPr id="10" name="TextBox 9">
             <a:extLst>
               <a:ext uri="{FF2B5EF4-FFF2-40B4-BE49-F238E27FC236}">
-                <a16:creationId xmlns:a16="http://schemas.microsoft.com/office/drawing/2014/main" id="{36B2F309-7043-6823-CFA0-172ABBDCC853}"/>
+                <a16:creationId xmlns:a16="http://schemas.microsoft.com/office/drawing/2014/main" id="{A1165E49-195B-D982-E30C-70A3234AC40D}"/>
               </a:ext>
             </a:extLst>
           </p:cNvPr>
@@ -11965,7 +11965,7 @@
           <p:cNvPr id="11" name="TextBox 10">
             <a:extLst>
               <a:ext uri="{FF2B5EF4-FFF2-40B4-BE49-F238E27FC236}">
-                <a16:creationId xmlns:a16="http://schemas.microsoft.com/office/drawing/2014/main" id="{17DBB224-D5BB-F090-AADD-C76D84E361A2}"/>
+                <a16:creationId xmlns:a16="http://schemas.microsoft.com/office/drawing/2014/main" id="{2E41658C-D1C5-1F20-B98F-DD47AA2E6B00}"/>
               </a:ext>
             </a:extLst>
           </p:cNvPr>
@@ -12011,7 +12011,7 @@
           <p:cNvPr id="12" name="Oval 11">
             <a:extLst>
               <a:ext uri="{FF2B5EF4-FFF2-40B4-BE49-F238E27FC236}">
-                <a16:creationId xmlns:a16="http://schemas.microsoft.com/office/drawing/2014/main" id="{CA55D6EC-49B0-50BF-30B1-1EF9EF6A90C7}"/>
+                <a16:creationId xmlns:a16="http://schemas.microsoft.com/office/drawing/2014/main" id="{0843AE3B-9DCA-CC4A-3854-A0BF7BC3B1B9}"/>
               </a:ext>
             </a:extLst>
           </p:cNvPr>
@@ -12087,7 +12087,7 @@
           <p:cNvPr id="13" name="TextBox 12">
             <a:extLst>
               <a:ext uri="{FF2B5EF4-FFF2-40B4-BE49-F238E27FC236}">
-                <a16:creationId xmlns:a16="http://schemas.microsoft.com/office/drawing/2014/main" id="{F5AAAE46-66FE-3DDC-9D9C-4E4BC7DF0296}"/>
+                <a16:creationId xmlns:a16="http://schemas.microsoft.com/office/drawing/2014/main" id="{0F7DD32E-B369-0472-FA56-76AB2CA7F62D}"/>
               </a:ext>
             </a:extLst>
           </p:cNvPr>
@@ -12133,7 +12133,7 @@
           <p:cNvPr id="14" name="TextBox 13">
             <a:extLst>
               <a:ext uri="{FF2B5EF4-FFF2-40B4-BE49-F238E27FC236}">
-                <a16:creationId xmlns:a16="http://schemas.microsoft.com/office/drawing/2014/main" id="{085032E0-6489-1F95-FE19-9A5392963135}"/>
+                <a16:creationId xmlns:a16="http://schemas.microsoft.com/office/drawing/2014/main" id="{2BBE61AD-E8D1-AD1C-4C09-E34D0ADD340D}"/>
               </a:ext>
             </a:extLst>
           </p:cNvPr>
@@ -12179,7 +12179,7 @@
           <p:cNvPr id="15" name="Oval 14">
             <a:extLst>
               <a:ext uri="{FF2B5EF4-FFF2-40B4-BE49-F238E27FC236}">
-                <a16:creationId xmlns:a16="http://schemas.microsoft.com/office/drawing/2014/main" id="{45E3243F-F3BD-96FD-7973-8E668BE1F9CA}"/>
+                <a16:creationId xmlns:a16="http://schemas.microsoft.com/office/drawing/2014/main" id="{BAE8C221-C32B-97CE-39F0-2503C6C92A71}"/>
               </a:ext>
             </a:extLst>
           </p:cNvPr>
@@ -12255,7 +12255,7 @@
           <p:cNvPr id="16" name="TextBox 15">
             <a:extLst>
               <a:ext uri="{FF2B5EF4-FFF2-40B4-BE49-F238E27FC236}">
-                <a16:creationId xmlns:a16="http://schemas.microsoft.com/office/drawing/2014/main" id="{E65204F4-DBB9-78AB-2BE7-89739FC41C8D}"/>
+                <a16:creationId xmlns:a16="http://schemas.microsoft.com/office/drawing/2014/main" id="{7DE96077-AE11-593F-9DA1-54EF5B2EA4A4}"/>
               </a:ext>
             </a:extLst>
           </p:cNvPr>
@@ -12301,7 +12301,7 @@
           <p:cNvPr id="17" name="TextBox 16">
             <a:extLst>
               <a:ext uri="{FF2B5EF4-FFF2-40B4-BE49-F238E27FC236}">
-                <a16:creationId xmlns:a16="http://schemas.microsoft.com/office/drawing/2014/main" id="{C1519ECA-C2B2-426B-F335-8450EFC22E7D}"/>
+                <a16:creationId xmlns:a16="http://schemas.microsoft.com/office/drawing/2014/main" id="{4182330A-2E4B-7C62-286D-8EA43F9029A5}"/>
               </a:ext>
             </a:extLst>
           </p:cNvPr>
@@ -12347,7 +12347,7 @@
           <p:cNvPr id="19" name="Picture 18">
             <a:extLst>
               <a:ext uri="{FF2B5EF4-FFF2-40B4-BE49-F238E27FC236}">
-                <a16:creationId xmlns:a16="http://schemas.microsoft.com/office/drawing/2014/main" id="{D7B028DE-82FE-871B-D738-3DB358EBECAA}"/>
+                <a16:creationId xmlns:a16="http://schemas.microsoft.com/office/drawing/2014/main" id="{593519BC-56F3-DAB6-253F-223BE0A07FBF}"/>
               </a:ext>
             </a:extLst>
           </p:cNvPr>
@@ -12371,7 +12371,7 @@
         <p:spPr>
           <a:xfrm>
             <a:off x="6858000" y="1219200"/>
-            <a:ext cx="4724400" cy="1837267"/>
+            <a:ext cx="4724400" cy="1637479"/>
           </a:xfrm>
           <a:prstGeom prst="rect">
             <a:avLst/>
@@ -12388,7 +12388,7 @@
           <p:cNvPr id="20" name="TextBox 19">
             <a:extLst>
               <a:ext uri="{FF2B5EF4-FFF2-40B4-BE49-F238E27FC236}">
-                <a16:creationId xmlns:a16="http://schemas.microsoft.com/office/drawing/2014/main" id="{87AE7AD1-426C-4D04-DA2F-1AD46E680297}"/>
+                <a16:creationId xmlns:a16="http://schemas.microsoft.com/office/drawing/2014/main" id="{9C0B8DA1-8601-FF51-022B-FB3B1D528DF6}"/>
               </a:ext>
             </a:extLst>
           </p:cNvPr>
@@ -12434,7 +12434,7 @@
           <p:cNvPr id="21" name="Rectangle: Rounded Corners 20">
             <a:extLst>
               <a:ext uri="{FF2B5EF4-FFF2-40B4-BE49-F238E27FC236}">
-                <a16:creationId xmlns:a16="http://schemas.microsoft.com/office/drawing/2014/main" id="{51FF6AE3-08E3-2176-ACCF-E61549E5E729}"/>
+                <a16:creationId xmlns:a16="http://schemas.microsoft.com/office/drawing/2014/main" id="{B512E677-71BC-8ED8-5F91-2C82B7FCEFA5}"/>
               </a:ext>
             </a:extLst>
           </p:cNvPr>
@@ -12504,7 +12504,7 @@
           <p:cNvPr id="22" name="TextBox 21">
             <a:extLst>
               <a:ext uri="{FF2B5EF4-FFF2-40B4-BE49-F238E27FC236}">
-                <a16:creationId xmlns:a16="http://schemas.microsoft.com/office/drawing/2014/main" id="{04749409-1CF9-4C9C-993A-6609C9CD1D78}"/>
+                <a16:creationId xmlns:a16="http://schemas.microsoft.com/office/drawing/2014/main" id="{9F40B439-FA69-FA7F-B28C-71849E3053DF}"/>
               </a:ext>
             </a:extLst>
           </p:cNvPr>
@@ -12550,7 +12550,7 @@
           <p:cNvPr id="23" name="TextBox 22">
             <a:extLst>
               <a:ext uri="{FF2B5EF4-FFF2-40B4-BE49-F238E27FC236}">
-                <a16:creationId xmlns:a16="http://schemas.microsoft.com/office/drawing/2014/main" id="{4B46A69B-E70D-0C8E-D9B8-24161E95C137}"/>
+                <a16:creationId xmlns:a16="http://schemas.microsoft.com/office/drawing/2014/main" id="{AE721930-133F-C1DB-A8BB-246024515018}"/>
               </a:ext>
             </a:extLst>
           </p:cNvPr>
@@ -12595,7 +12595,7 @@
     </p:spTree>
     <p:extLst>
       <p:ext uri="{BB962C8B-B14F-4D97-AF65-F5344CB8AC3E}">
-        <p14:creationId xmlns:p14="http://schemas.microsoft.com/office/powerpoint/2010/main" val="2596078402"/>
+        <p14:creationId xmlns:p14="http://schemas.microsoft.com/office/powerpoint/2010/main" val="3939252150"/>
       </p:ext>
     </p:extLst>
   </p:cSld>
@@ -12635,7 +12635,7 @@
           <p:cNvPr id="2" name="TextBox 1">
             <a:extLst>
               <a:ext uri="{FF2B5EF4-FFF2-40B4-BE49-F238E27FC236}">
-                <a16:creationId xmlns:a16="http://schemas.microsoft.com/office/drawing/2014/main" id="{D4F84BD4-CA6D-DD44-CEB0-727AE5B5BD7B}"/>
+                <a16:creationId xmlns:a16="http://schemas.microsoft.com/office/drawing/2014/main" id="{FCFBDF0C-03B0-8E26-41CD-4D025C5022E6}"/>
               </a:ext>
             </a:extLst>
           </p:cNvPr>
@@ -12681,7 +12681,7 @@
           <p:cNvPr id="3" name="Rectangle: Rounded Corners 2">
             <a:extLst>
               <a:ext uri="{FF2B5EF4-FFF2-40B4-BE49-F238E27FC236}">
-                <a16:creationId xmlns:a16="http://schemas.microsoft.com/office/drawing/2014/main" id="{14D35C28-96BC-FDDE-A400-9A38795C4C6B}"/>
+                <a16:creationId xmlns:a16="http://schemas.microsoft.com/office/drawing/2014/main" id="{4D28F5AB-959B-2035-516D-3D116227F55B}"/>
               </a:ext>
             </a:extLst>
           </p:cNvPr>
@@ -12751,7 +12751,7 @@
           <p:cNvPr id="4" name="TextBox 3">
             <a:extLst>
               <a:ext uri="{FF2B5EF4-FFF2-40B4-BE49-F238E27FC236}">
-                <a16:creationId xmlns:a16="http://schemas.microsoft.com/office/drawing/2014/main" id="{C1B49AE9-D6C8-5B0A-85D8-2130E8BBABE0}"/>
+                <a16:creationId xmlns:a16="http://schemas.microsoft.com/office/drawing/2014/main" id="{3D6006A5-25F9-D285-9684-E443C1B42C9D}"/>
               </a:ext>
             </a:extLst>
           </p:cNvPr>
@@ -12791,7 +12791,7 @@
           <p:cNvPr id="5" name="TextBox 4">
             <a:extLst>
               <a:ext uri="{FF2B5EF4-FFF2-40B4-BE49-F238E27FC236}">
-                <a16:creationId xmlns:a16="http://schemas.microsoft.com/office/drawing/2014/main" id="{D180FBA5-E946-8E47-2878-B0B147F0E73A}"/>
+                <a16:creationId xmlns:a16="http://schemas.microsoft.com/office/drawing/2014/main" id="{CCC75A23-21CD-BD00-AB1C-45050F30C966}"/>
               </a:ext>
             </a:extLst>
           </p:cNvPr>
@@ -12832,7 +12832,7 @@
           <p:cNvPr id="6" name="TextBox 5">
             <a:extLst>
               <a:ext uri="{FF2B5EF4-FFF2-40B4-BE49-F238E27FC236}">
-                <a16:creationId xmlns:a16="http://schemas.microsoft.com/office/drawing/2014/main" id="{852ED602-2886-7D3D-029A-2E800583FAE8}"/>
+                <a16:creationId xmlns:a16="http://schemas.microsoft.com/office/drawing/2014/main" id="{FF48D0D3-FAF5-DAE0-B532-6107F13C4124}"/>
               </a:ext>
             </a:extLst>
           </p:cNvPr>
@@ -12872,7 +12872,7 @@
           <p:cNvPr id="7" name="TextBox 6">
             <a:extLst>
               <a:ext uri="{FF2B5EF4-FFF2-40B4-BE49-F238E27FC236}">
-                <a16:creationId xmlns:a16="http://schemas.microsoft.com/office/drawing/2014/main" id="{6AF2C088-8D31-CF3D-EF81-7421717E9CC3}"/>
+                <a16:creationId xmlns:a16="http://schemas.microsoft.com/office/drawing/2014/main" id="{6EF3249C-6353-3429-C40D-C8F77F0EA422}"/>
               </a:ext>
             </a:extLst>
           </p:cNvPr>
@@ -12918,7 +12918,7 @@
           <p:cNvPr id="8" name="TextBox 7">
             <a:extLst>
               <a:ext uri="{FF2B5EF4-FFF2-40B4-BE49-F238E27FC236}">
-                <a16:creationId xmlns:a16="http://schemas.microsoft.com/office/drawing/2014/main" id="{E6FA07E7-9ED3-88B7-0A23-7C74EB3913BC}"/>
+                <a16:creationId xmlns:a16="http://schemas.microsoft.com/office/drawing/2014/main" id="{06911DF7-DBE5-24D3-CFBB-452B94AC345F}"/>
               </a:ext>
             </a:extLst>
           </p:cNvPr>
@@ -12964,7 +12964,7 @@
           <p:cNvPr id="9" name="TextBox 8">
             <a:extLst>
               <a:ext uri="{FF2B5EF4-FFF2-40B4-BE49-F238E27FC236}">
-                <a16:creationId xmlns:a16="http://schemas.microsoft.com/office/drawing/2014/main" id="{082C4F84-0129-0A85-BBC8-80F88CE739CE}"/>
+                <a16:creationId xmlns:a16="http://schemas.microsoft.com/office/drawing/2014/main" id="{0781AF71-E0FB-EB11-FEE5-28AB61404BE8}"/>
               </a:ext>
             </a:extLst>
           </p:cNvPr>
@@ -13010,7 +13010,7 @@
           <p:cNvPr id="10" name="Table 9">
             <a:extLst>
               <a:ext uri="{FF2B5EF4-FFF2-40B4-BE49-F238E27FC236}">
-                <a16:creationId xmlns:a16="http://schemas.microsoft.com/office/drawing/2014/main" id="{FAAD3784-CD8C-E73B-1625-194C9ECE5FD1}"/>
+                <a16:creationId xmlns:a16="http://schemas.microsoft.com/office/drawing/2014/main" id="{5B5C0859-5EEF-323F-00F4-7E37CE64C467}"/>
               </a:ext>
             </a:extLst>
           </p:cNvPr>
@@ -13020,7 +13020,7 @@
           <p:nvPr>
             <p:extLst>
               <p:ext uri="{D42A27DB-BD31-4B8C-83A1-F6EECF244321}">
-                <p14:modId xmlns:p14="http://schemas.microsoft.com/office/powerpoint/2010/main" val="67259051"/>
+                <p14:modId xmlns:p14="http://schemas.microsoft.com/office/powerpoint/2010/main" val="2196699509"/>
               </p:ext>
             </p:extLst>
           </p:nvPr>
@@ -13039,21 +13039,21 @@
                 <a:gridCol w="1905000">
                   <a:extLst>
                     <a:ext uri="{9D8B030D-6E8A-4147-A177-3AD203B41FA5}">
-                      <a16:colId xmlns:a16="http://schemas.microsoft.com/office/drawing/2014/main" val="1415162259"/>
+                      <a16:colId xmlns:a16="http://schemas.microsoft.com/office/drawing/2014/main" val="3658349358"/>
                     </a:ext>
                   </a:extLst>
                 </a:gridCol>
                 <a:gridCol w="2413000">
                   <a:extLst>
                     <a:ext uri="{9D8B030D-6E8A-4147-A177-3AD203B41FA5}">
-                      <a16:colId xmlns:a16="http://schemas.microsoft.com/office/drawing/2014/main" val="1375915125"/>
+                      <a16:colId xmlns:a16="http://schemas.microsoft.com/office/drawing/2014/main" val="4251038765"/>
                     </a:ext>
                   </a:extLst>
                 </a:gridCol>
                 <a:gridCol w="2032000">
                   <a:extLst>
                     <a:ext uri="{9D8B030D-6E8A-4147-A177-3AD203B41FA5}">
-                      <a16:colId xmlns:a16="http://schemas.microsoft.com/office/drawing/2014/main" val="4199924233"/>
+                      <a16:colId xmlns:a16="http://schemas.microsoft.com/office/drawing/2014/main" val="47794513"/>
                     </a:ext>
                   </a:extLst>
                 </a:gridCol>
@@ -13127,7 +13127,7 @@
                 </a:tc>
                 <a:extLst>
                   <a:ext uri="{0D108BD9-81ED-4DB2-BD59-A6C34878D82A}">
-                    <a16:rowId xmlns:a16="http://schemas.microsoft.com/office/drawing/2014/main" val="361054233"/>
+                    <a16:rowId xmlns:a16="http://schemas.microsoft.com/office/drawing/2014/main" val="1720233538"/>
                   </a:ext>
                 </a:extLst>
               </a:tr>
@@ -13212,7 +13212,7 @@
                 </a:tc>
                 <a:extLst>
                   <a:ext uri="{0D108BD9-81ED-4DB2-BD59-A6C34878D82A}">
-                    <a16:rowId xmlns:a16="http://schemas.microsoft.com/office/drawing/2014/main" val="2959678648"/>
+                    <a16:rowId xmlns:a16="http://schemas.microsoft.com/office/drawing/2014/main" val="2916994068"/>
                   </a:ext>
                 </a:extLst>
               </a:tr>
@@ -13291,7 +13291,7 @@
                 </a:tc>
                 <a:extLst>
                   <a:ext uri="{0D108BD9-81ED-4DB2-BD59-A6C34878D82A}">
-                    <a16:rowId xmlns:a16="http://schemas.microsoft.com/office/drawing/2014/main" val="568926261"/>
+                    <a16:rowId xmlns:a16="http://schemas.microsoft.com/office/drawing/2014/main" val="243371682"/>
                   </a:ext>
                 </a:extLst>
               </a:tr>
@@ -13370,7 +13370,7 @@
                 </a:tc>
                 <a:extLst>
                   <a:ext uri="{0D108BD9-81ED-4DB2-BD59-A6C34878D82A}">
-                    <a16:rowId xmlns:a16="http://schemas.microsoft.com/office/drawing/2014/main" val="2167205588"/>
+                    <a16:rowId xmlns:a16="http://schemas.microsoft.com/office/drawing/2014/main" val="2542116333"/>
                   </a:ext>
                 </a:extLst>
               </a:tr>
@@ -13383,7 +13383,7 @@
           <p:cNvPr id="11" name="Rectangle: Rounded Corners 10">
             <a:extLst>
               <a:ext uri="{FF2B5EF4-FFF2-40B4-BE49-F238E27FC236}">
-                <a16:creationId xmlns:a16="http://schemas.microsoft.com/office/drawing/2014/main" id="{FDD5AE3E-7485-7FE6-35CB-972C69FB3EBB}"/>
+                <a16:creationId xmlns:a16="http://schemas.microsoft.com/office/drawing/2014/main" id="{9DF73A8F-A722-B428-1626-7897A7143E5C}"/>
               </a:ext>
             </a:extLst>
           </p:cNvPr>
@@ -13453,7 +13453,7 @@
           <p:cNvPr id="12" name="TextBox 11">
             <a:extLst>
               <a:ext uri="{FF2B5EF4-FFF2-40B4-BE49-F238E27FC236}">
-                <a16:creationId xmlns:a16="http://schemas.microsoft.com/office/drawing/2014/main" id="{BC72DD2B-6904-FEC6-991A-D600661159FB}"/>
+                <a16:creationId xmlns:a16="http://schemas.microsoft.com/office/drawing/2014/main" id="{B2F449B4-A176-A39F-EC1B-222D5B36B922}"/>
               </a:ext>
             </a:extLst>
           </p:cNvPr>
@@ -13493,7 +13493,7 @@
           <p:cNvPr id="13" name="Oval 12">
             <a:extLst>
               <a:ext uri="{FF2B5EF4-FFF2-40B4-BE49-F238E27FC236}">
-                <a16:creationId xmlns:a16="http://schemas.microsoft.com/office/drawing/2014/main" id="{1C9E7BD2-7DAC-E8DA-303B-83B78E631E0F}"/>
+                <a16:creationId xmlns:a16="http://schemas.microsoft.com/office/drawing/2014/main" id="{BB5B4C39-6196-B129-B0FC-26CB43916FDA}"/>
               </a:ext>
             </a:extLst>
           </p:cNvPr>
@@ -13569,7 +13569,7 @@
           <p:cNvPr id="14" name="TextBox 13">
             <a:extLst>
               <a:ext uri="{FF2B5EF4-FFF2-40B4-BE49-F238E27FC236}">
-                <a16:creationId xmlns:a16="http://schemas.microsoft.com/office/drawing/2014/main" id="{5B379FDB-4825-4C63-15DB-DFFD6141B638}"/>
+                <a16:creationId xmlns:a16="http://schemas.microsoft.com/office/drawing/2014/main" id="{D4BF8A55-9700-F084-4461-6A641F1251A0}"/>
               </a:ext>
             </a:extLst>
           </p:cNvPr>
@@ -13609,7 +13609,7 @@
           <p:cNvPr id="15" name="TextBox 14">
             <a:extLst>
               <a:ext uri="{FF2B5EF4-FFF2-40B4-BE49-F238E27FC236}">
-                <a16:creationId xmlns:a16="http://schemas.microsoft.com/office/drawing/2014/main" id="{3D8B4E7E-0C81-4C8E-905F-0B0B1F180CCC}"/>
+                <a16:creationId xmlns:a16="http://schemas.microsoft.com/office/drawing/2014/main" id="{5E2407B6-3AA6-C663-B8B3-D257B9D984E5}"/>
               </a:ext>
             </a:extLst>
           </p:cNvPr>
@@ -13655,7 +13655,7 @@
           <p:cNvPr id="16" name="Oval 15">
             <a:extLst>
               <a:ext uri="{FF2B5EF4-FFF2-40B4-BE49-F238E27FC236}">
-                <a16:creationId xmlns:a16="http://schemas.microsoft.com/office/drawing/2014/main" id="{E3E4FE72-245A-7029-1621-C3FC2A00496F}"/>
+                <a16:creationId xmlns:a16="http://schemas.microsoft.com/office/drawing/2014/main" id="{0C218562-18BB-6D16-863D-A37A60D606A7}"/>
               </a:ext>
             </a:extLst>
           </p:cNvPr>
@@ -13731,7 +13731,7 @@
           <p:cNvPr id="17" name="TextBox 16">
             <a:extLst>
               <a:ext uri="{FF2B5EF4-FFF2-40B4-BE49-F238E27FC236}">
-                <a16:creationId xmlns:a16="http://schemas.microsoft.com/office/drawing/2014/main" id="{9B39274F-859B-89CA-E981-525B0B112806}"/>
+                <a16:creationId xmlns:a16="http://schemas.microsoft.com/office/drawing/2014/main" id="{15C94259-E94D-8555-0302-366255953C1E}"/>
               </a:ext>
             </a:extLst>
           </p:cNvPr>
@@ -13777,7 +13777,7 @@
           <p:cNvPr id="18" name="TextBox 17">
             <a:extLst>
               <a:ext uri="{FF2B5EF4-FFF2-40B4-BE49-F238E27FC236}">
-                <a16:creationId xmlns:a16="http://schemas.microsoft.com/office/drawing/2014/main" id="{05EF6F5D-2A52-6EEF-87BB-C89164CAB1B1}"/>
+                <a16:creationId xmlns:a16="http://schemas.microsoft.com/office/drawing/2014/main" id="{6933C7A9-FAF3-F70D-9DDF-0691BEC1EBA8}"/>
               </a:ext>
             </a:extLst>
           </p:cNvPr>
@@ -13823,7 +13823,7 @@
           <p:cNvPr id="19" name="Oval 18">
             <a:extLst>
               <a:ext uri="{FF2B5EF4-FFF2-40B4-BE49-F238E27FC236}">
-                <a16:creationId xmlns:a16="http://schemas.microsoft.com/office/drawing/2014/main" id="{0C4AB10C-676E-8543-00AF-F111C5D7EF3F}"/>
+                <a16:creationId xmlns:a16="http://schemas.microsoft.com/office/drawing/2014/main" id="{C3625124-EC6F-B9A1-B721-54072AA95D7E}"/>
               </a:ext>
             </a:extLst>
           </p:cNvPr>
@@ -13899,7 +13899,7 @@
           <p:cNvPr id="20" name="TextBox 19">
             <a:extLst>
               <a:ext uri="{FF2B5EF4-FFF2-40B4-BE49-F238E27FC236}">
-                <a16:creationId xmlns:a16="http://schemas.microsoft.com/office/drawing/2014/main" id="{47A67589-3FF5-5FB0-B389-E299FDCB5DFA}"/>
+                <a16:creationId xmlns:a16="http://schemas.microsoft.com/office/drawing/2014/main" id="{D616624C-6774-9DA4-2B3B-C784D54D4BF6}"/>
               </a:ext>
             </a:extLst>
           </p:cNvPr>
@@ -13939,7 +13939,7 @@
           <p:cNvPr id="21" name="TextBox 20">
             <a:extLst>
               <a:ext uri="{FF2B5EF4-FFF2-40B4-BE49-F238E27FC236}">
-                <a16:creationId xmlns:a16="http://schemas.microsoft.com/office/drawing/2014/main" id="{645290EE-B362-CD2F-794A-5C18E1D36B6E}"/>
+                <a16:creationId xmlns:a16="http://schemas.microsoft.com/office/drawing/2014/main" id="{660225A4-4AC8-804E-2E50-D613C8875197}"/>
               </a:ext>
             </a:extLst>
           </p:cNvPr>
@@ -13985,7 +13985,7 @@
           <p:cNvPr id="22" name="TextBox 21">
             <a:extLst>
               <a:ext uri="{FF2B5EF4-FFF2-40B4-BE49-F238E27FC236}">
-                <a16:creationId xmlns:a16="http://schemas.microsoft.com/office/drawing/2014/main" id="{119025DA-FC0B-AAF1-B955-7410E0AB95DA}"/>
+                <a16:creationId xmlns:a16="http://schemas.microsoft.com/office/drawing/2014/main" id="{BB5FF9C2-86BC-7F90-426E-A727C2F9986D}"/>
               </a:ext>
             </a:extLst>
           </p:cNvPr>
@@ -14031,7 +14031,7 @@
           <p:cNvPr id="23" name="TextBox 22">
             <a:extLst>
               <a:ext uri="{FF2B5EF4-FFF2-40B4-BE49-F238E27FC236}">
-                <a16:creationId xmlns:a16="http://schemas.microsoft.com/office/drawing/2014/main" id="{EA1E6289-F853-5D8B-0D3D-56F270878E4A}"/>
+                <a16:creationId xmlns:a16="http://schemas.microsoft.com/office/drawing/2014/main" id="{5158F63E-F2CE-B4FB-FAE4-2BAE9CA5E699}"/>
               </a:ext>
             </a:extLst>
           </p:cNvPr>
@@ -14070,7 +14070,7 @@
     </p:spTree>
     <p:extLst>
       <p:ext uri="{BB962C8B-B14F-4D97-AF65-F5344CB8AC3E}">
-        <p14:creationId xmlns:p14="http://schemas.microsoft.com/office/powerpoint/2010/main" val="1732380028"/>
+        <p14:creationId xmlns:p14="http://schemas.microsoft.com/office/powerpoint/2010/main" val="2823521045"/>
       </p:ext>
     </p:extLst>
   </p:cSld>

</xml_diff>